<commit_message>
docs: slide de dificuldades encontradas e quadro Kanban citado no deck do T3
</commit_message>
<xml_diff>
--- a/trabalhos/T3-Apresentacao-Intermediaria.pptx
+++ b/trabalhos/T3-Apresentacao-Intermediaria.pptx
@@ -26,6 +26,7 @@
     <p:sldId id="271" r:id="rId26"/>
     <p:sldId id="272" r:id="rId27"/>
     <p:sldId id="273" r:id="rId28"/>
+    <p:sldId id="274" r:id="rId29"/>
   </p:sldIdLst>
   <p:sldSz cx="12192000" cy="6858000"/>
   <p:notesSz cx="6858000" cy="9144000"/>
@@ -820,7 +821,7 @@
           <a:lstStyle/>
           <a:p>
             <a:r>
-              <a:t>Andreas. Planejamos em sprints de duas semanas no Azure Boards, com cada história quebrada em tarefas de tela e de API. Conversamos pelo WhatsApp e discutimos o projeto no tempo de aula. O que decidimos fica registrado no repositório, no Guia, nos ADRs e nos Ajustes da Sprint 5. Integramos por PR, e a CI verde é a nossa definição de pronto.</a:t>
+              <a:t>Andreas. Planejamos em sprints de duas semanas e acompanhamos no quadro Kanban do Azure Boards, com cada história quebrada em tarefas de tela e de API. Conversamos pelo WhatsApp e discutimos o projeto no tempo de aula. O que decidimos fica registrado no repositório, no Guia, nos ADRs e nos Ajustes da Sprint 5. Integramos por PR, e a CI verde é a nossa definição de pronto.</a:t>
             </a:r>
           </a:p>
         </p:txBody>
@@ -890,7 +891,7 @@
           <a:lstStyle/>
           <a:p>
             <a:r>
-              <a:t>Andreas. Dizer quais itens assumiu. Preencher Quem e Até antes do ensaio e criar os itens no quadro da Sprint 6, de 03/11 a 16/11.</a:t>
+              <a:t>Andreas. Cada dificuldade foi contada por quem a viveu: a integração pelo Tiago, o protótipo pelo Guilherme e a regra de vagas pelo Gabriel. Este slide só as reúne, com as lições que o time tirou delas. Se perguntarem detalhes, passar para o dono de cada uma.</a:t>
             </a:r>
           </a:p>
         </p:txBody>
@@ -916,6 +917,76 @@
 </file>
 
 <file path=ppt/notesSlides/notesSlide15.xml><?xml version="1.0" encoding="utf-8"?>
+<p:notes xmlns:a="http://schemas.openxmlformats.org/drawingml/2006/main" xmlns:p="http://schemas.openxmlformats.org/presentationml/2006/main" xmlns:r="http://schemas.openxmlformats.org/officeDocument/2006/relationships">
+  <p:cSld>
+    <p:spTree>
+      <p:nvGrpSpPr>
+        <p:cNvPr id="1" name=""/>
+        <p:cNvGrpSpPr/>
+        <p:nvPr/>
+      </p:nvGrpSpPr>
+      <p:grpSpPr>
+        <a:xfrm>
+          <a:off x="0" y="0"/>
+          <a:ext cx="0" cy="0"/>
+          <a:chOff x="0" y="0"/>
+          <a:chExt cx="0" cy="0"/>
+        </a:xfrm>
+      </p:grpSpPr>
+      <p:sp>
+        <p:nvSpPr>
+          <p:cNvPr id="2" name="Slide Image Placeholder 1"/>
+          <p:cNvSpPr>
+            <a:spLocks noGrp="1"/>
+          </p:cNvSpPr>
+          <p:nvPr>
+            <p:ph type="sldImg" idx="2"/>
+          </p:nvPr>
+        </p:nvSpPr>
+        <p:spPr/>
+      </p:sp>
+      <p:sp>
+        <p:nvSpPr>
+          <p:cNvPr id="3" name="Notes Placeholder 2"/>
+          <p:cNvSpPr>
+            <a:spLocks noGrp="1"/>
+          </p:cNvSpPr>
+          <p:nvPr>
+            <p:ph type="body" idx="3" sz="quarter"/>
+          </p:nvPr>
+        </p:nvSpPr>
+        <p:spPr/>
+        <p:txBody>
+          <a:bodyPr/>
+          <a:lstStyle/>
+          <a:p>
+            <a:r>
+              <a:t>Andreas. Dizer quais itens assumiu. Preencher Quem e Até antes do ensaio e criar os itens no quadro da Sprint 6, de 03/11 a 16/11.</a:t>
+            </a:r>
+          </a:p>
+        </p:txBody>
+      </p:sp>
+      <p:sp>
+        <p:nvSpPr>
+          <p:cNvPr id="4" name="Slide Number Placeholder 3"/>
+          <p:cNvSpPr>
+            <a:spLocks noGrp="1"/>
+          </p:cNvSpPr>
+          <p:nvPr>
+            <p:ph type="sldNum" idx="5" sz="quarter"/>
+          </p:nvPr>
+        </p:nvSpPr>
+        <p:spPr/>
+      </p:sp>
+    </p:spTree>
+  </p:cSld>
+  <p:clrMapOvr>
+    <a:masterClrMapping/>
+  </p:clrMapOvr>
+</p:notes>
+</file>
+
+<file path=ppt/notesSlides/notesSlide16.xml><?xml version="1.0" encoding="utf-8"?>
 <p:notes xmlns:a="http://schemas.openxmlformats.org/drawingml/2006/main" xmlns:p="http://schemas.openxmlformats.org/presentationml/2006/main" xmlns:r="http://schemas.openxmlformats.org/officeDocument/2006/relationships">
   <p:cSld>
     <p:spTree>
@@ -16882,7 +16953,7 @@
                 </a:solidFill>
                 <a:latin typeface="Roboto"/>
               </a:rPr>
-              <a:t>Sprints de duas semanas no Azure Boards. Cada história é quebrada em tarefas de tela e de API, com responsável.</a:t>
+              <a:t>Sprints de duas semanas, acompanhadas no quadro Kanban do Azure Boards. Cada história é quebrada em tarefas de tela e de API, com responsável.</a:t>
             </a:r>
           </a:p>
         </p:txBody>
@@ -17215,147 +17286,34 @@
                 </a:solidFill>
                 <a:latin typeface="Roboto"/>
               </a:rPr>
-              <a:t>Planejamento até 17/11</a:t>
-            </a:r>
-          </a:p>
-        </p:txBody>
-      </p:sp>
-      <p:sp>
-        <p:nvSpPr>
-          <p:cNvPr id="4" name="TextBox 3"/>
-          <p:cNvSpPr txBox="1"/>
-          <p:nvPr/>
-        </p:nvSpPr>
-        <p:spPr>
-          <a:xfrm>
-            <a:off x="685800" y="1730231"/>
-            <a:ext cx="6667500" cy="167640"/>
-          </a:xfrm>
-          <a:prstGeom prst="rect">
-            <a:avLst/>
-          </a:prstGeom>
-          <a:noFill/>
-        </p:spPr>
-        <p:txBody>
-          <a:bodyPr wrap="square" lIns="0" rIns="0" tIns="0" bIns="0" anchor="t">
-            <a:spAutoFit/>
-          </a:bodyPr>
-          <a:lstStyle/>
-          <a:p>
-            <a:pPr algn="l">
-              <a:lnSpc>
-                <a:spcPct val="120000"/>
-              </a:lnSpc>
-            </a:pPr>
-            <a:r>
-              <a:rPr sz="819" b="1" i="0" spc="120">
-                <a:solidFill>
-                  <a:srgbClr val="21049A"/>
-                </a:solidFill>
-                <a:latin typeface="Roboto"/>
-              </a:rPr>
-              <a:t>O QUÊ</a:t>
-            </a:r>
-          </a:p>
-        </p:txBody>
-      </p:sp>
-      <p:sp>
-        <p:nvSpPr>
-          <p:cNvPr id="5" name="TextBox 4"/>
-          <p:cNvSpPr txBox="1"/>
-          <p:nvPr/>
-        </p:nvSpPr>
-        <p:spPr>
-          <a:xfrm>
-            <a:off x="7620000" y="1730231"/>
-            <a:ext cx="1905000" cy="167640"/>
-          </a:xfrm>
-          <a:prstGeom prst="rect">
-            <a:avLst/>
-          </a:prstGeom>
-          <a:noFill/>
-        </p:spPr>
-        <p:txBody>
-          <a:bodyPr wrap="square" lIns="0" rIns="0" tIns="0" bIns="0" anchor="t">
-            <a:spAutoFit/>
-          </a:bodyPr>
-          <a:lstStyle/>
-          <a:p>
-            <a:pPr algn="l">
-              <a:lnSpc>
-                <a:spcPct val="120000"/>
-              </a:lnSpc>
-            </a:pPr>
-            <a:r>
-              <a:rPr sz="819" b="1" i="0" spc="120">
-                <a:solidFill>
-                  <a:srgbClr val="21049A"/>
-                </a:solidFill>
-                <a:latin typeface="Roboto"/>
-              </a:rPr>
-              <a:t>QUEM</a:t>
-            </a:r>
-          </a:p>
-        </p:txBody>
-      </p:sp>
-      <p:sp>
-        <p:nvSpPr>
-          <p:cNvPr id="6" name="TextBox 5"/>
-          <p:cNvSpPr txBox="1"/>
-          <p:nvPr/>
-        </p:nvSpPr>
-        <p:spPr>
-          <a:xfrm>
-            <a:off x="9620250" y="1730231"/>
-            <a:ext cx="1885950" cy="167640"/>
-          </a:xfrm>
-          <a:prstGeom prst="rect">
-            <a:avLst/>
-          </a:prstGeom>
-          <a:noFill/>
-        </p:spPr>
-        <p:txBody>
-          <a:bodyPr wrap="square" lIns="0" rIns="0" tIns="0" bIns="0" anchor="t">
-            <a:spAutoFit/>
-          </a:bodyPr>
-          <a:lstStyle/>
-          <a:p>
-            <a:pPr algn="l">
-              <a:lnSpc>
-                <a:spcPct val="120000"/>
-              </a:lnSpc>
-            </a:pPr>
-            <a:r>
-              <a:rPr sz="819" b="1" i="0" spc="120">
-                <a:solidFill>
-                  <a:srgbClr val="21049A"/>
-                </a:solidFill>
-                <a:latin typeface="Roboto"/>
-              </a:rPr>
-              <a:t>ATÉ</a:t>
-            </a:r>
-          </a:p>
-        </p:txBody>
-      </p:sp>
-      <p:sp>
-        <p:nvSpPr>
-          <p:cNvPr id="7" name="Rectangle 6"/>
+              <a:t>Dificuldades encontradas</a:t>
+            </a:r>
+          </a:p>
+        </p:txBody>
+      </p:sp>
+      <p:sp>
+        <p:nvSpPr>
+          <p:cNvPr id="4" name="Rounded Rectangle 3"/>
           <p:cNvSpPr/>
           <p:nvPr/>
         </p:nvSpPr>
         <p:spPr>
           <a:xfrm>
-            <a:off x="685800" y="1958831"/>
-            <a:ext cx="10820400" cy="19050"/>
-          </a:xfrm>
-          <a:prstGeom prst="rect">
-            <a:avLst/>
+            <a:off x="685800" y="2428585"/>
+            <a:ext cx="3454400" cy="2133600"/>
+          </a:xfrm>
+          <a:prstGeom prst="roundRect">
+            <a:avLst>
+              <a:gd name="adj" fmla="val 3571"/>
+            </a:avLst>
           </a:prstGeom>
           <a:solidFill>
-            <a:srgbClr val="21049A"/>
+            <a:srgbClr val="F2F2F5"/>
           </a:solidFill>
-          <a:ln>
-            <a:noFill/>
+          <a:ln w="12700">
+            <a:solidFill>
+              <a:srgbClr val="D9D9D9"/>
+            </a:solidFill>
           </a:ln>
           <a:effectLst/>
         </p:spPr>
@@ -17383,14 +17341,14 @@
       </p:sp>
       <p:sp>
         <p:nvSpPr>
-          <p:cNvPr id="8" name="TextBox 7"/>
+          <p:cNvPr id="5" name="TextBox 4"/>
           <p:cNvSpPr txBox="1"/>
           <p:nvPr/>
         </p:nvSpPr>
         <p:spPr>
           <a:xfrm>
-            <a:off x="685800" y="2111231"/>
-            <a:ext cx="6496050" cy="762000"/>
+            <a:off x="914400" y="2619085"/>
+            <a:ext cx="2997200" cy="167640"/>
           </a:xfrm>
           <a:prstGeom prst="rect">
             <a:avLst/>
@@ -17405,31 +17363,31 @@
           <a:p>
             <a:pPr algn="l">
               <a:lnSpc>
-                <a:spcPct val="135000"/>
+                <a:spcPct val="120000"/>
               </a:lnSpc>
             </a:pPr>
             <a:r>
-              <a:rPr sz="1350" b="1" i="0">
-                <a:solidFill>
-                  <a:srgbClr val="21049A"/>
+              <a:rPr sz="819" b="1" i="0" spc="140">
+                <a:solidFill>
+                  <a:srgbClr val="E94D1C"/>
                 </a:solidFill>
                 <a:latin typeface="Roboto"/>
               </a:rPr>
-              <a:t>Revisar os artefatos das Sprints 1 a 3 contra o código, ligando cada história ao caso de uso, à rota, à tela e ao teste</a:t>
-            </a:r>
-          </a:p>
-        </p:txBody>
-      </p:sp>
-      <p:sp>
-        <p:nvSpPr>
-          <p:cNvPr id="9" name="TextBox 8"/>
+              <a:t>INTEGRAÇÃO</a:t>
+            </a:r>
+          </a:p>
+        </p:txBody>
+      </p:sp>
+      <p:sp>
+        <p:nvSpPr>
+          <p:cNvPr id="6" name="TextBox 5"/>
           <p:cNvSpPr txBox="1"/>
           <p:nvPr/>
         </p:nvSpPr>
         <p:spPr>
           <a:xfrm>
-            <a:off x="7620000" y="2111231"/>
-            <a:ext cx="1733550" cy="762000"/>
+            <a:off x="914400" y="2847685"/>
+            <a:ext cx="2997200" cy="304800"/>
           </a:xfrm>
           <a:prstGeom prst="rect">
             <a:avLst/>
@@ -17444,31 +17402,31 @@
           <a:p>
             <a:pPr algn="l">
               <a:lnSpc>
-                <a:spcPct val="135000"/>
+                <a:spcPct val="120000"/>
               </a:lnSpc>
             </a:pPr>
             <a:r>
-              <a:rPr sz="1280" b="0" i="0">
-                <a:solidFill>
-                  <a:srgbClr val="1A1A1E"/>
+              <a:rPr sz="1500" b="1" i="0">
+                <a:solidFill>
+                  <a:srgbClr val="21049A"/>
                 </a:solidFill>
                 <a:latin typeface="Roboto"/>
               </a:rPr>
-              <a:t>a definir</a:t>
-            </a:r>
-          </a:p>
-        </p:txBody>
-      </p:sp>
-      <p:sp>
-        <p:nvSpPr>
-          <p:cNvPr id="10" name="TextBox 9"/>
+              <a:t>Trabalho feito em paralelo</a:t>
+            </a:r>
+          </a:p>
+        </p:txBody>
+      </p:sp>
+      <p:sp>
+        <p:nvSpPr>
+          <p:cNvPr id="7" name="TextBox 6"/>
           <p:cNvSpPr txBox="1"/>
           <p:nvPr/>
         </p:nvSpPr>
         <p:spPr>
           <a:xfrm>
-            <a:off x="9620250" y="2111231"/>
-            <a:ext cx="1714500" cy="762000"/>
+            <a:off x="914400" y="3228685"/>
+            <a:ext cx="2997200" cy="1181100"/>
           </a:xfrm>
           <a:prstGeom prst="rect">
             <a:avLst/>
@@ -17483,40 +17441,44 @@
           <a:p>
             <a:pPr algn="l">
               <a:lnSpc>
-                <a:spcPct val="135000"/>
+                <a:spcPct val="145000"/>
               </a:lnSpc>
             </a:pPr>
             <a:r>
-              <a:rPr sz="1280" b="0" i="0">
-                <a:solidFill>
-                  <a:srgbClr val="1A1A1E"/>
+              <a:rPr sz="1120" b="0" i="0">
+                <a:solidFill>
+                  <a:srgbClr val="3A3A44"/>
                 </a:solidFill>
                 <a:latin typeface="Roboto"/>
               </a:rPr>
-              <a:t>a definir</a:t>
-            </a:r>
-          </a:p>
-        </p:txBody>
-      </p:sp>
-      <p:sp>
-        <p:nvSpPr>
-          <p:cNvPr id="11" name="Rectangle 10"/>
+              <a:t>O front e o back foram escritos fora da main e precisaram ser adequados ao pacote de tipos e às camadas para entrar.</a:t>
+            </a:r>
+          </a:p>
+        </p:txBody>
+      </p:sp>
+      <p:sp>
+        <p:nvSpPr>
+          <p:cNvPr id="8" name="Rounded Rectangle 7"/>
           <p:cNvSpPr/>
           <p:nvPr/>
         </p:nvSpPr>
         <p:spPr>
           <a:xfrm>
-            <a:off x="685800" y="2710316"/>
-            <a:ext cx="10820400" cy="9525"/>
-          </a:xfrm>
-          <a:prstGeom prst="rect">
-            <a:avLst/>
+            <a:off x="4368800" y="2428585"/>
+            <a:ext cx="3454400" cy="2133600"/>
+          </a:xfrm>
+          <a:prstGeom prst="roundRect">
+            <a:avLst>
+              <a:gd name="adj" fmla="val 3571"/>
+            </a:avLst>
           </a:prstGeom>
           <a:solidFill>
-            <a:srgbClr val="EDEDF2"/>
+            <a:srgbClr val="F2F2F5"/>
           </a:solidFill>
-          <a:ln>
-            <a:noFill/>
+          <a:ln w="12700">
+            <a:solidFill>
+              <a:srgbClr val="D9D9D9"/>
+            </a:solidFill>
           </a:ln>
           <a:effectLst/>
         </p:spPr>
@@ -17544,14 +17506,14 @@
       </p:sp>
       <p:sp>
         <p:nvSpPr>
-          <p:cNvPr id="12" name="TextBox 11"/>
+          <p:cNvPr id="9" name="TextBox 8"/>
           <p:cNvSpPr txBox="1"/>
           <p:nvPr/>
         </p:nvSpPr>
         <p:spPr>
           <a:xfrm>
-            <a:off x="685800" y="2834141"/>
-            <a:ext cx="6496050" cy="762000"/>
+            <a:off x="4597400" y="2619085"/>
+            <a:ext cx="2997200" cy="167640"/>
           </a:xfrm>
           <a:prstGeom prst="rect">
             <a:avLst/>
@@ -17566,31 +17528,31 @@
           <a:p>
             <a:pPr algn="l">
               <a:lnSpc>
-                <a:spcPct val="135000"/>
+                <a:spcPct val="120000"/>
               </a:lnSpc>
             </a:pPr>
             <a:r>
-              <a:rPr sz="1350" b="1" i="0">
-                <a:solidFill>
-                  <a:srgbClr val="21049A"/>
+              <a:rPr sz="819" b="1" i="0" spc="140">
+                <a:solidFill>
+                  <a:srgbClr val="E94D1C"/>
                 </a:solidFill>
                 <a:latin typeface="Roboto"/>
               </a:rPr>
-              <a:t>Diagrama de sequência da lista de presença</a:t>
-            </a:r>
-          </a:p>
-        </p:txBody>
-      </p:sp>
-      <p:sp>
-        <p:nvSpPr>
-          <p:cNvPr id="13" name="TextBox 12"/>
+              <a:t>FRONT-END</a:t>
+            </a:r>
+          </a:p>
+        </p:txBody>
+      </p:sp>
+      <p:sp>
+        <p:nvSpPr>
+          <p:cNvPr id="10" name="TextBox 9"/>
           <p:cNvSpPr txBox="1"/>
           <p:nvPr/>
         </p:nvSpPr>
         <p:spPr>
           <a:xfrm>
-            <a:off x="7620000" y="2834141"/>
-            <a:ext cx="1733550" cy="762000"/>
+            <a:off x="4597400" y="2847685"/>
+            <a:ext cx="2997200" cy="304800"/>
           </a:xfrm>
           <a:prstGeom prst="rect">
             <a:avLst/>
@@ -17605,31 +17567,31 @@
           <a:p>
             <a:pPr algn="l">
               <a:lnSpc>
-                <a:spcPct val="135000"/>
+                <a:spcPct val="120000"/>
               </a:lnSpc>
             </a:pPr>
             <a:r>
-              <a:rPr sz="1280" b="0" i="0">
-                <a:solidFill>
-                  <a:srgbClr val="1A1A1E"/>
+              <a:rPr sz="1500" b="1" i="0">
+                <a:solidFill>
+                  <a:srgbClr val="21049A"/>
                 </a:solidFill>
                 <a:latin typeface="Roboto"/>
               </a:rPr>
-              <a:t>a definir</a:t>
-            </a:r>
-          </a:p>
-        </p:txBody>
-      </p:sp>
-      <p:sp>
-        <p:nvSpPr>
-          <p:cNvPr id="14" name="TextBox 13"/>
+              <a:t>Regras no protótipo</a:t>
+            </a:r>
+          </a:p>
+        </p:txBody>
+      </p:sp>
+      <p:sp>
+        <p:nvSpPr>
+          <p:cNvPr id="11" name="TextBox 10"/>
           <p:cNvSpPr txBox="1"/>
           <p:nvPr/>
         </p:nvSpPr>
         <p:spPr>
           <a:xfrm>
-            <a:off x="9620250" y="2834141"/>
-            <a:ext cx="1714500" cy="762000"/>
+            <a:off x="4597400" y="3228685"/>
+            <a:ext cx="2997200" cy="1181100"/>
           </a:xfrm>
           <a:prstGeom prst="rect">
             <a:avLst/>
@@ -17644,40 +17606,44 @@
           <a:p>
             <a:pPr algn="l">
               <a:lnSpc>
-                <a:spcPct val="135000"/>
+                <a:spcPct val="145000"/>
               </a:lnSpc>
             </a:pPr>
             <a:r>
-              <a:rPr sz="1280" b="0" i="0">
-                <a:solidFill>
-                  <a:srgbClr val="1A1A1E"/>
+              <a:rPr sz="1120" b="0" i="0">
+                <a:solidFill>
+                  <a:srgbClr val="3A3A44"/>
                 </a:solidFill>
                 <a:latin typeface="Roboto"/>
               </a:rPr>
-              <a:t>a definir</a:t>
-            </a:r>
-          </a:p>
-        </p:txBody>
-      </p:sp>
-      <p:sp>
-        <p:nvSpPr>
-          <p:cNvPr id="15" name="Rectangle 14"/>
+              <a:t>O protótipo nasceu antes da arquitetura estar no código. Contagem de vagas, CSV e token ficavam na tela.</a:t>
+            </a:r>
+          </a:p>
+        </p:txBody>
+      </p:sp>
+      <p:sp>
+        <p:nvSpPr>
+          <p:cNvPr id="12" name="Rounded Rectangle 11"/>
           <p:cNvSpPr/>
           <p:nvPr/>
         </p:nvSpPr>
         <p:spPr>
           <a:xfrm>
-            <a:off x="685800" y="3195596"/>
-            <a:ext cx="10820400" cy="9525"/>
-          </a:xfrm>
-          <a:prstGeom prst="rect">
-            <a:avLst/>
+            <a:off x="8051800" y="2428585"/>
+            <a:ext cx="3454400" cy="2133600"/>
+          </a:xfrm>
+          <a:prstGeom prst="roundRect">
+            <a:avLst>
+              <a:gd name="adj" fmla="val 3571"/>
+            </a:avLst>
           </a:prstGeom>
           <a:solidFill>
-            <a:srgbClr val="EDEDF2"/>
+            <a:srgbClr val="F2F2F5"/>
           </a:solidFill>
-          <a:ln>
-            <a:noFill/>
+          <a:ln w="12700">
+            <a:solidFill>
+              <a:srgbClr val="D9D9D9"/>
+            </a:solidFill>
           </a:ln>
           <a:effectLst/>
         </p:spPr>
@@ -17705,14 +17671,14 @@
       </p:sp>
       <p:sp>
         <p:nvSpPr>
-          <p:cNvPr id="16" name="TextBox 15"/>
+          <p:cNvPr id="13" name="TextBox 12"/>
           <p:cNvSpPr txBox="1"/>
           <p:nvPr/>
         </p:nvSpPr>
         <p:spPr>
           <a:xfrm>
-            <a:off x="685800" y="3319421"/>
-            <a:ext cx="6496050" cy="762000"/>
+            <a:off x="8280400" y="2619085"/>
+            <a:ext cx="2997200" cy="167640"/>
           </a:xfrm>
           <a:prstGeom prst="rect">
             <a:avLst/>
@@ -17727,31 +17693,31 @@
           <a:p>
             <a:pPr algn="l">
               <a:lnSpc>
-                <a:spcPct val="135000"/>
+                <a:spcPct val="120000"/>
               </a:lnSpc>
             </a:pPr>
             <a:r>
-              <a:rPr sz="1350" b="1" i="0">
-                <a:solidFill>
-                  <a:srgbClr val="21049A"/>
+              <a:rPr sz="819" b="1" i="0" spc="140">
+                <a:solidFill>
+                  <a:srgbClr val="E94D1C"/>
                 </a:solidFill>
                 <a:latin typeface="Roboto"/>
               </a:rPr>
-              <a:t>Protótipo de baixa fidelidade com as telas reais</a:t>
-            </a:r>
-          </a:p>
-        </p:txBody>
-      </p:sp>
-      <p:sp>
-        <p:nvSpPr>
-          <p:cNvPr id="17" name="TextBox 16"/>
+              <a:t>BACK-END</a:t>
+            </a:r>
+          </a:p>
+        </p:txBody>
+      </p:sp>
+      <p:sp>
+        <p:nvSpPr>
+          <p:cNvPr id="14" name="TextBox 13"/>
           <p:cNvSpPr txBox="1"/>
           <p:nvPr/>
         </p:nvSpPr>
         <p:spPr>
           <a:xfrm>
-            <a:off x="7620000" y="3319421"/>
-            <a:ext cx="1733550" cy="762000"/>
+            <a:off x="8280400" y="2847685"/>
+            <a:ext cx="2997200" cy="304800"/>
           </a:xfrm>
           <a:prstGeom prst="rect">
             <a:avLst/>
@@ -17766,31 +17732,31 @@
           <a:p>
             <a:pPr algn="l">
               <a:lnSpc>
-                <a:spcPct val="135000"/>
+                <a:spcPct val="120000"/>
               </a:lnSpc>
             </a:pPr>
             <a:r>
-              <a:rPr sz="1280" b="0" i="0">
-                <a:solidFill>
-                  <a:srgbClr val="1A1A1E"/>
+              <a:rPr sz="1500" b="1" i="0">
+                <a:solidFill>
+                  <a:srgbClr val="21049A"/>
                 </a:solidFill>
                 <a:latin typeface="Roboto"/>
               </a:rPr>
-              <a:t>a definir</a:t>
-            </a:r>
-          </a:p>
-        </p:txBody>
-      </p:sp>
-      <p:sp>
-        <p:nvSpPr>
-          <p:cNvPr id="18" name="TextBox 17"/>
+              <a:t>Regra na camada errada</a:t>
+            </a:r>
+          </a:p>
+        </p:txBody>
+      </p:sp>
+      <p:sp>
+        <p:nvSpPr>
+          <p:cNvPr id="15" name="TextBox 14"/>
           <p:cNvSpPr txBox="1"/>
           <p:nvPr/>
         </p:nvSpPr>
         <p:spPr>
           <a:xfrm>
-            <a:off x="9620250" y="3319421"/>
-            <a:ext cx="1714500" cy="762000"/>
+            <a:off x="8280400" y="3228685"/>
+            <a:ext cx="2997200" cy="1181100"/>
           </a:xfrm>
           <a:prstGeom prst="rect">
             <a:avLst/>
@@ -17805,551 +17771,24 @@
           <a:p>
             <a:pPr algn="l">
               <a:lnSpc>
-                <a:spcPct val="135000"/>
+                <a:spcPct val="145000"/>
               </a:lnSpc>
             </a:pPr>
             <a:r>
-              <a:rPr sz="1280" b="0" i="0">
-                <a:solidFill>
-                  <a:srgbClr val="1A1A1E"/>
+              <a:rPr sz="1120" b="0" i="0">
+                <a:solidFill>
+                  <a:srgbClr val="3A3A44"/>
                 </a:solidFill>
                 <a:latin typeface="Roboto"/>
               </a:rPr>
-              <a:t>a definir</a:t>
-            </a:r>
-          </a:p>
-        </p:txBody>
-      </p:sp>
-      <p:sp>
-        <p:nvSpPr>
-          <p:cNvPr id="19" name="Rectangle 18"/>
-          <p:cNvSpPr/>
-          <p:nvPr/>
-        </p:nvSpPr>
-        <p:spPr>
-          <a:xfrm>
-            <a:off x="685800" y="3680875"/>
-            <a:ext cx="10820400" cy="9525"/>
-          </a:xfrm>
-          <a:prstGeom prst="rect">
-            <a:avLst/>
-          </a:prstGeom>
-          <a:solidFill>
-            <a:srgbClr val="EDEDF2"/>
-          </a:solidFill>
-          <a:ln>
-            <a:noFill/>
-          </a:ln>
-          <a:effectLst/>
-        </p:spPr>
-        <p:style>
-          <a:lnRef idx="1">
-            <a:schemeClr val="accent1"/>
-          </a:lnRef>
-          <a:fillRef idx="3">
-            <a:schemeClr val="accent1"/>
-          </a:fillRef>
-          <a:effectRef idx="2">
-            <a:schemeClr val="accent1"/>
-          </a:effectRef>
-          <a:fontRef idx="minor">
-            <a:schemeClr val="lt1"/>
-          </a:fontRef>
-        </p:style>
-        <p:txBody>
-          <a:bodyPr rtlCol="0" anchor="ctr" wrap="square" lIns="0" rIns="0" tIns="0" bIns="0"/>
-          <a:lstStyle/>
-          <a:p>
-            <a:pPr algn="ctr"/>
-          </a:p>
-        </p:txBody>
-      </p:sp>
-      <p:sp>
-        <p:nvSpPr>
-          <p:cNvPr id="20" name="TextBox 19"/>
-          <p:cNvSpPr txBox="1"/>
-          <p:nvPr/>
-        </p:nvSpPr>
-        <p:spPr>
-          <a:xfrm>
-            <a:off x="685800" y="3804700"/>
-            <a:ext cx="6496050" cy="762000"/>
-          </a:xfrm>
-          <a:prstGeom prst="rect">
-            <a:avLst/>
-          </a:prstGeom>
-          <a:noFill/>
-        </p:spPr>
-        <p:txBody>
-          <a:bodyPr wrap="square" lIns="0" rIns="0" tIns="0" bIns="0" anchor="t">
-            <a:spAutoFit/>
-          </a:bodyPr>
-          <a:lstStyle/>
-          <a:p>
-            <a:pPr algn="l">
-              <a:lnSpc>
-                <a:spcPct val="135000"/>
-              </a:lnSpc>
-            </a:pPr>
-            <a:r>
-              <a:rPr sz="1350" b="1" i="0">
-                <a:solidFill>
-                  <a:srgbClr val="21049A"/>
-                </a:solidFill>
-                <a:latin typeface="Roboto"/>
-              </a:rPr>
-              <a:t>Aval do time às decisões novas da arquitetura</a:t>
-            </a:r>
-          </a:p>
-        </p:txBody>
-      </p:sp>
-      <p:sp>
-        <p:nvSpPr>
-          <p:cNvPr id="21" name="TextBox 20"/>
-          <p:cNvSpPr txBox="1"/>
-          <p:nvPr/>
-        </p:nvSpPr>
-        <p:spPr>
-          <a:xfrm>
-            <a:off x="7620000" y="3804700"/>
-            <a:ext cx="1733550" cy="762000"/>
-          </a:xfrm>
-          <a:prstGeom prst="rect">
-            <a:avLst/>
-          </a:prstGeom>
-          <a:noFill/>
-        </p:spPr>
-        <p:txBody>
-          <a:bodyPr wrap="square" lIns="0" rIns="0" tIns="0" bIns="0" anchor="t">
-            <a:spAutoFit/>
-          </a:bodyPr>
-          <a:lstStyle/>
-          <a:p>
-            <a:pPr algn="l">
-              <a:lnSpc>
-                <a:spcPct val="135000"/>
-              </a:lnSpc>
-            </a:pPr>
-            <a:r>
-              <a:rPr sz="1280" b="0" i="0">
-                <a:solidFill>
-                  <a:srgbClr val="1A1A1E"/>
-                </a:solidFill>
-                <a:latin typeface="Roboto"/>
-              </a:rPr>
-              <a:t>a definir</a:t>
-            </a:r>
-          </a:p>
-        </p:txBody>
-      </p:sp>
-      <p:sp>
-        <p:nvSpPr>
-          <p:cNvPr id="22" name="TextBox 21"/>
-          <p:cNvSpPr txBox="1"/>
-          <p:nvPr/>
-        </p:nvSpPr>
-        <p:spPr>
-          <a:xfrm>
-            <a:off x="9620250" y="3804700"/>
-            <a:ext cx="1714500" cy="762000"/>
-          </a:xfrm>
-          <a:prstGeom prst="rect">
-            <a:avLst/>
-          </a:prstGeom>
-          <a:noFill/>
-        </p:spPr>
-        <p:txBody>
-          <a:bodyPr wrap="square" lIns="0" rIns="0" tIns="0" bIns="0" anchor="t">
-            <a:spAutoFit/>
-          </a:bodyPr>
-          <a:lstStyle/>
-          <a:p>
-            <a:pPr algn="l">
-              <a:lnSpc>
-                <a:spcPct val="135000"/>
-              </a:lnSpc>
-            </a:pPr>
-            <a:r>
-              <a:rPr sz="1280" b="0" i="0">
-                <a:solidFill>
-                  <a:srgbClr val="1A1A1E"/>
-                </a:solidFill>
-                <a:latin typeface="Roboto"/>
-              </a:rPr>
-              <a:t>a definir</a:t>
-            </a:r>
-          </a:p>
-        </p:txBody>
-      </p:sp>
-      <p:sp>
-        <p:nvSpPr>
-          <p:cNvPr id="23" name="Rectangle 22"/>
-          <p:cNvSpPr/>
-          <p:nvPr/>
-        </p:nvSpPr>
-        <p:spPr>
-          <a:xfrm>
-            <a:off x="685800" y="4166155"/>
-            <a:ext cx="10820400" cy="9525"/>
-          </a:xfrm>
-          <a:prstGeom prst="rect">
-            <a:avLst/>
-          </a:prstGeom>
-          <a:solidFill>
-            <a:srgbClr val="EDEDF2"/>
-          </a:solidFill>
-          <a:ln>
-            <a:noFill/>
-          </a:ln>
-          <a:effectLst/>
-        </p:spPr>
-        <p:style>
-          <a:lnRef idx="1">
-            <a:schemeClr val="accent1"/>
-          </a:lnRef>
-          <a:fillRef idx="3">
-            <a:schemeClr val="accent1"/>
-          </a:fillRef>
-          <a:effectRef idx="2">
-            <a:schemeClr val="accent1"/>
-          </a:effectRef>
-          <a:fontRef idx="minor">
-            <a:schemeClr val="lt1"/>
-          </a:fontRef>
-        </p:style>
-        <p:txBody>
-          <a:bodyPr rtlCol="0" anchor="ctr" wrap="square" lIns="0" rIns="0" tIns="0" bIns="0"/>
-          <a:lstStyle/>
-          <a:p>
-            <a:pPr algn="ctr"/>
-          </a:p>
-        </p:txBody>
-      </p:sp>
-      <p:sp>
-        <p:nvSpPr>
-          <p:cNvPr id="24" name="TextBox 23"/>
-          <p:cNvSpPr txBox="1"/>
-          <p:nvPr/>
-        </p:nvSpPr>
-        <p:spPr>
-          <a:xfrm>
-            <a:off x="685800" y="4289980"/>
-            <a:ext cx="6496050" cy="762000"/>
-          </a:xfrm>
-          <a:prstGeom prst="rect">
-            <a:avLst/>
-          </a:prstGeom>
-          <a:noFill/>
-        </p:spPr>
-        <p:txBody>
-          <a:bodyPr wrap="square" lIns="0" rIns="0" tIns="0" bIns="0" anchor="t">
-            <a:spAutoFit/>
-          </a:bodyPr>
-          <a:lstStyle/>
-          <a:p>
-            <a:pPr algn="l">
-              <a:lnSpc>
-                <a:spcPct val="135000"/>
-              </a:lnSpc>
-            </a:pPr>
-            <a:r>
-              <a:rPr sz="1350" b="1" i="0">
-                <a:solidFill>
-                  <a:srgbClr val="21049A"/>
-                </a:solidFill>
-                <a:latin typeface="Roboto"/>
-              </a:rPr>
-              <a:t>Fechar o Team Charter</a:t>
-            </a:r>
-          </a:p>
-        </p:txBody>
-      </p:sp>
-      <p:sp>
-        <p:nvSpPr>
-          <p:cNvPr id="25" name="TextBox 24"/>
-          <p:cNvSpPr txBox="1"/>
-          <p:nvPr/>
-        </p:nvSpPr>
-        <p:spPr>
-          <a:xfrm>
-            <a:off x="7620000" y="4289980"/>
-            <a:ext cx="1733550" cy="762000"/>
-          </a:xfrm>
-          <a:prstGeom prst="rect">
-            <a:avLst/>
-          </a:prstGeom>
-          <a:noFill/>
-        </p:spPr>
-        <p:txBody>
-          <a:bodyPr wrap="square" lIns="0" rIns="0" tIns="0" bIns="0" anchor="t">
-            <a:spAutoFit/>
-          </a:bodyPr>
-          <a:lstStyle/>
-          <a:p>
-            <a:pPr algn="l">
-              <a:lnSpc>
-                <a:spcPct val="135000"/>
-              </a:lnSpc>
-            </a:pPr>
-            <a:r>
-              <a:rPr sz="1280" b="0" i="0">
-                <a:solidFill>
-                  <a:srgbClr val="1A1A1E"/>
-                </a:solidFill>
-                <a:latin typeface="Roboto"/>
-              </a:rPr>
-              <a:t>a definir</a:t>
-            </a:r>
-          </a:p>
-        </p:txBody>
-      </p:sp>
-      <p:sp>
-        <p:nvSpPr>
-          <p:cNvPr id="26" name="TextBox 25"/>
-          <p:cNvSpPr txBox="1"/>
-          <p:nvPr/>
-        </p:nvSpPr>
-        <p:spPr>
-          <a:xfrm>
-            <a:off x="9620250" y="4289980"/>
-            <a:ext cx="1714500" cy="762000"/>
-          </a:xfrm>
-          <a:prstGeom prst="rect">
-            <a:avLst/>
-          </a:prstGeom>
-          <a:noFill/>
-        </p:spPr>
-        <p:txBody>
-          <a:bodyPr wrap="square" lIns="0" rIns="0" tIns="0" bIns="0" anchor="t">
-            <a:spAutoFit/>
-          </a:bodyPr>
-          <a:lstStyle/>
-          <a:p>
-            <a:pPr algn="l">
-              <a:lnSpc>
-                <a:spcPct val="135000"/>
-              </a:lnSpc>
-            </a:pPr>
-            <a:r>
-              <a:rPr sz="1280" b="0" i="0">
-                <a:solidFill>
-                  <a:srgbClr val="1A1A1E"/>
-                </a:solidFill>
-                <a:latin typeface="Roboto"/>
-              </a:rPr>
-              <a:t>a definir</a:t>
-            </a:r>
-          </a:p>
-        </p:txBody>
-      </p:sp>
-      <p:sp>
-        <p:nvSpPr>
-          <p:cNvPr id="27" name="Rectangle 26"/>
-          <p:cNvSpPr/>
-          <p:nvPr/>
-        </p:nvSpPr>
-        <p:spPr>
-          <a:xfrm>
-            <a:off x="685800" y="4651435"/>
-            <a:ext cx="10820400" cy="9525"/>
-          </a:xfrm>
-          <a:prstGeom prst="rect">
-            <a:avLst/>
-          </a:prstGeom>
-          <a:solidFill>
-            <a:srgbClr val="EDEDF2"/>
-          </a:solidFill>
-          <a:ln>
-            <a:noFill/>
-          </a:ln>
-          <a:effectLst/>
-        </p:spPr>
-        <p:style>
-          <a:lnRef idx="1">
-            <a:schemeClr val="accent1"/>
-          </a:lnRef>
-          <a:fillRef idx="3">
-            <a:schemeClr val="accent1"/>
-          </a:fillRef>
-          <a:effectRef idx="2">
-            <a:schemeClr val="accent1"/>
-          </a:effectRef>
-          <a:fontRef idx="minor">
-            <a:schemeClr val="lt1"/>
-          </a:fontRef>
-        </p:style>
-        <p:txBody>
-          <a:bodyPr rtlCol="0" anchor="ctr" wrap="square" lIns="0" rIns="0" tIns="0" bIns="0"/>
-          <a:lstStyle/>
-          <a:p>
-            <a:pPr algn="ctr"/>
-          </a:p>
-        </p:txBody>
-      </p:sp>
-      <p:sp>
-        <p:nvSpPr>
-          <p:cNvPr id="28" name="TextBox 27"/>
-          <p:cNvSpPr txBox="1"/>
-          <p:nvPr/>
-        </p:nvSpPr>
-        <p:spPr>
-          <a:xfrm>
-            <a:off x="685800" y="4775260"/>
-            <a:ext cx="6496050" cy="762000"/>
-          </a:xfrm>
-          <a:prstGeom prst="rect">
-            <a:avLst/>
-          </a:prstGeom>
-          <a:noFill/>
-        </p:spPr>
-        <p:txBody>
-          <a:bodyPr wrap="square" lIns="0" rIns="0" tIns="0" bIns="0" anchor="t">
-            <a:spAutoFit/>
-          </a:bodyPr>
-          <a:lstStyle/>
-          <a:p>
-            <a:pPr algn="l">
-              <a:lnSpc>
-                <a:spcPct val="135000"/>
-              </a:lnSpc>
-            </a:pPr>
-            <a:r>
-              <a:rPr sz="1350" b="1" i="0">
-                <a:solidFill>
-                  <a:srgbClr val="21049A"/>
-                </a:solidFill>
-                <a:latin typeface="Roboto"/>
-              </a:rPr>
-              <a:t>Deck e ensaio do Pitch Final</a:t>
-            </a:r>
-          </a:p>
-        </p:txBody>
-      </p:sp>
-      <p:sp>
-        <p:nvSpPr>
-          <p:cNvPr id="29" name="TextBox 28"/>
-          <p:cNvSpPr txBox="1"/>
-          <p:nvPr/>
-        </p:nvSpPr>
-        <p:spPr>
-          <a:xfrm>
-            <a:off x="7620000" y="4775260"/>
-            <a:ext cx="1733550" cy="762000"/>
-          </a:xfrm>
-          <a:prstGeom prst="rect">
-            <a:avLst/>
-          </a:prstGeom>
-          <a:noFill/>
-        </p:spPr>
-        <p:txBody>
-          <a:bodyPr wrap="square" lIns="0" rIns="0" tIns="0" bIns="0" anchor="t">
-            <a:spAutoFit/>
-          </a:bodyPr>
-          <a:lstStyle/>
-          <a:p>
-            <a:pPr algn="l">
-              <a:lnSpc>
-                <a:spcPct val="135000"/>
-              </a:lnSpc>
-            </a:pPr>
-            <a:r>
-              <a:rPr sz="1280" b="0" i="0">
-                <a:solidFill>
-                  <a:srgbClr val="1A1A1E"/>
-                </a:solidFill>
-                <a:latin typeface="Roboto"/>
-              </a:rPr>
-              <a:t>a definir</a:t>
-            </a:r>
-          </a:p>
-        </p:txBody>
-      </p:sp>
-      <p:sp>
-        <p:nvSpPr>
-          <p:cNvPr id="30" name="TextBox 29"/>
-          <p:cNvSpPr txBox="1"/>
-          <p:nvPr/>
-        </p:nvSpPr>
-        <p:spPr>
-          <a:xfrm>
-            <a:off x="9620250" y="4775260"/>
-            <a:ext cx="1714500" cy="762000"/>
-          </a:xfrm>
-          <a:prstGeom prst="rect">
-            <a:avLst/>
-          </a:prstGeom>
-          <a:noFill/>
-        </p:spPr>
-        <p:txBody>
-          <a:bodyPr wrap="square" lIns="0" rIns="0" tIns="0" bIns="0" anchor="t">
-            <a:spAutoFit/>
-          </a:bodyPr>
-          <a:lstStyle/>
-          <a:p>
-            <a:pPr algn="l">
-              <a:lnSpc>
-                <a:spcPct val="135000"/>
-              </a:lnSpc>
-            </a:pPr>
-            <a:r>
-              <a:rPr sz="1280" b="0" i="0">
-                <a:solidFill>
-                  <a:srgbClr val="1A1A1E"/>
-                </a:solidFill>
-                <a:latin typeface="Roboto"/>
-              </a:rPr>
-              <a:t>a definir</a:t>
-            </a:r>
-          </a:p>
-        </p:txBody>
-      </p:sp>
-      <p:sp>
-        <p:nvSpPr>
-          <p:cNvPr id="31" name="Rectangle 30"/>
-          <p:cNvSpPr/>
-          <p:nvPr/>
-        </p:nvSpPr>
-        <p:spPr>
-          <a:xfrm>
-            <a:off x="685800" y="5136714"/>
-            <a:ext cx="10820400" cy="9525"/>
-          </a:xfrm>
-          <a:prstGeom prst="rect">
-            <a:avLst/>
-          </a:prstGeom>
-          <a:solidFill>
-            <a:srgbClr val="EDEDF2"/>
-          </a:solidFill>
-          <a:ln>
-            <a:noFill/>
-          </a:ln>
-          <a:effectLst/>
-        </p:spPr>
-        <p:style>
-          <a:lnRef idx="1">
-            <a:schemeClr val="accent1"/>
-          </a:lnRef>
-          <a:fillRef idx="3">
-            <a:schemeClr val="accent1"/>
-          </a:fillRef>
-          <a:effectRef idx="2">
-            <a:schemeClr val="accent1"/>
-          </a:effectRef>
-          <a:fontRef idx="minor">
-            <a:schemeClr val="lt1"/>
-          </a:fontRef>
-        </p:style>
-        <p:txBody>
-          <a:bodyPr rtlCol="0" anchor="ctr" wrap="square" lIns="0" rIns="0" tIns="0" bIns="0"/>
-          <a:lstStyle/>
-          <a:p>
-            <a:pPr algn="ctr"/>
-          </a:p>
-        </p:txBody>
-      </p:sp>
-      <p:sp>
-        <p:nvSpPr>
-          <p:cNvPr id="32" name="Rectangle 31"/>
+              <a:t>A regra das vagas estava na consulta da camada de Dados. O cálculo passou para o Domínio.</a:t>
+            </a:r>
+          </a:p>
+        </p:txBody>
+      </p:sp>
+      <p:sp>
+        <p:nvSpPr>
+          <p:cNvPr id="16" name="Rectangle 15"/>
           <p:cNvSpPr/>
           <p:nvPr/>
         </p:nvSpPr>
@@ -18393,7 +17832,7 @@
       </p:sp>
       <p:sp>
         <p:nvSpPr>
-          <p:cNvPr id="33" name="TextBox 32"/>
+          <p:cNvPr id="17" name="TextBox 16"/>
           <p:cNvSpPr txBox="1"/>
           <p:nvPr/>
         </p:nvSpPr>
@@ -18432,7 +17871,7 @@
       </p:sp>
       <p:sp>
         <p:nvSpPr>
-          <p:cNvPr id="34" name="TextBox 33"/>
+          <p:cNvPr id="18" name="TextBox 17"/>
           <p:cNvSpPr txBox="1"/>
           <p:nvPr/>
         </p:nvSpPr>
@@ -18464,14 +17903,14 @@
                 </a:solidFill>
                 <a:latin typeface="Roboto"/>
               </a:rPr>
-              <a:t>Planejamento, Andreas</a:t>
-            </a:r>
-          </a:p>
-        </p:txBody>
-      </p:sp>
-      <p:sp>
-        <p:nvSpPr>
-          <p:cNvPr id="35" name="TextBox 34"/>
+              <a:t>Dificuldades, Andreas</a:t>
+            </a:r>
+          </a:p>
+        </p:txBody>
+      </p:sp>
+      <p:sp>
+        <p:nvSpPr>
+          <p:cNvPr id="19" name="TextBox 18"/>
           <p:cNvSpPr txBox="1"/>
           <p:nvPr/>
         </p:nvSpPr>
@@ -18517,359 +17956,6 @@
 </file>
 
 <file path=ppt/slides/slide15.xml><?xml version="1.0" encoding="utf-8"?>
-<p:sld xmlns:a="http://schemas.openxmlformats.org/drawingml/2006/main" xmlns:p="http://schemas.openxmlformats.org/presentationml/2006/main" xmlns:r="http://schemas.openxmlformats.org/officeDocument/2006/relationships">
-  <p:cSld>
-    <p:spTree>
-      <p:nvGrpSpPr>
-        <p:cNvPr id="1" name=""/>
-        <p:cNvGrpSpPr/>
-        <p:nvPr/>
-      </p:nvGrpSpPr>
-      <p:grpSpPr/>
-      <p:pic>
-        <p:nvPicPr>
-          <p:cNvPr id="2" name="Picture 1" descr="fundo-secao.jpg"/>
-          <p:cNvPicPr>
-            <a:picLocks noChangeAspect="1"/>
-          </p:cNvPicPr>
-          <p:nvPr/>
-        </p:nvPicPr>
-        <p:blipFill>
-          <a:blip r:embed="rId2"/>
-          <a:stretch>
-            <a:fillRect/>
-          </a:stretch>
-        </p:blipFill>
-        <p:spPr>
-          <a:xfrm>
-            <a:off x="0" y="0"/>
-            <a:ext cx="12192000" cy="6858000"/>
-          </a:xfrm>
-          <a:prstGeom prst="rect">
-            <a:avLst/>
-          </a:prstGeom>
-        </p:spPr>
-      </p:pic>
-      <p:pic>
-        <p:nvPicPr>
-          <p:cNvPr id="3" name="Picture 2" descr="u-branco.png"/>
-          <p:cNvPicPr>
-            <a:picLocks noChangeAspect="1"/>
-          </p:cNvPicPr>
-          <p:nvPr/>
-        </p:nvPicPr>
-        <p:blipFill>
-          <a:blip r:embed="rId3"/>
-          <a:stretch>
-            <a:fillRect/>
-          </a:stretch>
-        </p:blipFill>
-        <p:spPr>
-          <a:xfrm>
-            <a:off x="10744200" y="457200"/>
-            <a:ext cx="342900" cy="342900"/>
-          </a:xfrm>
-          <a:prstGeom prst="rect">
-            <a:avLst/>
-          </a:prstGeom>
-        </p:spPr>
-      </p:pic>
-      <p:sp>
-        <p:nvSpPr>
-          <p:cNvPr id="4" name="Rectangle 3"/>
-          <p:cNvSpPr/>
-          <p:nvPr/>
-        </p:nvSpPr>
-        <p:spPr>
-          <a:xfrm>
-            <a:off x="914400" y="1638300"/>
-            <a:ext cx="38100" cy="171450"/>
-          </a:xfrm>
-          <a:prstGeom prst="rect">
-            <a:avLst/>
-          </a:prstGeom>
-          <a:solidFill>
-            <a:srgbClr val="E94D1C"/>
-          </a:solidFill>
-          <a:ln>
-            <a:noFill/>
-          </a:ln>
-          <a:effectLst/>
-        </p:spPr>
-        <p:style>
-          <a:lnRef idx="1">
-            <a:schemeClr val="accent1"/>
-          </a:lnRef>
-          <a:fillRef idx="3">
-            <a:schemeClr val="accent1"/>
-          </a:fillRef>
-          <a:effectRef idx="2">
-            <a:schemeClr val="accent1"/>
-          </a:effectRef>
-          <a:fontRef idx="minor">
-            <a:schemeClr val="lt1"/>
-          </a:fontRef>
-        </p:style>
-        <p:txBody>
-          <a:bodyPr rtlCol="0" anchor="ctr" wrap="square" lIns="0" rIns="0" tIns="0" bIns="0"/>
-          <a:lstStyle/>
-          <a:p>
-            <a:pPr algn="ctr"/>
-          </a:p>
-        </p:txBody>
-      </p:sp>
-      <p:sp>
-        <p:nvSpPr>
-          <p:cNvPr id="5" name="TextBox 4"/>
-          <p:cNvSpPr txBox="1"/>
-          <p:nvPr/>
-        </p:nvSpPr>
-        <p:spPr>
-          <a:xfrm>
-            <a:off x="1066800" y="1600200"/>
-            <a:ext cx="8572500" cy="228600"/>
-          </a:xfrm>
-          <a:prstGeom prst="rect">
-            <a:avLst/>
-          </a:prstGeom>
-          <a:noFill/>
-        </p:spPr>
-        <p:txBody>
-          <a:bodyPr wrap="square" lIns="0" rIns="0" tIns="0" bIns="0" anchor="t">
-            <a:spAutoFit/>
-          </a:bodyPr>
-          <a:lstStyle/>
-          <a:p>
-            <a:pPr algn="l">
-              <a:lnSpc>
-                <a:spcPct val="120000"/>
-              </a:lnSpc>
-            </a:pPr>
-            <a:r>
-              <a:rPr sz="1120" b="1" i="0" spc="160">
-                <a:solidFill>
-                  <a:srgbClr val="FFFFFF"/>
-                </a:solidFill>
-                <a:latin typeface="Roboto"/>
-              </a:rPr>
-              <a:t>TIME 04</a:t>
-            </a:r>
-          </a:p>
-        </p:txBody>
-      </p:sp>
-      <p:sp>
-        <p:nvSpPr>
-          <p:cNvPr id="6" name="TextBox 5"/>
-          <p:cNvSpPr txBox="1"/>
-          <p:nvPr/>
-        </p:nvSpPr>
-        <p:spPr>
-          <a:xfrm>
-            <a:off x="914400" y="1866900"/>
-            <a:ext cx="9715500" cy="1905000"/>
-          </a:xfrm>
-          <a:prstGeom prst="rect">
-            <a:avLst/>
-          </a:prstGeom>
-          <a:noFill/>
-        </p:spPr>
-        <p:txBody>
-          <a:bodyPr wrap="square" lIns="0" rIns="0" tIns="0" bIns="0" anchor="t">
-            <a:spAutoFit/>
-          </a:bodyPr>
-          <a:lstStyle/>
-          <a:p>
-            <a:pPr algn="l">
-              <a:lnSpc>
-                <a:spcPct val="106000"/>
-              </a:lnSpc>
-            </a:pPr>
-            <a:r>
-              <a:rPr sz="3900" b="1" i="0">
-                <a:solidFill>
-                  <a:srgbClr val="FFFFFF"/>
-                </a:solidFill>
-                <a:latin typeface="Roboto"/>
-              </a:rPr>
-              <a:t>Perguntas</a:t>
-            </a:r>
-          </a:p>
-        </p:txBody>
-      </p:sp>
-      <p:sp>
-        <p:nvSpPr>
-          <p:cNvPr id="7" name="TextBox 6"/>
-          <p:cNvSpPr txBox="1"/>
-          <p:nvPr/>
-        </p:nvSpPr>
-        <p:spPr>
-          <a:xfrm>
-            <a:off x="914400" y="4095750"/>
-            <a:ext cx="8572500" cy="1524000"/>
-          </a:xfrm>
-          <a:prstGeom prst="rect">
-            <a:avLst/>
-          </a:prstGeom>
-          <a:noFill/>
-        </p:spPr>
-        <p:txBody>
-          <a:bodyPr wrap="square" lIns="0" rIns="0" tIns="0" bIns="0" anchor="t">
-            <a:spAutoFit/>
-          </a:bodyPr>
-          <a:lstStyle/>
-          <a:p>
-            <a:pPr algn="l">
-              <a:lnSpc>
-                <a:spcPct val="150000"/>
-              </a:lnSpc>
-            </a:pPr>
-            <a:r>
-              <a:rPr sz="1420" b="0" i="0">
-                <a:solidFill>
-                  <a:srgbClr val="E2DEF5"/>
-                </a:solidFill>
-                <a:latin typeface="Roboto"/>
-              </a:rPr>
-              <a:t>Andreas Grings: problema, requisitos e planejamento</a:t>
-            </a:r>
-          </a:p>
-          <a:p>
-            <a:pPr>
-              <a:lnSpc>
-                <a:spcPct val="150000"/>
-              </a:lnSpc>
-            </a:pPr>
-            <a:r>
-              <a:rPr sz="1420" b="0" i="0">
-                <a:solidFill>
-                  <a:srgbClr val="E2DEF5"/>
-                </a:solidFill>
-                <a:latin typeface="Roboto"/>
-              </a:rPr>
-              <a:t>Tiago Passos: arquitetura, Docker e GitHub</a:t>
-            </a:r>
-          </a:p>
-          <a:p>
-            <a:pPr>
-              <a:lnSpc>
-                <a:spcPct val="150000"/>
-              </a:lnSpc>
-            </a:pPr>
-            <a:r>
-              <a:rPr sz="1420" b="0" i="0">
-                <a:solidFill>
-                  <a:srgbClr val="E2DEF5"/>
-                </a:solidFill>
-                <a:latin typeface="Roboto"/>
-              </a:rPr>
-              <a:t>Guilherme Toebe: front-end e Azure Boards</a:t>
-            </a:r>
-          </a:p>
-          <a:p>
-            <a:pPr>
-              <a:lnSpc>
-                <a:spcPct val="150000"/>
-              </a:lnSpc>
-            </a:pPr>
-            <a:r>
-              <a:rPr sz="1420" b="0" i="0">
-                <a:solidFill>
-                  <a:srgbClr val="E2DEF5"/>
-                </a:solidFill>
-                <a:latin typeface="Roboto"/>
-              </a:rPr>
-              <a:t>Gabriel Tomasi: back-end, regras e testes</a:t>
-            </a:r>
-          </a:p>
-        </p:txBody>
-      </p:sp>
-      <p:sp>
-        <p:nvSpPr>
-          <p:cNvPr id="8" name="TextBox 7"/>
-          <p:cNvSpPr txBox="1"/>
-          <p:nvPr/>
-        </p:nvSpPr>
-        <p:spPr>
-          <a:xfrm>
-            <a:off x="685800" y="6324600"/>
-            <a:ext cx="6667500" cy="182880"/>
-          </a:xfrm>
-          <a:prstGeom prst="rect">
-            <a:avLst/>
-          </a:prstGeom>
-          <a:noFill/>
-        </p:spPr>
-        <p:txBody>
-          <a:bodyPr wrap="square" lIns="0" rIns="0" tIns="0" bIns="0" anchor="t">
-            <a:spAutoFit/>
-          </a:bodyPr>
-          <a:lstStyle/>
-          <a:p>
-            <a:pPr algn="l">
-              <a:lnSpc>
-                <a:spcPct val="120000"/>
-              </a:lnSpc>
-            </a:pPr>
-            <a:r>
-              <a:rPr sz="900" b="0" i="0">
-                <a:solidFill>
-                  <a:srgbClr val="FFFFFF"/>
-                </a:solidFill>
-                <a:latin typeface="Roboto"/>
-              </a:rPr>
-              <a:t>Perguntas</a:t>
-            </a:r>
-          </a:p>
-        </p:txBody>
-      </p:sp>
-      <p:sp>
-        <p:nvSpPr>
-          <p:cNvPr id="9" name="TextBox 8"/>
-          <p:cNvSpPr txBox="1"/>
-          <p:nvPr/>
-        </p:nvSpPr>
-        <p:spPr>
-          <a:xfrm>
-            <a:off x="10477500" y="6324600"/>
-            <a:ext cx="1028700" cy="182880"/>
-          </a:xfrm>
-          <a:prstGeom prst="rect">
-            <a:avLst/>
-          </a:prstGeom>
-          <a:noFill/>
-        </p:spPr>
-        <p:txBody>
-          <a:bodyPr wrap="square" lIns="0" rIns="0" tIns="0" bIns="0" anchor="t">
-            <a:spAutoFit/>
-          </a:bodyPr>
-          <a:lstStyle/>
-          <a:p>
-            <a:pPr algn="r">
-              <a:lnSpc>
-                <a:spcPct val="120000"/>
-              </a:lnSpc>
-            </a:pPr>
-            <a:r>
-              <a:rPr sz="900" b="1" i="0">
-                <a:solidFill>
-                  <a:srgbClr val="FFFFFF"/>
-                </a:solidFill>
-                <a:latin typeface="Roboto"/>
-              </a:rPr>
-              <a:t>15</a:t>
-            </a:r>
-          </a:p>
-        </p:txBody>
-      </p:sp>
-    </p:spTree>
-  </p:cSld>
-  <p:clrMapOvr>
-    <a:masterClrMapping/>
-  </p:clrMapOvr>
-</p:sld>
-</file>
-
-<file path=ppt/slides/slide16.xml><?xml version="1.0" encoding="utf-8"?>
 <p:sld xmlns:a="http://schemas.openxmlformats.org/drawingml/2006/main" xmlns:p="http://schemas.openxmlformats.org/presentationml/2006/main" xmlns:r="http://schemas.openxmlformats.org/officeDocument/2006/relationships">
   <p:cSld>
     <p:bg>
@@ -18945,14 +18031,1261 @@
                 </a:solidFill>
                 <a:latin typeface="Roboto"/>
               </a:rPr>
-              <a:t>Telas do anfitrião</a:t>
-            </a:r>
-          </a:p>
-        </p:txBody>
-      </p:sp>
+              <a:t>Planejamento até 17/11</a:t>
+            </a:r>
+          </a:p>
+        </p:txBody>
+      </p:sp>
+      <p:sp>
+        <p:nvSpPr>
+          <p:cNvPr id="4" name="TextBox 3"/>
+          <p:cNvSpPr txBox="1"/>
+          <p:nvPr/>
+        </p:nvSpPr>
+        <p:spPr>
+          <a:xfrm>
+            <a:off x="685800" y="2025796"/>
+            <a:ext cx="6667500" cy="167640"/>
+          </a:xfrm>
+          <a:prstGeom prst="rect">
+            <a:avLst/>
+          </a:prstGeom>
+          <a:noFill/>
+        </p:spPr>
+        <p:txBody>
+          <a:bodyPr wrap="square" lIns="0" rIns="0" tIns="0" bIns="0" anchor="t">
+            <a:spAutoFit/>
+          </a:bodyPr>
+          <a:lstStyle/>
+          <a:p>
+            <a:pPr algn="l">
+              <a:lnSpc>
+                <a:spcPct val="120000"/>
+              </a:lnSpc>
+            </a:pPr>
+            <a:r>
+              <a:rPr sz="819" b="1" i="0" spc="120">
+                <a:solidFill>
+                  <a:srgbClr val="21049A"/>
+                </a:solidFill>
+                <a:latin typeface="Roboto"/>
+              </a:rPr>
+              <a:t>O QUÊ</a:t>
+            </a:r>
+          </a:p>
+        </p:txBody>
+      </p:sp>
+      <p:sp>
+        <p:nvSpPr>
+          <p:cNvPr id="5" name="TextBox 4"/>
+          <p:cNvSpPr txBox="1"/>
+          <p:nvPr/>
+        </p:nvSpPr>
+        <p:spPr>
+          <a:xfrm>
+            <a:off x="7620000" y="2025796"/>
+            <a:ext cx="1905000" cy="167640"/>
+          </a:xfrm>
+          <a:prstGeom prst="rect">
+            <a:avLst/>
+          </a:prstGeom>
+          <a:noFill/>
+        </p:spPr>
+        <p:txBody>
+          <a:bodyPr wrap="square" lIns="0" rIns="0" tIns="0" bIns="0" anchor="t">
+            <a:spAutoFit/>
+          </a:bodyPr>
+          <a:lstStyle/>
+          <a:p>
+            <a:pPr algn="l">
+              <a:lnSpc>
+                <a:spcPct val="120000"/>
+              </a:lnSpc>
+            </a:pPr>
+            <a:r>
+              <a:rPr sz="819" b="1" i="0" spc="120">
+                <a:solidFill>
+                  <a:srgbClr val="21049A"/>
+                </a:solidFill>
+                <a:latin typeface="Roboto"/>
+              </a:rPr>
+              <a:t>QUEM</a:t>
+            </a:r>
+          </a:p>
+        </p:txBody>
+      </p:sp>
+      <p:sp>
+        <p:nvSpPr>
+          <p:cNvPr id="6" name="TextBox 5"/>
+          <p:cNvSpPr txBox="1"/>
+          <p:nvPr/>
+        </p:nvSpPr>
+        <p:spPr>
+          <a:xfrm>
+            <a:off x="9620250" y="2025796"/>
+            <a:ext cx="1885950" cy="167640"/>
+          </a:xfrm>
+          <a:prstGeom prst="rect">
+            <a:avLst/>
+          </a:prstGeom>
+          <a:noFill/>
+        </p:spPr>
+        <p:txBody>
+          <a:bodyPr wrap="square" lIns="0" rIns="0" tIns="0" bIns="0" anchor="t">
+            <a:spAutoFit/>
+          </a:bodyPr>
+          <a:lstStyle/>
+          <a:p>
+            <a:pPr algn="l">
+              <a:lnSpc>
+                <a:spcPct val="120000"/>
+              </a:lnSpc>
+            </a:pPr>
+            <a:r>
+              <a:rPr sz="819" b="1" i="0" spc="120">
+                <a:solidFill>
+                  <a:srgbClr val="21049A"/>
+                </a:solidFill>
+                <a:latin typeface="Roboto"/>
+              </a:rPr>
+              <a:t>ATÉ</a:t>
+            </a:r>
+          </a:p>
+        </p:txBody>
+      </p:sp>
+      <p:sp>
+        <p:nvSpPr>
+          <p:cNvPr id="7" name="Rectangle 6"/>
+          <p:cNvSpPr/>
+          <p:nvPr/>
+        </p:nvSpPr>
+        <p:spPr>
+          <a:xfrm>
+            <a:off x="685800" y="2254396"/>
+            <a:ext cx="10820400" cy="19050"/>
+          </a:xfrm>
+          <a:prstGeom prst="rect">
+            <a:avLst/>
+          </a:prstGeom>
+          <a:solidFill>
+            <a:srgbClr val="21049A"/>
+          </a:solidFill>
+          <a:ln>
+            <a:noFill/>
+          </a:ln>
+          <a:effectLst/>
+        </p:spPr>
+        <p:style>
+          <a:lnRef idx="1">
+            <a:schemeClr val="accent1"/>
+          </a:lnRef>
+          <a:fillRef idx="3">
+            <a:schemeClr val="accent1"/>
+          </a:fillRef>
+          <a:effectRef idx="2">
+            <a:schemeClr val="accent1"/>
+          </a:effectRef>
+          <a:fontRef idx="minor">
+            <a:schemeClr val="lt1"/>
+          </a:fontRef>
+        </p:style>
+        <p:txBody>
+          <a:bodyPr rtlCol="0" anchor="ctr" wrap="square" lIns="0" rIns="0" tIns="0" bIns="0"/>
+          <a:lstStyle/>
+          <a:p>
+            <a:pPr algn="ctr"/>
+          </a:p>
+        </p:txBody>
+      </p:sp>
+      <p:sp>
+        <p:nvSpPr>
+          <p:cNvPr id="8" name="TextBox 7"/>
+          <p:cNvSpPr txBox="1"/>
+          <p:nvPr/>
+        </p:nvSpPr>
+        <p:spPr>
+          <a:xfrm>
+            <a:off x="685800" y="2406796"/>
+            <a:ext cx="6496050" cy="762000"/>
+          </a:xfrm>
+          <a:prstGeom prst="rect">
+            <a:avLst/>
+          </a:prstGeom>
+          <a:noFill/>
+        </p:spPr>
+        <p:txBody>
+          <a:bodyPr wrap="square" lIns="0" rIns="0" tIns="0" bIns="0" anchor="t">
+            <a:spAutoFit/>
+          </a:bodyPr>
+          <a:lstStyle/>
+          <a:p>
+            <a:pPr algn="l">
+              <a:lnSpc>
+                <a:spcPct val="135000"/>
+              </a:lnSpc>
+            </a:pPr>
+            <a:r>
+              <a:rPr sz="1350" b="1" i="0">
+                <a:solidFill>
+                  <a:srgbClr val="21049A"/>
+                </a:solidFill>
+                <a:latin typeface="Roboto"/>
+              </a:rPr>
+              <a:t>Revisar os artefatos das Sprints 1 a 3 contra o código, ligando cada história ao caso de uso, à rota, à tela e ao teste</a:t>
+            </a:r>
+          </a:p>
+        </p:txBody>
+      </p:sp>
+      <p:sp>
+        <p:nvSpPr>
+          <p:cNvPr id="9" name="TextBox 8"/>
+          <p:cNvSpPr txBox="1"/>
+          <p:nvPr/>
+        </p:nvSpPr>
+        <p:spPr>
+          <a:xfrm>
+            <a:off x="7620000" y="2406796"/>
+            <a:ext cx="1733550" cy="762000"/>
+          </a:xfrm>
+          <a:prstGeom prst="rect">
+            <a:avLst/>
+          </a:prstGeom>
+          <a:noFill/>
+        </p:spPr>
+        <p:txBody>
+          <a:bodyPr wrap="square" lIns="0" rIns="0" tIns="0" bIns="0" anchor="t">
+            <a:spAutoFit/>
+          </a:bodyPr>
+          <a:lstStyle/>
+          <a:p>
+            <a:pPr algn="l">
+              <a:lnSpc>
+                <a:spcPct val="135000"/>
+              </a:lnSpc>
+            </a:pPr>
+            <a:r>
+              <a:rPr sz="1280" b="0" i="0">
+                <a:solidFill>
+                  <a:srgbClr val="1A1A1E"/>
+                </a:solidFill>
+                <a:latin typeface="Roboto"/>
+              </a:rPr>
+              <a:t>a definir</a:t>
+            </a:r>
+          </a:p>
+        </p:txBody>
+      </p:sp>
+      <p:sp>
+        <p:nvSpPr>
+          <p:cNvPr id="10" name="TextBox 9"/>
+          <p:cNvSpPr txBox="1"/>
+          <p:nvPr/>
+        </p:nvSpPr>
+        <p:spPr>
+          <a:xfrm>
+            <a:off x="9620250" y="2406796"/>
+            <a:ext cx="1714500" cy="762000"/>
+          </a:xfrm>
+          <a:prstGeom prst="rect">
+            <a:avLst/>
+          </a:prstGeom>
+          <a:noFill/>
+        </p:spPr>
+        <p:txBody>
+          <a:bodyPr wrap="square" lIns="0" rIns="0" tIns="0" bIns="0" anchor="t">
+            <a:spAutoFit/>
+          </a:bodyPr>
+          <a:lstStyle/>
+          <a:p>
+            <a:pPr algn="l">
+              <a:lnSpc>
+                <a:spcPct val="135000"/>
+              </a:lnSpc>
+            </a:pPr>
+            <a:r>
+              <a:rPr sz="1280" b="0" i="0">
+                <a:solidFill>
+                  <a:srgbClr val="1A1A1E"/>
+                </a:solidFill>
+                <a:latin typeface="Roboto"/>
+              </a:rPr>
+              <a:t>a definir</a:t>
+            </a:r>
+          </a:p>
+        </p:txBody>
+      </p:sp>
+      <p:sp>
+        <p:nvSpPr>
+          <p:cNvPr id="11" name="Rectangle 10"/>
+          <p:cNvSpPr/>
+          <p:nvPr/>
+        </p:nvSpPr>
+        <p:spPr>
+          <a:xfrm>
+            <a:off x="685800" y="3005880"/>
+            <a:ext cx="10820400" cy="9525"/>
+          </a:xfrm>
+          <a:prstGeom prst="rect">
+            <a:avLst/>
+          </a:prstGeom>
+          <a:solidFill>
+            <a:srgbClr val="EDEDF2"/>
+          </a:solidFill>
+          <a:ln>
+            <a:noFill/>
+          </a:ln>
+          <a:effectLst/>
+        </p:spPr>
+        <p:style>
+          <a:lnRef idx="1">
+            <a:schemeClr val="accent1"/>
+          </a:lnRef>
+          <a:fillRef idx="3">
+            <a:schemeClr val="accent1"/>
+          </a:fillRef>
+          <a:effectRef idx="2">
+            <a:schemeClr val="accent1"/>
+          </a:effectRef>
+          <a:fontRef idx="minor">
+            <a:schemeClr val="lt1"/>
+          </a:fontRef>
+        </p:style>
+        <p:txBody>
+          <a:bodyPr rtlCol="0" anchor="ctr" wrap="square" lIns="0" rIns="0" tIns="0" bIns="0"/>
+          <a:lstStyle/>
+          <a:p>
+            <a:pPr algn="ctr"/>
+          </a:p>
+        </p:txBody>
+      </p:sp>
+      <p:sp>
+        <p:nvSpPr>
+          <p:cNvPr id="12" name="TextBox 11"/>
+          <p:cNvSpPr txBox="1"/>
+          <p:nvPr/>
+        </p:nvSpPr>
+        <p:spPr>
+          <a:xfrm>
+            <a:off x="685800" y="3129705"/>
+            <a:ext cx="6496050" cy="762000"/>
+          </a:xfrm>
+          <a:prstGeom prst="rect">
+            <a:avLst/>
+          </a:prstGeom>
+          <a:noFill/>
+        </p:spPr>
+        <p:txBody>
+          <a:bodyPr wrap="square" lIns="0" rIns="0" tIns="0" bIns="0" anchor="t">
+            <a:spAutoFit/>
+          </a:bodyPr>
+          <a:lstStyle/>
+          <a:p>
+            <a:pPr algn="l">
+              <a:lnSpc>
+                <a:spcPct val="135000"/>
+              </a:lnSpc>
+            </a:pPr>
+            <a:r>
+              <a:rPr sz="1350" b="1" i="0">
+                <a:solidFill>
+                  <a:srgbClr val="21049A"/>
+                </a:solidFill>
+                <a:latin typeface="Roboto"/>
+              </a:rPr>
+              <a:t>Diagrama de sequência da lista de presença</a:t>
+            </a:r>
+          </a:p>
+        </p:txBody>
+      </p:sp>
+      <p:sp>
+        <p:nvSpPr>
+          <p:cNvPr id="13" name="TextBox 12"/>
+          <p:cNvSpPr txBox="1"/>
+          <p:nvPr/>
+        </p:nvSpPr>
+        <p:spPr>
+          <a:xfrm>
+            <a:off x="7620000" y="3129705"/>
+            <a:ext cx="1733550" cy="762000"/>
+          </a:xfrm>
+          <a:prstGeom prst="rect">
+            <a:avLst/>
+          </a:prstGeom>
+          <a:noFill/>
+        </p:spPr>
+        <p:txBody>
+          <a:bodyPr wrap="square" lIns="0" rIns="0" tIns="0" bIns="0" anchor="t">
+            <a:spAutoFit/>
+          </a:bodyPr>
+          <a:lstStyle/>
+          <a:p>
+            <a:pPr algn="l">
+              <a:lnSpc>
+                <a:spcPct val="135000"/>
+              </a:lnSpc>
+            </a:pPr>
+            <a:r>
+              <a:rPr sz="1280" b="0" i="0">
+                <a:solidFill>
+                  <a:srgbClr val="1A1A1E"/>
+                </a:solidFill>
+                <a:latin typeface="Roboto"/>
+              </a:rPr>
+              <a:t>a definir</a:t>
+            </a:r>
+          </a:p>
+        </p:txBody>
+      </p:sp>
+      <p:sp>
+        <p:nvSpPr>
+          <p:cNvPr id="14" name="TextBox 13"/>
+          <p:cNvSpPr txBox="1"/>
+          <p:nvPr/>
+        </p:nvSpPr>
+        <p:spPr>
+          <a:xfrm>
+            <a:off x="9620250" y="3129705"/>
+            <a:ext cx="1714500" cy="762000"/>
+          </a:xfrm>
+          <a:prstGeom prst="rect">
+            <a:avLst/>
+          </a:prstGeom>
+          <a:noFill/>
+        </p:spPr>
+        <p:txBody>
+          <a:bodyPr wrap="square" lIns="0" rIns="0" tIns="0" bIns="0" anchor="t">
+            <a:spAutoFit/>
+          </a:bodyPr>
+          <a:lstStyle/>
+          <a:p>
+            <a:pPr algn="l">
+              <a:lnSpc>
+                <a:spcPct val="135000"/>
+              </a:lnSpc>
+            </a:pPr>
+            <a:r>
+              <a:rPr sz="1280" b="0" i="0">
+                <a:solidFill>
+                  <a:srgbClr val="1A1A1E"/>
+                </a:solidFill>
+                <a:latin typeface="Roboto"/>
+              </a:rPr>
+              <a:t>a definir</a:t>
+            </a:r>
+          </a:p>
+        </p:txBody>
+      </p:sp>
+      <p:sp>
+        <p:nvSpPr>
+          <p:cNvPr id="15" name="Rectangle 14"/>
+          <p:cNvSpPr/>
+          <p:nvPr/>
+        </p:nvSpPr>
+        <p:spPr>
+          <a:xfrm>
+            <a:off x="685800" y="3491160"/>
+            <a:ext cx="10820400" cy="9525"/>
+          </a:xfrm>
+          <a:prstGeom prst="rect">
+            <a:avLst/>
+          </a:prstGeom>
+          <a:solidFill>
+            <a:srgbClr val="EDEDF2"/>
+          </a:solidFill>
+          <a:ln>
+            <a:noFill/>
+          </a:ln>
+          <a:effectLst/>
+        </p:spPr>
+        <p:style>
+          <a:lnRef idx="1">
+            <a:schemeClr val="accent1"/>
+          </a:lnRef>
+          <a:fillRef idx="3">
+            <a:schemeClr val="accent1"/>
+          </a:fillRef>
+          <a:effectRef idx="2">
+            <a:schemeClr val="accent1"/>
+          </a:effectRef>
+          <a:fontRef idx="minor">
+            <a:schemeClr val="lt1"/>
+          </a:fontRef>
+        </p:style>
+        <p:txBody>
+          <a:bodyPr rtlCol="0" anchor="ctr" wrap="square" lIns="0" rIns="0" tIns="0" bIns="0"/>
+          <a:lstStyle/>
+          <a:p>
+            <a:pPr algn="ctr"/>
+          </a:p>
+        </p:txBody>
+      </p:sp>
+      <p:sp>
+        <p:nvSpPr>
+          <p:cNvPr id="16" name="TextBox 15"/>
+          <p:cNvSpPr txBox="1"/>
+          <p:nvPr/>
+        </p:nvSpPr>
+        <p:spPr>
+          <a:xfrm>
+            <a:off x="685800" y="3614985"/>
+            <a:ext cx="6496050" cy="762000"/>
+          </a:xfrm>
+          <a:prstGeom prst="rect">
+            <a:avLst/>
+          </a:prstGeom>
+          <a:noFill/>
+        </p:spPr>
+        <p:txBody>
+          <a:bodyPr wrap="square" lIns="0" rIns="0" tIns="0" bIns="0" anchor="t">
+            <a:spAutoFit/>
+          </a:bodyPr>
+          <a:lstStyle/>
+          <a:p>
+            <a:pPr algn="l">
+              <a:lnSpc>
+                <a:spcPct val="135000"/>
+              </a:lnSpc>
+            </a:pPr>
+            <a:r>
+              <a:rPr sz="1350" b="1" i="0">
+                <a:solidFill>
+                  <a:srgbClr val="21049A"/>
+                </a:solidFill>
+                <a:latin typeface="Roboto"/>
+              </a:rPr>
+              <a:t>Protótipo de baixa fidelidade com as telas reais</a:t>
+            </a:r>
+          </a:p>
+        </p:txBody>
+      </p:sp>
+      <p:sp>
+        <p:nvSpPr>
+          <p:cNvPr id="17" name="TextBox 16"/>
+          <p:cNvSpPr txBox="1"/>
+          <p:nvPr/>
+        </p:nvSpPr>
+        <p:spPr>
+          <a:xfrm>
+            <a:off x="7620000" y="3614985"/>
+            <a:ext cx="1733550" cy="762000"/>
+          </a:xfrm>
+          <a:prstGeom prst="rect">
+            <a:avLst/>
+          </a:prstGeom>
+          <a:noFill/>
+        </p:spPr>
+        <p:txBody>
+          <a:bodyPr wrap="square" lIns="0" rIns="0" tIns="0" bIns="0" anchor="t">
+            <a:spAutoFit/>
+          </a:bodyPr>
+          <a:lstStyle/>
+          <a:p>
+            <a:pPr algn="l">
+              <a:lnSpc>
+                <a:spcPct val="135000"/>
+              </a:lnSpc>
+            </a:pPr>
+            <a:r>
+              <a:rPr sz="1280" b="0" i="0">
+                <a:solidFill>
+                  <a:srgbClr val="1A1A1E"/>
+                </a:solidFill>
+                <a:latin typeface="Roboto"/>
+              </a:rPr>
+              <a:t>a definir</a:t>
+            </a:r>
+          </a:p>
+        </p:txBody>
+      </p:sp>
+      <p:sp>
+        <p:nvSpPr>
+          <p:cNvPr id="18" name="TextBox 17"/>
+          <p:cNvSpPr txBox="1"/>
+          <p:nvPr/>
+        </p:nvSpPr>
+        <p:spPr>
+          <a:xfrm>
+            <a:off x="9620250" y="3614985"/>
+            <a:ext cx="1714500" cy="762000"/>
+          </a:xfrm>
+          <a:prstGeom prst="rect">
+            <a:avLst/>
+          </a:prstGeom>
+          <a:noFill/>
+        </p:spPr>
+        <p:txBody>
+          <a:bodyPr wrap="square" lIns="0" rIns="0" tIns="0" bIns="0" anchor="t">
+            <a:spAutoFit/>
+          </a:bodyPr>
+          <a:lstStyle/>
+          <a:p>
+            <a:pPr algn="l">
+              <a:lnSpc>
+                <a:spcPct val="135000"/>
+              </a:lnSpc>
+            </a:pPr>
+            <a:r>
+              <a:rPr sz="1280" b="0" i="0">
+                <a:solidFill>
+                  <a:srgbClr val="1A1A1E"/>
+                </a:solidFill>
+                <a:latin typeface="Roboto"/>
+              </a:rPr>
+              <a:t>a definir</a:t>
+            </a:r>
+          </a:p>
+        </p:txBody>
+      </p:sp>
+      <p:sp>
+        <p:nvSpPr>
+          <p:cNvPr id="19" name="Rectangle 18"/>
+          <p:cNvSpPr/>
+          <p:nvPr/>
+        </p:nvSpPr>
+        <p:spPr>
+          <a:xfrm>
+            <a:off x="685800" y="3976440"/>
+            <a:ext cx="10820400" cy="9525"/>
+          </a:xfrm>
+          <a:prstGeom prst="rect">
+            <a:avLst/>
+          </a:prstGeom>
+          <a:solidFill>
+            <a:srgbClr val="EDEDF2"/>
+          </a:solidFill>
+          <a:ln>
+            <a:noFill/>
+          </a:ln>
+          <a:effectLst/>
+        </p:spPr>
+        <p:style>
+          <a:lnRef idx="1">
+            <a:schemeClr val="accent1"/>
+          </a:lnRef>
+          <a:fillRef idx="3">
+            <a:schemeClr val="accent1"/>
+          </a:fillRef>
+          <a:effectRef idx="2">
+            <a:schemeClr val="accent1"/>
+          </a:effectRef>
+          <a:fontRef idx="minor">
+            <a:schemeClr val="lt1"/>
+          </a:fontRef>
+        </p:style>
+        <p:txBody>
+          <a:bodyPr rtlCol="0" anchor="ctr" wrap="square" lIns="0" rIns="0" tIns="0" bIns="0"/>
+          <a:lstStyle/>
+          <a:p>
+            <a:pPr algn="ctr"/>
+          </a:p>
+        </p:txBody>
+      </p:sp>
+      <p:sp>
+        <p:nvSpPr>
+          <p:cNvPr id="20" name="TextBox 19"/>
+          <p:cNvSpPr txBox="1"/>
+          <p:nvPr/>
+        </p:nvSpPr>
+        <p:spPr>
+          <a:xfrm>
+            <a:off x="685800" y="4100265"/>
+            <a:ext cx="6496050" cy="762000"/>
+          </a:xfrm>
+          <a:prstGeom prst="rect">
+            <a:avLst/>
+          </a:prstGeom>
+          <a:noFill/>
+        </p:spPr>
+        <p:txBody>
+          <a:bodyPr wrap="square" lIns="0" rIns="0" tIns="0" bIns="0" anchor="t">
+            <a:spAutoFit/>
+          </a:bodyPr>
+          <a:lstStyle/>
+          <a:p>
+            <a:pPr algn="l">
+              <a:lnSpc>
+                <a:spcPct val="135000"/>
+              </a:lnSpc>
+            </a:pPr>
+            <a:r>
+              <a:rPr sz="1350" b="1" i="0">
+                <a:solidFill>
+                  <a:srgbClr val="21049A"/>
+                </a:solidFill>
+                <a:latin typeface="Roboto"/>
+              </a:rPr>
+              <a:t>Aval do time às decisões novas da arquitetura</a:t>
+            </a:r>
+          </a:p>
+        </p:txBody>
+      </p:sp>
+      <p:sp>
+        <p:nvSpPr>
+          <p:cNvPr id="21" name="TextBox 20"/>
+          <p:cNvSpPr txBox="1"/>
+          <p:nvPr/>
+        </p:nvSpPr>
+        <p:spPr>
+          <a:xfrm>
+            <a:off x="7620000" y="4100265"/>
+            <a:ext cx="1733550" cy="762000"/>
+          </a:xfrm>
+          <a:prstGeom prst="rect">
+            <a:avLst/>
+          </a:prstGeom>
+          <a:noFill/>
+        </p:spPr>
+        <p:txBody>
+          <a:bodyPr wrap="square" lIns="0" rIns="0" tIns="0" bIns="0" anchor="t">
+            <a:spAutoFit/>
+          </a:bodyPr>
+          <a:lstStyle/>
+          <a:p>
+            <a:pPr algn="l">
+              <a:lnSpc>
+                <a:spcPct val="135000"/>
+              </a:lnSpc>
+            </a:pPr>
+            <a:r>
+              <a:rPr sz="1280" b="0" i="0">
+                <a:solidFill>
+                  <a:srgbClr val="1A1A1E"/>
+                </a:solidFill>
+                <a:latin typeface="Roboto"/>
+              </a:rPr>
+              <a:t>a definir</a:t>
+            </a:r>
+          </a:p>
+        </p:txBody>
+      </p:sp>
+      <p:sp>
+        <p:nvSpPr>
+          <p:cNvPr id="22" name="TextBox 21"/>
+          <p:cNvSpPr txBox="1"/>
+          <p:nvPr/>
+        </p:nvSpPr>
+        <p:spPr>
+          <a:xfrm>
+            <a:off x="9620250" y="4100265"/>
+            <a:ext cx="1714500" cy="762000"/>
+          </a:xfrm>
+          <a:prstGeom prst="rect">
+            <a:avLst/>
+          </a:prstGeom>
+          <a:noFill/>
+        </p:spPr>
+        <p:txBody>
+          <a:bodyPr wrap="square" lIns="0" rIns="0" tIns="0" bIns="0" anchor="t">
+            <a:spAutoFit/>
+          </a:bodyPr>
+          <a:lstStyle/>
+          <a:p>
+            <a:pPr algn="l">
+              <a:lnSpc>
+                <a:spcPct val="135000"/>
+              </a:lnSpc>
+            </a:pPr>
+            <a:r>
+              <a:rPr sz="1280" b="0" i="0">
+                <a:solidFill>
+                  <a:srgbClr val="1A1A1E"/>
+                </a:solidFill>
+                <a:latin typeface="Roboto"/>
+              </a:rPr>
+              <a:t>a definir</a:t>
+            </a:r>
+          </a:p>
+        </p:txBody>
+      </p:sp>
+      <p:sp>
+        <p:nvSpPr>
+          <p:cNvPr id="23" name="Rectangle 22"/>
+          <p:cNvSpPr/>
+          <p:nvPr/>
+        </p:nvSpPr>
+        <p:spPr>
+          <a:xfrm>
+            <a:off x="685800" y="4461720"/>
+            <a:ext cx="10820400" cy="9525"/>
+          </a:xfrm>
+          <a:prstGeom prst="rect">
+            <a:avLst/>
+          </a:prstGeom>
+          <a:solidFill>
+            <a:srgbClr val="EDEDF2"/>
+          </a:solidFill>
+          <a:ln>
+            <a:noFill/>
+          </a:ln>
+          <a:effectLst/>
+        </p:spPr>
+        <p:style>
+          <a:lnRef idx="1">
+            <a:schemeClr val="accent1"/>
+          </a:lnRef>
+          <a:fillRef idx="3">
+            <a:schemeClr val="accent1"/>
+          </a:fillRef>
+          <a:effectRef idx="2">
+            <a:schemeClr val="accent1"/>
+          </a:effectRef>
+          <a:fontRef idx="minor">
+            <a:schemeClr val="lt1"/>
+          </a:fontRef>
+        </p:style>
+        <p:txBody>
+          <a:bodyPr rtlCol="0" anchor="ctr" wrap="square" lIns="0" rIns="0" tIns="0" bIns="0"/>
+          <a:lstStyle/>
+          <a:p>
+            <a:pPr algn="ctr"/>
+          </a:p>
+        </p:txBody>
+      </p:sp>
+      <p:sp>
+        <p:nvSpPr>
+          <p:cNvPr id="24" name="TextBox 23"/>
+          <p:cNvSpPr txBox="1"/>
+          <p:nvPr/>
+        </p:nvSpPr>
+        <p:spPr>
+          <a:xfrm>
+            <a:off x="685800" y="4585545"/>
+            <a:ext cx="6496050" cy="762000"/>
+          </a:xfrm>
+          <a:prstGeom prst="rect">
+            <a:avLst/>
+          </a:prstGeom>
+          <a:noFill/>
+        </p:spPr>
+        <p:txBody>
+          <a:bodyPr wrap="square" lIns="0" rIns="0" tIns="0" bIns="0" anchor="t">
+            <a:spAutoFit/>
+          </a:bodyPr>
+          <a:lstStyle/>
+          <a:p>
+            <a:pPr algn="l">
+              <a:lnSpc>
+                <a:spcPct val="135000"/>
+              </a:lnSpc>
+            </a:pPr>
+            <a:r>
+              <a:rPr sz="1350" b="1" i="0">
+                <a:solidFill>
+                  <a:srgbClr val="21049A"/>
+                </a:solidFill>
+                <a:latin typeface="Roboto"/>
+              </a:rPr>
+              <a:t>Fechar o Team Charter</a:t>
+            </a:r>
+          </a:p>
+        </p:txBody>
+      </p:sp>
+      <p:sp>
+        <p:nvSpPr>
+          <p:cNvPr id="25" name="TextBox 24"/>
+          <p:cNvSpPr txBox="1"/>
+          <p:nvPr/>
+        </p:nvSpPr>
+        <p:spPr>
+          <a:xfrm>
+            <a:off x="7620000" y="4585545"/>
+            <a:ext cx="1733550" cy="762000"/>
+          </a:xfrm>
+          <a:prstGeom prst="rect">
+            <a:avLst/>
+          </a:prstGeom>
+          <a:noFill/>
+        </p:spPr>
+        <p:txBody>
+          <a:bodyPr wrap="square" lIns="0" rIns="0" tIns="0" bIns="0" anchor="t">
+            <a:spAutoFit/>
+          </a:bodyPr>
+          <a:lstStyle/>
+          <a:p>
+            <a:pPr algn="l">
+              <a:lnSpc>
+                <a:spcPct val="135000"/>
+              </a:lnSpc>
+            </a:pPr>
+            <a:r>
+              <a:rPr sz="1280" b="0" i="0">
+                <a:solidFill>
+                  <a:srgbClr val="1A1A1E"/>
+                </a:solidFill>
+                <a:latin typeface="Roboto"/>
+              </a:rPr>
+              <a:t>a definir</a:t>
+            </a:r>
+          </a:p>
+        </p:txBody>
+      </p:sp>
+      <p:sp>
+        <p:nvSpPr>
+          <p:cNvPr id="26" name="TextBox 25"/>
+          <p:cNvSpPr txBox="1"/>
+          <p:nvPr/>
+        </p:nvSpPr>
+        <p:spPr>
+          <a:xfrm>
+            <a:off x="9620250" y="4585545"/>
+            <a:ext cx="1714500" cy="762000"/>
+          </a:xfrm>
+          <a:prstGeom prst="rect">
+            <a:avLst/>
+          </a:prstGeom>
+          <a:noFill/>
+        </p:spPr>
+        <p:txBody>
+          <a:bodyPr wrap="square" lIns="0" rIns="0" tIns="0" bIns="0" anchor="t">
+            <a:spAutoFit/>
+          </a:bodyPr>
+          <a:lstStyle/>
+          <a:p>
+            <a:pPr algn="l">
+              <a:lnSpc>
+                <a:spcPct val="135000"/>
+              </a:lnSpc>
+            </a:pPr>
+            <a:r>
+              <a:rPr sz="1280" b="0" i="0">
+                <a:solidFill>
+                  <a:srgbClr val="1A1A1E"/>
+                </a:solidFill>
+                <a:latin typeface="Roboto"/>
+              </a:rPr>
+              <a:t>a definir</a:t>
+            </a:r>
+          </a:p>
+        </p:txBody>
+      </p:sp>
+      <p:sp>
+        <p:nvSpPr>
+          <p:cNvPr id="27" name="Rectangle 26"/>
+          <p:cNvSpPr/>
+          <p:nvPr/>
+        </p:nvSpPr>
+        <p:spPr>
+          <a:xfrm>
+            <a:off x="685800" y="4946999"/>
+            <a:ext cx="10820400" cy="9525"/>
+          </a:xfrm>
+          <a:prstGeom prst="rect">
+            <a:avLst/>
+          </a:prstGeom>
+          <a:solidFill>
+            <a:srgbClr val="EDEDF2"/>
+          </a:solidFill>
+          <a:ln>
+            <a:noFill/>
+          </a:ln>
+          <a:effectLst/>
+        </p:spPr>
+        <p:style>
+          <a:lnRef idx="1">
+            <a:schemeClr val="accent1"/>
+          </a:lnRef>
+          <a:fillRef idx="3">
+            <a:schemeClr val="accent1"/>
+          </a:fillRef>
+          <a:effectRef idx="2">
+            <a:schemeClr val="accent1"/>
+          </a:effectRef>
+          <a:fontRef idx="minor">
+            <a:schemeClr val="lt1"/>
+          </a:fontRef>
+        </p:style>
+        <p:txBody>
+          <a:bodyPr rtlCol="0" anchor="ctr" wrap="square" lIns="0" rIns="0" tIns="0" bIns="0"/>
+          <a:lstStyle/>
+          <a:p>
+            <a:pPr algn="ctr"/>
+          </a:p>
+        </p:txBody>
+      </p:sp>
+      <p:sp>
+        <p:nvSpPr>
+          <p:cNvPr id="28" name="TextBox 27"/>
+          <p:cNvSpPr txBox="1"/>
+          <p:nvPr/>
+        </p:nvSpPr>
+        <p:spPr>
+          <a:xfrm>
+            <a:off x="685800" y="5070824"/>
+            <a:ext cx="6496050" cy="762000"/>
+          </a:xfrm>
+          <a:prstGeom prst="rect">
+            <a:avLst/>
+          </a:prstGeom>
+          <a:noFill/>
+        </p:spPr>
+        <p:txBody>
+          <a:bodyPr wrap="square" lIns="0" rIns="0" tIns="0" bIns="0" anchor="t">
+            <a:spAutoFit/>
+          </a:bodyPr>
+          <a:lstStyle/>
+          <a:p>
+            <a:pPr algn="l">
+              <a:lnSpc>
+                <a:spcPct val="135000"/>
+              </a:lnSpc>
+            </a:pPr>
+            <a:r>
+              <a:rPr sz="1350" b="1" i="0">
+                <a:solidFill>
+                  <a:srgbClr val="21049A"/>
+                </a:solidFill>
+                <a:latin typeface="Roboto"/>
+              </a:rPr>
+              <a:t>Deck e ensaio do Pitch Final</a:t>
+            </a:r>
+          </a:p>
+        </p:txBody>
+      </p:sp>
+      <p:sp>
+        <p:nvSpPr>
+          <p:cNvPr id="29" name="TextBox 28"/>
+          <p:cNvSpPr txBox="1"/>
+          <p:nvPr/>
+        </p:nvSpPr>
+        <p:spPr>
+          <a:xfrm>
+            <a:off x="7620000" y="5070824"/>
+            <a:ext cx="1733550" cy="762000"/>
+          </a:xfrm>
+          <a:prstGeom prst="rect">
+            <a:avLst/>
+          </a:prstGeom>
+          <a:noFill/>
+        </p:spPr>
+        <p:txBody>
+          <a:bodyPr wrap="square" lIns="0" rIns="0" tIns="0" bIns="0" anchor="t">
+            <a:spAutoFit/>
+          </a:bodyPr>
+          <a:lstStyle/>
+          <a:p>
+            <a:pPr algn="l">
+              <a:lnSpc>
+                <a:spcPct val="135000"/>
+              </a:lnSpc>
+            </a:pPr>
+            <a:r>
+              <a:rPr sz="1280" b="0" i="0">
+                <a:solidFill>
+                  <a:srgbClr val="1A1A1E"/>
+                </a:solidFill>
+                <a:latin typeface="Roboto"/>
+              </a:rPr>
+              <a:t>a definir</a:t>
+            </a:r>
+          </a:p>
+        </p:txBody>
+      </p:sp>
+      <p:sp>
+        <p:nvSpPr>
+          <p:cNvPr id="30" name="TextBox 29"/>
+          <p:cNvSpPr txBox="1"/>
+          <p:nvPr/>
+        </p:nvSpPr>
+        <p:spPr>
+          <a:xfrm>
+            <a:off x="9620250" y="5070824"/>
+            <a:ext cx="1714500" cy="762000"/>
+          </a:xfrm>
+          <a:prstGeom prst="rect">
+            <a:avLst/>
+          </a:prstGeom>
+          <a:noFill/>
+        </p:spPr>
+        <p:txBody>
+          <a:bodyPr wrap="square" lIns="0" rIns="0" tIns="0" bIns="0" anchor="t">
+            <a:spAutoFit/>
+          </a:bodyPr>
+          <a:lstStyle/>
+          <a:p>
+            <a:pPr algn="l">
+              <a:lnSpc>
+                <a:spcPct val="135000"/>
+              </a:lnSpc>
+            </a:pPr>
+            <a:r>
+              <a:rPr sz="1280" b="0" i="0">
+                <a:solidFill>
+                  <a:srgbClr val="1A1A1E"/>
+                </a:solidFill>
+                <a:latin typeface="Roboto"/>
+              </a:rPr>
+              <a:t>a definir</a:t>
+            </a:r>
+          </a:p>
+        </p:txBody>
+      </p:sp>
+      <p:sp>
+        <p:nvSpPr>
+          <p:cNvPr id="31" name="Rectangle 30"/>
+          <p:cNvSpPr/>
+          <p:nvPr/>
+        </p:nvSpPr>
+        <p:spPr>
+          <a:xfrm>
+            <a:off x="685800" y="5432279"/>
+            <a:ext cx="10820400" cy="9525"/>
+          </a:xfrm>
+          <a:prstGeom prst="rect">
+            <a:avLst/>
+          </a:prstGeom>
+          <a:solidFill>
+            <a:srgbClr val="EDEDF2"/>
+          </a:solidFill>
+          <a:ln>
+            <a:noFill/>
+          </a:ln>
+          <a:effectLst/>
+        </p:spPr>
+        <p:style>
+          <a:lnRef idx="1">
+            <a:schemeClr val="accent1"/>
+          </a:lnRef>
+          <a:fillRef idx="3">
+            <a:schemeClr val="accent1"/>
+          </a:fillRef>
+          <a:effectRef idx="2">
+            <a:schemeClr val="accent1"/>
+          </a:effectRef>
+          <a:fontRef idx="minor">
+            <a:schemeClr val="lt1"/>
+          </a:fontRef>
+        </p:style>
+        <p:txBody>
+          <a:bodyPr rtlCol="0" anchor="ctr" wrap="square" lIns="0" rIns="0" tIns="0" bIns="0"/>
+          <a:lstStyle/>
+          <a:p>
+            <a:pPr algn="ctr"/>
+          </a:p>
+        </p:txBody>
+      </p:sp>
+      <p:sp>
+        <p:nvSpPr>
+          <p:cNvPr id="32" name="TextBox 31"/>
+          <p:cNvSpPr txBox="1"/>
+          <p:nvPr/>
+        </p:nvSpPr>
+        <p:spPr>
+          <a:xfrm>
+            <a:off x="685800" y="6324600"/>
+            <a:ext cx="6667500" cy="182880"/>
+          </a:xfrm>
+          <a:prstGeom prst="rect">
+            <a:avLst/>
+          </a:prstGeom>
+          <a:noFill/>
+        </p:spPr>
+        <p:txBody>
+          <a:bodyPr wrap="square" lIns="0" rIns="0" tIns="0" bIns="0" anchor="t">
+            <a:spAutoFit/>
+          </a:bodyPr>
+          <a:lstStyle/>
+          <a:p>
+            <a:pPr algn="l">
+              <a:lnSpc>
+                <a:spcPct val="120000"/>
+              </a:lnSpc>
+            </a:pPr>
+            <a:r>
+              <a:rPr sz="900" b="0" i="0">
+                <a:solidFill>
+                  <a:srgbClr val="6B6B78"/>
+                </a:solidFill>
+                <a:latin typeface="Roboto"/>
+              </a:rPr>
+              <a:t>Planejamento, Andreas</a:t>
+            </a:r>
+          </a:p>
+        </p:txBody>
+      </p:sp>
+      <p:sp>
+        <p:nvSpPr>
+          <p:cNvPr id="33" name="TextBox 32"/>
+          <p:cNvSpPr txBox="1"/>
+          <p:nvPr/>
+        </p:nvSpPr>
+        <p:spPr>
+          <a:xfrm>
+            <a:off x="10477500" y="6324600"/>
+            <a:ext cx="1028700" cy="182880"/>
+          </a:xfrm>
+          <a:prstGeom prst="rect">
+            <a:avLst/>
+          </a:prstGeom>
+          <a:noFill/>
+        </p:spPr>
+        <p:txBody>
+          <a:bodyPr wrap="square" lIns="0" rIns="0" tIns="0" bIns="0" anchor="t">
+            <a:spAutoFit/>
+          </a:bodyPr>
+          <a:lstStyle/>
+          <a:p>
+            <a:pPr algn="r">
+              <a:lnSpc>
+                <a:spcPct val="120000"/>
+              </a:lnSpc>
+            </a:pPr>
+            <a:r>
+              <a:rPr sz="900" b="1" i="0">
+                <a:solidFill>
+                  <a:srgbClr val="21049A"/>
+                </a:solidFill>
+                <a:latin typeface="Roboto"/>
+              </a:rPr>
+              <a:t>15</a:t>
+            </a:r>
+          </a:p>
+        </p:txBody>
+      </p:sp>
+    </p:spTree>
+  </p:cSld>
+  <p:clrMapOvr>
+    <a:masterClrMapping/>
+  </p:clrMapOvr>
+</p:sld>
+</file>
+
+<file path=ppt/slides/slide16.xml><?xml version="1.0" encoding="utf-8"?>
+<p:sld xmlns:a="http://schemas.openxmlformats.org/drawingml/2006/main" xmlns:p="http://schemas.openxmlformats.org/presentationml/2006/main" xmlns:r="http://schemas.openxmlformats.org/officeDocument/2006/relationships">
+  <p:cSld>
+    <p:spTree>
+      <p:nvGrpSpPr>
+        <p:cNvPr id="1" name=""/>
+        <p:cNvGrpSpPr/>
+        <p:nvPr/>
+      </p:nvGrpSpPr>
+      <p:grpSpPr/>
       <p:pic>
         <p:nvPicPr>
-          <p:cNvPr id="4" name="Picture 3" descr="c01-entrada.png"/>
+          <p:cNvPr id="2" name="Picture 1" descr="fundo-secao.jpg"/>
+          <p:cNvPicPr>
+            <a:picLocks noChangeAspect="1"/>
+          </p:cNvPicPr>
+          <p:nvPr/>
+        </p:nvPicPr>
+        <p:blipFill>
+          <a:blip r:embed="rId2"/>
+          <a:stretch>
+            <a:fillRect/>
+          </a:stretch>
+        </p:blipFill>
+        <p:spPr>
+          <a:xfrm>
+            <a:off x="0" y="0"/>
+            <a:ext cx="12192000" cy="6858000"/>
+          </a:xfrm>
+          <a:prstGeom prst="rect">
+            <a:avLst/>
+          </a:prstGeom>
+        </p:spPr>
+      </p:pic>
+      <p:pic>
+        <p:nvPicPr>
+          <p:cNvPr id="3" name="Picture 2" descr="u-branco.png"/>
           <p:cNvPicPr>
             <a:picLocks noChangeAspect="1"/>
           </p:cNvPicPr>
@@ -18966,136 +19299,24 @@
         </p:blipFill>
         <p:spPr>
           <a:xfrm>
-            <a:off x="685800" y="1814368"/>
-            <a:ext cx="5257800" cy="3286125"/>
-          </a:xfrm>
-          <a:prstGeom prst="rect">
-            <a:avLst/>
-          </a:prstGeom>
-          <a:ln w="9525">
-            <a:solidFill>
-              <a:srgbClr val="D9D9D9"/>
-            </a:solidFill>
-          </a:ln>
+            <a:off x="10744200" y="457200"/>
+            <a:ext cx="342900" cy="342900"/>
+          </a:xfrm>
+          <a:prstGeom prst="rect">
+            <a:avLst/>
+          </a:prstGeom>
         </p:spPr>
       </p:pic>
       <p:sp>
         <p:nvSpPr>
-          <p:cNvPr id="5" name="TextBox 4"/>
-          <p:cNvSpPr txBox="1"/>
-          <p:nvPr/>
-        </p:nvSpPr>
-        <p:spPr>
-          <a:xfrm>
-            <a:off x="685800" y="5195743"/>
-            <a:ext cx="5257800" cy="198120"/>
-          </a:xfrm>
-          <a:prstGeom prst="rect">
-            <a:avLst/>
-          </a:prstGeom>
-          <a:noFill/>
-        </p:spPr>
-        <p:txBody>
-          <a:bodyPr wrap="square" lIns="0" rIns="0" tIns="0" bIns="0" anchor="t">
-            <a:spAutoFit/>
-          </a:bodyPr>
-          <a:lstStyle/>
-          <a:p>
-            <a:pPr algn="ctr">
-              <a:lnSpc>
-                <a:spcPct val="120000"/>
-              </a:lnSpc>
-            </a:pPr>
-            <a:r>
-              <a:rPr sz="980" b="0" i="0">
-                <a:solidFill>
-                  <a:srgbClr val="6B6B78"/>
-                </a:solidFill>
-                <a:latin typeface="Roboto"/>
-              </a:rPr>
-              <a:t>Entrada e cadastro</a:t>
-            </a:r>
-          </a:p>
-        </p:txBody>
-      </p:sp>
-      <p:pic>
-        <p:nvPicPr>
-          <p:cNvPr id="6" name="Picture 5" descr="c08-lista.png"/>
-          <p:cNvPicPr>
-            <a:picLocks noChangeAspect="1"/>
-          </p:cNvPicPr>
-          <p:nvPr/>
-        </p:nvPicPr>
-        <p:blipFill>
-          <a:blip r:embed="rId4"/>
-          <a:stretch>
-            <a:fillRect/>
-          </a:stretch>
-        </p:blipFill>
-        <p:spPr>
-          <a:xfrm>
-            <a:off x="6248400" y="1814368"/>
-            <a:ext cx="5257800" cy="3286125"/>
-          </a:xfrm>
-          <a:prstGeom prst="rect">
-            <a:avLst/>
-          </a:prstGeom>
-          <a:ln w="9525">
-            <a:solidFill>
-              <a:srgbClr val="D9D9D9"/>
-            </a:solidFill>
-          </a:ln>
-        </p:spPr>
-      </p:pic>
-      <p:sp>
-        <p:nvSpPr>
-          <p:cNvPr id="7" name="TextBox 6"/>
-          <p:cNvSpPr txBox="1"/>
-          <p:nvPr/>
-        </p:nvSpPr>
-        <p:spPr>
-          <a:xfrm>
-            <a:off x="6248400" y="5195743"/>
-            <a:ext cx="5257800" cy="198120"/>
-          </a:xfrm>
-          <a:prstGeom prst="rect">
-            <a:avLst/>
-          </a:prstGeom>
-          <a:noFill/>
-        </p:spPr>
-        <p:txBody>
-          <a:bodyPr wrap="square" lIns="0" rIns="0" tIns="0" bIns="0" anchor="t">
-            <a:spAutoFit/>
-          </a:bodyPr>
-          <a:lstStyle/>
-          <a:p>
-            <a:pPr algn="ctr">
-              <a:lnSpc>
-                <a:spcPct val="120000"/>
-              </a:lnSpc>
-            </a:pPr>
-            <a:r>
-              <a:rPr sz="980" b="0" i="0">
-                <a:solidFill>
-                  <a:srgbClr val="6B6B78"/>
-                </a:solidFill>
-                <a:latin typeface="Roboto"/>
-              </a:rPr>
-              <a:t>Lista de convites</a:t>
-            </a:r>
-          </a:p>
-        </p:txBody>
-      </p:sp>
-      <p:sp>
-        <p:nvSpPr>
-          <p:cNvPr id="8" name="Rectangle 7"/>
+          <p:cNvPr id="4" name="Rectangle 3"/>
           <p:cNvSpPr/>
           <p:nvPr/>
         </p:nvSpPr>
         <p:spPr>
           <a:xfrm>
-            <a:off x="685800" y="5809960"/>
-            <a:ext cx="28575" cy="209840"/>
+            <a:off x="914400" y="1638300"/>
+            <a:ext cx="38100" cy="171450"/>
           </a:xfrm>
           <a:prstGeom prst="rect">
             <a:avLst/>
@@ -19132,14 +19353,14 @@
       </p:sp>
       <p:sp>
         <p:nvSpPr>
-          <p:cNvPr id="9" name="TextBox 8"/>
+          <p:cNvPr id="5" name="TextBox 4"/>
           <p:cNvSpPr txBox="1"/>
           <p:nvPr/>
         </p:nvSpPr>
         <p:spPr>
           <a:xfrm>
-            <a:off x="876300" y="5790910"/>
-            <a:ext cx="10629900" cy="343190"/>
+            <a:off x="1066800" y="1600200"/>
+            <a:ext cx="8572500" cy="228600"/>
           </a:xfrm>
           <a:prstGeom prst="rect">
             <a:avLst/>
@@ -19154,31 +19375,31 @@
           <a:p>
             <a:pPr algn="l">
               <a:lnSpc>
-                <a:spcPct val="150000"/>
+                <a:spcPct val="120000"/>
               </a:lnSpc>
             </a:pPr>
             <a:r>
-              <a:rPr sz="1280" b="0" i="0">
-                <a:solidFill>
-                  <a:srgbClr val="3A3A44"/>
+              <a:rPr sz="1120" b="1" i="0" spc="160">
+                <a:solidFill>
+                  <a:srgbClr val="FFFFFF"/>
                 </a:solidFill>
                 <a:latin typeface="Roboto"/>
               </a:rPr>
-              <a:t>Capturas da aplicação rodando localmente em 26/10/2026.</a:t>
-            </a:r>
-          </a:p>
-        </p:txBody>
-      </p:sp>
-      <p:sp>
-        <p:nvSpPr>
-          <p:cNvPr id="10" name="TextBox 9"/>
+              <a:t>TIME 04</a:t>
+            </a:r>
+          </a:p>
+        </p:txBody>
+      </p:sp>
+      <p:sp>
+        <p:nvSpPr>
+          <p:cNvPr id="6" name="TextBox 5"/>
           <p:cNvSpPr txBox="1"/>
           <p:nvPr/>
         </p:nvSpPr>
         <p:spPr>
           <a:xfrm>
-            <a:off x="685800" y="6324600"/>
-            <a:ext cx="6667500" cy="182880"/>
+            <a:off x="914400" y="1866900"/>
+            <a:ext cx="9715500" cy="1905000"/>
           </a:xfrm>
           <a:prstGeom prst="rect">
             <a:avLst/>
@@ -19193,31 +19414,31 @@
           <a:p>
             <a:pPr algn="l">
               <a:lnSpc>
-                <a:spcPct val="120000"/>
+                <a:spcPct val="106000"/>
               </a:lnSpc>
             </a:pPr>
             <a:r>
-              <a:rPr sz="900" b="0" i="0">
-                <a:solidFill>
-                  <a:srgbClr val="6B6B78"/>
+              <a:rPr sz="3900" b="1" i="0">
+                <a:solidFill>
+                  <a:srgbClr val="FFFFFF"/>
                 </a:solidFill>
                 <a:latin typeface="Roboto"/>
               </a:rPr>
-              <a:t>Apêndice</a:t>
-            </a:r>
-          </a:p>
-        </p:txBody>
-      </p:sp>
-      <p:sp>
-        <p:nvSpPr>
-          <p:cNvPr id="11" name="TextBox 10"/>
+              <a:t>Perguntas</a:t>
+            </a:r>
+          </a:p>
+        </p:txBody>
+      </p:sp>
+      <p:sp>
+        <p:nvSpPr>
+          <p:cNvPr id="7" name="TextBox 6"/>
           <p:cNvSpPr txBox="1"/>
           <p:nvPr/>
         </p:nvSpPr>
         <p:spPr>
           <a:xfrm>
-            <a:off x="10477500" y="6324600"/>
-            <a:ext cx="1028700" cy="182880"/>
+            <a:off x="914400" y="4095750"/>
+            <a:ext cx="8572500" cy="1524000"/>
           </a:xfrm>
           <a:prstGeom prst="rect">
             <a:avLst/>
@@ -19230,6 +19451,132 @@
           </a:bodyPr>
           <a:lstStyle/>
           <a:p>
+            <a:pPr algn="l">
+              <a:lnSpc>
+                <a:spcPct val="150000"/>
+              </a:lnSpc>
+            </a:pPr>
+            <a:r>
+              <a:rPr sz="1420" b="0" i="0">
+                <a:solidFill>
+                  <a:srgbClr val="E2DEF5"/>
+                </a:solidFill>
+                <a:latin typeface="Roboto"/>
+              </a:rPr>
+              <a:t>Andreas Grings: problema, requisitos e planejamento</a:t>
+            </a:r>
+          </a:p>
+          <a:p>
+            <a:pPr>
+              <a:lnSpc>
+                <a:spcPct val="150000"/>
+              </a:lnSpc>
+            </a:pPr>
+            <a:r>
+              <a:rPr sz="1420" b="0" i="0">
+                <a:solidFill>
+                  <a:srgbClr val="E2DEF5"/>
+                </a:solidFill>
+                <a:latin typeface="Roboto"/>
+              </a:rPr>
+              <a:t>Tiago Passos: arquitetura, Docker e GitHub</a:t>
+            </a:r>
+          </a:p>
+          <a:p>
+            <a:pPr>
+              <a:lnSpc>
+                <a:spcPct val="150000"/>
+              </a:lnSpc>
+            </a:pPr>
+            <a:r>
+              <a:rPr sz="1420" b="0" i="0">
+                <a:solidFill>
+                  <a:srgbClr val="E2DEF5"/>
+                </a:solidFill>
+                <a:latin typeface="Roboto"/>
+              </a:rPr>
+              <a:t>Guilherme Toebe: front-end e Azure Boards</a:t>
+            </a:r>
+          </a:p>
+          <a:p>
+            <a:pPr>
+              <a:lnSpc>
+                <a:spcPct val="150000"/>
+              </a:lnSpc>
+            </a:pPr>
+            <a:r>
+              <a:rPr sz="1420" b="0" i="0">
+                <a:solidFill>
+                  <a:srgbClr val="E2DEF5"/>
+                </a:solidFill>
+                <a:latin typeface="Roboto"/>
+              </a:rPr>
+              <a:t>Gabriel Tomasi: back-end, regras e testes</a:t>
+            </a:r>
+          </a:p>
+        </p:txBody>
+      </p:sp>
+      <p:sp>
+        <p:nvSpPr>
+          <p:cNvPr id="8" name="TextBox 7"/>
+          <p:cNvSpPr txBox="1"/>
+          <p:nvPr/>
+        </p:nvSpPr>
+        <p:spPr>
+          <a:xfrm>
+            <a:off x="685800" y="6324600"/>
+            <a:ext cx="6667500" cy="182880"/>
+          </a:xfrm>
+          <a:prstGeom prst="rect">
+            <a:avLst/>
+          </a:prstGeom>
+          <a:noFill/>
+        </p:spPr>
+        <p:txBody>
+          <a:bodyPr wrap="square" lIns="0" rIns="0" tIns="0" bIns="0" anchor="t">
+            <a:spAutoFit/>
+          </a:bodyPr>
+          <a:lstStyle/>
+          <a:p>
+            <a:pPr algn="l">
+              <a:lnSpc>
+                <a:spcPct val="120000"/>
+              </a:lnSpc>
+            </a:pPr>
+            <a:r>
+              <a:rPr sz="900" b="0" i="0">
+                <a:solidFill>
+                  <a:srgbClr val="FFFFFF"/>
+                </a:solidFill>
+                <a:latin typeface="Roboto"/>
+              </a:rPr>
+              <a:t>Perguntas</a:t>
+            </a:r>
+          </a:p>
+        </p:txBody>
+      </p:sp>
+      <p:sp>
+        <p:nvSpPr>
+          <p:cNvPr id="9" name="TextBox 8"/>
+          <p:cNvSpPr txBox="1"/>
+          <p:nvPr/>
+        </p:nvSpPr>
+        <p:spPr>
+          <a:xfrm>
+            <a:off x="10477500" y="6324600"/>
+            <a:ext cx="1028700" cy="182880"/>
+          </a:xfrm>
+          <a:prstGeom prst="rect">
+            <a:avLst/>
+          </a:prstGeom>
+          <a:noFill/>
+        </p:spPr>
+        <p:txBody>
+          <a:bodyPr wrap="square" lIns="0" rIns="0" tIns="0" bIns="0" anchor="t">
+            <a:spAutoFit/>
+          </a:bodyPr>
+          <a:lstStyle/>
+          <a:p>
             <a:pPr algn="r">
               <a:lnSpc>
                 <a:spcPct val="120000"/>
@@ -19238,7 +19585,7 @@
             <a:r>
               <a:rPr sz="900" b="1" i="0">
                 <a:solidFill>
-                  <a:srgbClr val="21049A"/>
+                  <a:srgbClr val="FFFFFF"/>
                 </a:solidFill>
                 <a:latin typeface="Roboto"/>
               </a:rPr>
@@ -19331,14 +19678,14 @@
                 </a:solidFill>
                 <a:latin typeface="Roboto"/>
               </a:rPr>
-              <a:t>Telas do convidado</a:t>
+              <a:t>Telas do anfitrião</a:t>
             </a:r>
           </a:p>
         </p:txBody>
       </p:sp>
       <p:pic>
         <p:nvPicPr>
-          <p:cNvPr id="4" name="Picture 3" descr="c03-convite.png"/>
+          <p:cNvPr id="4" name="Picture 3" descr="c01-entrada.png"/>
           <p:cNvPicPr>
             <a:picLocks noChangeAspect="1"/>
           </p:cNvPicPr>
@@ -19352,8 +19699,8 @@
         </p:blipFill>
         <p:spPr>
           <a:xfrm>
-            <a:off x="2346848" y="1676400"/>
-            <a:ext cx="1645976" cy="3562060"/>
+            <a:off x="685800" y="1814368"/>
+            <a:ext cx="5257800" cy="3286125"/>
           </a:xfrm>
           <a:prstGeom prst="rect">
             <a:avLst/>
@@ -19373,8 +19720,8 @@
         </p:nvSpPr>
         <p:spPr>
           <a:xfrm>
-            <a:off x="2346848" y="5333710"/>
-            <a:ext cx="1645976" cy="198120"/>
+            <a:off x="685800" y="5195743"/>
+            <a:ext cx="5257800" cy="198120"/>
           </a:xfrm>
           <a:prstGeom prst="rect">
             <a:avLst/>
@@ -19399,14 +19746,14 @@
                 </a:solidFill>
                 <a:latin typeface="Roboto"/>
               </a:rPr>
-              <a:t>Convite</a:t>
+              <a:t>Entrada e cadastro</a:t>
             </a:r>
           </a:p>
         </p:txBody>
       </p:sp>
       <p:pic>
         <p:nvPicPr>
-          <p:cNvPr id="6" name="Picture 5" descr="c04-resposta.png"/>
+          <p:cNvPr id="6" name="Picture 5" descr="c08-lista.png"/>
           <p:cNvPicPr>
             <a:picLocks noChangeAspect="1"/>
           </p:cNvPicPr>
@@ -19420,8 +19767,8 @@
         </p:blipFill>
         <p:spPr>
           <a:xfrm>
-            <a:off x="4297624" y="1676400"/>
-            <a:ext cx="1645976" cy="3562060"/>
+            <a:off x="6248400" y="1814368"/>
+            <a:ext cx="5257800" cy="3286125"/>
           </a:xfrm>
           <a:prstGeom prst="rect">
             <a:avLst/>
@@ -19441,8 +19788,8 @@
         </p:nvSpPr>
         <p:spPr>
           <a:xfrm>
-            <a:off x="4297624" y="5333710"/>
-            <a:ext cx="1645976" cy="198120"/>
+            <a:off x="6248400" y="5195743"/>
+            <a:ext cx="5257800" cy="198120"/>
           </a:xfrm>
           <a:prstGeom prst="rect">
             <a:avLst/>
@@ -19467,150 +19814,14 @@
                 </a:solidFill>
                 <a:latin typeface="Roboto"/>
               </a:rPr>
-              <a:t>Resposta enviada</a:t>
-            </a:r>
-          </a:p>
-        </p:txBody>
-      </p:sp>
-      <p:pic>
-        <p:nvPicPr>
-          <p:cNvPr id="8" name="Picture 7" descr="c05-lotado.png"/>
-          <p:cNvPicPr>
-            <a:picLocks noChangeAspect="1"/>
-          </p:cNvPicPr>
-          <p:nvPr/>
-        </p:nvPicPr>
-        <p:blipFill>
-          <a:blip r:embed="rId5"/>
-          <a:stretch>
-            <a:fillRect/>
-          </a:stretch>
-        </p:blipFill>
-        <p:spPr>
-          <a:xfrm>
-            <a:off x="6248400" y="1676400"/>
-            <a:ext cx="1645976" cy="3562060"/>
-          </a:xfrm>
-          <a:prstGeom prst="rect">
-            <a:avLst/>
-          </a:prstGeom>
-          <a:ln w="9525">
-            <a:solidFill>
-              <a:srgbClr val="D9D9D9"/>
-            </a:solidFill>
-          </a:ln>
-        </p:spPr>
-      </p:pic>
-      <p:sp>
-        <p:nvSpPr>
-          <p:cNvPr id="9" name="TextBox 8"/>
-          <p:cNvSpPr txBox="1"/>
-          <p:nvPr/>
-        </p:nvSpPr>
-        <p:spPr>
-          <a:xfrm>
-            <a:off x="6248400" y="5333710"/>
-            <a:ext cx="1645976" cy="198120"/>
-          </a:xfrm>
-          <a:prstGeom prst="rect">
-            <a:avLst/>
-          </a:prstGeom>
-          <a:noFill/>
-        </p:spPr>
-        <p:txBody>
-          <a:bodyPr wrap="square" lIns="0" rIns="0" tIns="0" bIns="0" anchor="t">
-            <a:spAutoFit/>
-          </a:bodyPr>
-          <a:lstStyle/>
-          <a:p>
-            <a:pPr algn="ctr">
-              <a:lnSpc>
-                <a:spcPct val="120000"/>
-              </a:lnSpc>
-            </a:pPr>
-            <a:r>
-              <a:rPr sz="980" b="0" i="0">
-                <a:solidFill>
-                  <a:srgbClr val="6B6B78"/>
-                </a:solidFill>
-                <a:latin typeface="Roboto"/>
-              </a:rPr>
-              <a:t>Convite lotado</a:t>
-            </a:r>
-          </a:p>
-        </p:txBody>
-      </p:sp>
-      <p:pic>
-        <p:nvPicPr>
-          <p:cNvPr id="10" name="Picture 9" descr="c06-link-pessoal.png"/>
-          <p:cNvPicPr>
-            <a:picLocks noChangeAspect="1"/>
-          </p:cNvPicPr>
-          <p:nvPr/>
-        </p:nvPicPr>
-        <p:blipFill>
-          <a:blip r:embed="rId6"/>
-          <a:stretch>
-            <a:fillRect/>
-          </a:stretch>
-        </p:blipFill>
-        <p:spPr>
-          <a:xfrm>
-            <a:off x="8199176" y="1676400"/>
-            <a:ext cx="1645976" cy="3562060"/>
-          </a:xfrm>
-          <a:prstGeom prst="rect">
-            <a:avLst/>
-          </a:prstGeom>
-          <a:ln w="9525">
-            <a:solidFill>
-              <a:srgbClr val="D9D9D9"/>
-            </a:solidFill>
-          </a:ln>
-        </p:spPr>
-      </p:pic>
-      <p:sp>
-        <p:nvSpPr>
-          <p:cNvPr id="11" name="TextBox 10"/>
-          <p:cNvSpPr txBox="1"/>
-          <p:nvPr/>
-        </p:nvSpPr>
-        <p:spPr>
-          <a:xfrm>
-            <a:off x="8199176" y="5333710"/>
-            <a:ext cx="1645976" cy="198120"/>
-          </a:xfrm>
-          <a:prstGeom prst="rect">
-            <a:avLst/>
-          </a:prstGeom>
-          <a:noFill/>
-        </p:spPr>
-        <p:txBody>
-          <a:bodyPr wrap="square" lIns="0" rIns="0" tIns="0" bIns="0" anchor="t">
-            <a:spAutoFit/>
-          </a:bodyPr>
-          <a:lstStyle/>
-          <a:p>
-            <a:pPr algn="ctr">
-              <a:lnSpc>
-                <a:spcPct val="120000"/>
-              </a:lnSpc>
-            </a:pPr>
-            <a:r>
-              <a:rPr sz="980" b="0" i="0">
-                <a:solidFill>
-                  <a:srgbClr val="6B6B78"/>
-                </a:solidFill>
-                <a:latin typeface="Roboto"/>
-              </a:rPr>
-              <a:t>Link pessoal</a:t>
-            </a:r>
-          </a:p>
-        </p:txBody>
-      </p:sp>
-      <p:sp>
-        <p:nvSpPr>
-          <p:cNvPr id="12" name="Rectangle 11"/>
+              <a:t>Lista de convites</a:t>
+            </a:r>
+          </a:p>
+        </p:txBody>
+      </p:sp>
+      <p:sp>
+        <p:nvSpPr>
+          <p:cNvPr id="8" name="Rectangle 7"/>
           <p:cNvSpPr/>
           <p:nvPr/>
         </p:nvSpPr>
@@ -19654,7 +19865,7 @@
       </p:sp>
       <p:sp>
         <p:nvSpPr>
-          <p:cNvPr id="13" name="TextBox 12"/>
+          <p:cNvPr id="9" name="TextBox 8"/>
           <p:cNvSpPr txBox="1"/>
           <p:nvPr/>
         </p:nvSpPr>
@@ -19693,7 +19904,7 @@
       </p:sp>
       <p:sp>
         <p:nvSpPr>
-          <p:cNvPr id="14" name="TextBox 13"/>
+          <p:cNvPr id="10" name="TextBox 9"/>
           <p:cNvSpPr txBox="1"/>
           <p:nvPr/>
         </p:nvSpPr>
@@ -19732,7 +19943,7 @@
       </p:sp>
       <p:sp>
         <p:nvSpPr>
-          <p:cNvPr id="15" name="TextBox 14"/>
+          <p:cNvPr id="11" name="TextBox 10"/>
           <p:cNvSpPr txBox="1"/>
           <p:nvPr/>
         </p:nvSpPr>
@@ -19853,14 +20064,14 @@
                 </a:solidFill>
                 <a:latin typeface="Roboto"/>
               </a:rPr>
-              <a:t>Painel e convite despublicado</a:t>
+              <a:t>Telas do convidado</a:t>
             </a:r>
           </a:p>
         </p:txBody>
       </p:sp>
       <p:pic>
         <p:nvPicPr>
-          <p:cNvPr id="4" name="Picture 3" descr="c07-painel.png"/>
+          <p:cNvPr id="4" name="Picture 3" descr="c03-convite.png"/>
           <p:cNvPicPr>
             <a:picLocks noChangeAspect="1"/>
           </p:cNvPicPr>
@@ -19874,8 +20085,8 @@
         </p:blipFill>
         <p:spPr>
           <a:xfrm>
-            <a:off x="2270964" y="1676400"/>
-            <a:ext cx="5699297" cy="3562060"/>
+            <a:off x="2346848" y="1676400"/>
+            <a:ext cx="1645976" cy="3562060"/>
           </a:xfrm>
           <a:prstGeom prst="rect">
             <a:avLst/>
@@ -19895,8 +20106,8 @@
         </p:nvSpPr>
         <p:spPr>
           <a:xfrm>
-            <a:off x="2270964" y="5333710"/>
-            <a:ext cx="5699297" cy="198120"/>
+            <a:off x="2346848" y="5333710"/>
+            <a:ext cx="1645976" cy="198120"/>
           </a:xfrm>
           <a:prstGeom prst="rect">
             <a:avLst/>
@@ -19921,14 +20132,14 @@
                 </a:solidFill>
                 <a:latin typeface="Roboto"/>
               </a:rPr>
-              <a:t>Painel de respostas</a:t>
+              <a:t>Convite</a:t>
             </a:r>
           </a:p>
         </p:txBody>
       </p:sp>
       <p:pic>
         <p:nvPicPr>
-          <p:cNvPr id="6" name="Picture 5" descr="c09-nao-encontrado.png"/>
+          <p:cNvPr id="6" name="Picture 5" descr="c04-resposta.png"/>
           <p:cNvPicPr>
             <a:picLocks noChangeAspect="1"/>
           </p:cNvPicPr>
@@ -19942,7 +20153,7 @@
         </p:blipFill>
         <p:spPr>
           <a:xfrm>
-            <a:off x="8275060" y="1676400"/>
+            <a:off x="4297624" y="1676400"/>
             <a:ext cx="1645976" cy="3562060"/>
           </a:xfrm>
           <a:prstGeom prst="rect">
@@ -19963,7 +20174,7 @@
         </p:nvSpPr>
         <p:spPr>
           <a:xfrm>
-            <a:off x="8275060" y="5333710"/>
+            <a:off x="4297624" y="5333710"/>
             <a:ext cx="1645976" cy="198120"/>
           </a:xfrm>
           <a:prstGeom prst="rect">
@@ -19989,14 +20200,150 @@
                 </a:solidFill>
                 <a:latin typeface="Roboto"/>
               </a:rPr>
-              <a:t>Link do convite depois de despublicar</a:t>
-            </a:r>
-          </a:p>
-        </p:txBody>
-      </p:sp>
-      <p:sp>
-        <p:nvSpPr>
-          <p:cNvPr id="8" name="Rectangle 7"/>
+              <a:t>Resposta enviada</a:t>
+            </a:r>
+          </a:p>
+        </p:txBody>
+      </p:sp>
+      <p:pic>
+        <p:nvPicPr>
+          <p:cNvPr id="8" name="Picture 7" descr="c05-lotado.png"/>
+          <p:cNvPicPr>
+            <a:picLocks noChangeAspect="1"/>
+          </p:cNvPicPr>
+          <p:nvPr/>
+        </p:nvPicPr>
+        <p:blipFill>
+          <a:blip r:embed="rId5"/>
+          <a:stretch>
+            <a:fillRect/>
+          </a:stretch>
+        </p:blipFill>
+        <p:spPr>
+          <a:xfrm>
+            <a:off x="6248400" y="1676400"/>
+            <a:ext cx="1645976" cy="3562060"/>
+          </a:xfrm>
+          <a:prstGeom prst="rect">
+            <a:avLst/>
+          </a:prstGeom>
+          <a:ln w="9525">
+            <a:solidFill>
+              <a:srgbClr val="D9D9D9"/>
+            </a:solidFill>
+          </a:ln>
+        </p:spPr>
+      </p:pic>
+      <p:sp>
+        <p:nvSpPr>
+          <p:cNvPr id="9" name="TextBox 8"/>
+          <p:cNvSpPr txBox="1"/>
+          <p:nvPr/>
+        </p:nvSpPr>
+        <p:spPr>
+          <a:xfrm>
+            <a:off x="6248400" y="5333710"/>
+            <a:ext cx="1645976" cy="198120"/>
+          </a:xfrm>
+          <a:prstGeom prst="rect">
+            <a:avLst/>
+          </a:prstGeom>
+          <a:noFill/>
+        </p:spPr>
+        <p:txBody>
+          <a:bodyPr wrap="square" lIns="0" rIns="0" tIns="0" bIns="0" anchor="t">
+            <a:spAutoFit/>
+          </a:bodyPr>
+          <a:lstStyle/>
+          <a:p>
+            <a:pPr algn="ctr">
+              <a:lnSpc>
+                <a:spcPct val="120000"/>
+              </a:lnSpc>
+            </a:pPr>
+            <a:r>
+              <a:rPr sz="980" b="0" i="0">
+                <a:solidFill>
+                  <a:srgbClr val="6B6B78"/>
+                </a:solidFill>
+                <a:latin typeface="Roboto"/>
+              </a:rPr>
+              <a:t>Convite lotado</a:t>
+            </a:r>
+          </a:p>
+        </p:txBody>
+      </p:sp>
+      <p:pic>
+        <p:nvPicPr>
+          <p:cNvPr id="10" name="Picture 9" descr="c06-link-pessoal.png"/>
+          <p:cNvPicPr>
+            <a:picLocks noChangeAspect="1"/>
+          </p:cNvPicPr>
+          <p:nvPr/>
+        </p:nvPicPr>
+        <p:blipFill>
+          <a:blip r:embed="rId6"/>
+          <a:stretch>
+            <a:fillRect/>
+          </a:stretch>
+        </p:blipFill>
+        <p:spPr>
+          <a:xfrm>
+            <a:off x="8199176" y="1676400"/>
+            <a:ext cx="1645976" cy="3562060"/>
+          </a:xfrm>
+          <a:prstGeom prst="rect">
+            <a:avLst/>
+          </a:prstGeom>
+          <a:ln w="9525">
+            <a:solidFill>
+              <a:srgbClr val="D9D9D9"/>
+            </a:solidFill>
+          </a:ln>
+        </p:spPr>
+      </p:pic>
+      <p:sp>
+        <p:nvSpPr>
+          <p:cNvPr id="11" name="TextBox 10"/>
+          <p:cNvSpPr txBox="1"/>
+          <p:nvPr/>
+        </p:nvSpPr>
+        <p:spPr>
+          <a:xfrm>
+            <a:off x="8199176" y="5333710"/>
+            <a:ext cx="1645976" cy="198120"/>
+          </a:xfrm>
+          <a:prstGeom prst="rect">
+            <a:avLst/>
+          </a:prstGeom>
+          <a:noFill/>
+        </p:spPr>
+        <p:txBody>
+          <a:bodyPr wrap="square" lIns="0" rIns="0" tIns="0" bIns="0" anchor="t">
+            <a:spAutoFit/>
+          </a:bodyPr>
+          <a:lstStyle/>
+          <a:p>
+            <a:pPr algn="ctr">
+              <a:lnSpc>
+                <a:spcPct val="120000"/>
+              </a:lnSpc>
+            </a:pPr>
+            <a:r>
+              <a:rPr sz="980" b="0" i="0">
+                <a:solidFill>
+                  <a:srgbClr val="6B6B78"/>
+                </a:solidFill>
+                <a:latin typeface="Roboto"/>
+              </a:rPr>
+              <a:t>Link pessoal</a:t>
+            </a:r>
+          </a:p>
+        </p:txBody>
+      </p:sp>
+      <p:sp>
+        <p:nvSpPr>
+          <p:cNvPr id="12" name="Rectangle 11"/>
           <p:cNvSpPr/>
           <p:nvPr/>
         </p:nvSpPr>
@@ -20040,7 +20387,7 @@
       </p:sp>
       <p:sp>
         <p:nvSpPr>
-          <p:cNvPr id="9" name="TextBox 8"/>
+          <p:cNvPr id="13" name="TextBox 12"/>
           <p:cNvSpPr txBox="1"/>
           <p:nvPr/>
         </p:nvSpPr>
@@ -20079,7 +20426,7 @@
       </p:sp>
       <p:sp>
         <p:nvSpPr>
-          <p:cNvPr id="10" name="TextBox 9"/>
+          <p:cNvPr id="14" name="TextBox 13"/>
           <p:cNvSpPr txBox="1"/>
           <p:nvPr/>
         </p:nvSpPr>
@@ -20118,7 +20465,7 @@
       </p:sp>
       <p:sp>
         <p:nvSpPr>
-          <p:cNvPr id="11" name="TextBox 10"/>
+          <p:cNvPr id="15" name="TextBox 14"/>
           <p:cNvSpPr txBox="1"/>
           <p:nvPr/>
         </p:nvSpPr>
@@ -20151,6 +20498,392 @@
                 <a:latin typeface="Roboto"/>
               </a:rPr>
               <a:t>18</a:t>
+            </a:r>
+          </a:p>
+        </p:txBody>
+      </p:sp>
+    </p:spTree>
+  </p:cSld>
+  <p:clrMapOvr>
+    <a:masterClrMapping/>
+  </p:clrMapOvr>
+</p:sld>
+</file>
+
+<file path=ppt/slides/slide19.xml><?xml version="1.0" encoding="utf-8"?>
+<p:sld xmlns:a="http://schemas.openxmlformats.org/drawingml/2006/main" xmlns:p="http://schemas.openxmlformats.org/presentationml/2006/main" xmlns:r="http://schemas.openxmlformats.org/officeDocument/2006/relationships">
+  <p:cSld>
+    <p:bg>
+      <p:bgPr>
+        <a:solidFill>
+          <a:srgbClr val="FFFFFF"/>
+        </a:solidFill>
+        <a:effectLst/>
+      </p:bgPr>
+    </p:bg>
+    <p:spTree>
+      <p:nvGrpSpPr>
+        <p:cNvPr id="1" name=""/>
+        <p:cNvGrpSpPr/>
+        <p:nvPr/>
+      </p:nvGrpSpPr>
+      <p:grpSpPr/>
+      <p:pic>
+        <p:nvPicPr>
+          <p:cNvPr id="2" name="Picture 1" descr="u-azul.png"/>
+          <p:cNvPicPr>
+            <a:picLocks noChangeAspect="1"/>
+          </p:cNvPicPr>
+          <p:nvPr/>
+        </p:nvPicPr>
+        <p:blipFill>
+          <a:blip r:embed="rId2"/>
+          <a:stretch>
+            <a:fillRect/>
+          </a:stretch>
+        </p:blipFill>
+        <p:spPr>
+          <a:xfrm>
+            <a:off x="10744200" y="457200"/>
+            <a:ext cx="342900" cy="342900"/>
+          </a:xfrm>
+          <a:prstGeom prst="rect">
+            <a:avLst/>
+          </a:prstGeom>
+        </p:spPr>
+      </p:pic>
+      <p:sp>
+        <p:nvSpPr>
+          <p:cNvPr id="3" name="TextBox 2"/>
+          <p:cNvSpPr txBox="1"/>
+          <p:nvPr/>
+        </p:nvSpPr>
+        <p:spPr>
+          <a:xfrm>
+            <a:off x="685800" y="685800"/>
+            <a:ext cx="9620250" cy="1524000"/>
+          </a:xfrm>
+          <a:prstGeom prst="rect">
+            <a:avLst/>
+          </a:prstGeom>
+          <a:noFill/>
+        </p:spPr>
+        <p:txBody>
+          <a:bodyPr wrap="square" lIns="0" rIns="0" tIns="0" bIns="0" anchor="t">
+            <a:spAutoFit/>
+          </a:bodyPr>
+          <a:lstStyle/>
+          <a:p>
+            <a:pPr algn="l">
+              <a:lnSpc>
+                <a:spcPct val="104000"/>
+              </a:lnSpc>
+            </a:pPr>
+            <a:r>
+              <a:rPr sz="3000" b="1" i="0">
+                <a:solidFill>
+                  <a:srgbClr val="21049A"/>
+                </a:solidFill>
+                <a:latin typeface="Roboto"/>
+              </a:rPr>
+              <a:t>Painel e convite despublicado</a:t>
+            </a:r>
+          </a:p>
+        </p:txBody>
+      </p:sp>
+      <p:pic>
+        <p:nvPicPr>
+          <p:cNvPr id="4" name="Picture 3" descr="c07-painel.png"/>
+          <p:cNvPicPr>
+            <a:picLocks noChangeAspect="1"/>
+          </p:cNvPicPr>
+          <p:nvPr/>
+        </p:nvPicPr>
+        <p:blipFill>
+          <a:blip r:embed="rId3"/>
+          <a:stretch>
+            <a:fillRect/>
+          </a:stretch>
+        </p:blipFill>
+        <p:spPr>
+          <a:xfrm>
+            <a:off x="2270964" y="1676400"/>
+            <a:ext cx="5699297" cy="3562060"/>
+          </a:xfrm>
+          <a:prstGeom prst="rect">
+            <a:avLst/>
+          </a:prstGeom>
+          <a:ln w="9525">
+            <a:solidFill>
+              <a:srgbClr val="D9D9D9"/>
+            </a:solidFill>
+          </a:ln>
+        </p:spPr>
+      </p:pic>
+      <p:sp>
+        <p:nvSpPr>
+          <p:cNvPr id="5" name="TextBox 4"/>
+          <p:cNvSpPr txBox="1"/>
+          <p:nvPr/>
+        </p:nvSpPr>
+        <p:spPr>
+          <a:xfrm>
+            <a:off x="2270964" y="5333710"/>
+            <a:ext cx="5699297" cy="198120"/>
+          </a:xfrm>
+          <a:prstGeom prst="rect">
+            <a:avLst/>
+          </a:prstGeom>
+          <a:noFill/>
+        </p:spPr>
+        <p:txBody>
+          <a:bodyPr wrap="square" lIns="0" rIns="0" tIns="0" bIns="0" anchor="t">
+            <a:spAutoFit/>
+          </a:bodyPr>
+          <a:lstStyle/>
+          <a:p>
+            <a:pPr algn="ctr">
+              <a:lnSpc>
+                <a:spcPct val="120000"/>
+              </a:lnSpc>
+            </a:pPr>
+            <a:r>
+              <a:rPr sz="980" b="0" i="0">
+                <a:solidFill>
+                  <a:srgbClr val="6B6B78"/>
+                </a:solidFill>
+                <a:latin typeface="Roboto"/>
+              </a:rPr>
+              <a:t>Painel de respostas</a:t>
+            </a:r>
+          </a:p>
+        </p:txBody>
+      </p:sp>
+      <p:pic>
+        <p:nvPicPr>
+          <p:cNvPr id="6" name="Picture 5" descr="c09-nao-encontrado.png"/>
+          <p:cNvPicPr>
+            <a:picLocks noChangeAspect="1"/>
+          </p:cNvPicPr>
+          <p:nvPr/>
+        </p:nvPicPr>
+        <p:blipFill>
+          <a:blip r:embed="rId4"/>
+          <a:stretch>
+            <a:fillRect/>
+          </a:stretch>
+        </p:blipFill>
+        <p:spPr>
+          <a:xfrm>
+            <a:off x="8275060" y="1676400"/>
+            <a:ext cx="1645976" cy="3562060"/>
+          </a:xfrm>
+          <a:prstGeom prst="rect">
+            <a:avLst/>
+          </a:prstGeom>
+          <a:ln w="9525">
+            <a:solidFill>
+              <a:srgbClr val="D9D9D9"/>
+            </a:solidFill>
+          </a:ln>
+        </p:spPr>
+      </p:pic>
+      <p:sp>
+        <p:nvSpPr>
+          <p:cNvPr id="7" name="TextBox 6"/>
+          <p:cNvSpPr txBox="1"/>
+          <p:nvPr/>
+        </p:nvSpPr>
+        <p:spPr>
+          <a:xfrm>
+            <a:off x="8275060" y="5333710"/>
+            <a:ext cx="1645976" cy="198120"/>
+          </a:xfrm>
+          <a:prstGeom prst="rect">
+            <a:avLst/>
+          </a:prstGeom>
+          <a:noFill/>
+        </p:spPr>
+        <p:txBody>
+          <a:bodyPr wrap="square" lIns="0" rIns="0" tIns="0" bIns="0" anchor="t">
+            <a:spAutoFit/>
+          </a:bodyPr>
+          <a:lstStyle/>
+          <a:p>
+            <a:pPr algn="ctr">
+              <a:lnSpc>
+                <a:spcPct val="120000"/>
+              </a:lnSpc>
+            </a:pPr>
+            <a:r>
+              <a:rPr sz="980" b="0" i="0">
+                <a:solidFill>
+                  <a:srgbClr val="6B6B78"/>
+                </a:solidFill>
+                <a:latin typeface="Roboto"/>
+              </a:rPr>
+              <a:t>Link do convite depois de despublicar</a:t>
+            </a:r>
+          </a:p>
+        </p:txBody>
+      </p:sp>
+      <p:sp>
+        <p:nvSpPr>
+          <p:cNvPr id="8" name="Rectangle 7"/>
+          <p:cNvSpPr/>
+          <p:nvPr/>
+        </p:nvSpPr>
+        <p:spPr>
+          <a:xfrm>
+            <a:off x="685800" y="5809960"/>
+            <a:ext cx="28575" cy="209840"/>
+          </a:xfrm>
+          <a:prstGeom prst="rect">
+            <a:avLst/>
+          </a:prstGeom>
+          <a:solidFill>
+            <a:srgbClr val="E94D1C"/>
+          </a:solidFill>
+          <a:ln>
+            <a:noFill/>
+          </a:ln>
+          <a:effectLst/>
+        </p:spPr>
+        <p:style>
+          <a:lnRef idx="1">
+            <a:schemeClr val="accent1"/>
+          </a:lnRef>
+          <a:fillRef idx="3">
+            <a:schemeClr val="accent1"/>
+          </a:fillRef>
+          <a:effectRef idx="2">
+            <a:schemeClr val="accent1"/>
+          </a:effectRef>
+          <a:fontRef idx="minor">
+            <a:schemeClr val="lt1"/>
+          </a:fontRef>
+        </p:style>
+        <p:txBody>
+          <a:bodyPr rtlCol="0" anchor="ctr" wrap="square" lIns="0" rIns="0" tIns="0" bIns="0"/>
+          <a:lstStyle/>
+          <a:p>
+            <a:pPr algn="ctr"/>
+          </a:p>
+        </p:txBody>
+      </p:sp>
+      <p:sp>
+        <p:nvSpPr>
+          <p:cNvPr id="9" name="TextBox 8"/>
+          <p:cNvSpPr txBox="1"/>
+          <p:nvPr/>
+        </p:nvSpPr>
+        <p:spPr>
+          <a:xfrm>
+            <a:off x="876300" y="5790910"/>
+            <a:ext cx="10629900" cy="343190"/>
+          </a:xfrm>
+          <a:prstGeom prst="rect">
+            <a:avLst/>
+          </a:prstGeom>
+          <a:noFill/>
+        </p:spPr>
+        <p:txBody>
+          <a:bodyPr wrap="square" lIns="0" rIns="0" tIns="0" bIns="0" anchor="t">
+            <a:spAutoFit/>
+          </a:bodyPr>
+          <a:lstStyle/>
+          <a:p>
+            <a:pPr algn="l">
+              <a:lnSpc>
+                <a:spcPct val="150000"/>
+              </a:lnSpc>
+            </a:pPr>
+            <a:r>
+              <a:rPr sz="1280" b="0" i="0">
+                <a:solidFill>
+                  <a:srgbClr val="3A3A44"/>
+                </a:solidFill>
+                <a:latin typeface="Roboto"/>
+              </a:rPr>
+              <a:t>Capturas da aplicação rodando localmente em 26/10/2026.</a:t>
+            </a:r>
+          </a:p>
+        </p:txBody>
+      </p:sp>
+      <p:sp>
+        <p:nvSpPr>
+          <p:cNvPr id="10" name="TextBox 9"/>
+          <p:cNvSpPr txBox="1"/>
+          <p:nvPr/>
+        </p:nvSpPr>
+        <p:spPr>
+          <a:xfrm>
+            <a:off x="685800" y="6324600"/>
+            <a:ext cx="6667500" cy="182880"/>
+          </a:xfrm>
+          <a:prstGeom prst="rect">
+            <a:avLst/>
+          </a:prstGeom>
+          <a:noFill/>
+        </p:spPr>
+        <p:txBody>
+          <a:bodyPr wrap="square" lIns="0" rIns="0" tIns="0" bIns="0" anchor="t">
+            <a:spAutoFit/>
+          </a:bodyPr>
+          <a:lstStyle/>
+          <a:p>
+            <a:pPr algn="l">
+              <a:lnSpc>
+                <a:spcPct val="120000"/>
+              </a:lnSpc>
+            </a:pPr>
+            <a:r>
+              <a:rPr sz="900" b="0" i="0">
+                <a:solidFill>
+                  <a:srgbClr val="6B6B78"/>
+                </a:solidFill>
+                <a:latin typeface="Roboto"/>
+              </a:rPr>
+              <a:t>Apêndice</a:t>
+            </a:r>
+          </a:p>
+        </p:txBody>
+      </p:sp>
+      <p:sp>
+        <p:nvSpPr>
+          <p:cNvPr id="11" name="TextBox 10"/>
+          <p:cNvSpPr txBox="1"/>
+          <p:nvPr/>
+        </p:nvSpPr>
+        <p:spPr>
+          <a:xfrm>
+            <a:off x="10477500" y="6324600"/>
+            <a:ext cx="1028700" cy="182880"/>
+          </a:xfrm>
+          <a:prstGeom prst="rect">
+            <a:avLst/>
+          </a:prstGeom>
+          <a:noFill/>
+        </p:spPr>
+        <p:txBody>
+          <a:bodyPr wrap="square" lIns="0" rIns="0" tIns="0" bIns="0" anchor="t">
+            <a:spAutoFit/>
+          </a:bodyPr>
+          <a:lstStyle/>
+          <a:p>
+            <a:pPr algn="r">
+              <a:lnSpc>
+                <a:spcPct val="120000"/>
+              </a:lnSpc>
+            </a:pPr>
+            <a:r>
+              <a:rPr sz="900" b="1" i="0">
+                <a:solidFill>
+                  <a:srgbClr val="21049A"/>
+                </a:solidFill>
+                <a:latin typeface="Roboto"/>
+              </a:rPr>
+              <a:t>19</a:t>
             </a:r>
           </a:p>
         </p:txBody>

</xml_diff>

<commit_message>
docs: correções da revisão do deck do T3, com o quadro Kanban e a CI no apêndice
</commit_message>
<xml_diff>
--- a/trabalhos/T3-Apresentacao-Intermediaria.pptx
+++ b/trabalhos/T3-Apresentacao-Intermediaria.pptx
@@ -27,6 +27,7 @@
     <p:sldId id="272" r:id="rId27"/>
     <p:sldId id="273" r:id="rId28"/>
     <p:sldId id="274" r:id="rId29"/>
+    <p:sldId id="275" r:id="rId30"/>
   </p:sldIdLst>
   <p:sldSz cx="12192000" cy="6858000"/>
   <p:notesSz cx="6858000" cy="9144000"/>
@@ -611,7 +612,7 @@
           <a:lstStyle/>
           <a:p>
             <a:r>
-              <a:t>Gabriel. As regras que vou mostrar são as que estão hoje no código. A primeira versão das rotas e dessas regras foi minha, inclusive a transação com a trava na linha do convite. Na integração, algumas regras mudaram de camada, e eu conto isso no fim do bloco. Fecho do slide: o Domínio calcula quantas vagas a resposta pede, e a camada de Dados confere o teto dentro da transação.</a:t>
+              <a:t>Gabriel. As regras que vou mostrar são as que estão hoje no código. A primeira versão das rotas e dessas regras foi minha, inclusive a transação com a trava na linha do convite. Na integração, algumas regras mudaram de camada, e eu conto isso no fim do bloco. Quando não cabe, a camada de Dados devolve a recusa ao Domínio, que dá nome ao erro, e a Apresentação responde. Fecho do slide: o Domínio calcula quantas vagas a resposta pede, e a camada de Dados confere o teto dentro da transação.</a:t>
             </a:r>
           </a:p>
         </p:txBody>
@@ -751,7 +752,7 @@
           <a:lstStyle/>
           <a:p>
             <a:r>
-              <a:t>Este slide fica na tela enquanto o Guilherme assume o compartilhamento. Abrir dizendo: a conta já está criada para poupar tempo; cadastro e entrada estão no apêndice. Depois da demonstração, na mesma tela: o quadro do Azure Boards (Guilherme), o GitHub (Tiago) e a organização do trabalho (Andreas).</a:t>
+              <a:t>Este slide fica na tela enquanto o Guilherme assume o compartilhamento. Abrir dizendo: a conta já está criada para poupar tempo; a tela de entrada está no apêndice. O Guilherme opera a tela em todos os passos, e o Gabriel narra os passos do convidado. Depois da demonstração, na mesma tela: o quadro do Azure Boards (Guilherme), o GitHub (Tiago) e a organização do trabalho (Andreas).</a:t>
             </a:r>
           </a:p>
         </p:txBody>
@@ -12736,7 +12737,7 @@
                 </a:solidFill>
                 <a:latin typeface="Roboto"/>
               </a:rPr>
-              <a:t>TRABALHO 3, APRESENTAÇÃO INTERMEDIÁRIA</a:t>
+              <a:t>TRABALHO 3, APRESENTAÇÃO INTERMEDIÁRIA, TIME 04</a:t>
             </a:r>
           </a:p>
         </p:txBody>
@@ -12883,7 +12884,7 @@
       </p:sp>
       <p:pic>
         <p:nvPicPr>
-          <p:cNvPr id="8" name="Picture 7" descr="c03-convite.png"/>
+          <p:cNvPr id="8" name="Picture 7" descr="c03-capa.png"/>
           <p:cNvPicPr>
             <a:picLocks noChangeAspect="1"/>
           </p:cNvPicPr>
@@ -12898,7 +12899,7 @@
         <p:spPr>
           <a:xfrm>
             <a:off x="8858250" y="1143000"/>
-            <a:ext cx="2112654" cy="4572000"/>
+            <a:ext cx="2215006" cy="4572000"/>
           </a:xfrm>
           <a:prstGeom prst="rect">
             <a:avLst/>
@@ -13172,22 +13173,6 @@
                 <a:latin typeface="Roboto"/>
               </a:rPr>
               <a:t>27/10/2026</a:t>
-            </a:r>
-          </a:p>
-          <a:p>
-            <a:pPr>
-              <a:lnSpc>
-                <a:spcPct val="140000"/>
-              </a:lnSpc>
-            </a:pPr>
-            <a:r>
-              <a:rPr sz="980" b="0" i="0">
-                <a:solidFill>
-                  <a:srgbClr val="E0DBF2"/>
-                </a:solidFill>
-                <a:latin typeface="Roboto"/>
-              </a:rPr>
-              <a:t>Time 04</a:t>
             </a:r>
           </a:p>
         </p:txBody>
@@ -13289,12 +13274,12 @@
         </p:nvSpPr>
         <p:spPr>
           <a:xfrm>
-            <a:off x="685800" y="1933575"/>
-            <a:ext cx="10820400" cy="990600"/>
+            <a:off x="685800" y="1819275"/>
+            <a:ext cx="10820400" cy="1066800"/>
           </a:xfrm>
           <a:prstGeom prst="roundRect">
             <a:avLst>
-              <a:gd name="adj" fmla="val 3846"/>
+              <a:gd name="adj" fmla="val 3571"/>
             </a:avLst>
           </a:prstGeom>
           <a:solidFill>
@@ -13335,12 +13320,12 @@
         </p:nvSpPr>
         <p:spPr>
           <a:xfrm>
-            <a:off x="685800" y="1933575"/>
-            <a:ext cx="1428750" cy="990600"/>
+            <a:off x="685800" y="1819275"/>
+            <a:ext cx="1295400" cy="1066800"/>
           </a:xfrm>
           <a:prstGeom prst="roundRect">
             <a:avLst>
-              <a:gd name="adj" fmla="val 3846"/>
+              <a:gd name="adj" fmla="val 3571"/>
             </a:avLst>
           </a:prstGeom>
           <a:solidFill>
@@ -13381,8 +13366,8 @@
         </p:nvSpPr>
         <p:spPr>
           <a:xfrm>
-            <a:off x="685800" y="2324100"/>
-            <a:ext cx="1428750" cy="228600"/>
+            <a:off x="685800" y="2238375"/>
+            <a:ext cx="1295400" cy="243840"/>
           </a:xfrm>
           <a:prstGeom prst="rect">
             <a:avLst/>
@@ -13401,7 +13386,7 @@
               </a:lnSpc>
             </a:pPr>
             <a:r>
-              <a:rPr sz="1120" b="1" i="0">
+              <a:rPr sz="1200" b="1" i="0">
                 <a:solidFill>
                   <a:srgbClr val="FFFFFF"/>
                 </a:solidFill>
@@ -13420,12 +13405,12 @@
         </p:nvSpPr>
         <p:spPr>
           <a:xfrm>
-            <a:off x="685800" y="3000375"/>
-            <a:ext cx="10820400" cy="990600"/>
+            <a:off x="685800" y="2962275"/>
+            <a:ext cx="10820400" cy="1066800"/>
           </a:xfrm>
           <a:prstGeom prst="roundRect">
             <a:avLst>
-              <a:gd name="adj" fmla="val 3846"/>
+              <a:gd name="adj" fmla="val 3571"/>
             </a:avLst>
           </a:prstGeom>
           <a:solidFill>
@@ -13466,12 +13451,12 @@
         </p:nvSpPr>
         <p:spPr>
           <a:xfrm>
-            <a:off x="685800" y="3000375"/>
-            <a:ext cx="1428750" cy="990600"/>
+            <a:off x="685800" y="2962275"/>
+            <a:ext cx="1295400" cy="1066800"/>
           </a:xfrm>
           <a:prstGeom prst="roundRect">
             <a:avLst>
-              <a:gd name="adj" fmla="val 3846"/>
+              <a:gd name="adj" fmla="val 3571"/>
             </a:avLst>
           </a:prstGeom>
           <a:solidFill>
@@ -13512,8 +13497,8 @@
         </p:nvSpPr>
         <p:spPr>
           <a:xfrm>
-            <a:off x="685800" y="3390900"/>
-            <a:ext cx="1428750" cy="228600"/>
+            <a:off x="685800" y="3381375"/>
+            <a:ext cx="1295400" cy="243840"/>
           </a:xfrm>
           <a:prstGeom prst="rect">
             <a:avLst/>
@@ -13532,7 +13517,7 @@
               </a:lnSpc>
             </a:pPr>
             <a:r>
-              <a:rPr sz="1120" b="1" i="0">
+              <a:rPr sz="1200" b="1" i="0">
                 <a:solidFill>
                   <a:srgbClr val="FFFFFF"/>
                 </a:solidFill>
@@ -13551,12 +13536,12 @@
         </p:nvSpPr>
         <p:spPr>
           <a:xfrm>
-            <a:off x="685800" y="4067175"/>
-            <a:ext cx="10820400" cy="990600"/>
+            <a:off x="685800" y="4105275"/>
+            <a:ext cx="10820400" cy="1066800"/>
           </a:xfrm>
           <a:prstGeom prst="roundRect">
             <a:avLst>
-              <a:gd name="adj" fmla="val 3846"/>
+              <a:gd name="adj" fmla="val 3571"/>
             </a:avLst>
           </a:prstGeom>
           <a:solidFill>
@@ -13597,12 +13582,12 @@
         </p:nvSpPr>
         <p:spPr>
           <a:xfrm>
-            <a:off x="685800" y="4067175"/>
-            <a:ext cx="1428750" cy="990600"/>
+            <a:off x="685800" y="4105275"/>
+            <a:ext cx="1295400" cy="1066800"/>
           </a:xfrm>
           <a:prstGeom prst="roundRect">
             <a:avLst>
-              <a:gd name="adj" fmla="val 3846"/>
+              <a:gd name="adj" fmla="val 3571"/>
             </a:avLst>
           </a:prstGeom>
           <a:solidFill>
@@ -13643,8 +13628,8 @@
         </p:nvSpPr>
         <p:spPr>
           <a:xfrm>
-            <a:off x="685800" y="4457700"/>
-            <a:ext cx="1428750" cy="228600"/>
+            <a:off x="685800" y="4524375"/>
+            <a:ext cx="1295400" cy="243840"/>
           </a:xfrm>
           <a:prstGeom prst="rect">
             <a:avLst/>
@@ -13663,7 +13648,7 @@
               </a:lnSpc>
             </a:pPr>
             <a:r>
-              <a:rPr sz="1120" b="1" i="0">
+              <a:rPr sz="1200" b="1" i="0">
                 <a:solidFill>
                   <a:srgbClr val="FFFFFF"/>
                 </a:solidFill>
@@ -13682,12 +13667,12 @@
         </p:nvSpPr>
         <p:spPr>
           <a:xfrm>
-            <a:off x="2286000" y="2047875"/>
-            <a:ext cx="1428750" cy="762000"/>
+            <a:off x="2114550" y="1914525"/>
+            <a:ext cx="1232807" cy="876300"/>
           </a:xfrm>
           <a:prstGeom prst="roundRect">
             <a:avLst>
-              <a:gd name="adj" fmla="val 5000"/>
+              <a:gd name="adj" fmla="val 4347"/>
             </a:avLst>
           </a:prstGeom>
           <a:solidFill>
@@ -13730,8 +13715,8 @@
         </p:nvSpPr>
         <p:spPr>
           <a:xfrm>
-            <a:off x="2381250" y="2124075"/>
-            <a:ext cx="1238250" cy="609600"/>
+            <a:off x="2200275" y="1971675"/>
+            <a:ext cx="1061357" cy="762000"/>
           </a:xfrm>
           <a:prstGeom prst="rect">
             <a:avLst/>
@@ -13746,17 +13731,17 @@
           <a:p>
             <a:pPr algn="l">
               <a:lnSpc>
-                <a:spcPct val="120000"/>
+                <a:spcPct val="115000"/>
               </a:lnSpc>
             </a:pPr>
             <a:r>
-              <a:rPr sz="1010" b="0" i="0">
+              <a:rPr sz="1120" b="0" i="0">
                 <a:solidFill>
                   <a:srgbClr val="3A3A44"/>
                 </a:solidFill>
                 <a:latin typeface="Roboto"/>
               </a:rPr>
-              <a:t>Recebe a resposta e confere o formato e o limite de tráfego</a:t>
+              <a:t>Confere o formato e o limite de tráfego</a:t>
             </a:r>
           </a:p>
         </p:txBody>
@@ -13769,12 +13754,12 @@
         </p:nvSpPr>
         <p:spPr>
           <a:xfrm>
-            <a:off x="3838575" y="3114675"/>
-            <a:ext cx="1428750" cy="762000"/>
+            <a:off x="3461657" y="3057525"/>
+            <a:ext cx="1232807" cy="876300"/>
           </a:xfrm>
           <a:prstGeom prst="roundRect">
             <a:avLst>
-              <a:gd name="adj" fmla="val 5000"/>
+              <a:gd name="adj" fmla="val 4347"/>
             </a:avLst>
           </a:prstGeom>
           <a:solidFill>
@@ -13817,8 +13802,8 @@
         </p:nvSpPr>
         <p:spPr>
           <a:xfrm>
-            <a:off x="3933825" y="3190875"/>
-            <a:ext cx="1238250" cy="609600"/>
+            <a:off x="3547382" y="3114675"/>
+            <a:ext cx="1061357" cy="762000"/>
           </a:xfrm>
           <a:prstGeom prst="rect">
             <a:avLst/>
@@ -13833,11 +13818,11 @@
           <a:p>
             <a:pPr algn="l">
               <a:lnSpc>
-                <a:spcPct val="120000"/>
+                <a:spcPct val="115000"/>
               </a:lnSpc>
             </a:pPr>
             <a:r>
-              <a:rPr sz="1010" b="0" i="0">
+              <a:rPr sz="1120" b="0" i="0">
                 <a:solidFill>
                   <a:srgbClr val="3A3A44"/>
                 </a:solidFill>
@@ -13856,12 +13841,12 @@
         </p:nvSpPr>
         <p:spPr>
           <a:xfrm>
-            <a:off x="5391150" y="3114675"/>
-            <a:ext cx="1428750" cy="762000"/>
+            <a:off x="4808764" y="3057525"/>
+            <a:ext cx="1232807" cy="876300"/>
           </a:xfrm>
           <a:prstGeom prst="roundRect">
             <a:avLst>
-              <a:gd name="adj" fmla="val 5000"/>
+              <a:gd name="adj" fmla="val 4347"/>
             </a:avLst>
           </a:prstGeom>
           <a:solidFill>
@@ -13904,8 +13889,8 @@
         </p:nvSpPr>
         <p:spPr>
           <a:xfrm>
-            <a:off x="5486400" y="3190875"/>
-            <a:ext cx="1238250" cy="609600"/>
+            <a:off x="4894489" y="3114675"/>
+            <a:ext cx="1061357" cy="762000"/>
           </a:xfrm>
           <a:prstGeom prst="rect">
             <a:avLst/>
@@ -13920,17 +13905,17 @@
           <a:p>
             <a:pPr algn="l">
               <a:lnSpc>
-                <a:spcPct val="120000"/>
+                <a:spcPct val="115000"/>
               </a:lnSpc>
             </a:pPr>
             <a:r>
-              <a:rPr sz="1010" b="0" i="0">
+              <a:rPr sz="1120" b="0" i="0">
                 <a:solidFill>
                   <a:srgbClr val="3A3A44"/>
                 </a:solidFill>
                 <a:latin typeface="Roboto"/>
               </a:rPr>
-              <a:t>Calcula as vagas que a resposta pede</a:t>
+              <a:t>Calcula as vagas pedidas</a:t>
             </a:r>
           </a:p>
         </p:txBody>
@@ -13943,12 +13928,12 @@
         </p:nvSpPr>
         <p:spPr>
           <a:xfrm>
-            <a:off x="6943725" y="4181475"/>
-            <a:ext cx="1428750" cy="762000"/>
+            <a:off x="6155871" y="4200525"/>
+            <a:ext cx="1232807" cy="876300"/>
           </a:xfrm>
           <a:prstGeom prst="roundRect">
             <a:avLst>
-              <a:gd name="adj" fmla="val 5000"/>
+              <a:gd name="adj" fmla="val 4347"/>
             </a:avLst>
           </a:prstGeom>
           <a:solidFill>
@@ -13991,8 +13976,8 @@
         </p:nvSpPr>
         <p:spPr>
           <a:xfrm>
-            <a:off x="7038975" y="4257675"/>
-            <a:ext cx="1238250" cy="609600"/>
+            <a:off x="6241596" y="4257675"/>
+            <a:ext cx="1061357" cy="762000"/>
           </a:xfrm>
           <a:prstGeom prst="rect">
             <a:avLst/>
@@ -14007,17 +13992,17 @@
           <a:p>
             <a:pPr algn="l">
               <a:lnSpc>
-                <a:spcPct val="120000"/>
+                <a:spcPct val="115000"/>
               </a:lnSpc>
             </a:pPr>
             <a:r>
-              <a:rPr sz="1010" b="0" i="0">
+              <a:rPr sz="1120" b="0" i="0">
                 <a:solidFill>
                   <a:srgbClr val="3A3A44"/>
                 </a:solidFill>
                 <a:latin typeface="Roboto"/>
               </a:rPr>
-              <a:t>Abre a transação e trava a linha do convite</a:t>
+              <a:t>Trava o convite e soma as vagas ocupadas</a:t>
             </a:r>
           </a:p>
         </p:txBody>
@@ -14030,12 +14015,12 @@
         </p:nvSpPr>
         <p:spPr>
           <a:xfrm>
-            <a:off x="8496300" y="4181475"/>
-            <a:ext cx="1428750" cy="762000"/>
+            <a:off x="7502979" y="4200525"/>
+            <a:ext cx="1232807" cy="876300"/>
           </a:xfrm>
           <a:prstGeom prst="roundRect">
             <a:avLst>
-              <a:gd name="adj" fmla="val 5000"/>
+              <a:gd name="adj" fmla="val 4347"/>
             </a:avLst>
           </a:prstGeom>
           <a:solidFill>
@@ -14078,8 +14063,8 @@
         </p:nvSpPr>
         <p:spPr>
           <a:xfrm>
-            <a:off x="8591550" y="4257675"/>
-            <a:ext cx="1238250" cy="609600"/>
+            <a:off x="7588704" y="4257675"/>
+            <a:ext cx="1061357" cy="762000"/>
           </a:xfrm>
           <a:prstGeom prst="rect">
             <a:avLst/>
@@ -14094,17 +14079,17 @@
           <a:p>
             <a:pPr algn="l">
               <a:lnSpc>
-                <a:spcPct val="120000"/>
+                <a:spcPct val="115000"/>
               </a:lnSpc>
             </a:pPr>
             <a:r>
-              <a:rPr sz="1010" b="0" i="0">
+              <a:rPr sz="1120" b="0" i="0">
                 <a:solidFill>
                   <a:srgbClr val="3A3A44"/>
                 </a:solidFill>
                 <a:latin typeface="Roboto"/>
               </a:rPr>
-              <a:t>Soma as vagas ocupadas, confere o teto e grava, ou devolve a recusa</a:t>
+              <a:t>Confere o teto e grava, ou devolve a recusa</a:t>
             </a:r>
           </a:p>
         </p:txBody>
@@ -14117,12 +14102,99 @@
         </p:nvSpPr>
         <p:spPr>
           <a:xfrm>
-            <a:off x="10048875" y="2047875"/>
-            <a:ext cx="1428750" cy="762000"/>
+            <a:off x="8850086" y="3057525"/>
+            <a:ext cx="1232807" cy="876300"/>
           </a:xfrm>
           <a:prstGeom prst="roundRect">
             <a:avLst>
-              <a:gd name="adj" fmla="val 5000"/>
+              <a:gd name="adj" fmla="val 4347"/>
+            </a:avLst>
+          </a:prstGeom>
+          <a:solidFill>
+            <a:srgbClr val="FFFFFF"/>
+          </a:solidFill>
+          <a:ln w="19050">
+            <a:solidFill>
+              <a:srgbClr val="E94D1C"/>
+            </a:solidFill>
+          </a:ln>
+          <a:effectLst/>
+        </p:spPr>
+        <p:style>
+          <a:lnRef idx="1">
+            <a:schemeClr val="accent1"/>
+          </a:lnRef>
+          <a:fillRef idx="3">
+            <a:schemeClr val="accent1"/>
+          </a:fillRef>
+          <a:effectRef idx="2">
+            <a:schemeClr val="accent1"/>
+          </a:effectRef>
+          <a:fontRef idx="minor">
+            <a:schemeClr val="lt1"/>
+          </a:fontRef>
+        </p:style>
+        <p:txBody>
+          <a:bodyPr rtlCol="0" anchor="ctr" wrap="square" lIns="0" rIns="0" tIns="0" bIns="0"/>
+          <a:lstStyle/>
+          <a:p>
+            <a:pPr algn="ctr"/>
+          </a:p>
+        </p:txBody>
+      </p:sp>
+      <p:sp>
+        <p:nvSpPr>
+          <p:cNvPr id="24" name="TextBox 23"/>
+          <p:cNvSpPr txBox="1"/>
+          <p:nvPr/>
+        </p:nvSpPr>
+        <p:spPr>
+          <a:xfrm>
+            <a:off x="8935811" y="3114675"/>
+            <a:ext cx="1061357" cy="762000"/>
+          </a:xfrm>
+          <a:prstGeom prst="rect">
+            <a:avLst/>
+          </a:prstGeom>
+          <a:noFill/>
+        </p:spPr>
+        <p:txBody>
+          <a:bodyPr wrap="square" lIns="0" rIns="0" tIns="0" bIns="0" anchor="ctr">
+            <a:spAutoFit/>
+          </a:bodyPr>
+          <a:lstStyle/>
+          <a:p>
+            <a:pPr algn="l">
+              <a:lnSpc>
+                <a:spcPct val="115000"/>
+              </a:lnSpc>
+            </a:pPr>
+            <a:r>
+              <a:rPr sz="1120" b="0" i="0">
+                <a:solidFill>
+                  <a:srgbClr val="3A3A44"/>
+                </a:solidFill>
+                <a:latin typeface="Roboto"/>
+              </a:rPr>
+              <a:t>Dá nome à recusa: convite lotado</a:t>
+            </a:r>
+          </a:p>
+        </p:txBody>
+      </p:sp>
+      <p:sp>
+        <p:nvSpPr>
+          <p:cNvPr id="25" name="Rounded Rectangle 24"/>
+          <p:cNvSpPr/>
+          <p:nvPr/>
+        </p:nvSpPr>
+        <p:spPr>
+          <a:xfrm>
+            <a:off x="10197193" y="1914525"/>
+            <a:ext cx="1232807" cy="876300"/>
+          </a:xfrm>
+          <a:prstGeom prst="roundRect">
+            <a:avLst>
+              <a:gd name="adj" fmla="val 4347"/>
             </a:avLst>
           </a:prstGeom>
           <a:solidFill>
@@ -14159,14 +14231,14 @@
       </p:sp>
       <p:sp>
         <p:nvSpPr>
-          <p:cNvPr id="24" name="TextBox 23"/>
+          <p:cNvPr id="26" name="TextBox 25"/>
           <p:cNvSpPr txBox="1"/>
           <p:nvPr/>
         </p:nvSpPr>
         <p:spPr>
           <a:xfrm>
-            <a:off x="10144125" y="2124075"/>
-            <a:ext cx="1238250" cy="609600"/>
+            <a:off x="10282918" y="1971675"/>
+            <a:ext cx="1061357" cy="762000"/>
           </a:xfrm>
           <a:prstGeom prst="rect">
             <a:avLst/>
@@ -14181,11 +14253,11 @@
           <a:p>
             <a:pPr algn="l">
               <a:lnSpc>
-                <a:spcPct val="120000"/>
+                <a:spcPct val="115000"/>
               </a:lnSpc>
             </a:pPr>
             <a:r>
-              <a:rPr sz="1010" b="0" i="0">
+              <a:rPr sz="1120" b="0" i="0">
                 <a:solidFill>
                   <a:srgbClr val="3A3A44"/>
                 </a:solidFill>
@@ -14198,14 +14270,14 @@
       </p:sp>
       <p:cxnSp>
         <p:nvCxnSpPr>
-          <p:cNvPr id="25" name="Connector 24"/>
+          <p:cNvPr id="27" name="Connector 26"/>
           <p:cNvCxnSpPr/>
           <p:nvPr/>
         </p:nvCxnSpPr>
         <p:spPr>
           <a:xfrm>
-            <a:off x="3714750" y="2428875"/>
-            <a:ext cx="61912" cy="0"/>
+            <a:off x="3347357" y="2352675"/>
+            <a:ext cx="57150" cy="0"/>
           </a:xfrm>
           <a:prstGeom prst="line">
             <a:avLst/>
@@ -14214,77 +14286,6 @@
             <a:solidFill>
               <a:srgbClr val="6B6B78"/>
             </a:solidFill>
-          </a:ln>
-        </p:spPr>
-        <p:style>
-          <a:lnRef idx="2">
-            <a:schemeClr val="accent1"/>
-          </a:lnRef>
-          <a:fillRef idx="0">
-            <a:schemeClr val="accent1"/>
-          </a:fillRef>
-          <a:effectRef idx="1">
-            <a:schemeClr val="accent1"/>
-          </a:effectRef>
-          <a:fontRef idx="minor">
-            <a:schemeClr val="tx1"/>
-          </a:fontRef>
-        </p:style>
-      </p:cxnSp>
-      <p:cxnSp>
-        <p:nvCxnSpPr>
-          <p:cNvPr id="26" name="Connector 25"/>
-          <p:cNvCxnSpPr/>
-          <p:nvPr/>
-        </p:nvCxnSpPr>
-        <p:spPr>
-          <a:xfrm>
-            <a:off x="3776662" y="2428875"/>
-            <a:ext cx="0" cy="1066800"/>
-          </a:xfrm>
-          <a:prstGeom prst="line">
-            <a:avLst/>
-          </a:prstGeom>
-          <a:ln w="19050">
-            <a:solidFill>
-              <a:srgbClr val="6B6B78"/>
-            </a:solidFill>
-          </a:ln>
-        </p:spPr>
-        <p:style>
-          <a:lnRef idx="2">
-            <a:schemeClr val="accent1"/>
-          </a:lnRef>
-          <a:fillRef idx="0">
-            <a:schemeClr val="accent1"/>
-          </a:fillRef>
-          <a:effectRef idx="1">
-            <a:schemeClr val="accent1"/>
-          </a:effectRef>
-          <a:fontRef idx="minor">
-            <a:schemeClr val="tx1"/>
-          </a:fontRef>
-        </p:style>
-      </p:cxnSp>
-      <p:cxnSp>
-        <p:nvCxnSpPr>
-          <p:cNvPr id="27" name="Connector 26"/>
-          <p:cNvCxnSpPr/>
-          <p:nvPr/>
-        </p:nvCxnSpPr>
-        <p:spPr>
-          <a:xfrm>
-            <a:off x="3776662" y="3495675"/>
-            <a:ext cx="61913" cy="0"/>
-          </a:xfrm>
-          <a:prstGeom prst="line">
-            <a:avLst/>
-          </a:prstGeom>
-          <a:ln w="19050">
-            <a:solidFill>
-              <a:srgbClr val="6B6B78"/>
-            </a:solidFill>
-            <a:tailEnd type="triangle" w="med" len="med"/>
           </a:ln>
         </p:spPr>
         <p:style>
@@ -14310,8 +14311,8 @@
         </p:nvCxnSpPr>
         <p:spPr>
           <a:xfrm>
-            <a:off x="5267325" y="3495675"/>
-            <a:ext cx="123825" cy="0"/>
+            <a:off x="3404507" y="2352675"/>
+            <a:ext cx="0" cy="1143000"/>
           </a:xfrm>
           <a:prstGeom prst="line">
             <a:avLst/>
@@ -14320,7 +14321,6 @@
             <a:solidFill>
               <a:srgbClr val="6B6B78"/>
             </a:solidFill>
-            <a:tailEnd type="triangle" w="med" len="med"/>
           </a:ln>
         </p:spPr>
         <p:style>
@@ -14346,8 +14346,8 @@
         </p:nvCxnSpPr>
         <p:spPr>
           <a:xfrm>
-            <a:off x="6819900" y="3495675"/>
-            <a:ext cx="61912" cy="0"/>
+            <a:off x="3404507" y="3495675"/>
+            <a:ext cx="57150" cy="0"/>
           </a:xfrm>
           <a:prstGeom prst="line">
             <a:avLst/>
@@ -14356,6 +14356,7 @@
             <a:solidFill>
               <a:srgbClr val="6B6B78"/>
             </a:solidFill>
+            <a:tailEnd type="triangle" w="med" len="med"/>
           </a:ln>
         </p:spPr>
         <p:style>
@@ -14381,8 +14382,8 @@
         </p:nvCxnSpPr>
         <p:spPr>
           <a:xfrm>
-            <a:off x="6881812" y="3495675"/>
-            <a:ext cx="0" cy="1066800"/>
+            <a:off x="4694464" y="3495675"/>
+            <a:ext cx="114300" cy="0"/>
           </a:xfrm>
           <a:prstGeom prst="line">
             <a:avLst/>
@@ -14391,6 +14392,7 @@
             <a:solidFill>
               <a:srgbClr val="6B6B78"/>
             </a:solidFill>
+            <a:tailEnd type="triangle" w="med" len="med"/>
           </a:ln>
         </p:spPr>
         <p:style>
@@ -14416,8 +14418,8 @@
         </p:nvCxnSpPr>
         <p:spPr>
           <a:xfrm>
-            <a:off x="6881812" y="4562475"/>
-            <a:ext cx="61913" cy="0"/>
+            <a:off x="6041571" y="3495675"/>
+            <a:ext cx="57150" cy="0"/>
           </a:xfrm>
           <a:prstGeom prst="line">
             <a:avLst/>
@@ -14426,7 +14428,6 @@
             <a:solidFill>
               <a:srgbClr val="6B6B78"/>
             </a:solidFill>
-            <a:tailEnd type="triangle" w="med" len="med"/>
           </a:ln>
         </p:spPr>
         <p:style>
@@ -14452,8 +14453,8 @@
         </p:nvCxnSpPr>
         <p:spPr>
           <a:xfrm>
-            <a:off x="8372475" y="4562475"/>
-            <a:ext cx="123825" cy="0"/>
+            <a:off x="6098721" y="3495675"/>
+            <a:ext cx="0" cy="1143000"/>
           </a:xfrm>
           <a:prstGeom prst="line">
             <a:avLst/>
@@ -14462,7 +14463,6 @@
             <a:solidFill>
               <a:srgbClr val="6B6B78"/>
             </a:solidFill>
-            <a:tailEnd type="triangle" w="med" len="med"/>
           </a:ln>
         </p:spPr>
         <p:style>
@@ -14488,8 +14488,8 @@
         </p:nvCxnSpPr>
         <p:spPr>
           <a:xfrm>
-            <a:off x="9925050" y="4562475"/>
-            <a:ext cx="61912" cy="0"/>
+            <a:off x="6098721" y="4638675"/>
+            <a:ext cx="57150" cy="0"/>
           </a:xfrm>
           <a:prstGeom prst="line">
             <a:avLst/>
@@ -14498,6 +14498,7 @@
             <a:solidFill>
               <a:srgbClr val="6B6B78"/>
             </a:solidFill>
+            <a:tailEnd type="triangle" w="med" len="med"/>
           </a:ln>
         </p:spPr>
         <p:style>
@@ -14522,9 +14523,9 @@
           <p:nvPr/>
         </p:nvCxnSpPr>
         <p:spPr>
-          <a:xfrm flipV="1">
-            <a:off x="9986962" y="2428875"/>
-            <a:ext cx="0" cy="2133600"/>
+          <a:xfrm>
+            <a:off x="7388679" y="4638675"/>
+            <a:ext cx="114300" cy="0"/>
           </a:xfrm>
           <a:prstGeom prst="line">
             <a:avLst/>
@@ -14533,6 +14534,7 @@
             <a:solidFill>
               <a:srgbClr val="6B6B78"/>
             </a:solidFill>
+            <a:tailEnd type="triangle" w="med" len="med"/>
           </a:ln>
         </p:spPr>
         <p:style>
@@ -14558,8 +14560,78 @@
         </p:nvCxnSpPr>
         <p:spPr>
           <a:xfrm>
-            <a:off x="9986962" y="2428875"/>
-            <a:ext cx="61913" cy="0"/>
+            <a:off x="8735786" y="4638675"/>
+            <a:ext cx="57150" cy="0"/>
+          </a:xfrm>
+          <a:prstGeom prst="line">
+            <a:avLst/>
+          </a:prstGeom>
+          <a:ln w="19050">
+            <a:solidFill>
+              <a:srgbClr val="6B6B78"/>
+            </a:solidFill>
+          </a:ln>
+        </p:spPr>
+        <p:style>
+          <a:lnRef idx="2">
+            <a:schemeClr val="accent1"/>
+          </a:lnRef>
+          <a:fillRef idx="0">
+            <a:schemeClr val="accent1"/>
+          </a:fillRef>
+          <a:effectRef idx="1">
+            <a:schemeClr val="accent1"/>
+          </a:effectRef>
+          <a:fontRef idx="minor">
+            <a:schemeClr val="tx1"/>
+          </a:fontRef>
+        </p:style>
+      </p:cxnSp>
+      <p:cxnSp>
+        <p:nvCxnSpPr>
+          <p:cNvPr id="36" name="Connector 35"/>
+          <p:cNvCxnSpPr/>
+          <p:nvPr/>
+        </p:nvCxnSpPr>
+        <p:spPr>
+          <a:xfrm flipV="1">
+            <a:off x="8792936" y="3495675"/>
+            <a:ext cx="0" cy="1143000"/>
+          </a:xfrm>
+          <a:prstGeom prst="line">
+            <a:avLst/>
+          </a:prstGeom>
+          <a:ln w="19050">
+            <a:solidFill>
+              <a:srgbClr val="6B6B78"/>
+            </a:solidFill>
+          </a:ln>
+        </p:spPr>
+        <p:style>
+          <a:lnRef idx="2">
+            <a:schemeClr val="accent1"/>
+          </a:lnRef>
+          <a:fillRef idx="0">
+            <a:schemeClr val="accent1"/>
+          </a:fillRef>
+          <a:effectRef idx="1">
+            <a:schemeClr val="accent1"/>
+          </a:effectRef>
+          <a:fontRef idx="minor">
+            <a:schemeClr val="tx1"/>
+          </a:fontRef>
+        </p:style>
+      </p:cxnSp>
+      <p:cxnSp>
+        <p:nvCxnSpPr>
+          <p:cNvPr id="37" name="Connector 36"/>
+          <p:cNvCxnSpPr/>
+          <p:nvPr/>
+        </p:nvCxnSpPr>
+        <p:spPr>
+          <a:xfrm>
+            <a:off x="8792936" y="3495675"/>
+            <a:ext cx="57150" cy="0"/>
           </a:xfrm>
           <a:prstGeom prst="line">
             <a:avLst/>
@@ -14586,9 +14658,115 @@
           </a:fontRef>
         </p:style>
       </p:cxnSp>
-      <p:sp>
-        <p:nvSpPr>
-          <p:cNvPr id="36" name="Rectangle 35"/>
+      <p:cxnSp>
+        <p:nvCxnSpPr>
+          <p:cNvPr id="38" name="Connector 37"/>
+          <p:cNvCxnSpPr/>
+          <p:nvPr/>
+        </p:nvCxnSpPr>
+        <p:spPr>
+          <a:xfrm>
+            <a:off x="10082893" y="3495675"/>
+            <a:ext cx="57150" cy="0"/>
+          </a:xfrm>
+          <a:prstGeom prst="line">
+            <a:avLst/>
+          </a:prstGeom>
+          <a:ln w="19050">
+            <a:solidFill>
+              <a:srgbClr val="6B6B78"/>
+            </a:solidFill>
+          </a:ln>
+        </p:spPr>
+        <p:style>
+          <a:lnRef idx="2">
+            <a:schemeClr val="accent1"/>
+          </a:lnRef>
+          <a:fillRef idx="0">
+            <a:schemeClr val="accent1"/>
+          </a:fillRef>
+          <a:effectRef idx="1">
+            <a:schemeClr val="accent1"/>
+          </a:effectRef>
+          <a:fontRef idx="minor">
+            <a:schemeClr val="tx1"/>
+          </a:fontRef>
+        </p:style>
+      </p:cxnSp>
+      <p:cxnSp>
+        <p:nvCxnSpPr>
+          <p:cNvPr id="39" name="Connector 38"/>
+          <p:cNvCxnSpPr/>
+          <p:nvPr/>
+        </p:nvCxnSpPr>
+        <p:spPr>
+          <a:xfrm flipV="1">
+            <a:off x="10140043" y="2352675"/>
+            <a:ext cx="0" cy="1143000"/>
+          </a:xfrm>
+          <a:prstGeom prst="line">
+            <a:avLst/>
+          </a:prstGeom>
+          <a:ln w="19050">
+            <a:solidFill>
+              <a:srgbClr val="6B6B78"/>
+            </a:solidFill>
+          </a:ln>
+        </p:spPr>
+        <p:style>
+          <a:lnRef idx="2">
+            <a:schemeClr val="accent1"/>
+          </a:lnRef>
+          <a:fillRef idx="0">
+            <a:schemeClr val="accent1"/>
+          </a:fillRef>
+          <a:effectRef idx="1">
+            <a:schemeClr val="accent1"/>
+          </a:effectRef>
+          <a:fontRef idx="minor">
+            <a:schemeClr val="tx1"/>
+          </a:fontRef>
+        </p:style>
+      </p:cxnSp>
+      <p:cxnSp>
+        <p:nvCxnSpPr>
+          <p:cNvPr id="40" name="Connector 39"/>
+          <p:cNvCxnSpPr/>
+          <p:nvPr/>
+        </p:nvCxnSpPr>
+        <p:spPr>
+          <a:xfrm>
+            <a:off x="10140043" y="2352675"/>
+            <a:ext cx="57150" cy="0"/>
+          </a:xfrm>
+          <a:prstGeom prst="line">
+            <a:avLst/>
+          </a:prstGeom>
+          <a:ln w="19050">
+            <a:solidFill>
+              <a:srgbClr val="6B6B78"/>
+            </a:solidFill>
+            <a:tailEnd type="triangle" w="med" len="med"/>
+          </a:ln>
+        </p:spPr>
+        <p:style>
+          <a:lnRef idx="2">
+            <a:schemeClr val="accent1"/>
+          </a:lnRef>
+          <a:fillRef idx="0">
+            <a:schemeClr val="accent1"/>
+          </a:fillRef>
+          <a:effectRef idx="1">
+            <a:schemeClr val="accent1"/>
+          </a:effectRef>
+          <a:fontRef idx="minor">
+            <a:schemeClr val="tx1"/>
+          </a:fontRef>
+        </p:style>
+      </p:cxnSp>
+      <p:sp>
+        <p:nvSpPr>
+          <p:cNvPr id="41" name="Rectangle 40"/>
           <p:cNvSpPr/>
           <p:nvPr/>
         </p:nvSpPr>
@@ -14632,7 +14810,7 @@
       </p:sp>
       <p:sp>
         <p:nvSpPr>
-          <p:cNvPr id="37" name="TextBox 36"/>
+          <p:cNvPr id="42" name="TextBox 41"/>
           <p:cNvSpPr txBox="1"/>
           <p:nvPr/>
         </p:nvSpPr>
@@ -14664,14 +14842,14 @@
                 </a:solidFill>
                 <a:latin typeface="Roboto"/>
               </a:rPr>
-              <a:t>Sim ocupa uma vaga mais os acompanhantes. Talvez e não ocupam zero. Não vou zera os acompanhantes e a observação. Alergia exige descrição.</a:t>
-            </a:r>
-          </a:p>
-        </p:txBody>
-      </p:sp>
-      <p:sp>
-        <p:nvSpPr>
-          <p:cNvPr id="38" name="TextBox 37"/>
+              <a:t>“Sim” ocupa uma vaga para o convidado e uma para cada acompanhante. “Talvez” e “Não” não ocupam vaga. “Não” zera acompanhantes e observação. Alergia exige descrição.</a:t>
+            </a:r>
+          </a:p>
+        </p:txBody>
+      </p:sp>
+      <p:sp>
+        <p:nvSpPr>
+          <p:cNvPr id="43" name="TextBox 42"/>
           <p:cNvSpPr txBox="1"/>
           <p:nvPr/>
         </p:nvSpPr>
@@ -14710,7 +14888,7 @@
       </p:sp>
       <p:sp>
         <p:nvSpPr>
-          <p:cNvPr id="39" name="TextBox 38"/>
+          <p:cNvPr id="44" name="TextBox 43"/>
           <p:cNvSpPr txBox="1"/>
           <p:nvPr/>
         </p:nvSpPr>
@@ -14844,12 +15022,12 @@
         </p:nvSpPr>
         <p:spPr>
           <a:xfrm>
-            <a:off x="685800" y="2552555"/>
-            <a:ext cx="3454400" cy="2133600"/>
+            <a:off x="685800" y="2482642"/>
+            <a:ext cx="3454400" cy="2273427"/>
           </a:xfrm>
           <a:prstGeom prst="roundRect">
             <a:avLst>
-              <a:gd name="adj" fmla="val 3571"/>
+              <a:gd name="adj" fmla="val 3351"/>
             </a:avLst>
           </a:prstGeom>
           <a:solidFill>
@@ -14892,7 +15070,7 @@
         </p:nvSpPr>
         <p:spPr>
           <a:xfrm>
-            <a:off x="914400" y="2743055"/>
+            <a:off x="914400" y="2673142"/>
             <a:ext cx="2997200" cy="167640"/>
           </a:xfrm>
           <a:prstGeom prst="rect">
@@ -14931,7 +15109,7 @@
         </p:nvSpPr>
         <p:spPr>
           <a:xfrm>
-            <a:off x="914400" y="2971655"/>
+            <a:off x="914400" y="2901742"/>
             <a:ext cx="2997200" cy="304800"/>
           </a:xfrm>
           <a:prstGeom prst="rect">
@@ -14970,8 +15148,8 @@
         </p:nvSpPr>
         <p:spPr>
           <a:xfrm>
-            <a:off x="914400" y="3352655"/>
-            <a:ext cx="2997200" cy="1181100"/>
+            <a:off x="914400" y="3282742"/>
+            <a:ext cx="2997200" cy="1320927"/>
           </a:xfrm>
           <a:prstGeom prst="rect">
             <a:avLst/>
@@ -14990,13 +15168,13 @@
               </a:lnSpc>
             </a:pPr>
             <a:r>
-              <a:rPr sz="1120" b="0" i="0">
+              <a:rPr sz="1350" b="0" i="0">
                 <a:solidFill>
                   <a:srgbClr val="3A3A44"/>
                 </a:solidFill>
                 <a:latin typeface="Roboto"/>
               </a:rPr>
-              <a:t>Vagas pedidas por resposta, recusa do não vou, descrição da alergia, comparação por dia no fuso do projeto e publicação.</a:t>
+              <a:t>Vagas pedidas por resposta, o não vou zerando acompanhantes e observação, descrição da alergia, comparação por dia no fuso do projeto e publicação.</a:t>
             </a:r>
           </a:p>
         </p:txBody>
@@ -15009,12 +15187,12 @@
         </p:nvSpPr>
         <p:spPr>
           <a:xfrm>
-            <a:off x="4368800" y="2552555"/>
-            <a:ext cx="3454400" cy="2133600"/>
+            <a:off x="4368800" y="2482642"/>
+            <a:ext cx="3454400" cy="2273427"/>
           </a:xfrm>
           <a:prstGeom prst="roundRect">
             <a:avLst>
-              <a:gd name="adj" fmla="val 3571"/>
+              <a:gd name="adj" fmla="val 3351"/>
             </a:avLst>
           </a:prstGeom>
           <a:solidFill>
@@ -15057,7 +15235,7 @@
         </p:nvSpPr>
         <p:spPr>
           <a:xfrm>
-            <a:off x="4597400" y="2743055"/>
+            <a:off x="4597400" y="2673142"/>
             <a:ext cx="2997200" cy="167640"/>
           </a:xfrm>
           <a:prstGeom prst="rect">
@@ -15096,7 +15274,7 @@
         </p:nvSpPr>
         <p:spPr>
           <a:xfrm>
-            <a:off x="4597400" y="2971655"/>
+            <a:off x="4597400" y="2901742"/>
             <a:ext cx="2997200" cy="304800"/>
           </a:xfrm>
           <a:prstGeom prst="rect">
@@ -15135,8 +15313,8 @@
         </p:nvSpPr>
         <p:spPr>
           <a:xfrm>
-            <a:off x="4597400" y="3352655"/>
-            <a:ext cx="2997200" cy="1181100"/>
+            <a:off x="4597400" y="3282742"/>
+            <a:ext cx="2997200" cy="1320927"/>
           </a:xfrm>
           <a:prstGeom prst="rect">
             <a:avLst/>
@@ -15155,7 +15333,7 @@
               </a:lnSpc>
             </a:pPr>
             <a:r>
-              <a:rPr sz="1120" b="0" i="0">
+              <a:rPr sz="1350" b="0" i="0">
                 <a:solidFill>
                   <a:srgbClr val="3A3A44"/>
                 </a:solidFill>
@@ -15174,12 +15352,12 @@
         </p:nvSpPr>
         <p:spPr>
           <a:xfrm>
-            <a:off x="8051800" y="2552555"/>
-            <a:ext cx="3454400" cy="2133600"/>
+            <a:off x="8051800" y="2482642"/>
+            <a:ext cx="3454400" cy="2273427"/>
           </a:xfrm>
           <a:prstGeom prst="roundRect">
             <a:avLst>
-              <a:gd name="adj" fmla="val 3571"/>
+              <a:gd name="adj" fmla="val 3351"/>
             </a:avLst>
           </a:prstGeom>
           <a:solidFill>
@@ -15222,7 +15400,7 @@
         </p:nvSpPr>
         <p:spPr>
           <a:xfrm>
-            <a:off x="8280400" y="2743055"/>
+            <a:off x="8280400" y="2673142"/>
             <a:ext cx="2997200" cy="167640"/>
           </a:xfrm>
           <a:prstGeom prst="rect">
@@ -15261,7 +15439,7 @@
         </p:nvSpPr>
         <p:spPr>
           <a:xfrm>
-            <a:off x="8280400" y="2971655"/>
+            <a:off x="8280400" y="2901742"/>
             <a:ext cx="2997200" cy="304800"/>
           </a:xfrm>
           <a:prstGeom prst="rect">
@@ -15300,8 +15478,8 @@
         </p:nvSpPr>
         <p:spPr>
           <a:xfrm>
-            <a:off x="8280400" y="3352655"/>
-            <a:ext cx="2997200" cy="1181100"/>
+            <a:off x="8280400" y="3282742"/>
+            <a:ext cx="2997200" cy="1320927"/>
           </a:xfrm>
           <a:prstGeom prst="rect">
             <a:avLst/>
@@ -15320,7 +15498,7 @@
               </a:lnSpc>
             </a:pPr>
             <a:r>
-              <a:rPr sz="1120" b="0" i="0">
+              <a:rPr sz="1350" b="0" i="0">
                 <a:solidFill>
                   <a:srgbClr val="3A3A44"/>
                 </a:solidFill>
@@ -15693,7 +15871,7 @@
                 </a:solidFill>
                 <a:latin typeface="Roboto"/>
               </a:rPr>
-              <a:t>QUEM CONDUZ</a:t>
+              <a:t>QUEM FALA</a:t>
             </a:r>
           </a:p>
         </p:txBody>
@@ -17445,7 +17623,7 @@
               </a:lnSpc>
             </a:pPr>
             <a:r>
-              <a:rPr sz="1120" b="0" i="0">
+              <a:rPr sz="1350" b="0" i="0">
                 <a:solidFill>
                   <a:srgbClr val="3A3A44"/>
                 </a:solidFill>
@@ -17610,13 +17788,13 @@
               </a:lnSpc>
             </a:pPr>
             <a:r>
-              <a:rPr sz="1120" b="0" i="0">
+              <a:rPr sz="1350" b="0" i="0">
                 <a:solidFill>
                   <a:srgbClr val="3A3A44"/>
                 </a:solidFill>
                 <a:latin typeface="Roboto"/>
               </a:rPr>
-              <a:t>O protótipo nasceu antes da arquitetura estar no código. Contagem de vagas, CSV e token ficavam na tela.</a:t>
+              <a:t>O protótipo nasceu antes de a arquitetura estar no código. Contagem de vagas, CSV e token ficavam na tela.</a:t>
             </a:r>
           </a:p>
         </p:txBody>
@@ -17775,7 +17953,7 @@
               </a:lnSpc>
             </a:pPr>
             <a:r>
-              <a:rPr sz="1120" b="0" i="0">
+              <a:rPr sz="1350" b="0" i="0">
                 <a:solidFill>
                   <a:srgbClr val="3A3A44"/>
                 </a:solidFill>
@@ -18031,7 +18209,7 @@
                 </a:solidFill>
                 <a:latin typeface="Roboto"/>
               </a:rPr>
-              <a:t>Planejamento até 17/11</a:t>
+              <a:t>Planejamento até a apresentação final, em 17/11</a:t>
             </a:r>
           </a:p>
         </p:txBody>
@@ -18553,7 +18731,7 @@
                 </a:solidFill>
                 <a:latin typeface="Roboto"/>
               </a:rPr>
-              <a:t>Protótipo de baixa fidelidade com as telas reais</a:t>
+              <a:t>Completar o protótipo de baixa fidelidade da Sprint 3 a partir das telas reais</a:t>
             </a:r>
           </a:p>
         </p:txBody>
@@ -19437,7 +19615,7 @@
         </p:nvSpPr>
         <p:spPr>
           <a:xfrm>
-            <a:off x="914400" y="4095750"/>
+            <a:off x="914400" y="2762250"/>
             <a:ext cx="8572500" cy="1524000"/>
           </a:xfrm>
           <a:prstGeom prst="rect">
@@ -19550,7 +19728,7 @@
                 </a:solidFill>
                 <a:latin typeface="Roboto"/>
               </a:rPr>
-              <a:t>Perguntas</a:t>
+              <a:t>Perguntas, Andreas</a:t>
             </a:r>
           </a:p>
         </p:txBody>
@@ -19720,8 +19898,8 @@
         </p:nvSpPr>
         <p:spPr>
           <a:xfrm>
-            <a:off x="685800" y="5195743"/>
-            <a:ext cx="5257800" cy="198120"/>
+            <a:off x="495300" y="5195743"/>
+            <a:ext cx="5638800" cy="228600"/>
           </a:xfrm>
           <a:prstGeom prst="rect">
             <a:avLst/>
@@ -19740,13 +19918,13 @@
               </a:lnSpc>
             </a:pPr>
             <a:r>
-              <a:rPr sz="980" b="0" i="0">
+              <a:rPr sz="1120" b="0" i="0">
                 <a:solidFill>
                   <a:srgbClr val="6B6B78"/>
                 </a:solidFill>
                 <a:latin typeface="Roboto"/>
               </a:rPr>
-              <a:t>Entrada e cadastro</a:t>
+              <a:t>Tela de entrada, com o acesso ao cadastro</a:t>
             </a:r>
           </a:p>
         </p:txBody>
@@ -19788,8 +19966,8 @@
         </p:nvSpPr>
         <p:spPr>
           <a:xfrm>
-            <a:off x="6248400" y="5195743"/>
-            <a:ext cx="5257800" cy="198120"/>
+            <a:off x="6057900" y="5195743"/>
+            <a:ext cx="5638800" cy="228600"/>
           </a:xfrm>
           <a:prstGeom prst="rect">
             <a:avLst/>
@@ -19808,7 +19986,7 @@
               </a:lnSpc>
             </a:pPr>
             <a:r>
-              <a:rPr sz="980" b="0" i="0">
+              <a:rPr sz="1120" b="0" i="0">
                 <a:solidFill>
                   <a:srgbClr val="6B6B78"/>
                 </a:solidFill>
@@ -20106,8 +20284,8 @@
         </p:nvSpPr>
         <p:spPr>
           <a:xfrm>
-            <a:off x="2346848" y="5333710"/>
-            <a:ext cx="1645976" cy="198120"/>
+            <a:off x="2156348" y="5333710"/>
+            <a:ext cx="2026976" cy="228600"/>
           </a:xfrm>
           <a:prstGeom prst="rect">
             <a:avLst/>
@@ -20126,7 +20304,7 @@
               </a:lnSpc>
             </a:pPr>
             <a:r>
-              <a:rPr sz="980" b="0" i="0">
+              <a:rPr sz="1120" b="0" i="0">
                 <a:solidFill>
                   <a:srgbClr val="6B6B78"/>
                 </a:solidFill>
@@ -20174,8 +20352,8 @@
         </p:nvSpPr>
         <p:spPr>
           <a:xfrm>
-            <a:off x="4297624" y="5333710"/>
-            <a:ext cx="1645976" cy="198120"/>
+            <a:off x="4107124" y="5333710"/>
+            <a:ext cx="2026976" cy="228600"/>
           </a:xfrm>
           <a:prstGeom prst="rect">
             <a:avLst/>
@@ -20194,7 +20372,7 @@
               </a:lnSpc>
             </a:pPr>
             <a:r>
-              <a:rPr sz="980" b="0" i="0">
+              <a:rPr sz="1120" b="0" i="0">
                 <a:solidFill>
                   <a:srgbClr val="6B6B78"/>
                 </a:solidFill>
@@ -20242,8 +20420,8 @@
         </p:nvSpPr>
         <p:spPr>
           <a:xfrm>
-            <a:off x="6248400" y="5333710"/>
-            <a:ext cx="1645976" cy="198120"/>
+            <a:off x="6057900" y="5333710"/>
+            <a:ext cx="2026976" cy="228600"/>
           </a:xfrm>
           <a:prstGeom prst="rect">
             <a:avLst/>
@@ -20262,7 +20440,7 @@
               </a:lnSpc>
             </a:pPr>
             <a:r>
-              <a:rPr sz="980" b="0" i="0">
+              <a:rPr sz="1120" b="0" i="0">
                 <a:solidFill>
                   <a:srgbClr val="6B6B78"/>
                 </a:solidFill>
@@ -20310,8 +20488,8 @@
         </p:nvSpPr>
         <p:spPr>
           <a:xfrm>
-            <a:off x="8199176" y="5333710"/>
-            <a:ext cx="1645976" cy="198120"/>
+            <a:off x="8008676" y="5333710"/>
+            <a:ext cx="2026976" cy="228600"/>
           </a:xfrm>
           <a:prstGeom prst="rect">
             <a:avLst/>
@@ -20330,7 +20508,7 @@
               </a:lnSpc>
             </a:pPr>
             <a:r>
-              <a:rPr sz="980" b="0" i="0">
+              <a:rPr sz="1120" b="0" i="0">
                 <a:solidFill>
                   <a:srgbClr val="6B6B78"/>
                 </a:solidFill>
@@ -20628,8 +20806,8 @@
         </p:nvSpPr>
         <p:spPr>
           <a:xfrm>
-            <a:off x="2270964" y="5333710"/>
-            <a:ext cx="5699297" cy="198120"/>
+            <a:off x="2080464" y="5333710"/>
+            <a:ext cx="6080297" cy="228600"/>
           </a:xfrm>
           <a:prstGeom prst="rect">
             <a:avLst/>
@@ -20648,7 +20826,7 @@
               </a:lnSpc>
             </a:pPr>
             <a:r>
-              <a:rPr sz="980" b="0" i="0">
+              <a:rPr sz="1120" b="0" i="0">
                 <a:solidFill>
                   <a:srgbClr val="6B6B78"/>
                 </a:solidFill>
@@ -20696,8 +20874,8 @@
         </p:nvSpPr>
         <p:spPr>
           <a:xfrm>
-            <a:off x="8275060" y="5333710"/>
-            <a:ext cx="1645976" cy="198120"/>
+            <a:off x="8084560" y="5333710"/>
+            <a:ext cx="2026976" cy="228600"/>
           </a:xfrm>
           <a:prstGeom prst="rect">
             <a:avLst/>
@@ -20716,7 +20894,7 @@
               </a:lnSpc>
             </a:pPr>
             <a:r>
-              <a:rPr sz="980" b="0" i="0">
+              <a:rPr sz="1120" b="0" i="0">
                 <a:solidFill>
                   <a:srgbClr val="6B6B78"/>
                 </a:solidFill>
@@ -21422,6 +21600,392 @@
 </p:sld>
 </file>
 
+<file path=ppt/slides/slide20.xml><?xml version="1.0" encoding="utf-8"?>
+<p:sld xmlns:a="http://schemas.openxmlformats.org/drawingml/2006/main" xmlns:p="http://schemas.openxmlformats.org/presentationml/2006/main" xmlns:r="http://schemas.openxmlformats.org/officeDocument/2006/relationships">
+  <p:cSld>
+    <p:bg>
+      <p:bgPr>
+        <a:solidFill>
+          <a:srgbClr val="FFFFFF"/>
+        </a:solidFill>
+        <a:effectLst/>
+      </p:bgPr>
+    </p:bg>
+    <p:spTree>
+      <p:nvGrpSpPr>
+        <p:cNvPr id="1" name=""/>
+        <p:cNvGrpSpPr/>
+        <p:nvPr/>
+      </p:nvGrpSpPr>
+      <p:grpSpPr/>
+      <p:pic>
+        <p:nvPicPr>
+          <p:cNvPr id="2" name="Picture 1" descr="u-azul.png"/>
+          <p:cNvPicPr>
+            <a:picLocks noChangeAspect="1"/>
+          </p:cNvPicPr>
+          <p:nvPr/>
+        </p:nvPicPr>
+        <p:blipFill>
+          <a:blip r:embed="rId2"/>
+          <a:stretch>
+            <a:fillRect/>
+          </a:stretch>
+        </p:blipFill>
+        <p:spPr>
+          <a:xfrm>
+            <a:off x="10744200" y="457200"/>
+            <a:ext cx="342900" cy="342900"/>
+          </a:xfrm>
+          <a:prstGeom prst="rect">
+            <a:avLst/>
+          </a:prstGeom>
+        </p:spPr>
+      </p:pic>
+      <p:sp>
+        <p:nvSpPr>
+          <p:cNvPr id="3" name="TextBox 2"/>
+          <p:cNvSpPr txBox="1"/>
+          <p:nvPr/>
+        </p:nvSpPr>
+        <p:spPr>
+          <a:xfrm>
+            <a:off x="685800" y="685800"/>
+            <a:ext cx="9620250" cy="1524000"/>
+          </a:xfrm>
+          <a:prstGeom prst="rect">
+            <a:avLst/>
+          </a:prstGeom>
+          <a:noFill/>
+        </p:spPr>
+        <p:txBody>
+          <a:bodyPr wrap="square" lIns="0" rIns="0" tIns="0" bIns="0" anchor="t">
+            <a:spAutoFit/>
+          </a:bodyPr>
+          <a:lstStyle/>
+          <a:p>
+            <a:pPr algn="l">
+              <a:lnSpc>
+                <a:spcPct val="104000"/>
+              </a:lnSpc>
+            </a:pPr>
+            <a:r>
+              <a:rPr sz="3000" b="1" i="0">
+                <a:solidFill>
+                  <a:srgbClr val="21049A"/>
+                </a:solidFill>
+                <a:latin typeface="Roboto"/>
+              </a:rPr>
+              <a:t>Quadro Kanban e integração no GitHub</a:t>
+            </a:r>
+          </a:p>
+        </p:txBody>
+      </p:sp>
+      <p:pic>
+        <p:nvPicPr>
+          <p:cNvPr id="4" name="Picture 3" descr="c10-kanban.png"/>
+          <p:cNvPicPr>
+            <a:picLocks noChangeAspect="1"/>
+          </p:cNvPicPr>
+          <p:nvPr/>
+        </p:nvPicPr>
+        <p:blipFill>
+          <a:blip r:embed="rId3"/>
+          <a:stretch>
+            <a:fillRect/>
+          </a:stretch>
+        </p:blipFill>
+        <p:spPr>
+          <a:xfrm>
+            <a:off x="685800" y="1808599"/>
+            <a:ext cx="3164333" cy="3297662"/>
+          </a:xfrm>
+          <a:prstGeom prst="rect">
+            <a:avLst/>
+          </a:prstGeom>
+          <a:ln w="9525">
+            <a:solidFill>
+              <a:srgbClr val="D9D9D9"/>
+            </a:solidFill>
+          </a:ln>
+        </p:spPr>
+      </p:pic>
+      <p:sp>
+        <p:nvSpPr>
+          <p:cNvPr id="5" name="TextBox 4"/>
+          <p:cNvSpPr txBox="1"/>
+          <p:nvPr/>
+        </p:nvSpPr>
+        <p:spPr>
+          <a:xfrm>
+            <a:off x="495300" y="5201511"/>
+            <a:ext cx="3545333" cy="228600"/>
+          </a:xfrm>
+          <a:prstGeom prst="rect">
+            <a:avLst/>
+          </a:prstGeom>
+          <a:noFill/>
+        </p:spPr>
+        <p:txBody>
+          <a:bodyPr wrap="square" lIns="0" rIns="0" tIns="0" bIns="0" anchor="t">
+            <a:spAutoFit/>
+          </a:bodyPr>
+          <a:lstStyle/>
+          <a:p>
+            <a:pPr algn="ctr">
+              <a:lnSpc>
+                <a:spcPct val="120000"/>
+              </a:lnSpc>
+            </a:pPr>
+            <a:r>
+              <a:rPr sz="1120" b="0" i="0">
+                <a:solidFill>
+                  <a:srgbClr val="6B6B78"/>
+                </a:solidFill>
+                <a:latin typeface="Roboto"/>
+              </a:rPr>
+              <a:t>Quadro Kanban no Azure Boards</a:t>
+            </a:r>
+          </a:p>
+        </p:txBody>
+      </p:sp>
+      <p:pic>
+        <p:nvPicPr>
+          <p:cNvPr id="6" name="Picture 5" descr="c11-ci.png"/>
+          <p:cNvPicPr>
+            <a:picLocks noChangeAspect="1"/>
+          </p:cNvPicPr>
+          <p:nvPr/>
+        </p:nvPicPr>
+        <p:blipFill>
+          <a:blip r:embed="rId4"/>
+          <a:stretch>
+            <a:fillRect/>
+          </a:stretch>
+        </p:blipFill>
+        <p:spPr>
+          <a:xfrm>
+            <a:off x="4154933" y="1808599"/>
+            <a:ext cx="7351267" cy="3297662"/>
+          </a:xfrm>
+          <a:prstGeom prst="rect">
+            <a:avLst/>
+          </a:prstGeom>
+          <a:ln w="9525">
+            <a:solidFill>
+              <a:srgbClr val="D9D9D9"/>
+            </a:solidFill>
+          </a:ln>
+        </p:spPr>
+      </p:pic>
+      <p:sp>
+        <p:nvSpPr>
+          <p:cNvPr id="7" name="TextBox 6"/>
+          <p:cNvSpPr txBox="1"/>
+          <p:nvPr/>
+        </p:nvSpPr>
+        <p:spPr>
+          <a:xfrm>
+            <a:off x="3964433" y="5201511"/>
+            <a:ext cx="7732267" cy="228600"/>
+          </a:xfrm>
+          <a:prstGeom prst="rect">
+            <a:avLst/>
+          </a:prstGeom>
+          <a:noFill/>
+        </p:spPr>
+        <p:txBody>
+          <a:bodyPr wrap="square" lIns="0" rIns="0" tIns="0" bIns="0" anchor="t">
+            <a:spAutoFit/>
+          </a:bodyPr>
+          <a:lstStyle/>
+          <a:p>
+            <a:pPr algn="ctr">
+              <a:lnSpc>
+                <a:spcPct val="120000"/>
+              </a:lnSpc>
+            </a:pPr>
+            <a:r>
+              <a:rPr sz="1120" b="0" i="0">
+                <a:solidFill>
+                  <a:srgbClr val="6B6B78"/>
+                </a:solidFill>
+                <a:latin typeface="Roboto"/>
+              </a:rPr>
+              <a:t>Integração contínua aprovada no PR do back-end</a:t>
+            </a:r>
+          </a:p>
+        </p:txBody>
+      </p:sp>
+      <p:sp>
+        <p:nvSpPr>
+          <p:cNvPr id="8" name="Rectangle 7"/>
+          <p:cNvSpPr/>
+          <p:nvPr/>
+        </p:nvSpPr>
+        <p:spPr>
+          <a:xfrm>
+            <a:off x="685800" y="5809960"/>
+            <a:ext cx="28575" cy="209840"/>
+          </a:xfrm>
+          <a:prstGeom prst="rect">
+            <a:avLst/>
+          </a:prstGeom>
+          <a:solidFill>
+            <a:srgbClr val="E94D1C"/>
+          </a:solidFill>
+          <a:ln>
+            <a:noFill/>
+          </a:ln>
+          <a:effectLst/>
+        </p:spPr>
+        <p:style>
+          <a:lnRef idx="1">
+            <a:schemeClr val="accent1"/>
+          </a:lnRef>
+          <a:fillRef idx="3">
+            <a:schemeClr val="accent1"/>
+          </a:fillRef>
+          <a:effectRef idx="2">
+            <a:schemeClr val="accent1"/>
+          </a:effectRef>
+          <a:fontRef idx="minor">
+            <a:schemeClr val="lt1"/>
+          </a:fontRef>
+        </p:style>
+        <p:txBody>
+          <a:bodyPr rtlCol="0" anchor="ctr" wrap="square" lIns="0" rIns="0" tIns="0" bIns="0"/>
+          <a:lstStyle/>
+          <a:p>
+            <a:pPr algn="ctr"/>
+          </a:p>
+        </p:txBody>
+      </p:sp>
+      <p:sp>
+        <p:nvSpPr>
+          <p:cNvPr id="9" name="TextBox 8"/>
+          <p:cNvSpPr txBox="1"/>
+          <p:nvPr/>
+        </p:nvSpPr>
+        <p:spPr>
+          <a:xfrm>
+            <a:off x="876300" y="5790910"/>
+            <a:ext cx="10629900" cy="343190"/>
+          </a:xfrm>
+          <a:prstGeom prst="rect">
+            <a:avLst/>
+          </a:prstGeom>
+          <a:noFill/>
+        </p:spPr>
+        <p:txBody>
+          <a:bodyPr wrap="square" lIns="0" rIns="0" tIns="0" bIns="0" anchor="t">
+            <a:spAutoFit/>
+          </a:bodyPr>
+          <a:lstStyle/>
+          <a:p>
+            <a:pPr algn="l">
+              <a:lnSpc>
+                <a:spcPct val="150000"/>
+              </a:lnSpc>
+            </a:pPr>
+            <a:r>
+              <a:rPr sz="1280" b="0" i="0">
+                <a:solidFill>
+                  <a:srgbClr val="3A3A44"/>
+                </a:solidFill>
+                <a:latin typeface="Roboto"/>
+              </a:rPr>
+              <a:t>Capturas do Azure Boards e do GitHub em 26/10/2026.</a:t>
+            </a:r>
+          </a:p>
+        </p:txBody>
+      </p:sp>
+      <p:sp>
+        <p:nvSpPr>
+          <p:cNvPr id="10" name="TextBox 9"/>
+          <p:cNvSpPr txBox="1"/>
+          <p:nvPr/>
+        </p:nvSpPr>
+        <p:spPr>
+          <a:xfrm>
+            <a:off x="685800" y="6324600"/>
+            <a:ext cx="6667500" cy="182880"/>
+          </a:xfrm>
+          <a:prstGeom prst="rect">
+            <a:avLst/>
+          </a:prstGeom>
+          <a:noFill/>
+        </p:spPr>
+        <p:txBody>
+          <a:bodyPr wrap="square" lIns="0" rIns="0" tIns="0" bIns="0" anchor="t">
+            <a:spAutoFit/>
+          </a:bodyPr>
+          <a:lstStyle/>
+          <a:p>
+            <a:pPr algn="l">
+              <a:lnSpc>
+                <a:spcPct val="120000"/>
+              </a:lnSpc>
+            </a:pPr>
+            <a:r>
+              <a:rPr sz="900" b="0" i="0">
+                <a:solidFill>
+                  <a:srgbClr val="6B6B78"/>
+                </a:solidFill>
+                <a:latin typeface="Roboto"/>
+              </a:rPr>
+              <a:t>Apêndice</a:t>
+            </a:r>
+          </a:p>
+        </p:txBody>
+      </p:sp>
+      <p:sp>
+        <p:nvSpPr>
+          <p:cNvPr id="11" name="TextBox 10"/>
+          <p:cNvSpPr txBox="1"/>
+          <p:nvPr/>
+        </p:nvSpPr>
+        <p:spPr>
+          <a:xfrm>
+            <a:off x="10477500" y="6324600"/>
+            <a:ext cx="1028700" cy="182880"/>
+          </a:xfrm>
+          <a:prstGeom prst="rect">
+            <a:avLst/>
+          </a:prstGeom>
+          <a:noFill/>
+        </p:spPr>
+        <p:txBody>
+          <a:bodyPr wrap="square" lIns="0" rIns="0" tIns="0" bIns="0" anchor="t">
+            <a:spAutoFit/>
+          </a:bodyPr>
+          <a:lstStyle/>
+          <a:p>
+            <a:pPr algn="r">
+              <a:lnSpc>
+                <a:spcPct val="120000"/>
+              </a:lnSpc>
+            </a:pPr>
+            <a:r>
+              <a:rPr sz="900" b="1" i="0">
+                <a:solidFill>
+                  <a:srgbClr val="21049A"/>
+                </a:solidFill>
+                <a:latin typeface="Roboto"/>
+              </a:rPr>
+              <a:t>20</a:t>
+            </a:r>
+          </a:p>
+        </p:txBody>
+      </p:sp>
+    </p:spTree>
+  </p:cSld>
+  <p:clrMapOvr>
+    <a:masterClrMapping/>
+  </p:clrMapOvr>
+</p:sld>
+</file>
+
 <file path=ppt/slides/slide3.xml><?xml version="1.0" encoding="utf-8"?>
 <p:sld xmlns:a="http://schemas.openxmlformats.org/drawingml/2006/main" xmlns:p="http://schemas.openxmlformats.org/presentationml/2006/main" xmlns:r="http://schemas.openxmlformats.org/officeDocument/2006/relationships">
   <p:cSld>
@@ -21511,12 +22075,12 @@
         </p:nvSpPr>
         <p:spPr>
           <a:xfrm>
-            <a:off x="685800" y="1790555"/>
-            <a:ext cx="3454400" cy="1714500"/>
+            <a:off x="685800" y="1729519"/>
+            <a:ext cx="3454400" cy="1775536"/>
           </a:xfrm>
           <a:prstGeom prst="roundRect">
             <a:avLst>
-              <a:gd name="adj" fmla="val 4444"/>
+              <a:gd name="adj" fmla="val 4291"/>
             </a:avLst>
           </a:prstGeom>
           <a:solidFill>
@@ -21559,7 +22123,7 @@
         </p:nvSpPr>
         <p:spPr>
           <a:xfrm>
-            <a:off x="914400" y="1981055"/>
+            <a:off x="914400" y="1920019"/>
             <a:ext cx="2997200" cy="167640"/>
           </a:xfrm>
           <a:prstGeom prst="rect">
@@ -21598,7 +22162,7 @@
         </p:nvSpPr>
         <p:spPr>
           <a:xfrm>
-            <a:off x="914400" y="2209655"/>
+            <a:off x="914400" y="2148619"/>
             <a:ext cx="2997200" cy="304800"/>
           </a:xfrm>
           <a:prstGeom prst="rect">
@@ -21637,8 +22201,8 @@
         </p:nvSpPr>
         <p:spPr>
           <a:xfrm>
-            <a:off x="914400" y="2590655"/>
-            <a:ext cx="2997200" cy="762000"/>
+            <a:off x="914400" y="2529619"/>
+            <a:ext cx="2997200" cy="823036"/>
           </a:xfrm>
           <a:prstGeom prst="rect">
             <a:avLst/>
@@ -21657,7 +22221,7 @@
               </a:lnSpc>
             </a:pPr>
             <a:r>
-              <a:rPr sz="1120" b="0" i="0">
+              <a:rPr sz="1350" b="0" i="0">
                 <a:solidFill>
                   <a:srgbClr val="3A3A44"/>
                 </a:solidFill>
@@ -21676,12 +22240,12 @@
         </p:nvSpPr>
         <p:spPr>
           <a:xfrm>
-            <a:off x="4368800" y="1790555"/>
-            <a:ext cx="3454400" cy="1714500"/>
+            <a:off x="4368800" y="1729519"/>
+            <a:ext cx="3454400" cy="1775536"/>
           </a:xfrm>
           <a:prstGeom prst="roundRect">
             <a:avLst>
-              <a:gd name="adj" fmla="val 4444"/>
+              <a:gd name="adj" fmla="val 4291"/>
             </a:avLst>
           </a:prstGeom>
           <a:solidFill>
@@ -21724,7 +22288,7 @@
         </p:nvSpPr>
         <p:spPr>
           <a:xfrm>
-            <a:off x="4597400" y="1981055"/>
+            <a:off x="4597400" y="1920019"/>
             <a:ext cx="2997200" cy="167640"/>
           </a:xfrm>
           <a:prstGeom prst="rect">
@@ -21763,7 +22327,7 @@
         </p:nvSpPr>
         <p:spPr>
           <a:xfrm>
-            <a:off x="4597400" y="2209655"/>
+            <a:off x="4597400" y="2148619"/>
             <a:ext cx="2997200" cy="304800"/>
           </a:xfrm>
           <a:prstGeom prst="rect">
@@ -21802,8 +22366,8 @@
         </p:nvSpPr>
         <p:spPr>
           <a:xfrm>
-            <a:off x="4597400" y="2590655"/>
-            <a:ext cx="2997200" cy="762000"/>
+            <a:off x="4597400" y="2529619"/>
+            <a:ext cx="2997200" cy="823036"/>
           </a:xfrm>
           <a:prstGeom prst="rect">
             <a:avLst/>
@@ -21822,7 +22386,7 @@
               </a:lnSpc>
             </a:pPr>
             <a:r>
-              <a:rPr sz="1120" b="0" i="0">
+              <a:rPr sz="1350" b="0" i="0">
                 <a:solidFill>
                   <a:srgbClr val="3A3A44"/>
                 </a:solidFill>
@@ -21841,12 +22405,12 @@
         </p:nvSpPr>
         <p:spPr>
           <a:xfrm>
-            <a:off x="8051800" y="1790555"/>
-            <a:ext cx="3454400" cy="1714500"/>
+            <a:off x="8051800" y="1729519"/>
+            <a:ext cx="3454400" cy="1775536"/>
           </a:xfrm>
           <a:prstGeom prst="roundRect">
             <a:avLst>
-              <a:gd name="adj" fmla="val 4444"/>
+              <a:gd name="adj" fmla="val 4291"/>
             </a:avLst>
           </a:prstGeom>
           <a:solidFill>
@@ -21889,7 +22453,7 @@
         </p:nvSpPr>
         <p:spPr>
           <a:xfrm>
-            <a:off x="8280400" y="1981055"/>
+            <a:off x="8280400" y="1920019"/>
             <a:ext cx="2997200" cy="167640"/>
           </a:xfrm>
           <a:prstGeom prst="rect">
@@ -21928,7 +22492,7 @@
         </p:nvSpPr>
         <p:spPr>
           <a:xfrm>
-            <a:off x="8280400" y="2209655"/>
+            <a:off x="8280400" y="2148619"/>
             <a:ext cx="2997200" cy="304800"/>
           </a:xfrm>
           <a:prstGeom prst="rect">
@@ -21967,8 +22531,8 @@
         </p:nvSpPr>
         <p:spPr>
           <a:xfrm>
-            <a:off x="8280400" y="2590655"/>
-            <a:ext cx="2997200" cy="762000"/>
+            <a:off x="8280400" y="2529619"/>
+            <a:ext cx="2997200" cy="823036"/>
           </a:xfrm>
           <a:prstGeom prst="rect">
             <a:avLst/>
@@ -21987,7 +22551,7 @@
               </a:lnSpc>
             </a:pPr>
             <a:r>
-              <a:rPr sz="1120" b="0" i="0">
+              <a:rPr sz="1350" b="0" i="0">
                 <a:solidFill>
                   <a:srgbClr val="3A3A44"/>
                 </a:solidFill>
@@ -22007,11 +22571,11 @@
         <p:spPr>
           <a:xfrm>
             <a:off x="685800" y="3733655"/>
-            <a:ext cx="3454400" cy="1714500"/>
+            <a:ext cx="3454400" cy="1775536"/>
           </a:xfrm>
           <a:prstGeom prst="roundRect">
             <a:avLst>
-              <a:gd name="adj" fmla="val 4444"/>
+              <a:gd name="adj" fmla="val 4291"/>
             </a:avLst>
           </a:prstGeom>
           <a:solidFill>
@@ -22133,7 +22697,7 @@
         <p:spPr>
           <a:xfrm>
             <a:off x="914400" y="4533755"/>
-            <a:ext cx="2997200" cy="762000"/>
+            <a:ext cx="2997200" cy="823036"/>
           </a:xfrm>
           <a:prstGeom prst="rect">
             <a:avLst/>
@@ -22152,7 +22716,7 @@
               </a:lnSpc>
             </a:pPr>
             <a:r>
-              <a:rPr sz="1120" b="0" i="0">
+              <a:rPr sz="1350" b="0" i="0">
                 <a:solidFill>
                   <a:srgbClr val="3A3A44"/>
                 </a:solidFill>
@@ -22172,11 +22736,11 @@
         <p:spPr>
           <a:xfrm>
             <a:off x="4368800" y="3733655"/>
-            <a:ext cx="3454400" cy="1714500"/>
+            <a:ext cx="3454400" cy="1775536"/>
           </a:xfrm>
           <a:prstGeom prst="roundRect">
             <a:avLst>
-              <a:gd name="adj" fmla="val 4444"/>
+              <a:gd name="adj" fmla="val 4291"/>
             </a:avLst>
           </a:prstGeom>
           <a:solidFill>
@@ -22298,7 +22862,7 @@
         <p:spPr>
           <a:xfrm>
             <a:off x="4597400" y="4533755"/>
-            <a:ext cx="2997200" cy="762000"/>
+            <a:ext cx="2997200" cy="823036"/>
           </a:xfrm>
           <a:prstGeom prst="rect">
             <a:avLst/>
@@ -22317,7 +22881,7 @@
               </a:lnSpc>
             </a:pPr>
             <a:r>
-              <a:rPr sz="1120" b="0" i="0">
+              <a:rPr sz="1350" b="0" i="0">
                 <a:solidFill>
                   <a:srgbClr val="3A3A44"/>
                 </a:solidFill>
@@ -22337,11 +22901,11 @@
         <p:spPr>
           <a:xfrm>
             <a:off x="8051800" y="3733655"/>
-            <a:ext cx="3454400" cy="1714500"/>
+            <a:ext cx="3454400" cy="1775536"/>
           </a:xfrm>
           <a:prstGeom prst="roundRect">
             <a:avLst>
-              <a:gd name="adj" fmla="val 4444"/>
+              <a:gd name="adj" fmla="val 4291"/>
             </a:avLst>
           </a:prstGeom>
           <a:solidFill>
@@ -22463,7 +23027,7 @@
         <p:spPr>
           <a:xfrm>
             <a:off x="8280400" y="4533755"/>
-            <a:ext cx="2997200" cy="762000"/>
+            <a:ext cx="2997200" cy="823036"/>
           </a:xfrm>
           <a:prstGeom prst="rect">
             <a:avLst/>
@@ -22482,7 +23046,7 @@
               </a:lnSpc>
             </a:pPr>
             <a:r>
-              <a:rPr sz="1120" b="0" i="0">
+              <a:rPr sz="1350" b="0" i="0">
                 <a:solidFill>
                   <a:srgbClr val="3A3A44"/>
                 </a:solidFill>
@@ -22900,7 +23464,7 @@
               </a:lnSpc>
             </a:pPr>
             <a:r>
-              <a:rPr sz="1090" b="0" i="0">
+              <a:rPr sz="1120" b="0" i="0">
                 <a:solidFill>
                   <a:srgbClr val="3A3A44"/>
                 </a:solidFill>
@@ -22910,13 +23474,13 @@
             </a:r>
           </a:p>
           <a:p>
-            <a:pPr>
+            <a:pPr algn="ctr">
               <a:lnSpc>
                 <a:spcPct val="135000"/>
               </a:lnSpc>
             </a:pPr>
             <a:r>
-              <a:rPr sz="1090" b="0" i="0">
+              <a:rPr sz="1120" b="0" i="0">
                 <a:solidFill>
                   <a:srgbClr val="3A3A44"/>
                 </a:solidFill>
@@ -23040,7 +23604,7 @@
               </a:lnSpc>
             </a:pPr>
             <a:r>
-              <a:rPr sz="1090" b="0" i="0">
+              <a:rPr sz="1120" b="0" i="0">
                 <a:solidFill>
                   <a:srgbClr val="3A3A44"/>
                 </a:solidFill>
@@ -23050,13 +23614,13 @@
             </a:r>
           </a:p>
           <a:p>
-            <a:pPr>
+            <a:pPr algn="ctr">
               <a:lnSpc>
                 <a:spcPct val="135000"/>
               </a:lnSpc>
             </a:pPr>
             <a:r>
-              <a:rPr sz="1090" b="0" i="0">
+              <a:rPr sz="1120" b="0" i="0">
                 <a:solidFill>
                   <a:srgbClr val="3A3A44"/>
                 </a:solidFill>
@@ -23180,7 +23744,7 @@
               </a:lnSpc>
             </a:pPr>
             <a:r>
-              <a:rPr sz="1090" b="0" i="0">
+              <a:rPr sz="1120" b="0" i="0">
                 <a:solidFill>
                   <a:srgbClr val="3A3A44"/>
                 </a:solidFill>
@@ -23190,13 +23754,13 @@
             </a:r>
           </a:p>
           <a:p>
-            <a:pPr>
+            <a:pPr algn="ctr">
               <a:lnSpc>
                 <a:spcPct val="135000"/>
               </a:lnSpc>
             </a:pPr>
             <a:r>
-              <a:rPr sz="1090" b="0" i="0">
+              <a:rPr sz="1120" b="0" i="0">
                 <a:solidFill>
                   <a:srgbClr val="3A3A44"/>
                 </a:solidFill>
@@ -23320,7 +23884,7 @@
               </a:lnSpc>
             </a:pPr>
             <a:r>
-              <a:rPr sz="1090" b="0" i="0">
+              <a:rPr sz="1120" b="0" i="0">
                 <a:solidFill>
                   <a:srgbClr val="3A3A44"/>
                 </a:solidFill>
@@ -23330,13 +23894,13 @@
             </a:r>
           </a:p>
           <a:p>
-            <a:pPr>
+            <a:pPr algn="ctr">
               <a:lnSpc>
                 <a:spcPct val="135000"/>
               </a:lnSpc>
             </a:pPr>
             <a:r>
-              <a:rPr sz="1090" b="0" i="0">
+              <a:rPr sz="1120" b="0" i="0">
                 <a:solidFill>
                   <a:srgbClr val="3A3A44"/>
                 </a:solidFill>
@@ -23460,7 +24024,7 @@
               </a:lnSpc>
             </a:pPr>
             <a:r>
-              <a:rPr sz="1090" b="0" i="0">
+              <a:rPr sz="1120" b="0" i="0">
                 <a:solidFill>
                   <a:srgbClr val="3A3A44"/>
                 </a:solidFill>
@@ -23470,13 +24034,13 @@
             </a:r>
           </a:p>
           <a:p>
-            <a:pPr>
+            <a:pPr algn="ctr">
               <a:lnSpc>
                 <a:spcPct val="135000"/>
               </a:lnSpc>
             </a:pPr>
             <a:r>
-              <a:rPr sz="1090" b="0" i="0">
+              <a:rPr sz="1120" b="0" i="0">
                 <a:solidFill>
                   <a:srgbClr val="3A3A44"/>
                 </a:solidFill>
@@ -23600,7 +24164,7 @@
               </a:lnSpc>
             </a:pPr>
             <a:r>
-              <a:rPr sz="1090" b="0" i="0">
+              <a:rPr sz="1120" b="0" i="0">
                 <a:solidFill>
                   <a:srgbClr val="3A3A44"/>
                 </a:solidFill>
@@ -23610,13 +24174,13 @@
             </a:r>
           </a:p>
           <a:p>
-            <a:pPr>
+            <a:pPr algn="ctr">
               <a:lnSpc>
                 <a:spcPct val="135000"/>
               </a:lnSpc>
             </a:pPr>
             <a:r>
-              <a:rPr sz="1090" b="0" i="0">
+              <a:rPr sz="1120" b="0" i="0">
                 <a:solidFill>
                   <a:srgbClr val="3A3A44"/>
                 </a:solidFill>
@@ -23885,12 +24449,12 @@
         </p:nvSpPr>
         <p:spPr>
           <a:xfrm>
-            <a:off x="685800" y="2924175"/>
-            <a:ext cx="1428750" cy="876300"/>
+            <a:off x="685800" y="2828925"/>
+            <a:ext cx="1257300" cy="952500"/>
           </a:xfrm>
           <a:prstGeom prst="roundRect">
             <a:avLst>
-              <a:gd name="adj" fmla="val 5434"/>
+              <a:gd name="adj" fmla="val 5000"/>
             </a:avLst>
           </a:prstGeom>
           <a:solidFill>
@@ -23931,8 +24495,8 @@
         </p:nvSpPr>
         <p:spPr>
           <a:xfrm>
-            <a:off x="685800" y="3133725"/>
-            <a:ext cx="1428750" cy="243840"/>
+            <a:off x="685800" y="3019425"/>
+            <a:ext cx="1257300" cy="259080"/>
           </a:xfrm>
           <a:prstGeom prst="rect">
             <a:avLst/>
@@ -23951,7 +24515,7 @@
               </a:lnSpc>
             </a:pPr>
             <a:r>
-              <a:rPr sz="1200" b="1" i="0">
+              <a:rPr sz="1280" b="1" i="0">
                 <a:solidFill>
                   <a:srgbClr val="FFFFFF"/>
                 </a:solidFill>
@@ -23970,8 +24534,8 @@
         </p:nvSpPr>
         <p:spPr>
           <a:xfrm>
-            <a:off x="762000" y="3381375"/>
-            <a:ext cx="1276350" cy="182880"/>
+            <a:off x="742950" y="3286125"/>
+            <a:ext cx="1143000" cy="213360"/>
           </a:xfrm>
           <a:prstGeom prst="rect">
             <a:avLst/>
@@ -23990,13 +24554,29 @@
               </a:lnSpc>
             </a:pPr>
             <a:r>
-              <a:rPr sz="900" b="0" i="0">
+              <a:rPr sz="1050" b="0" i="0">
                 <a:solidFill>
                   <a:srgbClr val="FFFFFF"/>
                 </a:solidFill>
                 <a:latin typeface="Roboto"/>
               </a:rPr>
-              <a:t>anfitrião e convidado</a:t>
+              <a:t>anfitrião e</a:t>
+            </a:r>
+          </a:p>
+          <a:p>
+            <a:pPr>
+              <a:lnSpc>
+                <a:spcPct val="120000"/>
+              </a:lnSpc>
+            </a:pPr>
+            <a:r>
+              <a:rPr sz="1050" b="0" i="0">
+                <a:solidFill>
+                  <a:srgbClr val="FFFFFF"/>
+                </a:solidFill>
+                <a:latin typeface="Roboto"/>
+              </a:rPr>
+              <a:t>convidado</a:t>
             </a:r>
           </a:p>
         </p:txBody>
@@ -24009,12 +24589,12 @@
         </p:nvSpPr>
         <p:spPr>
           <a:xfrm>
-            <a:off x="2857500" y="2009775"/>
-            <a:ext cx="2286000" cy="2705100"/>
+            <a:off x="2857500" y="1952625"/>
+            <a:ext cx="2228850" cy="2762250"/>
           </a:xfrm>
           <a:prstGeom prst="roundRect">
             <a:avLst>
-              <a:gd name="adj" fmla="val 2500"/>
+              <a:gd name="adj" fmla="val 2564"/>
             </a:avLst>
           </a:prstGeom>
           <a:solidFill>
@@ -24058,8 +24638,8 @@
         </p:nvSpPr>
         <p:spPr>
           <a:xfrm>
-            <a:off x="3028950" y="2143125"/>
-            <a:ext cx="1943100" cy="243840"/>
+            <a:off x="3009900" y="2066925"/>
+            <a:ext cx="1924050" cy="259080"/>
           </a:xfrm>
           <a:prstGeom prst="rect">
             <a:avLst/>
@@ -24078,7 +24658,7 @@
               </a:lnSpc>
             </a:pPr>
             <a:r>
-              <a:rPr sz="1200" b="1" i="0">
+              <a:rPr sz="1280" b="1" i="0">
                 <a:solidFill>
                   <a:srgbClr val="21049A"/>
                 </a:solidFill>
@@ -24097,8 +24677,8 @@
         </p:nvSpPr>
         <p:spPr>
           <a:xfrm>
-            <a:off x="3028950" y="2371725"/>
-            <a:ext cx="1943100" cy="190500"/>
+            <a:off x="3009900" y="2314575"/>
+            <a:ext cx="1924050" cy="213360"/>
           </a:xfrm>
           <a:prstGeom prst="rect">
             <a:avLst/>
@@ -24117,7 +24697,7 @@
               </a:lnSpc>
             </a:pPr>
             <a:r>
-              <a:rPr sz="940" b="0" i="0">
+              <a:rPr sz="1050" b="0" i="0">
                 <a:solidFill>
                   <a:srgbClr val="6B6B78"/>
                 </a:solidFill>
@@ -24136,12 +24716,12 @@
         </p:nvSpPr>
         <p:spPr>
           <a:xfrm>
-            <a:off x="3048000" y="2714625"/>
-            <a:ext cx="1905000" cy="438150"/>
+            <a:off x="3028950" y="2638425"/>
+            <a:ext cx="1885950" cy="457200"/>
           </a:xfrm>
           <a:prstGeom prst="roundRect">
             <a:avLst>
-              <a:gd name="adj" fmla="val 6521"/>
+              <a:gd name="adj" fmla="val 6250"/>
             </a:avLst>
           </a:prstGeom>
           <a:solidFill>
@@ -24184,8 +24764,8 @@
         </p:nvSpPr>
         <p:spPr>
           <a:xfrm>
-            <a:off x="3048000" y="2838450"/>
-            <a:ext cx="1905000" cy="213360"/>
+            <a:off x="3028950" y="2752725"/>
+            <a:ext cx="1885950" cy="243840"/>
           </a:xfrm>
           <a:prstGeom prst="rect">
             <a:avLst/>
@@ -24204,7 +24784,7 @@
               </a:lnSpc>
             </a:pPr>
             <a:r>
-              <a:rPr sz="1050" b="0" i="0">
+              <a:rPr sz="1200" b="0" i="0">
                 <a:solidFill>
                   <a:srgbClr val="21049A"/>
                 </a:solidFill>
@@ -24223,12 +24803,12 @@
         </p:nvSpPr>
         <p:spPr>
           <a:xfrm>
-            <a:off x="3048000" y="3305175"/>
-            <a:ext cx="1905000" cy="438150"/>
+            <a:off x="3028950" y="3228975"/>
+            <a:ext cx="1885950" cy="457200"/>
           </a:xfrm>
           <a:prstGeom prst="roundRect">
             <a:avLst>
-              <a:gd name="adj" fmla="val 6521"/>
+              <a:gd name="adj" fmla="val 6250"/>
             </a:avLst>
           </a:prstGeom>
           <a:solidFill>
@@ -24271,8 +24851,8 @@
         </p:nvSpPr>
         <p:spPr>
           <a:xfrm>
-            <a:off x="3048000" y="3429000"/>
-            <a:ext cx="1905000" cy="213360"/>
+            <a:off x="3028950" y="3343275"/>
+            <a:ext cx="1885950" cy="243840"/>
           </a:xfrm>
           <a:prstGeom prst="rect">
             <a:avLst/>
@@ -24291,7 +24871,7 @@
               </a:lnSpc>
             </a:pPr>
             <a:r>
-              <a:rPr sz="1050" b="0" i="0">
+              <a:rPr sz="1200" b="0" i="0">
                 <a:solidFill>
                   <a:srgbClr val="21049A"/>
                 </a:solidFill>
@@ -24310,12 +24890,12 @@
         </p:nvSpPr>
         <p:spPr>
           <a:xfrm>
-            <a:off x="3048000" y="3895725"/>
-            <a:ext cx="1905000" cy="438150"/>
+            <a:off x="3028950" y="3819525"/>
+            <a:ext cx="1885950" cy="457200"/>
           </a:xfrm>
           <a:prstGeom prst="roundRect">
             <a:avLst>
-              <a:gd name="adj" fmla="val 6521"/>
+              <a:gd name="adj" fmla="val 6250"/>
             </a:avLst>
           </a:prstGeom>
           <a:solidFill>
@@ -24358,8 +24938,8 @@
         </p:nvSpPr>
         <p:spPr>
           <a:xfrm>
-            <a:off x="3048000" y="4019550"/>
-            <a:ext cx="1905000" cy="213360"/>
+            <a:off x="3028950" y="3933825"/>
+            <a:ext cx="1885950" cy="243840"/>
           </a:xfrm>
           <a:prstGeom prst="rect">
             <a:avLst/>
@@ -24378,7 +24958,7 @@
               </a:lnSpc>
             </a:pPr>
             <a:r>
-              <a:rPr sz="1050" b="0" i="0">
+              <a:rPr sz="1200" b="0" i="0">
                 <a:solidFill>
                   <a:srgbClr val="21049A"/>
                 </a:solidFill>
@@ -24397,8 +24977,8 @@
         </p:nvSpPr>
         <p:spPr>
           <a:xfrm>
-            <a:off x="2857500" y="4505325"/>
-            <a:ext cx="2286000" cy="167640"/>
+            <a:off x="2857500" y="4486275"/>
+            <a:ext cx="2228850" cy="198120"/>
           </a:xfrm>
           <a:prstGeom prst="rect">
             <a:avLst/>
@@ -24417,7 +24997,7 @@
               </a:lnSpc>
             </a:pPr>
             <a:r>
-              <a:rPr sz="819" b="1" i="0" spc="120">
+              <a:rPr sz="980" b="1" i="0" spc="120">
                 <a:solidFill>
                   <a:srgbClr val="21049A"/>
                 </a:solidFill>
@@ -24436,12 +25016,12 @@
         </p:nvSpPr>
         <p:spPr>
           <a:xfrm>
-            <a:off x="6096000" y="2009775"/>
-            <a:ext cx="2476500" cy="2705100"/>
+            <a:off x="6210300" y="1952625"/>
+            <a:ext cx="2381250" cy="2762250"/>
           </a:xfrm>
           <a:prstGeom prst="roundRect">
             <a:avLst>
-              <a:gd name="adj" fmla="val 2307"/>
+              <a:gd name="adj" fmla="val 2400"/>
             </a:avLst>
           </a:prstGeom>
           <a:solidFill>
@@ -24485,8 +25065,8 @@
         </p:nvSpPr>
         <p:spPr>
           <a:xfrm>
-            <a:off x="6267450" y="2143125"/>
-            <a:ext cx="2133600" cy="243840"/>
+            <a:off x="6362700" y="2066925"/>
+            <a:ext cx="2076450" cy="259080"/>
           </a:xfrm>
           <a:prstGeom prst="rect">
             <a:avLst/>
@@ -24505,7 +25085,7 @@
               </a:lnSpc>
             </a:pPr>
             <a:r>
-              <a:rPr sz="1200" b="1" i="0">
+              <a:rPr sz="1280" b="1" i="0">
                 <a:solidFill>
                   <a:srgbClr val="E94D1C"/>
                 </a:solidFill>
@@ -24524,8 +25104,8 @@
         </p:nvSpPr>
         <p:spPr>
           <a:xfrm>
-            <a:off x="6267450" y="2371725"/>
-            <a:ext cx="2133600" cy="190500"/>
+            <a:off x="6362700" y="2314575"/>
+            <a:ext cx="2076450" cy="213360"/>
           </a:xfrm>
           <a:prstGeom prst="rect">
             <a:avLst/>
@@ -24544,13 +25124,13 @@
               </a:lnSpc>
             </a:pPr>
             <a:r>
-              <a:rPr sz="940" b="0" i="0">
+              <a:rPr sz="1050" b="0" i="0">
                 <a:solidFill>
                   <a:srgbClr val="6B6B78"/>
                 </a:solidFill>
                 <a:latin typeface="Roboto"/>
               </a:rPr>
-              <a:t>container api, porta 3001</a:t>
+              <a:t>container api, porta 3001 no host</a:t>
             </a:r>
           </a:p>
         </p:txBody>
@@ -24563,12 +25143,12 @@
         </p:nvSpPr>
         <p:spPr>
           <a:xfrm>
-            <a:off x="6286500" y="2714625"/>
-            <a:ext cx="2095500" cy="438150"/>
+            <a:off x="6381750" y="2638425"/>
+            <a:ext cx="2038350" cy="457200"/>
           </a:xfrm>
           <a:prstGeom prst="roundRect">
             <a:avLst>
-              <a:gd name="adj" fmla="val 6521"/>
+              <a:gd name="adj" fmla="val 6250"/>
             </a:avLst>
           </a:prstGeom>
           <a:solidFill>
@@ -24611,8 +25191,8 @@
         </p:nvSpPr>
         <p:spPr>
           <a:xfrm>
-            <a:off x="6286500" y="2838450"/>
-            <a:ext cx="2095500" cy="213360"/>
+            <a:off x="6381750" y="2752725"/>
+            <a:ext cx="2038350" cy="243840"/>
           </a:xfrm>
           <a:prstGeom prst="rect">
             <a:avLst/>
@@ -24631,7 +25211,7 @@
               </a:lnSpc>
             </a:pPr>
             <a:r>
-              <a:rPr sz="1050" b="0" i="0">
+              <a:rPr sz="1200" b="0" i="0">
                 <a:solidFill>
                   <a:srgbClr val="1A1A1E"/>
                 </a:solidFill>
@@ -24650,12 +25230,12 @@
         </p:nvSpPr>
         <p:spPr>
           <a:xfrm>
-            <a:off x="6286500" y="3305175"/>
-            <a:ext cx="2095500" cy="438150"/>
+            <a:off x="6381750" y="3228975"/>
+            <a:ext cx="2038350" cy="457200"/>
           </a:xfrm>
           <a:prstGeom prst="roundRect">
             <a:avLst>
-              <a:gd name="adj" fmla="val 6521"/>
+              <a:gd name="adj" fmla="val 6250"/>
             </a:avLst>
           </a:prstGeom>
           <a:solidFill>
@@ -24698,8 +25278,8 @@
         </p:nvSpPr>
         <p:spPr>
           <a:xfrm>
-            <a:off x="6286500" y="3429000"/>
-            <a:ext cx="2095500" cy="213360"/>
+            <a:off x="6381750" y="3343275"/>
+            <a:ext cx="2038350" cy="243840"/>
           </a:xfrm>
           <a:prstGeom prst="rect">
             <a:avLst/>
@@ -24718,7 +25298,7 @@
               </a:lnSpc>
             </a:pPr>
             <a:r>
-              <a:rPr sz="1050" b="0" i="0">
+              <a:rPr sz="1200" b="0" i="0">
                 <a:solidFill>
                   <a:srgbClr val="1A1A1E"/>
                 </a:solidFill>
@@ -24737,8 +25317,8 @@
         </p:nvCxnSpPr>
         <p:spPr>
           <a:xfrm>
-            <a:off x="7334250" y="3152775"/>
-            <a:ext cx="0" cy="152400"/>
+            <a:off x="7400925" y="3095625"/>
+            <a:ext cx="0" cy="133350"/>
           </a:xfrm>
           <a:prstGeom prst="line">
             <a:avLst/>
@@ -24773,12 +25353,12 @@
         </p:nvSpPr>
         <p:spPr>
           <a:xfrm>
-            <a:off x="6286500" y="3895725"/>
-            <a:ext cx="2095500" cy="438150"/>
+            <a:off x="6381750" y="3819525"/>
+            <a:ext cx="2038350" cy="457200"/>
           </a:xfrm>
           <a:prstGeom prst="roundRect">
             <a:avLst>
-              <a:gd name="adj" fmla="val 6521"/>
+              <a:gd name="adj" fmla="val 6250"/>
             </a:avLst>
           </a:prstGeom>
           <a:solidFill>
@@ -24821,8 +25401,8 @@
         </p:nvSpPr>
         <p:spPr>
           <a:xfrm>
-            <a:off x="6286500" y="4019550"/>
-            <a:ext cx="2095500" cy="213360"/>
+            <a:off x="6381750" y="3933825"/>
+            <a:ext cx="2038350" cy="243840"/>
           </a:xfrm>
           <a:prstGeom prst="rect">
             <a:avLst/>
@@ -24841,7 +25421,7 @@
               </a:lnSpc>
             </a:pPr>
             <a:r>
-              <a:rPr sz="1050" b="0" i="0">
+              <a:rPr sz="1200" b="0" i="0">
                 <a:solidFill>
                   <a:srgbClr val="1A1A1E"/>
                 </a:solidFill>
@@ -24860,8 +25440,8 @@
         </p:nvCxnSpPr>
         <p:spPr>
           <a:xfrm>
-            <a:off x="7334250" y="3743325"/>
-            <a:ext cx="0" cy="152400"/>
+            <a:off x="7400925" y="3686175"/>
+            <a:ext cx="0" cy="133350"/>
           </a:xfrm>
           <a:prstGeom prst="line">
             <a:avLst/>
@@ -24896,8 +25476,8 @@
         </p:nvSpPr>
         <p:spPr>
           <a:xfrm>
-            <a:off x="6096000" y="4505325"/>
-            <a:ext cx="2476500" cy="167640"/>
+            <a:off x="6210300" y="4486275"/>
+            <a:ext cx="2381250" cy="198120"/>
           </a:xfrm>
           <a:prstGeom prst="rect">
             <a:avLst/>
@@ -24916,7 +25496,7 @@
               </a:lnSpc>
             </a:pPr>
             <a:r>
-              <a:rPr sz="819" b="1" i="0" spc="120">
+              <a:rPr sz="980" b="1" i="0" spc="120">
                 <a:solidFill>
                   <a:srgbClr val="E94D1C"/>
                 </a:solidFill>
@@ -24935,12 +25515,12 @@
         </p:nvSpPr>
         <p:spPr>
           <a:xfrm>
-            <a:off x="9620250" y="2809875"/>
-            <a:ext cx="1809750" cy="1104900"/>
+            <a:off x="9715500" y="2733675"/>
+            <a:ext cx="1790700" cy="1181100"/>
           </a:xfrm>
           <a:prstGeom prst="roundRect">
             <a:avLst>
-              <a:gd name="adj" fmla="val 5172"/>
+              <a:gd name="adj" fmla="val 4838"/>
             </a:avLst>
           </a:prstGeom>
           <a:solidFill>
@@ -24984,8 +25564,8 @@
         </p:nvSpPr>
         <p:spPr>
           <a:xfrm>
-            <a:off x="9620250" y="3000375"/>
-            <a:ext cx="1809750" cy="243840"/>
+            <a:off x="9715500" y="2905125"/>
+            <a:ext cx="1790700" cy="259080"/>
           </a:xfrm>
           <a:prstGeom prst="rect">
             <a:avLst/>
@@ -25004,7 +25584,7 @@
               </a:lnSpc>
             </a:pPr>
             <a:r>
-              <a:rPr sz="1200" b="1" i="0">
+              <a:rPr sz="1280" b="1" i="0">
                 <a:solidFill>
                   <a:srgbClr val="1A1A1E"/>
                 </a:solidFill>
@@ -25023,8 +25603,8 @@
         </p:nvSpPr>
         <p:spPr>
           <a:xfrm>
-            <a:off x="9715500" y="3267075"/>
-            <a:ext cx="1619250" cy="190500"/>
+            <a:off x="9791700" y="3190875"/>
+            <a:ext cx="1638300" cy="213360"/>
           </a:xfrm>
           <a:prstGeom prst="rect">
             <a:avLst/>
@@ -25043,46 +25623,23 @@
               </a:lnSpc>
             </a:pPr>
             <a:r>
-              <a:rPr sz="940" b="0" i="0">
+              <a:rPr sz="1050" b="0" i="0">
                 <a:solidFill>
                   <a:srgbClr val="6B6B78"/>
                 </a:solidFill>
                 <a:latin typeface="Roboto"/>
               </a:rPr>
-              <a:t>container db</a:t>
-            </a:r>
-          </a:p>
-        </p:txBody>
-      </p:sp>
-      <p:sp>
-        <p:nvSpPr>
-          <p:cNvPr id="32" name="TextBox 31"/>
-          <p:cNvSpPr txBox="1"/>
-          <p:nvPr/>
-        </p:nvSpPr>
-        <p:spPr>
-          <a:xfrm>
-            <a:off x="9715500" y="3438525"/>
-            <a:ext cx="1619250" cy="190500"/>
-          </a:xfrm>
-          <a:prstGeom prst="rect">
-            <a:avLst/>
-          </a:prstGeom>
-          <a:noFill/>
-        </p:spPr>
-        <p:txBody>
-          <a:bodyPr wrap="square" lIns="0" rIns="0" tIns="0" bIns="0" anchor="t">
-            <a:spAutoFit/>
-          </a:bodyPr>
-          <a:lstStyle/>
-          <a:p>
-            <a:pPr algn="ctr">
+              <a:t>container db,</a:t>
+            </a:r>
+          </a:p>
+          <a:p>
+            <a:pPr>
               <a:lnSpc>
                 <a:spcPct val="120000"/>
               </a:lnSpc>
             </a:pPr>
             <a:r>
-              <a:rPr sz="940" b="0" i="0">
+              <a:rPr sz="1050" b="0" i="0">
                 <a:solidFill>
                   <a:srgbClr val="6B6B78"/>
                 </a:solidFill>
@@ -25095,14 +25652,14 @@
       </p:sp>
       <p:cxnSp>
         <p:nvCxnSpPr>
-          <p:cNvPr id="33" name="Connector 32"/>
+          <p:cNvPr id="32" name="Connector 31"/>
           <p:cNvCxnSpPr/>
           <p:nvPr/>
         </p:nvCxnSpPr>
         <p:spPr>
           <a:xfrm>
-            <a:off x="2114550" y="3152775"/>
-            <a:ext cx="742950" cy="0"/>
+            <a:off x="1981200" y="3305175"/>
+            <a:ext cx="838200" cy="0"/>
           </a:xfrm>
           <a:prstGeom prst="line">
             <a:avLst/>
@@ -25131,14 +25688,14 @@
       </p:cxnSp>
       <p:sp>
         <p:nvSpPr>
-          <p:cNvPr id="34" name="TextBox 33"/>
+          <p:cNvPr id="33" name="TextBox 32"/>
           <p:cNvSpPr txBox="1"/>
           <p:nvPr/>
         </p:nvSpPr>
         <p:spPr>
           <a:xfrm>
-            <a:off x="2114550" y="3228975"/>
-            <a:ext cx="742950" cy="182880"/>
+            <a:off x="1943100" y="2867025"/>
+            <a:ext cx="914400" cy="213360"/>
           </a:xfrm>
           <a:prstGeom prst="rect">
             <a:avLst/>
@@ -25157,7 +25714,7 @@
               </a:lnSpc>
             </a:pPr>
             <a:r>
-              <a:rPr sz="900" b="0" i="0">
+              <a:rPr sz="1050" b="0" i="0">
                 <a:solidFill>
                   <a:srgbClr val="21049A"/>
                 </a:solidFill>
@@ -25173,7 +25730,7 @@
               </a:lnSpc>
             </a:pPr>
             <a:r>
-              <a:rPr sz="900" b="0" i="0">
+              <a:rPr sz="1050" b="0" i="0">
                 <a:solidFill>
                   <a:srgbClr val="21049A"/>
                 </a:solidFill>
@@ -25186,14 +25743,14 @@
       </p:sp>
       <p:cxnSp>
         <p:nvCxnSpPr>
-          <p:cNvPr id="35" name="Connector 34"/>
+          <p:cNvPr id="34" name="Connector 33"/>
           <p:cNvCxnSpPr/>
           <p:nvPr/>
         </p:nvCxnSpPr>
         <p:spPr>
           <a:xfrm>
-            <a:off x="5143500" y="3152775"/>
-            <a:ext cx="952500" cy="0"/>
+            <a:off x="5124450" y="3305175"/>
+            <a:ext cx="1047750" cy="0"/>
           </a:xfrm>
           <a:prstGeom prst="line">
             <a:avLst/>
@@ -25222,14 +25779,14 @@
       </p:cxnSp>
       <p:sp>
         <p:nvSpPr>
-          <p:cNvPr id="36" name="TextBox 35"/>
+          <p:cNvPr id="35" name="TextBox 34"/>
           <p:cNvSpPr txBox="1"/>
           <p:nvPr/>
         </p:nvSpPr>
         <p:spPr>
           <a:xfrm>
-            <a:off x="5143500" y="2752725"/>
-            <a:ext cx="952500" cy="182880"/>
+            <a:off x="5086350" y="2867025"/>
+            <a:ext cx="1123950" cy="213360"/>
           </a:xfrm>
           <a:prstGeom prst="rect">
             <a:avLst/>
@@ -25248,7 +25805,7 @@
               </a:lnSpc>
             </a:pPr>
             <a:r>
-              <a:rPr sz="900" b="0" i="0">
+              <a:rPr sz="1050" b="0" i="0">
                 <a:solidFill>
                   <a:srgbClr val="21049A"/>
                 </a:solidFill>
@@ -25264,7 +25821,7 @@
               </a:lnSpc>
             </a:pPr>
             <a:r>
-              <a:rPr sz="900" b="0" i="0">
+              <a:rPr sz="1050" b="0" i="0">
                 <a:solidFill>
                   <a:srgbClr val="21049A"/>
                 </a:solidFill>
@@ -25277,13 +25834,13 @@
       </p:sp>
       <p:cxnSp>
         <p:nvCxnSpPr>
-          <p:cNvPr id="37" name="Connector 36"/>
+          <p:cNvPr id="36" name="Connector 35"/>
           <p:cNvCxnSpPr/>
           <p:nvPr/>
         </p:nvCxnSpPr>
         <p:spPr>
           <a:xfrm>
-            <a:off x="8572500" y="3362325"/>
+            <a:off x="8629650" y="3305175"/>
             <a:ext cx="1047750" cy="0"/>
           </a:xfrm>
           <a:prstGeom prst="line">
@@ -25313,14 +25870,14 @@
       </p:cxnSp>
       <p:sp>
         <p:nvSpPr>
-          <p:cNvPr id="38" name="TextBox 37"/>
+          <p:cNvPr id="37" name="TextBox 36"/>
           <p:cNvSpPr txBox="1"/>
           <p:nvPr/>
         </p:nvSpPr>
         <p:spPr>
           <a:xfrm>
-            <a:off x="8572500" y="3133725"/>
-            <a:ext cx="1047750" cy="182880"/>
+            <a:off x="8591550" y="2867025"/>
+            <a:ext cx="1123950" cy="213360"/>
           </a:xfrm>
           <a:prstGeom prst="rect">
             <a:avLst/>
@@ -25339,7 +25896,7 @@
               </a:lnSpc>
             </a:pPr>
             <a:r>
-              <a:rPr sz="900" b="0" i="0">
+              <a:rPr sz="1050" b="0" i="0">
                 <a:solidFill>
                   <a:srgbClr val="6B6B78"/>
                 </a:solidFill>
@@ -25350,6 +25907,41 @@
           </a:p>
         </p:txBody>
       </p:sp>
+      <p:cxnSp>
+        <p:nvCxnSpPr>
+          <p:cNvPr id="38" name="Connector 37"/>
+          <p:cNvCxnSpPr/>
+          <p:nvPr/>
+        </p:nvCxnSpPr>
+        <p:spPr>
+          <a:xfrm>
+            <a:off x="1314450" y="3781425"/>
+            <a:ext cx="0" cy="1200150"/>
+          </a:xfrm>
+          <a:prstGeom prst="line">
+            <a:avLst/>
+          </a:prstGeom>
+          <a:ln w="25400">
+            <a:solidFill>
+              <a:srgbClr val="E94D1C"/>
+            </a:solidFill>
+          </a:ln>
+        </p:spPr>
+        <p:style>
+          <a:lnRef idx="2">
+            <a:schemeClr val="accent1"/>
+          </a:lnRef>
+          <a:fillRef idx="0">
+            <a:schemeClr val="accent1"/>
+          </a:fillRef>
+          <a:effectRef idx="1">
+            <a:schemeClr val="accent1"/>
+          </a:effectRef>
+          <a:fontRef idx="minor">
+            <a:schemeClr val="tx1"/>
+          </a:fontRef>
+        </p:style>
+      </p:cxnSp>
       <p:cxnSp>
         <p:nvCxnSpPr>
           <p:cNvPr id="39" name="Connector 38"/>
@@ -25358,8 +25950,8 @@
         </p:nvCxnSpPr>
         <p:spPr>
           <a:xfrm>
-            <a:off x="1400175" y="3800475"/>
-            <a:ext cx="0" cy="1181100"/>
+            <a:off x="1314450" y="4981575"/>
+            <a:ext cx="6086475" cy="0"/>
           </a:xfrm>
           <a:prstGeom prst="line">
             <a:avLst/>
@@ -25392,9 +25984,9 @@
           <p:nvPr/>
         </p:nvCxnSpPr>
         <p:spPr>
-          <a:xfrm>
-            <a:off x="1400175" y="4981575"/>
-            <a:ext cx="5934075" cy="0"/>
+          <a:xfrm flipV="1">
+            <a:off x="7400925" y="4714875"/>
+            <a:ext cx="0" cy="266700"/>
           </a:xfrm>
           <a:prstGeom prst="line">
             <a:avLst/>
@@ -25403,6 +25995,7 @@
             <a:solidFill>
               <a:srgbClr val="E94D1C"/>
             </a:solidFill>
+            <a:tailEnd type="triangle" w="med" len="med"/>
           </a:ln>
         </p:spPr>
         <p:style>
@@ -25420,52 +26013,16 @@
           </a:fontRef>
         </p:style>
       </p:cxnSp>
-      <p:cxnSp>
-        <p:nvCxnSpPr>
-          <p:cNvPr id="41" name="Connector 40"/>
-          <p:cNvCxnSpPr/>
-          <p:nvPr/>
-        </p:nvCxnSpPr>
-        <p:spPr>
-          <a:xfrm flipV="1">
-            <a:off x="7334250" y="4714875"/>
-            <a:ext cx="0" cy="266700"/>
-          </a:xfrm>
-          <a:prstGeom prst="line">
-            <a:avLst/>
-          </a:prstGeom>
-          <a:ln w="25400">
-            <a:solidFill>
-              <a:srgbClr val="E94D1C"/>
-            </a:solidFill>
-            <a:tailEnd type="triangle" w="med" len="med"/>
-          </a:ln>
-        </p:spPr>
-        <p:style>
-          <a:lnRef idx="2">
-            <a:schemeClr val="accent1"/>
-          </a:lnRef>
-          <a:fillRef idx="0">
-            <a:schemeClr val="accent1"/>
-          </a:fillRef>
-          <a:effectRef idx="1">
-            <a:schemeClr val="accent1"/>
-          </a:effectRef>
-          <a:fontRef idx="minor">
-            <a:schemeClr val="tx1"/>
-          </a:fontRef>
-        </p:style>
-      </p:cxnSp>
-      <p:sp>
-        <p:nvSpPr>
-          <p:cNvPr id="42" name="TextBox 41"/>
+      <p:sp>
+        <p:nvSpPr>
+          <p:cNvPr id="41" name="TextBox 40"/>
           <p:cNvSpPr txBox="1"/>
           <p:nvPr/>
         </p:nvSpPr>
         <p:spPr>
           <a:xfrm>
-            <a:off x="1524000" y="5038725"/>
-            <a:ext cx="4476750" cy="182880"/>
+            <a:off x="1428750" y="5038725"/>
+            <a:ext cx="4953000" cy="228600"/>
           </a:xfrm>
           <a:prstGeom prst="rect">
             <a:avLst/>
@@ -25484,7 +26041,7 @@
               </a:lnSpc>
             </a:pPr>
             <a:r>
-              <a:rPr sz="900" b="0" i="0">
+              <a:rPr sz="1120" b="0" i="0">
                 <a:solidFill>
                   <a:srgbClr val="E94D1C"/>
                 </a:solidFill>
@@ -25497,18 +26054,18 @@
       </p:sp>
       <p:sp>
         <p:nvSpPr>
-          <p:cNvPr id="43" name="Rounded Rectangle 42"/>
+          <p:cNvPr id="42" name="Rounded Rectangle 41"/>
           <p:cNvSpPr/>
           <p:nvPr/>
         </p:nvSpPr>
         <p:spPr>
           <a:xfrm>
-            <a:off x="2857500" y="5343525"/>
-            <a:ext cx="5715000" cy="419100"/>
+            <a:off x="2857500" y="5381625"/>
+            <a:ext cx="5734050" cy="438150"/>
           </a:xfrm>
           <a:prstGeom prst="roundRect">
             <a:avLst>
-              <a:gd name="adj" fmla="val 9090"/>
+              <a:gd name="adj" fmla="val 8695"/>
             </a:avLst>
           </a:prstGeom>
           <a:solidFill>
@@ -25545,14 +26102,14 @@
       </p:sp>
       <p:sp>
         <p:nvSpPr>
-          <p:cNvPr id="44" name="TextBox 43"/>
+          <p:cNvPr id="43" name="TextBox 42"/>
           <p:cNvSpPr txBox="1"/>
           <p:nvPr/>
         </p:nvSpPr>
         <p:spPr>
           <a:xfrm>
-            <a:off x="3009900" y="5457825"/>
-            <a:ext cx="5410200" cy="285750"/>
+            <a:off x="3009900" y="5495925"/>
+            <a:ext cx="5429250" cy="285750"/>
           </a:xfrm>
           <a:prstGeom prst="rect">
             <a:avLst/>
@@ -25571,29 +26128,29 @@
               </a:lnSpc>
             </a:pPr>
             <a:r>
-              <a:rPr sz="980" b="1" i="0">
+              <a:rPr sz="1050" b="1" i="0">
                 <a:solidFill>
                   <a:srgbClr val="3A3A44"/>
                 </a:solidFill>
                 <a:latin typeface="Roboto"/>
               </a:rPr>
-              <a:t>contract</a:t>
-            </a:r>
-            <a:r>
-              <a:rPr sz="980" b="0" i="0">
+              <a:t>Pacote de tipos compartilhado (contract):</a:t>
+            </a:r>
+            <a:r>
+              <a:rPr sz="1050" b="0" i="0">
                 <a:solidFill>
                   <a:srgbClr val="3A3A44"/>
                 </a:solidFill>
                 <a:latin typeface="Roboto"/>
               </a:rPr>
-              <a:t>: tipos de pedido e resposta usados pelo front e pela API</a:t>
-            </a:r>
-          </a:p>
-        </p:txBody>
-      </p:sp>
-      <p:sp>
-        <p:nvSpPr>
-          <p:cNvPr id="45" name="TextBox 44"/>
+              <a:t> pedidos e respostas usados pelo front e pela API</a:t>
+            </a:r>
+          </a:p>
+        </p:txBody>
+      </p:sp>
+      <p:sp>
+        <p:nvSpPr>
+          <p:cNvPr id="44" name="TextBox 43"/>
           <p:cNvSpPr txBox="1"/>
           <p:nvPr/>
         </p:nvSpPr>
@@ -25632,7 +26189,7 @@
       </p:sp>
       <p:sp>
         <p:nvSpPr>
-          <p:cNvPr id="46" name="TextBox 45"/>
+          <p:cNvPr id="45" name="TextBox 44"/>
           <p:cNvSpPr txBox="1"/>
           <p:nvPr/>
         </p:nvSpPr>
@@ -25753,7 +26310,7 @@
                 </a:solidFill>
                 <a:latin typeface="Roboto"/>
               </a:rPr>
-              <a:t>Base do projeto: lint, CI e docker compose</a:t>
+              <a:t>Base do projeto: lint, integração contínua e Docker</a:t>
             </a:r>
           </a:p>
         </p:txBody>
@@ -26828,7 +27385,7 @@
                 </a:solidFill>
                 <a:latin typeface="Roboto"/>
               </a:rPr>
-              <a:t>Nenhuma rota confirma que um convite existe</a:t>
+              <a:t>Quem não tem acesso não descobre se um convite existe</a:t>
             </a:r>
           </a:p>
         </p:txBody>
@@ -26867,7 +27424,7 @@
                 </a:solidFill>
                 <a:latin typeface="Roboto"/>
               </a:rPr>
-              <a:t>Na Apresentação. Link inválido e convite despublicado dão o mesmo 404 na página pública, e o convite de outro anfitrião dá o mesmo 404 no painel. Um teste de ponta a ponta compara corpo e cabeçalho.</a:t>
+              <a:t>No Domínio e na Apresentação. Link inválido, convite despublicado e convite de outro anfitrião dão o mesmo 404, com o mesmo corpo e cabeçalho, conferido por um teste de ponta a ponta.</a:t>
             </a:r>
           </a:p>
         </p:txBody>
@@ -27447,8 +28004,8 @@
         </p:nvSpPr>
         <p:spPr>
           <a:xfrm>
-            <a:off x="1608497" y="5085771"/>
-            <a:ext cx="5302593" cy="198120"/>
+            <a:off x="1417997" y="5085771"/>
+            <a:ext cx="5683593" cy="228600"/>
           </a:xfrm>
           <a:prstGeom prst="rect">
             <a:avLst/>
@@ -27467,7 +28024,7 @@
               </a:lnSpc>
             </a:pPr>
             <a:r>
-              <a:rPr sz="980" b="0" i="0">
+              <a:rPr sz="1120" b="0" i="0">
                 <a:solidFill>
                   <a:srgbClr val="6B6B78"/>
                 </a:solidFill>
@@ -27515,8 +28072,8 @@
         </p:nvSpPr>
         <p:spPr>
           <a:xfrm>
-            <a:off x="7215890" y="5085771"/>
-            <a:ext cx="1531407" cy="198120"/>
+            <a:off x="7025390" y="5085771"/>
+            <a:ext cx="1912407" cy="228600"/>
           </a:xfrm>
           <a:prstGeom prst="rect">
             <a:avLst/>
@@ -27535,7 +28092,7 @@
               </a:lnSpc>
             </a:pPr>
             <a:r>
-              <a:rPr sz="980" b="0" i="0">
+              <a:rPr sz="1120" b="0" i="0">
                 <a:solidFill>
                   <a:srgbClr val="6B6B78"/>
                 </a:solidFill>
@@ -27583,8 +28140,8 @@
         </p:nvSpPr>
         <p:spPr>
           <a:xfrm>
-            <a:off x="9052097" y="5085771"/>
-            <a:ext cx="1531407" cy="198120"/>
+            <a:off x="8861597" y="5085771"/>
+            <a:ext cx="1912407" cy="228600"/>
           </a:xfrm>
           <a:prstGeom prst="rect">
             <a:avLst/>
@@ -27603,7 +28160,7 @@
               </a:lnSpc>
             </a:pPr>
             <a:r>
-              <a:rPr sz="980" b="0" i="0">
+              <a:rPr sz="1120" b="0" i="0">
                 <a:solidFill>
                   <a:srgbClr val="6B6B78"/>
                 </a:solidFill>

</xml_diff>

<commit_message>
docs: planejamento do T3 como lista, sem dono, prazo nem Team Charter
</commit_message>
<xml_diff>
--- a/trabalhos/T3-Apresentacao-Intermediaria.pptx
+++ b/trabalhos/T3-Apresentacao-Intermediaria.pptx
@@ -962,7 +962,7 @@
           <a:lstStyle/>
           <a:p>
             <a:r>
-              <a:t>Andreas. Dizer quais itens assumiu. Preencher Quem e Até antes do ensaio e criar os itens no quadro da Sprint 6, de 03/11 a 16/11.</a:t>
+              <a:t>Andreas. Estes são os itens da Sprint 6, de 03/11 a 16/11, até a apresentação final em 17/11. Se tiver assumido algum deles, dizer qual.</a:t>
             </a:r>
           </a:p>
         </p:txBody>
@@ -18216,137 +18216,20 @@
       </p:sp>
       <p:sp>
         <p:nvSpPr>
-          <p:cNvPr id="4" name="TextBox 3"/>
-          <p:cNvSpPr txBox="1"/>
-          <p:nvPr/>
-        </p:nvSpPr>
-        <p:spPr>
-          <a:xfrm>
-            <a:off x="685800" y="2025796"/>
-            <a:ext cx="6667500" cy="167640"/>
-          </a:xfrm>
-          <a:prstGeom prst="rect">
-            <a:avLst/>
-          </a:prstGeom>
-          <a:noFill/>
-        </p:spPr>
-        <p:txBody>
-          <a:bodyPr wrap="square" lIns="0" rIns="0" tIns="0" bIns="0" anchor="t">
-            <a:spAutoFit/>
-          </a:bodyPr>
-          <a:lstStyle/>
-          <a:p>
-            <a:pPr algn="l">
-              <a:lnSpc>
-                <a:spcPct val="120000"/>
-              </a:lnSpc>
-            </a:pPr>
-            <a:r>
-              <a:rPr sz="819" b="1" i="0" spc="120">
-                <a:solidFill>
-                  <a:srgbClr val="21049A"/>
-                </a:solidFill>
-                <a:latin typeface="Roboto"/>
-              </a:rPr>
-              <a:t>O QUÊ</a:t>
-            </a:r>
-          </a:p>
-        </p:txBody>
-      </p:sp>
-      <p:sp>
-        <p:nvSpPr>
-          <p:cNvPr id="5" name="TextBox 4"/>
-          <p:cNvSpPr txBox="1"/>
-          <p:nvPr/>
-        </p:nvSpPr>
-        <p:spPr>
-          <a:xfrm>
-            <a:off x="7620000" y="2025796"/>
-            <a:ext cx="1905000" cy="167640"/>
-          </a:xfrm>
-          <a:prstGeom prst="rect">
-            <a:avLst/>
-          </a:prstGeom>
-          <a:noFill/>
-        </p:spPr>
-        <p:txBody>
-          <a:bodyPr wrap="square" lIns="0" rIns="0" tIns="0" bIns="0" anchor="t">
-            <a:spAutoFit/>
-          </a:bodyPr>
-          <a:lstStyle/>
-          <a:p>
-            <a:pPr algn="l">
-              <a:lnSpc>
-                <a:spcPct val="120000"/>
-              </a:lnSpc>
-            </a:pPr>
-            <a:r>
-              <a:rPr sz="819" b="1" i="0" spc="120">
-                <a:solidFill>
-                  <a:srgbClr val="21049A"/>
-                </a:solidFill>
-                <a:latin typeface="Roboto"/>
-              </a:rPr>
-              <a:t>QUEM</a:t>
-            </a:r>
-          </a:p>
-        </p:txBody>
-      </p:sp>
-      <p:sp>
-        <p:nvSpPr>
-          <p:cNvPr id="6" name="TextBox 5"/>
-          <p:cNvSpPr txBox="1"/>
-          <p:nvPr/>
-        </p:nvSpPr>
-        <p:spPr>
-          <a:xfrm>
-            <a:off x="9620250" y="2025796"/>
-            <a:ext cx="1885950" cy="167640"/>
-          </a:xfrm>
-          <a:prstGeom prst="rect">
-            <a:avLst/>
-          </a:prstGeom>
-          <a:noFill/>
-        </p:spPr>
-        <p:txBody>
-          <a:bodyPr wrap="square" lIns="0" rIns="0" tIns="0" bIns="0" anchor="t">
-            <a:spAutoFit/>
-          </a:bodyPr>
-          <a:lstStyle/>
-          <a:p>
-            <a:pPr algn="l">
-              <a:lnSpc>
-                <a:spcPct val="120000"/>
-              </a:lnSpc>
-            </a:pPr>
-            <a:r>
-              <a:rPr sz="819" b="1" i="0" spc="120">
-                <a:solidFill>
-                  <a:srgbClr val="21049A"/>
-                </a:solidFill>
-                <a:latin typeface="Roboto"/>
-              </a:rPr>
-              <a:t>ATÉ</a:t>
-            </a:r>
-          </a:p>
-        </p:txBody>
-      </p:sp>
-      <p:sp>
-        <p:nvSpPr>
-          <p:cNvPr id="7" name="Rectangle 6"/>
+          <p:cNvPr id="4" name="Rectangle 3"/>
           <p:cNvSpPr/>
           <p:nvPr/>
         </p:nvSpPr>
         <p:spPr>
           <a:xfrm>
-            <a:off x="685800" y="2254396"/>
-            <a:ext cx="10820400" cy="19050"/>
+            <a:off x="704850" y="2574798"/>
+            <a:ext cx="57150" cy="57150"/>
           </a:xfrm>
           <a:prstGeom prst="rect">
             <a:avLst/>
           </a:prstGeom>
           <a:solidFill>
-            <a:srgbClr val="21049A"/>
+            <a:srgbClr val="E94D1C"/>
           </a:solidFill>
           <a:ln>
             <a:noFill/>
@@ -18377,14 +18260,14 @@
       </p:sp>
       <p:sp>
         <p:nvSpPr>
-          <p:cNvPr id="8" name="TextBox 7"/>
+          <p:cNvPr id="5" name="TextBox 4"/>
           <p:cNvSpPr txBox="1"/>
           <p:nvPr/>
         </p:nvSpPr>
         <p:spPr>
           <a:xfrm>
-            <a:off x="685800" y="2406796"/>
-            <a:ext cx="6496050" cy="762000"/>
+            <a:off x="971550" y="2465832"/>
+            <a:ext cx="10134600" cy="95250"/>
           </a:xfrm>
           <a:prstGeom prst="rect">
             <a:avLst/>
@@ -18399,115 +18282,37 @@
           <a:p>
             <a:pPr algn="l">
               <a:lnSpc>
-                <a:spcPct val="135000"/>
+                <a:spcPct val="130000"/>
               </a:lnSpc>
             </a:pPr>
             <a:r>
-              <a:rPr sz="1350" b="1" i="0">
-                <a:solidFill>
-                  <a:srgbClr val="21049A"/>
+              <a:rPr sz="1650" b="0" i="0">
+                <a:solidFill>
+                  <a:srgbClr val="1A1A1E"/>
                 </a:solidFill>
                 <a:latin typeface="Roboto"/>
               </a:rPr>
-              <a:t>Revisar os artefatos das Sprints 1 a 3 contra o código, ligando cada história ao caso de uso, à rota, à tela e ao teste</a:t>
-            </a:r>
-          </a:p>
-        </p:txBody>
-      </p:sp>
-      <p:sp>
-        <p:nvSpPr>
-          <p:cNvPr id="9" name="TextBox 8"/>
-          <p:cNvSpPr txBox="1"/>
-          <p:nvPr/>
-        </p:nvSpPr>
-        <p:spPr>
-          <a:xfrm>
-            <a:off x="7620000" y="2406796"/>
-            <a:ext cx="1733550" cy="762000"/>
-          </a:xfrm>
-          <a:prstGeom prst="rect">
-            <a:avLst/>
-          </a:prstGeom>
-          <a:noFill/>
-        </p:spPr>
-        <p:txBody>
-          <a:bodyPr wrap="square" lIns="0" rIns="0" tIns="0" bIns="0" anchor="t">
-            <a:spAutoFit/>
-          </a:bodyPr>
-          <a:lstStyle/>
-          <a:p>
-            <a:pPr algn="l">
-              <a:lnSpc>
-                <a:spcPct val="135000"/>
-              </a:lnSpc>
-            </a:pPr>
-            <a:r>
-              <a:rPr sz="1280" b="0" i="0">
-                <a:solidFill>
-                  <a:srgbClr val="1A1A1E"/>
-                </a:solidFill>
-                <a:latin typeface="Roboto"/>
-              </a:rPr>
-              <a:t>a definir</a:t>
-            </a:r>
-          </a:p>
-        </p:txBody>
-      </p:sp>
-      <p:sp>
-        <p:nvSpPr>
-          <p:cNvPr id="10" name="TextBox 9"/>
-          <p:cNvSpPr txBox="1"/>
-          <p:nvPr/>
-        </p:nvSpPr>
-        <p:spPr>
-          <a:xfrm>
-            <a:off x="9620250" y="2406796"/>
-            <a:ext cx="1714500" cy="762000"/>
-          </a:xfrm>
-          <a:prstGeom prst="rect">
-            <a:avLst/>
-          </a:prstGeom>
-          <a:noFill/>
-        </p:spPr>
-        <p:txBody>
-          <a:bodyPr wrap="square" lIns="0" rIns="0" tIns="0" bIns="0" anchor="t">
-            <a:spAutoFit/>
-          </a:bodyPr>
-          <a:lstStyle/>
-          <a:p>
-            <a:pPr algn="l">
-              <a:lnSpc>
-                <a:spcPct val="135000"/>
-              </a:lnSpc>
-            </a:pPr>
-            <a:r>
-              <a:rPr sz="1280" b="0" i="0">
-                <a:solidFill>
-                  <a:srgbClr val="1A1A1E"/>
-                </a:solidFill>
-                <a:latin typeface="Roboto"/>
-              </a:rPr>
-              <a:t>a definir</a:t>
-            </a:r>
-          </a:p>
-        </p:txBody>
-      </p:sp>
-      <p:sp>
-        <p:nvSpPr>
-          <p:cNvPr id="11" name="Rectangle 10"/>
+              <a:t>Revisar os artefatos das Sprints 1 a 3 contra o código, ligando cada história ao caso de uso, à rota, à tela e ao teste.</a:t>
+            </a:r>
+          </a:p>
+        </p:txBody>
+      </p:sp>
+      <p:sp>
+        <p:nvSpPr>
+          <p:cNvPr id="6" name="Rectangle 5"/>
           <p:cNvSpPr/>
           <p:nvPr/>
         </p:nvSpPr>
         <p:spPr>
           <a:xfrm>
-            <a:off x="685800" y="3005880"/>
-            <a:ext cx="10820400" cy="9525"/>
+            <a:off x="704850" y="3413760"/>
+            <a:ext cx="57150" cy="57150"/>
           </a:xfrm>
           <a:prstGeom prst="rect">
             <a:avLst/>
           </a:prstGeom>
           <a:solidFill>
-            <a:srgbClr val="EDEDF2"/>
+            <a:srgbClr val="E94D1C"/>
           </a:solidFill>
           <a:ln>
             <a:noFill/>
@@ -18538,14 +18343,14 @@
       </p:sp>
       <p:sp>
         <p:nvSpPr>
-          <p:cNvPr id="12" name="TextBox 11"/>
+          <p:cNvPr id="7" name="TextBox 6"/>
           <p:cNvSpPr txBox="1"/>
           <p:nvPr/>
         </p:nvSpPr>
         <p:spPr>
           <a:xfrm>
-            <a:off x="685800" y="3129705"/>
-            <a:ext cx="6496050" cy="762000"/>
+            <a:off x="971550" y="3304794"/>
+            <a:ext cx="10134600" cy="95250"/>
           </a:xfrm>
           <a:prstGeom prst="rect">
             <a:avLst/>
@@ -18560,115 +18365,37 @@
           <a:p>
             <a:pPr algn="l">
               <a:lnSpc>
-                <a:spcPct val="135000"/>
+                <a:spcPct val="130000"/>
               </a:lnSpc>
             </a:pPr>
             <a:r>
-              <a:rPr sz="1350" b="1" i="0">
-                <a:solidFill>
-                  <a:srgbClr val="21049A"/>
+              <a:rPr sz="1650" b="0" i="0">
+                <a:solidFill>
+                  <a:srgbClr val="1A1A1E"/>
                 </a:solidFill>
                 <a:latin typeface="Roboto"/>
               </a:rPr>
-              <a:t>Diagrama de sequência da lista de presença</a:t>
-            </a:r>
-          </a:p>
-        </p:txBody>
-      </p:sp>
-      <p:sp>
-        <p:nvSpPr>
-          <p:cNvPr id="13" name="TextBox 12"/>
-          <p:cNvSpPr txBox="1"/>
-          <p:nvPr/>
-        </p:nvSpPr>
-        <p:spPr>
-          <a:xfrm>
-            <a:off x="7620000" y="3129705"/>
-            <a:ext cx="1733550" cy="762000"/>
-          </a:xfrm>
-          <a:prstGeom prst="rect">
-            <a:avLst/>
-          </a:prstGeom>
-          <a:noFill/>
-        </p:spPr>
-        <p:txBody>
-          <a:bodyPr wrap="square" lIns="0" rIns="0" tIns="0" bIns="0" anchor="t">
-            <a:spAutoFit/>
-          </a:bodyPr>
-          <a:lstStyle/>
-          <a:p>
-            <a:pPr algn="l">
-              <a:lnSpc>
-                <a:spcPct val="135000"/>
-              </a:lnSpc>
-            </a:pPr>
-            <a:r>
-              <a:rPr sz="1280" b="0" i="0">
-                <a:solidFill>
-                  <a:srgbClr val="1A1A1E"/>
-                </a:solidFill>
-                <a:latin typeface="Roboto"/>
-              </a:rPr>
-              <a:t>a definir</a:t>
-            </a:r>
-          </a:p>
-        </p:txBody>
-      </p:sp>
-      <p:sp>
-        <p:nvSpPr>
-          <p:cNvPr id="14" name="TextBox 13"/>
-          <p:cNvSpPr txBox="1"/>
-          <p:nvPr/>
-        </p:nvSpPr>
-        <p:spPr>
-          <a:xfrm>
-            <a:off x="9620250" y="3129705"/>
-            <a:ext cx="1714500" cy="762000"/>
-          </a:xfrm>
-          <a:prstGeom prst="rect">
-            <a:avLst/>
-          </a:prstGeom>
-          <a:noFill/>
-        </p:spPr>
-        <p:txBody>
-          <a:bodyPr wrap="square" lIns="0" rIns="0" tIns="0" bIns="0" anchor="t">
-            <a:spAutoFit/>
-          </a:bodyPr>
-          <a:lstStyle/>
-          <a:p>
-            <a:pPr algn="l">
-              <a:lnSpc>
-                <a:spcPct val="135000"/>
-              </a:lnSpc>
-            </a:pPr>
-            <a:r>
-              <a:rPr sz="1280" b="0" i="0">
-                <a:solidFill>
-                  <a:srgbClr val="1A1A1E"/>
-                </a:solidFill>
-                <a:latin typeface="Roboto"/>
-              </a:rPr>
-              <a:t>a definir</a:t>
-            </a:r>
-          </a:p>
-        </p:txBody>
-      </p:sp>
-      <p:sp>
-        <p:nvSpPr>
-          <p:cNvPr id="15" name="Rectangle 14"/>
+              <a:t>Desenhar o diagrama de sequência da lista de presença, que faltou no Grau A.</a:t>
+            </a:r>
+          </a:p>
+        </p:txBody>
+      </p:sp>
+      <p:sp>
+        <p:nvSpPr>
+          <p:cNvPr id="8" name="Rectangle 7"/>
           <p:cNvSpPr/>
           <p:nvPr/>
         </p:nvSpPr>
         <p:spPr>
           <a:xfrm>
-            <a:off x="685800" y="3491160"/>
-            <a:ext cx="10820400" cy="9525"/>
+            <a:off x="704850" y="3976116"/>
+            <a:ext cx="57150" cy="57150"/>
           </a:xfrm>
           <a:prstGeom prst="rect">
             <a:avLst/>
           </a:prstGeom>
           <a:solidFill>
-            <a:srgbClr val="EDEDF2"/>
+            <a:srgbClr val="E94D1C"/>
           </a:solidFill>
           <a:ln>
             <a:noFill/>
@@ -18699,14 +18426,14 @@
       </p:sp>
       <p:sp>
         <p:nvSpPr>
-          <p:cNvPr id="16" name="TextBox 15"/>
+          <p:cNvPr id="9" name="TextBox 8"/>
           <p:cNvSpPr txBox="1"/>
           <p:nvPr/>
         </p:nvSpPr>
         <p:spPr>
           <a:xfrm>
-            <a:off x="685800" y="3614985"/>
-            <a:ext cx="6496050" cy="762000"/>
+            <a:off x="971550" y="3867150"/>
+            <a:ext cx="10134600" cy="95250"/>
           </a:xfrm>
           <a:prstGeom prst="rect">
             <a:avLst/>
@@ -18721,115 +18448,37 @@
           <a:p>
             <a:pPr algn="l">
               <a:lnSpc>
-                <a:spcPct val="135000"/>
+                <a:spcPct val="130000"/>
               </a:lnSpc>
             </a:pPr>
             <a:r>
-              <a:rPr sz="1350" b="1" i="0">
-                <a:solidFill>
-                  <a:srgbClr val="21049A"/>
+              <a:rPr sz="1650" b="0" i="0">
+                <a:solidFill>
+                  <a:srgbClr val="1A1A1E"/>
                 </a:solidFill>
                 <a:latin typeface="Roboto"/>
               </a:rPr>
-              <a:t>Completar o protótipo de baixa fidelidade da Sprint 3 a partir das telas reais</a:t>
-            </a:r>
-          </a:p>
-        </p:txBody>
-      </p:sp>
-      <p:sp>
-        <p:nvSpPr>
-          <p:cNvPr id="17" name="TextBox 16"/>
-          <p:cNvSpPr txBox="1"/>
-          <p:nvPr/>
-        </p:nvSpPr>
-        <p:spPr>
-          <a:xfrm>
-            <a:off x="7620000" y="3614985"/>
-            <a:ext cx="1733550" cy="762000"/>
-          </a:xfrm>
-          <a:prstGeom prst="rect">
-            <a:avLst/>
-          </a:prstGeom>
-          <a:noFill/>
-        </p:spPr>
-        <p:txBody>
-          <a:bodyPr wrap="square" lIns="0" rIns="0" tIns="0" bIns="0" anchor="t">
-            <a:spAutoFit/>
-          </a:bodyPr>
-          <a:lstStyle/>
-          <a:p>
-            <a:pPr algn="l">
-              <a:lnSpc>
-                <a:spcPct val="135000"/>
-              </a:lnSpc>
-            </a:pPr>
-            <a:r>
-              <a:rPr sz="1280" b="0" i="0">
-                <a:solidFill>
-                  <a:srgbClr val="1A1A1E"/>
-                </a:solidFill>
-                <a:latin typeface="Roboto"/>
-              </a:rPr>
-              <a:t>a definir</a:t>
-            </a:r>
-          </a:p>
-        </p:txBody>
-      </p:sp>
-      <p:sp>
-        <p:nvSpPr>
-          <p:cNvPr id="18" name="TextBox 17"/>
-          <p:cNvSpPr txBox="1"/>
-          <p:nvPr/>
-        </p:nvSpPr>
-        <p:spPr>
-          <a:xfrm>
-            <a:off x="9620250" y="3614985"/>
-            <a:ext cx="1714500" cy="762000"/>
-          </a:xfrm>
-          <a:prstGeom prst="rect">
-            <a:avLst/>
-          </a:prstGeom>
-          <a:noFill/>
-        </p:spPr>
-        <p:txBody>
-          <a:bodyPr wrap="square" lIns="0" rIns="0" tIns="0" bIns="0" anchor="t">
-            <a:spAutoFit/>
-          </a:bodyPr>
-          <a:lstStyle/>
-          <a:p>
-            <a:pPr algn="l">
-              <a:lnSpc>
-                <a:spcPct val="135000"/>
-              </a:lnSpc>
-            </a:pPr>
-            <a:r>
-              <a:rPr sz="1280" b="0" i="0">
-                <a:solidFill>
-                  <a:srgbClr val="1A1A1E"/>
-                </a:solidFill>
-                <a:latin typeface="Roboto"/>
-              </a:rPr>
-              <a:t>a definir</a:t>
-            </a:r>
-          </a:p>
-        </p:txBody>
-      </p:sp>
-      <p:sp>
-        <p:nvSpPr>
-          <p:cNvPr id="19" name="Rectangle 18"/>
+              <a:t>Completar o protótipo de baixa fidelidade da Sprint 3 a partir das telas reais.</a:t>
+            </a:r>
+          </a:p>
+        </p:txBody>
+      </p:sp>
+      <p:sp>
+        <p:nvSpPr>
+          <p:cNvPr id="10" name="Rectangle 9"/>
           <p:cNvSpPr/>
           <p:nvPr/>
         </p:nvSpPr>
         <p:spPr>
           <a:xfrm>
-            <a:off x="685800" y="3976440"/>
-            <a:ext cx="10820400" cy="9525"/>
+            <a:off x="704850" y="4538472"/>
+            <a:ext cx="57150" cy="57150"/>
           </a:xfrm>
           <a:prstGeom prst="rect">
             <a:avLst/>
           </a:prstGeom>
           <a:solidFill>
-            <a:srgbClr val="EDEDF2"/>
+            <a:srgbClr val="E94D1C"/>
           </a:solidFill>
           <a:ln>
             <a:noFill/>
@@ -18860,14 +18509,14 @@
       </p:sp>
       <p:sp>
         <p:nvSpPr>
-          <p:cNvPr id="20" name="TextBox 19"/>
+          <p:cNvPr id="11" name="TextBox 10"/>
           <p:cNvSpPr txBox="1"/>
           <p:nvPr/>
         </p:nvSpPr>
         <p:spPr>
           <a:xfrm>
-            <a:off x="685800" y="4100265"/>
-            <a:ext cx="6496050" cy="762000"/>
+            <a:off x="971550" y="4429506"/>
+            <a:ext cx="10134600" cy="95250"/>
           </a:xfrm>
           <a:prstGeom prst="rect">
             <a:avLst/>
@@ -18882,115 +18531,37 @@
           <a:p>
             <a:pPr algn="l">
               <a:lnSpc>
-                <a:spcPct val="135000"/>
+                <a:spcPct val="130000"/>
               </a:lnSpc>
             </a:pPr>
             <a:r>
-              <a:rPr sz="1350" b="1" i="0">
-                <a:solidFill>
-                  <a:srgbClr val="21049A"/>
+              <a:rPr sz="1650" b="0" i="0">
+                <a:solidFill>
+                  <a:srgbClr val="1A1A1E"/>
                 </a:solidFill>
                 <a:latin typeface="Roboto"/>
               </a:rPr>
-              <a:t>Aval do time às decisões novas da arquitetura</a:t>
-            </a:r>
-          </a:p>
-        </p:txBody>
-      </p:sp>
-      <p:sp>
-        <p:nvSpPr>
-          <p:cNvPr id="21" name="TextBox 20"/>
-          <p:cNvSpPr txBox="1"/>
-          <p:nvPr/>
-        </p:nvSpPr>
-        <p:spPr>
-          <a:xfrm>
-            <a:off x="7620000" y="4100265"/>
-            <a:ext cx="1733550" cy="762000"/>
-          </a:xfrm>
-          <a:prstGeom prst="rect">
-            <a:avLst/>
-          </a:prstGeom>
-          <a:noFill/>
-        </p:spPr>
-        <p:txBody>
-          <a:bodyPr wrap="square" lIns="0" rIns="0" tIns="0" bIns="0" anchor="t">
-            <a:spAutoFit/>
-          </a:bodyPr>
-          <a:lstStyle/>
-          <a:p>
-            <a:pPr algn="l">
-              <a:lnSpc>
-                <a:spcPct val="135000"/>
-              </a:lnSpc>
-            </a:pPr>
-            <a:r>
-              <a:rPr sz="1280" b="0" i="0">
-                <a:solidFill>
-                  <a:srgbClr val="1A1A1E"/>
-                </a:solidFill>
-                <a:latin typeface="Roboto"/>
-              </a:rPr>
-              <a:t>a definir</a:t>
-            </a:r>
-          </a:p>
-        </p:txBody>
-      </p:sp>
-      <p:sp>
-        <p:nvSpPr>
-          <p:cNvPr id="22" name="TextBox 21"/>
-          <p:cNvSpPr txBox="1"/>
-          <p:nvPr/>
-        </p:nvSpPr>
-        <p:spPr>
-          <a:xfrm>
-            <a:off x="9620250" y="4100265"/>
-            <a:ext cx="1714500" cy="762000"/>
-          </a:xfrm>
-          <a:prstGeom prst="rect">
-            <a:avLst/>
-          </a:prstGeom>
-          <a:noFill/>
-        </p:spPr>
-        <p:txBody>
-          <a:bodyPr wrap="square" lIns="0" rIns="0" tIns="0" bIns="0" anchor="t">
-            <a:spAutoFit/>
-          </a:bodyPr>
-          <a:lstStyle/>
-          <a:p>
-            <a:pPr algn="l">
-              <a:lnSpc>
-                <a:spcPct val="135000"/>
-              </a:lnSpc>
-            </a:pPr>
-            <a:r>
-              <a:rPr sz="1280" b="0" i="0">
-                <a:solidFill>
-                  <a:srgbClr val="1A1A1E"/>
-                </a:solidFill>
-                <a:latin typeface="Roboto"/>
-              </a:rPr>
-              <a:t>a definir</a:t>
-            </a:r>
-          </a:p>
-        </p:txBody>
-      </p:sp>
-      <p:sp>
-        <p:nvSpPr>
-          <p:cNvPr id="23" name="Rectangle 22"/>
+              <a:t>Dar o aval do time às decisões novas da arquitetura.</a:t>
+            </a:r>
+          </a:p>
+        </p:txBody>
+      </p:sp>
+      <p:sp>
+        <p:nvSpPr>
+          <p:cNvPr id="12" name="Rectangle 11"/>
           <p:cNvSpPr/>
           <p:nvPr/>
         </p:nvSpPr>
         <p:spPr>
           <a:xfrm>
-            <a:off x="685800" y="4461720"/>
-            <a:ext cx="10820400" cy="9525"/>
+            <a:off x="704850" y="5100828"/>
+            <a:ext cx="57150" cy="57150"/>
           </a:xfrm>
           <a:prstGeom prst="rect">
             <a:avLst/>
           </a:prstGeom>
           <a:solidFill>
-            <a:srgbClr val="EDEDF2"/>
+            <a:srgbClr val="E94D1C"/>
           </a:solidFill>
           <a:ln>
             <a:noFill/>
@@ -19021,14 +18592,14 @@
       </p:sp>
       <p:sp>
         <p:nvSpPr>
-          <p:cNvPr id="24" name="TextBox 23"/>
+          <p:cNvPr id="13" name="TextBox 12"/>
           <p:cNvSpPr txBox="1"/>
           <p:nvPr/>
         </p:nvSpPr>
         <p:spPr>
           <a:xfrm>
-            <a:off x="685800" y="4585545"/>
-            <a:ext cx="6496050" cy="762000"/>
+            <a:off x="971550" y="4991862"/>
+            <a:ext cx="10134600" cy="95250"/>
           </a:xfrm>
           <a:prstGeom prst="rect">
             <a:avLst/>
@@ -19043,31 +18614,31 @@
           <a:p>
             <a:pPr algn="l">
               <a:lnSpc>
-                <a:spcPct val="135000"/>
+                <a:spcPct val="130000"/>
               </a:lnSpc>
             </a:pPr>
             <a:r>
-              <a:rPr sz="1350" b="1" i="0">
-                <a:solidFill>
-                  <a:srgbClr val="21049A"/>
+              <a:rPr sz="1650" b="0" i="0">
+                <a:solidFill>
+                  <a:srgbClr val="1A1A1E"/>
                 </a:solidFill>
                 <a:latin typeface="Roboto"/>
               </a:rPr>
-              <a:t>Fechar o Team Charter</a:t>
-            </a:r>
-          </a:p>
-        </p:txBody>
-      </p:sp>
-      <p:sp>
-        <p:nvSpPr>
-          <p:cNvPr id="25" name="TextBox 24"/>
+              <a:t>Preparar e ensaiar o Pitch Final.</a:t>
+            </a:r>
+          </a:p>
+        </p:txBody>
+      </p:sp>
+      <p:sp>
+        <p:nvSpPr>
+          <p:cNvPr id="14" name="TextBox 13"/>
           <p:cNvSpPr txBox="1"/>
           <p:nvPr/>
         </p:nvSpPr>
         <p:spPr>
           <a:xfrm>
-            <a:off x="7620000" y="4585545"/>
-            <a:ext cx="1733550" cy="762000"/>
+            <a:off x="685800" y="6324600"/>
+            <a:ext cx="6667500" cy="182880"/>
           </a:xfrm>
           <a:prstGeom prst="rect">
             <a:avLst/>
@@ -19082,289 +18653,6 @@
           <a:p>
             <a:pPr algn="l">
               <a:lnSpc>
-                <a:spcPct val="135000"/>
-              </a:lnSpc>
-            </a:pPr>
-            <a:r>
-              <a:rPr sz="1280" b="0" i="0">
-                <a:solidFill>
-                  <a:srgbClr val="1A1A1E"/>
-                </a:solidFill>
-                <a:latin typeface="Roboto"/>
-              </a:rPr>
-              <a:t>a definir</a:t>
-            </a:r>
-          </a:p>
-        </p:txBody>
-      </p:sp>
-      <p:sp>
-        <p:nvSpPr>
-          <p:cNvPr id="26" name="TextBox 25"/>
-          <p:cNvSpPr txBox="1"/>
-          <p:nvPr/>
-        </p:nvSpPr>
-        <p:spPr>
-          <a:xfrm>
-            <a:off x="9620250" y="4585545"/>
-            <a:ext cx="1714500" cy="762000"/>
-          </a:xfrm>
-          <a:prstGeom prst="rect">
-            <a:avLst/>
-          </a:prstGeom>
-          <a:noFill/>
-        </p:spPr>
-        <p:txBody>
-          <a:bodyPr wrap="square" lIns="0" rIns="0" tIns="0" bIns="0" anchor="t">
-            <a:spAutoFit/>
-          </a:bodyPr>
-          <a:lstStyle/>
-          <a:p>
-            <a:pPr algn="l">
-              <a:lnSpc>
-                <a:spcPct val="135000"/>
-              </a:lnSpc>
-            </a:pPr>
-            <a:r>
-              <a:rPr sz="1280" b="0" i="0">
-                <a:solidFill>
-                  <a:srgbClr val="1A1A1E"/>
-                </a:solidFill>
-                <a:latin typeface="Roboto"/>
-              </a:rPr>
-              <a:t>a definir</a:t>
-            </a:r>
-          </a:p>
-        </p:txBody>
-      </p:sp>
-      <p:sp>
-        <p:nvSpPr>
-          <p:cNvPr id="27" name="Rectangle 26"/>
-          <p:cNvSpPr/>
-          <p:nvPr/>
-        </p:nvSpPr>
-        <p:spPr>
-          <a:xfrm>
-            <a:off x="685800" y="4946999"/>
-            <a:ext cx="10820400" cy="9525"/>
-          </a:xfrm>
-          <a:prstGeom prst="rect">
-            <a:avLst/>
-          </a:prstGeom>
-          <a:solidFill>
-            <a:srgbClr val="EDEDF2"/>
-          </a:solidFill>
-          <a:ln>
-            <a:noFill/>
-          </a:ln>
-          <a:effectLst/>
-        </p:spPr>
-        <p:style>
-          <a:lnRef idx="1">
-            <a:schemeClr val="accent1"/>
-          </a:lnRef>
-          <a:fillRef idx="3">
-            <a:schemeClr val="accent1"/>
-          </a:fillRef>
-          <a:effectRef idx="2">
-            <a:schemeClr val="accent1"/>
-          </a:effectRef>
-          <a:fontRef idx="minor">
-            <a:schemeClr val="lt1"/>
-          </a:fontRef>
-        </p:style>
-        <p:txBody>
-          <a:bodyPr rtlCol="0" anchor="ctr" wrap="square" lIns="0" rIns="0" tIns="0" bIns="0"/>
-          <a:lstStyle/>
-          <a:p>
-            <a:pPr algn="ctr"/>
-          </a:p>
-        </p:txBody>
-      </p:sp>
-      <p:sp>
-        <p:nvSpPr>
-          <p:cNvPr id="28" name="TextBox 27"/>
-          <p:cNvSpPr txBox="1"/>
-          <p:nvPr/>
-        </p:nvSpPr>
-        <p:spPr>
-          <a:xfrm>
-            <a:off x="685800" y="5070824"/>
-            <a:ext cx="6496050" cy="762000"/>
-          </a:xfrm>
-          <a:prstGeom prst="rect">
-            <a:avLst/>
-          </a:prstGeom>
-          <a:noFill/>
-        </p:spPr>
-        <p:txBody>
-          <a:bodyPr wrap="square" lIns="0" rIns="0" tIns="0" bIns="0" anchor="t">
-            <a:spAutoFit/>
-          </a:bodyPr>
-          <a:lstStyle/>
-          <a:p>
-            <a:pPr algn="l">
-              <a:lnSpc>
-                <a:spcPct val="135000"/>
-              </a:lnSpc>
-            </a:pPr>
-            <a:r>
-              <a:rPr sz="1350" b="1" i="0">
-                <a:solidFill>
-                  <a:srgbClr val="21049A"/>
-                </a:solidFill>
-                <a:latin typeface="Roboto"/>
-              </a:rPr>
-              <a:t>Deck e ensaio do Pitch Final</a:t>
-            </a:r>
-          </a:p>
-        </p:txBody>
-      </p:sp>
-      <p:sp>
-        <p:nvSpPr>
-          <p:cNvPr id="29" name="TextBox 28"/>
-          <p:cNvSpPr txBox="1"/>
-          <p:nvPr/>
-        </p:nvSpPr>
-        <p:spPr>
-          <a:xfrm>
-            <a:off x="7620000" y="5070824"/>
-            <a:ext cx="1733550" cy="762000"/>
-          </a:xfrm>
-          <a:prstGeom prst="rect">
-            <a:avLst/>
-          </a:prstGeom>
-          <a:noFill/>
-        </p:spPr>
-        <p:txBody>
-          <a:bodyPr wrap="square" lIns="0" rIns="0" tIns="0" bIns="0" anchor="t">
-            <a:spAutoFit/>
-          </a:bodyPr>
-          <a:lstStyle/>
-          <a:p>
-            <a:pPr algn="l">
-              <a:lnSpc>
-                <a:spcPct val="135000"/>
-              </a:lnSpc>
-            </a:pPr>
-            <a:r>
-              <a:rPr sz="1280" b="0" i="0">
-                <a:solidFill>
-                  <a:srgbClr val="1A1A1E"/>
-                </a:solidFill>
-                <a:latin typeface="Roboto"/>
-              </a:rPr>
-              <a:t>a definir</a:t>
-            </a:r>
-          </a:p>
-        </p:txBody>
-      </p:sp>
-      <p:sp>
-        <p:nvSpPr>
-          <p:cNvPr id="30" name="TextBox 29"/>
-          <p:cNvSpPr txBox="1"/>
-          <p:nvPr/>
-        </p:nvSpPr>
-        <p:spPr>
-          <a:xfrm>
-            <a:off x="9620250" y="5070824"/>
-            <a:ext cx="1714500" cy="762000"/>
-          </a:xfrm>
-          <a:prstGeom prst="rect">
-            <a:avLst/>
-          </a:prstGeom>
-          <a:noFill/>
-        </p:spPr>
-        <p:txBody>
-          <a:bodyPr wrap="square" lIns="0" rIns="0" tIns="0" bIns="0" anchor="t">
-            <a:spAutoFit/>
-          </a:bodyPr>
-          <a:lstStyle/>
-          <a:p>
-            <a:pPr algn="l">
-              <a:lnSpc>
-                <a:spcPct val="135000"/>
-              </a:lnSpc>
-            </a:pPr>
-            <a:r>
-              <a:rPr sz="1280" b="0" i="0">
-                <a:solidFill>
-                  <a:srgbClr val="1A1A1E"/>
-                </a:solidFill>
-                <a:latin typeface="Roboto"/>
-              </a:rPr>
-              <a:t>a definir</a:t>
-            </a:r>
-          </a:p>
-        </p:txBody>
-      </p:sp>
-      <p:sp>
-        <p:nvSpPr>
-          <p:cNvPr id="31" name="Rectangle 30"/>
-          <p:cNvSpPr/>
-          <p:nvPr/>
-        </p:nvSpPr>
-        <p:spPr>
-          <a:xfrm>
-            <a:off x="685800" y="5432279"/>
-            <a:ext cx="10820400" cy="9525"/>
-          </a:xfrm>
-          <a:prstGeom prst="rect">
-            <a:avLst/>
-          </a:prstGeom>
-          <a:solidFill>
-            <a:srgbClr val="EDEDF2"/>
-          </a:solidFill>
-          <a:ln>
-            <a:noFill/>
-          </a:ln>
-          <a:effectLst/>
-        </p:spPr>
-        <p:style>
-          <a:lnRef idx="1">
-            <a:schemeClr val="accent1"/>
-          </a:lnRef>
-          <a:fillRef idx="3">
-            <a:schemeClr val="accent1"/>
-          </a:fillRef>
-          <a:effectRef idx="2">
-            <a:schemeClr val="accent1"/>
-          </a:effectRef>
-          <a:fontRef idx="minor">
-            <a:schemeClr val="lt1"/>
-          </a:fontRef>
-        </p:style>
-        <p:txBody>
-          <a:bodyPr rtlCol="0" anchor="ctr" wrap="square" lIns="0" rIns="0" tIns="0" bIns="0"/>
-          <a:lstStyle/>
-          <a:p>
-            <a:pPr algn="ctr"/>
-          </a:p>
-        </p:txBody>
-      </p:sp>
-      <p:sp>
-        <p:nvSpPr>
-          <p:cNvPr id="32" name="TextBox 31"/>
-          <p:cNvSpPr txBox="1"/>
-          <p:nvPr/>
-        </p:nvSpPr>
-        <p:spPr>
-          <a:xfrm>
-            <a:off x="685800" y="6324600"/>
-            <a:ext cx="6667500" cy="182880"/>
-          </a:xfrm>
-          <a:prstGeom prst="rect">
-            <a:avLst/>
-          </a:prstGeom>
-          <a:noFill/>
-        </p:spPr>
-        <p:txBody>
-          <a:bodyPr wrap="square" lIns="0" rIns="0" tIns="0" bIns="0" anchor="t">
-            <a:spAutoFit/>
-          </a:bodyPr>
-          <a:lstStyle/>
-          <a:p>
-            <a:pPr algn="l">
-              <a:lnSpc>
                 <a:spcPct val="120000"/>
               </a:lnSpc>
             </a:pPr>
@@ -19382,7 +18670,7 @@
       </p:sp>
       <p:sp>
         <p:nvSpPr>
-          <p:cNvPr id="33" name="TextBox 32"/>
+          <p:cNvPr id="15" name="TextBox 14"/>
           <p:cNvSpPr txBox="1"/>
           <p:nvPr/>
         </p:nvSpPr>

</xml_diff>

<commit_message>
docs: deck do T3 com textos mais diretos, quebras corrigidas e o fechamento com o Tiago
</commit_message>
<xml_diff>
--- a/trabalhos/T3-Apresentacao-Intermediaria.pptx
+++ b/trabalhos/T3-Apresentacao-Intermediaria.pptx
@@ -542,7 +542,7 @@
           <a:lstStyle/>
           <a:p>
             <a:r>
-              <a:t>Andreas. Somos o Time 04. Nosso projeto é um app para gerenciamento de convites, com confirmação de presença e restrições alimentares. Vamos apresentar o problema e o escopo, a arquitetura implementada, o front-end, o back-end, uma demonstração e o planejamento até 17/11. Cada um responde pelo próprio bloco na arguição.</a:t>
+              <a:t>Andreas. Somos o Time 04. O nosso projeto é um app para gerenciar convites de festa: o anfitrião cria o convite e acompanha quem vai, e o convidado responde pelo link. Vamos mostrar o problema, a arquitetura implementada, o front-end, o back-end, a aplicação funcionando e o que falta até 17/11.</a:t>
             </a:r>
           </a:p>
         </p:txBody>
@@ -752,7 +752,7 @@
           <a:lstStyle/>
           <a:p>
             <a:r>
-              <a:t>Este slide fica na tela enquanto o Guilherme assume o compartilhamento. Abrir dizendo: a conta já está criada para poupar tempo; a tela de entrada está no apêndice. O Guilherme opera a tela em todos os passos, e o Gabriel narra os passos do convidado. Depois da demonstração, na mesma tela: o quadro do Azure Boards (Guilherme), o GitHub (Tiago) e a organização do trabalho (Andreas).</a:t>
+              <a:t>O Tiago opera a tela, na máquina dele, e os outros dois narram: o Guilherme as telas do anfitrião e o Gabriel a parte do convidado e o que a API faz. Abrir dizendo: a conta já está criada para poupar tempo; a tela de entrada está no apêndice. Depois da demonstração, na mesma tela: o quadro do Azure Boards (Guilherme narra) e o GitHub (Tiago).</a:t>
             </a:r>
           </a:p>
         </p:txBody>
@@ -822,7 +822,7 @@
           <a:lstStyle/>
           <a:p>
             <a:r>
-              <a:t>Andreas. Planejamos em sprints de duas semanas e acompanhamos no quadro Kanban do Azure Boards, com cada história quebrada em tarefas de tela e de API. Conversamos pelo WhatsApp e discutimos o projeto no tempo de aula. O que decidimos fica registrado no repositório, no Guia, nos ADRs e nos Ajustes da Sprint 5. Integramos por PR, e a CI verde é a nossa definição de pronto.</a:t>
+              <a:t>Tiago. Planejamos em sprints de duas semanas e acompanhamos no quadro Kanban do Azure Boards, com cada história dividida em tarefas de tela e de API. Não usamos o Teams: conversamos pelo WhatsApp e nas aulas, e o que decidimos fica registrado no repositório, no Guia, nos ADRs e nos Ajustes da Sprint 5. Cada mudança entra na main por PR, depois que a integração contínua passa.</a:t>
             </a:r>
           </a:p>
         </p:txBody>
@@ -892,7 +892,7 @@
           <a:lstStyle/>
           <a:p>
             <a:r>
-              <a:t>Andreas. Cada dificuldade foi contada por quem a viveu: a integração pelo Tiago, o protótipo pelo Guilherme e a regra de vagas pelo Gabriel. Este slide só as reúne, com as lições que o time tirou delas. Se perguntarem detalhes, passar para o dono de cada uma.</a:t>
+              <a:t>Tiago. Cada dificuldade já foi contada por quem passou por ela: a integração por mim, o protótipo pelo Guilherme e a regra de vagas pelo Gabriel. Aqui elas aparecem juntas. Se perguntarem detalhes, passar para quem passou por cada uma.</a:t>
             </a:r>
           </a:p>
         </p:txBody>
@@ -962,7 +962,7 @@
           <a:lstStyle/>
           <a:p>
             <a:r>
-              <a:t>Andreas. Estes são os itens da Sprint 6, de 03/11 a 16/11, até a apresentação final em 17/11. Se tiver assumido algum deles, dizer qual.</a:t>
+              <a:t>Tiago. Estes são os itens da Sprint 6, de 03/11 a 16/11, até a apresentação final em 17/11.</a:t>
             </a:r>
           </a:p>
         </p:txBody>
@@ -1032,7 +1032,7 @@
           <a:lstStyle/>
           <a:p>
             <a:r>
-              <a:t>Andreas, fechamento: as doze histórias estão implementadas, e as mudanças em relação à arquitetura do Grau A estão registradas com o motivo. Até 17/11 vamos revisar a documentação contra o código e preparar o Pitch. Para perguntas: requisitos e planejamento comigo, arquitetura e Docker com o Tiago, telas e quadro com o Guilherme, API e regras com o Gabriel.</a:t>
+              <a:t>Tiago, fechamento: as doze histórias estão implementadas, e as mudanças em relação à arquitetura do Grau A estão registradas com o motivo. Até 17/11 vamos revisar a documentação contra o código e preparar o Pitch. Para perguntas: problema e requisitos com o Andreas, arquitetura e Docker comigo, telas e quadro com o Guilherme, API e testes com o Gabriel.</a:t>
             </a:r>
           </a:p>
         </p:txBody>
@@ -1102,7 +1102,7 @@
           <a:lstStyle/>
           <a:p>
             <a:r>
-              <a:t>Andreas. As personas foram levantadas pelo time na Sprint 1: a anfitriã e o convidado como usuários primários, e o buffet como interessado secundário, que é quem recebe a lista.</a:t>
+              <a:t>Andreas. As personas foram levantadas na Sprint 1: a anfitriã e o convidado, que usam o app, e o buffet, que recebe a lista.</a:t>
             </a:r>
           </a:p>
         </p:txBody>
@@ -1172,7 +1172,7 @@
           <a:lstStyle/>
           <a:p>
             <a:r>
-              <a:t>Andreas. São seis grupos com as doze histórias de usuário. No quadro do Azure Boards elas aparecem como H01 a H12: conta do anfitrião é a H01, criação do convite da H02 à H04, compartilhamento H05 e H06, confirmação da H07 à H09, restrições alimentares H10, e o painel H11 e H12.</a:t>
+              <a:t>Andreas. São doze histórias de usuário nesses seis grupos, e as doze estão implementadas. No quadro do Azure Boards elas aparecem como H01 a H12: conta é a H01, criação do convite da H02 à H04, compartilhamento H05 e H06, confirmação da H07 à H09, restrições H10, e o painel H11 e H12. Passagem: o Tiago mostra como o projeto evoluiu e a arquitetura.</a:t>
             </a:r>
           </a:p>
         </p:txBody>
@@ -1242,7 +1242,7 @@
           <a:lstStyle/>
           <a:p>
             <a:r>
-              <a:t>Andreas. No Grau A o projeto tinha doze histórias, o Guia da Arquitetura e um protótipo de telas. Na Sprint 4 foi feita a base: o repositório, o pacote de tipos compartilhado entre front e back, a integração contínua e o compose. Na Sprint 5 o front e o back foram integrados nessa base, e o que precisou mudar na arquitetura foi registrado com o motivo. As doze histórias estão implementadas. Passagem: o Tiago apresenta a arquitetura implementada.</a:t>
+              <a:t>Tiago. No Grau A o projeto tinha as doze histórias, o Guia da Arquitetura e um protótipo de telas. Na Sprint 4 eu montei a base: o repositório, o pacote de tipos compartilhado entre front e back, a integração contínua e o compose. Na Sprint 5 o front e o back foram integrados nessa base, e o que precisou mudar na arquitetura foi registrado com o motivo.</a:t>
             </a:r>
           </a:p>
         </p:txBody>
@@ -1452,7 +1452,7 @@
           <a:lstStyle/>
           <a:p>
             <a:r>
-              <a:t>Tiago. Fala final: a regra do teto de vagas o Gabriel mostra no bloco dele. Dificuldade do bloco: juntar o front e o back, que foram escritos em paralelo, fora da main. A integração foi em duas etapas. Primeiro o front, com um mock que responde às rotas com os tipos do contract. Depois o back. Em cada etapa, o que não cabia na arquitetura foi adequado, registrado com o motivo nos Ajustes da Sprint 5, e só entrou na main com a CI verde. O contract permitiu juntar as duas partes sem reescrever tudo. Ele deveria ter sido feito antes das telas. Passagem: o Guilherme apresenta o front-end, que partiu do protótipo dele.</a:t>
+              <a:t>Tiago. A regra do teto de vagas fica para o Gabriel. Dificuldade do bloco: juntar o front e o back, que foram escritos em paralelo, fora da main. A integração foi em duas etapas. Primeiro o front, com um mock que responde às rotas com os tipos do contract. Depois o back. Em cada etapa, o que não cabia na arquitetura foi adequado, registrado com o motivo nos Ajustes da Sprint 5, e só entrou na main com a CI verde. O contract permitiu juntar as duas partes sem reescrever tudo. Ele deveria ter sido feito antes das telas. Passagem: o Guilherme apresenta o front-end, que partiu do protótipo dele.</a:t>
             </a:r>
           </a:p>
         </p:txBody>
@@ -12780,7 +12780,7 @@
             </a:r>
           </a:p>
           <a:p>
-            <a:pPr>
+            <a:pPr algn="l">
               <a:lnSpc>
                 <a:spcPct val="102000"/>
               </a:lnSpc>
@@ -12988,7 +12988,7 @@
             </a:r>
           </a:p>
           <a:p>
-            <a:pPr>
+            <a:pPr algn="l">
               <a:lnSpc>
                 <a:spcPct val="140000"/>
               </a:lnSpc>
@@ -13082,7 +13082,7 @@
             </a:r>
           </a:p>
           <a:p>
-            <a:pPr>
+            <a:pPr algn="l">
               <a:lnSpc>
                 <a:spcPct val="140000"/>
               </a:lnSpc>
@@ -15016,27 +15016,101 @@
       </p:sp>
       <p:sp>
         <p:nvSpPr>
-          <p:cNvPr id="4" name="Rounded Rectangle 3"/>
+          <p:cNvPr id="4" name="TextBox 3"/>
+          <p:cNvSpPr txBox="1"/>
+          <p:nvPr/>
+        </p:nvSpPr>
+        <p:spPr>
+          <a:xfrm>
+            <a:off x="685800" y="2384096"/>
+            <a:ext cx="3143250" cy="167640"/>
+          </a:xfrm>
+          <a:prstGeom prst="rect">
+            <a:avLst/>
+          </a:prstGeom>
+          <a:noFill/>
+        </p:spPr>
+        <p:txBody>
+          <a:bodyPr wrap="square" lIns="0" rIns="0" tIns="0" bIns="0" anchor="t">
+            <a:spAutoFit/>
+          </a:bodyPr>
+          <a:lstStyle/>
+          <a:p>
+            <a:pPr algn="l">
+              <a:lnSpc>
+                <a:spcPct val="120000"/>
+              </a:lnSpc>
+            </a:pPr>
+            <a:r>
+              <a:rPr sz="819" b="1" i="0" spc="120">
+                <a:solidFill>
+                  <a:srgbClr val="21049A"/>
+                </a:solidFill>
+                <a:latin typeface="Roboto"/>
+              </a:rPr>
+              <a:t>TESTES</a:t>
+            </a:r>
+          </a:p>
+        </p:txBody>
+      </p:sp>
+      <p:sp>
+        <p:nvSpPr>
+          <p:cNvPr id="5" name="TextBox 4"/>
+          <p:cNvSpPr txBox="1"/>
+          <p:nvPr/>
+        </p:nvSpPr>
+        <p:spPr>
+          <a:xfrm>
+            <a:off x="4000500" y="2384096"/>
+            <a:ext cx="7505700" cy="167640"/>
+          </a:xfrm>
+          <a:prstGeom prst="rect">
+            <a:avLst/>
+          </a:prstGeom>
+          <a:noFill/>
+        </p:spPr>
+        <p:txBody>
+          <a:bodyPr wrap="square" lIns="0" rIns="0" tIns="0" bIns="0" anchor="t">
+            <a:spAutoFit/>
+          </a:bodyPr>
+          <a:lstStyle/>
+          <a:p>
+            <a:pPr algn="l">
+              <a:lnSpc>
+                <a:spcPct val="120000"/>
+              </a:lnSpc>
+            </a:pPr>
+            <a:r>
+              <a:rPr sz="819" b="1" i="0" spc="120">
+                <a:solidFill>
+                  <a:srgbClr val="21049A"/>
+                </a:solidFill>
+                <a:latin typeface="Roboto"/>
+              </a:rPr>
+              <a:t>O QUE COBREM</a:t>
+            </a:r>
+          </a:p>
+        </p:txBody>
+      </p:sp>
+      <p:sp>
+        <p:nvSpPr>
+          <p:cNvPr id="6" name="Rectangle 5"/>
           <p:cNvSpPr/>
           <p:nvPr/>
         </p:nvSpPr>
         <p:spPr>
           <a:xfrm>
-            <a:off x="685800" y="2482642"/>
-            <a:ext cx="3454400" cy="2273427"/>
-          </a:xfrm>
-          <a:prstGeom prst="roundRect">
-            <a:avLst>
-              <a:gd name="adj" fmla="val 3351"/>
-            </a:avLst>
+            <a:off x="685800" y="2612696"/>
+            <a:ext cx="10820400" cy="19050"/>
+          </a:xfrm>
+          <a:prstGeom prst="rect">
+            <a:avLst/>
           </a:prstGeom>
           <a:solidFill>
-            <a:srgbClr val="F2F2F5"/>
+            <a:srgbClr val="21049A"/>
           </a:solidFill>
-          <a:ln w="12700">
-            <a:solidFill>
-              <a:srgbClr val="D9D9D9"/>
-            </a:solidFill>
+          <a:ln>
+            <a:noFill/>
           </a:ln>
           <a:effectLst/>
         </p:spPr>
@@ -15064,14 +15138,14 @@
       </p:sp>
       <p:sp>
         <p:nvSpPr>
-          <p:cNvPr id="5" name="TextBox 4"/>
+          <p:cNvPr id="7" name="TextBox 6"/>
           <p:cNvSpPr txBox="1"/>
           <p:nvPr/>
         </p:nvSpPr>
         <p:spPr>
           <a:xfrm>
-            <a:off x="914400" y="2673142"/>
-            <a:ext cx="2997200" cy="167640"/>
+            <a:off x="685800" y="2765096"/>
+            <a:ext cx="2971800" cy="762000"/>
           </a:xfrm>
           <a:prstGeom prst="rect">
             <a:avLst/>
@@ -15086,31 +15160,31 @@
           <a:p>
             <a:pPr algn="l">
               <a:lnSpc>
-                <a:spcPct val="120000"/>
+                <a:spcPct val="135000"/>
               </a:lnSpc>
             </a:pPr>
             <a:r>
-              <a:rPr sz="819" b="1" i="0" spc="140">
-                <a:solidFill>
-                  <a:srgbClr val="E94D1C"/>
+              <a:rPr sz="1350" b="1" i="0">
+                <a:solidFill>
+                  <a:srgbClr val="21049A"/>
                 </a:solidFill>
                 <a:latin typeface="Roboto"/>
               </a:rPr>
-              <a:t>DOMÍNIO</a:t>
-            </a:r>
-          </a:p>
-        </p:txBody>
-      </p:sp>
-      <p:sp>
-        <p:nvSpPr>
-          <p:cNvPr id="6" name="TextBox 5"/>
+              <a:t>Regras do Domínio</a:t>
+            </a:r>
+          </a:p>
+        </p:txBody>
+      </p:sp>
+      <p:sp>
+        <p:nvSpPr>
+          <p:cNvPr id="8" name="TextBox 7"/>
           <p:cNvSpPr txBox="1"/>
           <p:nvPr/>
         </p:nvSpPr>
         <p:spPr>
           <a:xfrm>
-            <a:off x="914400" y="2901742"/>
-            <a:ext cx="2997200" cy="304800"/>
+            <a:off x="4000500" y="2765096"/>
+            <a:ext cx="7334250" cy="762000"/>
           </a:xfrm>
           <a:prstGeom prst="rect">
             <a:avLst/>
@@ -15125,83 +15199,40 @@
           <a:p>
             <a:pPr algn="l">
               <a:lnSpc>
-                <a:spcPct val="120000"/>
+                <a:spcPct val="135000"/>
               </a:lnSpc>
             </a:pPr>
             <a:r>
-              <a:rPr sz="1500" b="1" i="0">
-                <a:solidFill>
-                  <a:srgbClr val="21049A"/>
+              <a:rPr sz="1280" b="0" i="0">
+                <a:solidFill>
+                  <a:srgbClr val="1A1A1E"/>
                 </a:solidFill>
                 <a:latin typeface="Roboto"/>
               </a:rPr>
-              <a:t>Regras</a:t>
-            </a:r>
-          </a:p>
-        </p:txBody>
-      </p:sp>
-      <p:sp>
-        <p:nvSpPr>
-          <p:cNvPr id="7" name="TextBox 6"/>
-          <p:cNvSpPr txBox="1"/>
-          <p:nvPr/>
-        </p:nvSpPr>
-        <p:spPr>
-          <a:xfrm>
-            <a:off x="914400" y="3282742"/>
-            <a:ext cx="2997200" cy="1320927"/>
-          </a:xfrm>
-          <a:prstGeom prst="rect">
-            <a:avLst/>
-          </a:prstGeom>
-          <a:noFill/>
-        </p:spPr>
-        <p:txBody>
-          <a:bodyPr wrap="square" lIns="0" rIns="0" tIns="0" bIns="0" anchor="t">
-            <a:spAutoFit/>
-          </a:bodyPr>
-          <a:lstStyle/>
-          <a:p>
-            <a:pPr algn="l">
-              <a:lnSpc>
-                <a:spcPct val="145000"/>
-              </a:lnSpc>
-            </a:pPr>
-            <a:r>
-              <a:rPr sz="1350" b="0" i="0">
-                <a:solidFill>
-                  <a:srgbClr val="3A3A44"/>
-                </a:solidFill>
-                <a:latin typeface="Roboto"/>
-              </a:rPr>
-              <a:t>Vagas pedidas por resposta, o não vou zerando acompanhantes e observação, descrição da alergia, comparação por dia no fuso do projeto e publicação.</a:t>
-            </a:r>
-          </a:p>
-        </p:txBody>
-      </p:sp>
-      <p:sp>
-        <p:nvSpPr>
-          <p:cNvPr id="8" name="Rounded Rectangle 7"/>
+              <a:t>Vagas pedidas por resposta, o não vou zerando acompanhantes e observação, descrição da alergia, data comparada por dia no fuso do projeto e publicação</a:t>
+            </a:r>
+          </a:p>
+        </p:txBody>
+      </p:sp>
+      <p:sp>
+        <p:nvSpPr>
+          <p:cNvPr id="9" name="Rectangle 8"/>
           <p:cNvSpPr/>
           <p:nvPr/>
         </p:nvSpPr>
         <p:spPr>
           <a:xfrm>
-            <a:off x="4368800" y="2482642"/>
-            <a:ext cx="3454400" cy="2273427"/>
-          </a:xfrm>
-          <a:prstGeom prst="roundRect">
-            <a:avLst>
-              <a:gd name="adj" fmla="val 3351"/>
-            </a:avLst>
+            <a:off x="685800" y="3337777"/>
+            <a:ext cx="10820400" cy="9525"/>
+          </a:xfrm>
+          <a:prstGeom prst="rect">
+            <a:avLst/>
           </a:prstGeom>
           <a:solidFill>
-            <a:srgbClr val="F2F2F5"/>
+            <a:srgbClr val="EDEDF2"/>
           </a:solidFill>
-          <a:ln w="19050">
-            <a:solidFill>
-              <a:srgbClr val="E94D1C"/>
-            </a:solidFill>
+          <a:ln>
+            <a:noFill/>
           </a:ln>
           <a:effectLst/>
         </p:spPr>
@@ -15229,14 +15260,14 @@
       </p:sp>
       <p:sp>
         <p:nvSpPr>
-          <p:cNvPr id="9" name="TextBox 8"/>
+          <p:cNvPr id="10" name="TextBox 9"/>
           <p:cNvSpPr txBox="1"/>
           <p:nvPr/>
         </p:nvSpPr>
         <p:spPr>
           <a:xfrm>
-            <a:off x="4597400" y="2673142"/>
-            <a:ext cx="2997200" cy="167640"/>
+            <a:off x="685800" y="3461602"/>
+            <a:ext cx="2971800" cy="762000"/>
           </a:xfrm>
           <a:prstGeom prst="rect">
             <a:avLst/>
@@ -15251,31 +15282,31 @@
           <a:p>
             <a:pPr algn="l">
               <a:lnSpc>
-                <a:spcPct val="120000"/>
+                <a:spcPct val="135000"/>
               </a:lnSpc>
             </a:pPr>
             <a:r>
-              <a:rPr sz="819" b="1" i="0" spc="140">
-                <a:solidFill>
-                  <a:srgbClr val="E94D1C"/>
+              <a:rPr sz="1350" b="1" i="0">
+                <a:solidFill>
+                  <a:srgbClr val="21049A"/>
                 </a:solidFill>
                 <a:latin typeface="Roboto"/>
               </a:rPr>
-              <a:t>BANCO</a:t>
-            </a:r>
-          </a:p>
-        </p:txBody>
-      </p:sp>
-      <p:sp>
-        <p:nvSpPr>
-          <p:cNvPr id="10" name="TextBox 9"/>
+              <a:t>Consultas no PostgreSQL</a:t>
+            </a:r>
+          </a:p>
+        </p:txBody>
+      </p:sp>
+      <p:sp>
+        <p:nvSpPr>
+          <p:cNvPr id="11" name="TextBox 10"/>
           <p:cNvSpPr txBox="1"/>
           <p:nvPr/>
         </p:nvSpPr>
         <p:spPr>
           <a:xfrm>
-            <a:off x="4597400" y="2901742"/>
-            <a:ext cx="2997200" cy="304800"/>
+            <a:off x="4000500" y="3461602"/>
+            <a:ext cx="7334250" cy="762000"/>
           </a:xfrm>
           <a:prstGeom prst="rect">
             <a:avLst/>
@@ -15290,83 +15321,40 @@
           <a:p>
             <a:pPr algn="l">
               <a:lnSpc>
-                <a:spcPct val="120000"/>
+                <a:spcPct val="135000"/>
               </a:lnSpc>
             </a:pPr>
             <a:r>
-              <a:rPr sz="1500" b="1" i="0">
-                <a:solidFill>
-                  <a:srgbClr val="E94D1C"/>
+              <a:rPr sz="1280" b="0" i="0">
+                <a:solidFill>
+                  <a:srgbClr val="1A1A1E"/>
                 </a:solidFill>
                 <a:latin typeface="Roboto"/>
               </a:rPr>
-              <a:t>Contra PostgreSQL</a:t>
-            </a:r>
-          </a:p>
-        </p:txBody>
-      </p:sp>
-      <p:sp>
-        <p:nvSpPr>
-          <p:cNvPr id="11" name="TextBox 10"/>
-          <p:cNvSpPr txBox="1"/>
-          <p:nvPr/>
-        </p:nvSpPr>
-        <p:spPr>
-          <a:xfrm>
-            <a:off x="4597400" y="3282742"/>
-            <a:ext cx="2997200" cy="1320927"/>
-          </a:xfrm>
-          <a:prstGeom prst="rect">
-            <a:avLst/>
-          </a:prstGeom>
-          <a:noFill/>
-        </p:spPr>
-        <p:txBody>
-          <a:bodyPr wrap="square" lIns="0" rIns="0" tIns="0" bIns="0" anchor="t">
-            <a:spAutoFit/>
-          </a:bodyPr>
-          <a:lstStyle/>
-          <a:p>
-            <a:pPr algn="l">
-              <a:lnSpc>
-                <a:spcPct val="145000"/>
-              </a:lnSpc>
-            </a:pPr>
-            <a:r>
-              <a:rPr sz="1350" b="0" i="0">
-                <a:solidFill>
-                  <a:srgbClr val="3A3A44"/>
-                </a:solidFill>
-                <a:latin typeface="Roboto"/>
-              </a:rPr>
-              <a:t>Gravação dentro do teto e concorrência: quatro respostas simultâneas pedindo duas vagas cada, num teto de cinco. Passam duas.</a:t>
-            </a:r>
-          </a:p>
-        </p:txBody>
-      </p:sp>
-      <p:sp>
-        <p:nvSpPr>
-          <p:cNvPr id="12" name="Rounded Rectangle 11"/>
+              <a:t>Gravação dentro do teto e concorrência: quatro respostas simultâneas pedindo duas vagas cada, num teto de cinco. Passam duas</a:t>
+            </a:r>
+          </a:p>
+        </p:txBody>
+      </p:sp>
+      <p:sp>
+        <p:nvSpPr>
+          <p:cNvPr id="12" name="Rectangle 11"/>
           <p:cNvSpPr/>
           <p:nvPr/>
         </p:nvSpPr>
         <p:spPr>
           <a:xfrm>
-            <a:off x="8051800" y="2482642"/>
-            <a:ext cx="3454400" cy="2273427"/>
-          </a:xfrm>
-          <a:prstGeom prst="roundRect">
-            <a:avLst>
-              <a:gd name="adj" fmla="val 3351"/>
-            </a:avLst>
+            <a:off x="685800" y="4034283"/>
+            <a:ext cx="10820400" cy="9525"/>
+          </a:xfrm>
+          <a:prstGeom prst="rect">
+            <a:avLst/>
           </a:prstGeom>
           <a:solidFill>
-            <a:srgbClr val="F2F2F5"/>
+            <a:srgbClr val="EDEDF2"/>
           </a:solidFill>
-          <a:ln w="12700">
-            <a:solidFill>
-              <a:srgbClr val="D9D9D9"/>
-            </a:solidFill>
+          <a:ln>
+            <a:noFill/>
           </a:ln>
           <a:effectLst/>
         </p:spPr>
@@ -15400,8 +15388,8 @@
         </p:nvSpPr>
         <p:spPr>
           <a:xfrm>
-            <a:off x="8280400" y="2673142"/>
-            <a:ext cx="2997200" cy="167640"/>
+            <a:off x="685800" y="4158108"/>
+            <a:ext cx="2971800" cy="762000"/>
           </a:xfrm>
           <a:prstGeom prst="rect">
             <a:avLst/>
@@ -15416,17 +15404,17 @@
           <a:p>
             <a:pPr algn="l">
               <a:lnSpc>
-                <a:spcPct val="120000"/>
+                <a:spcPct val="135000"/>
               </a:lnSpc>
             </a:pPr>
             <a:r>
-              <a:rPr sz="819" b="1" i="0" spc="140">
-                <a:solidFill>
-                  <a:srgbClr val="E94D1C"/>
+              <a:rPr sz="1350" b="1" i="0">
+                <a:solidFill>
+                  <a:srgbClr val="21049A"/>
                 </a:solidFill>
                 <a:latin typeface="Roboto"/>
               </a:rPr>
-              <a:t>ROTAS</a:t>
+              <a:t>Rotas de ponta a ponta</a:t>
             </a:r>
           </a:p>
         </p:txBody>
@@ -15439,8 +15427,8 @@
         </p:nvSpPr>
         <p:spPr>
           <a:xfrm>
-            <a:off x="8280400" y="2901742"/>
-            <a:ext cx="2997200" cy="304800"/>
+            <a:off x="4000500" y="4158108"/>
+            <a:ext cx="7334250" cy="762000"/>
           </a:xfrm>
           <a:prstGeom prst="rect">
             <a:avLst/>
@@ -15455,57 +15443,62 @@
           <a:p>
             <a:pPr algn="l">
               <a:lnSpc>
-                <a:spcPct val="120000"/>
+                <a:spcPct val="135000"/>
               </a:lnSpc>
             </a:pPr>
             <a:r>
-              <a:rPr sz="1500" b="1" i="0">
-                <a:solidFill>
-                  <a:srgbClr val="21049A"/>
+              <a:rPr sz="1280" b="0" i="0">
+                <a:solidFill>
+                  <a:srgbClr val="1A1A1E"/>
                 </a:solidFill>
                 <a:latin typeface="Roboto"/>
               </a:rPr>
-              <a:t>Ponta a ponta</a:t>
-            </a:r>
-          </a:p>
-        </p:txBody>
-      </p:sp>
-      <p:sp>
-        <p:nvSpPr>
-          <p:cNvPr id="15" name="TextBox 14"/>
-          <p:cNvSpPr txBox="1"/>
-          <p:nvPr/>
-        </p:nvSpPr>
-        <p:spPr>
-          <a:xfrm>
-            <a:off x="8280400" y="3282742"/>
-            <a:ext cx="2997200" cy="1320927"/>
-          </a:xfrm>
-          <a:prstGeom prst="rect">
-            <a:avLst/>
-          </a:prstGeom>
-          <a:noFill/>
-        </p:spPr>
-        <p:txBody>
-          <a:bodyPr wrap="square" lIns="0" rIns="0" tIns="0" bIns="0" anchor="t">
-            <a:spAutoFit/>
-          </a:bodyPr>
-          <a:lstStyle/>
-          <a:p>
-            <a:pPr algn="l">
-              <a:lnSpc>
-                <a:spcPct val="145000"/>
-              </a:lnSpc>
-            </a:pPr>
-            <a:r>
-              <a:rPr sz="1350" b="0" i="0">
-                <a:solidFill>
-                  <a:srgbClr val="3A3A44"/>
-                </a:solidFill>
-                <a:latin typeface="Roboto"/>
-              </a:rPr>
-              <a:t>O fluxo completo pelas rotas, e o mesmo 404 para link inválido, convite despublicado e convite de outro anfitrião.</a:t>
-            </a:r>
+              <a:t>O fluxo completo, e o mesmo 404 para link inválido, convite despublicado e convite de outro anfitrião</a:t>
+            </a:r>
+          </a:p>
+        </p:txBody>
+      </p:sp>
+      <p:sp>
+        <p:nvSpPr>
+          <p:cNvPr id="15" name="Rectangle 14"/>
+          <p:cNvSpPr/>
+          <p:nvPr/>
+        </p:nvSpPr>
+        <p:spPr>
+          <a:xfrm>
+            <a:off x="685800" y="4730789"/>
+            <a:ext cx="10820400" cy="9525"/>
+          </a:xfrm>
+          <a:prstGeom prst="rect">
+            <a:avLst/>
+          </a:prstGeom>
+          <a:solidFill>
+            <a:srgbClr val="EDEDF2"/>
+          </a:solidFill>
+          <a:ln>
+            <a:noFill/>
+          </a:ln>
+          <a:effectLst/>
+        </p:spPr>
+        <p:style>
+          <a:lnRef idx="1">
+            <a:schemeClr val="accent1"/>
+          </a:lnRef>
+          <a:fillRef idx="3">
+            <a:schemeClr val="accent1"/>
+          </a:fillRef>
+          <a:effectRef idx="2">
+            <a:schemeClr val="accent1"/>
+          </a:effectRef>
+          <a:fontRef idx="minor">
+            <a:schemeClr val="lt1"/>
+          </a:fontRef>
+        </p:style>
+        <p:txBody>
+          <a:bodyPr rtlCol="0" anchor="ctr" wrap="square" lIns="0" rIns="0" tIns="0" bIns="0"/>
+          <a:lstStyle/>
+          <a:p>
+            <a:pPr algn="ctr"/>
           </a:p>
         </p:txBody>
       </p:sp>
@@ -15587,7 +15580,7 @@
                 </a:solidFill>
                 <a:latin typeface="Roboto"/>
               </a:rPr>
-              <a:t>Os testes rodam na integração contínua em todo PR, com um PostgreSQL de serviço.</a:t>
+              <a:t>Todos rodam na integração contínua, a cada PR, com um PostgreSQL de serviço.</a:t>
             </a:r>
           </a:p>
         </p:txBody>
@@ -15767,8 +15760,8 @@
         </p:nvSpPr>
         <p:spPr>
           <a:xfrm>
-            <a:off x="685800" y="2038998"/>
-            <a:ext cx="3619500" cy="167640"/>
+            <a:off x="685800" y="2144611"/>
+            <a:ext cx="3143250" cy="167640"/>
           </a:xfrm>
           <a:prstGeom prst="rect">
             <a:avLst/>
@@ -15806,8 +15799,8 @@
         </p:nvSpPr>
         <p:spPr>
           <a:xfrm>
-            <a:off x="4476750" y="2038998"/>
-            <a:ext cx="4476750" cy="167640"/>
+            <a:off x="4000500" y="2144611"/>
+            <a:ext cx="5238750" cy="167640"/>
           </a:xfrm>
           <a:prstGeom prst="rect">
             <a:avLst/>
@@ -15845,8 +15838,8 @@
         </p:nvSpPr>
         <p:spPr>
           <a:xfrm>
-            <a:off x="9144000" y="2038998"/>
-            <a:ext cx="2362200" cy="167640"/>
+            <a:off x="9429750" y="2144611"/>
+            <a:ext cx="2076450" cy="167640"/>
           </a:xfrm>
           <a:prstGeom prst="rect">
             <a:avLst/>
@@ -15884,7 +15877,7 @@
         </p:nvSpPr>
         <p:spPr>
           <a:xfrm>
-            <a:off x="685800" y="2267598"/>
+            <a:off x="685800" y="2373211"/>
             <a:ext cx="10820400" cy="19050"/>
           </a:xfrm>
           <a:prstGeom prst="rect">
@@ -15928,8 +15921,8 @@
         </p:nvSpPr>
         <p:spPr>
           <a:xfrm>
-            <a:off x="685800" y="2419998"/>
-            <a:ext cx="3448050" cy="762000"/>
+            <a:off x="685800" y="2525611"/>
+            <a:ext cx="2971800" cy="762000"/>
           </a:xfrm>
           <a:prstGeom prst="rect">
             <a:avLst/>
@@ -15967,8 +15960,8 @@
         </p:nvSpPr>
         <p:spPr>
           <a:xfrm>
-            <a:off x="4476750" y="2419998"/>
-            <a:ext cx="4305300" cy="762000"/>
+            <a:off x="4000500" y="2525611"/>
+            <a:ext cx="5067300" cy="762000"/>
           </a:xfrm>
           <a:prstGeom prst="rect">
             <a:avLst/>
@@ -16006,8 +15999,8 @@
         </p:nvSpPr>
         <p:spPr>
           <a:xfrm>
-            <a:off x="9144000" y="2419998"/>
-            <a:ext cx="2190750" cy="762000"/>
+            <a:off x="9429750" y="2525611"/>
+            <a:ext cx="1905000" cy="762000"/>
           </a:xfrm>
           <a:prstGeom prst="rect">
             <a:avLst/>
@@ -16045,7 +16038,7 @@
         </p:nvSpPr>
         <p:spPr>
           <a:xfrm>
-            <a:off x="685800" y="2781452"/>
+            <a:off x="685800" y="2887066"/>
             <a:ext cx="10820400" cy="9525"/>
           </a:xfrm>
           <a:prstGeom prst="rect">
@@ -16089,8 +16082,8 @@
         </p:nvSpPr>
         <p:spPr>
           <a:xfrm>
-            <a:off x="685800" y="2905277"/>
-            <a:ext cx="3448050" cy="762000"/>
+            <a:off x="685800" y="3010891"/>
+            <a:ext cx="2971800" cy="762000"/>
           </a:xfrm>
           <a:prstGeom prst="rect">
             <a:avLst/>
@@ -16128,8 +16121,8 @@
         </p:nvSpPr>
         <p:spPr>
           <a:xfrm>
-            <a:off x="4476750" y="2905277"/>
-            <a:ext cx="4305300" cy="762000"/>
+            <a:off x="4000500" y="3010891"/>
+            <a:ext cx="5067300" cy="762000"/>
           </a:xfrm>
           <a:prstGeom prst="rect">
             <a:avLst/>
@@ -16167,8 +16160,8 @@
         </p:nvSpPr>
         <p:spPr>
           <a:xfrm>
-            <a:off x="9144000" y="2905277"/>
-            <a:ext cx="2190750" cy="762000"/>
+            <a:off x="9429750" y="3010891"/>
+            <a:ext cx="1905000" cy="762000"/>
           </a:xfrm>
           <a:prstGeom prst="rect">
             <a:avLst/>
@@ -16206,7 +16199,7 @@
         </p:nvSpPr>
         <p:spPr>
           <a:xfrm>
-            <a:off x="685800" y="3477958"/>
+            <a:off x="685800" y="3372345"/>
             <a:ext cx="10820400" cy="9525"/>
           </a:xfrm>
           <a:prstGeom prst="rect">
@@ -16250,8 +16243,8 @@
         </p:nvSpPr>
         <p:spPr>
           <a:xfrm>
-            <a:off x="685800" y="3601784"/>
-            <a:ext cx="3448050" cy="762000"/>
+            <a:off x="685800" y="3496170"/>
+            <a:ext cx="2971800" cy="762000"/>
           </a:xfrm>
           <a:prstGeom prst="rect">
             <a:avLst/>
@@ -16289,8 +16282,8 @@
         </p:nvSpPr>
         <p:spPr>
           <a:xfrm>
-            <a:off x="4476750" y="3601784"/>
-            <a:ext cx="4305300" cy="762000"/>
+            <a:off x="4000500" y="3496170"/>
+            <a:ext cx="5067300" cy="762000"/>
           </a:xfrm>
           <a:prstGeom prst="rect">
             <a:avLst/>
@@ -16328,8 +16321,8 @@
         </p:nvSpPr>
         <p:spPr>
           <a:xfrm>
-            <a:off x="9144000" y="3601784"/>
-            <a:ext cx="2190750" cy="762000"/>
+            <a:off x="9429750" y="3496170"/>
+            <a:ext cx="1905000" cy="762000"/>
           </a:xfrm>
           <a:prstGeom prst="rect">
             <a:avLst/>
@@ -16367,7 +16360,7 @@
         </p:nvSpPr>
         <p:spPr>
           <a:xfrm>
-            <a:off x="685800" y="3963238"/>
+            <a:off x="685800" y="3857625"/>
             <a:ext cx="10820400" cy="9525"/>
           </a:xfrm>
           <a:prstGeom prst="rect">
@@ -16411,8 +16404,8 @@
         </p:nvSpPr>
         <p:spPr>
           <a:xfrm>
-            <a:off x="685800" y="4087063"/>
-            <a:ext cx="3448050" cy="762000"/>
+            <a:off x="685800" y="3981450"/>
+            <a:ext cx="2971800" cy="762000"/>
           </a:xfrm>
           <a:prstGeom prst="rect">
             <a:avLst/>
@@ -16450,8 +16443,8 @@
         </p:nvSpPr>
         <p:spPr>
           <a:xfrm>
-            <a:off x="4476750" y="4087063"/>
-            <a:ext cx="4305300" cy="762000"/>
+            <a:off x="4000500" y="3981450"/>
+            <a:ext cx="5067300" cy="762000"/>
           </a:xfrm>
           <a:prstGeom prst="rect">
             <a:avLst/>
@@ -16489,8 +16482,8 @@
         </p:nvSpPr>
         <p:spPr>
           <a:xfrm>
-            <a:off x="9144000" y="4087063"/>
-            <a:ext cx="2190750" cy="762000"/>
+            <a:off x="9429750" y="3981450"/>
+            <a:ext cx="1905000" cy="762000"/>
           </a:xfrm>
           <a:prstGeom prst="rect">
             <a:avLst/>
@@ -16528,7 +16521,7 @@
         </p:nvSpPr>
         <p:spPr>
           <a:xfrm>
-            <a:off x="685800" y="4448518"/>
+            <a:off x="685800" y="4342905"/>
             <a:ext cx="10820400" cy="9525"/>
           </a:xfrm>
           <a:prstGeom prst="rect">
@@ -16572,8 +16565,8 @@
         </p:nvSpPr>
         <p:spPr>
           <a:xfrm>
-            <a:off x="685800" y="4572343"/>
-            <a:ext cx="3448050" cy="762000"/>
+            <a:off x="685800" y="4466730"/>
+            <a:ext cx="2971800" cy="762000"/>
           </a:xfrm>
           <a:prstGeom prst="rect">
             <a:avLst/>
@@ -16611,8 +16604,8 @@
         </p:nvSpPr>
         <p:spPr>
           <a:xfrm>
-            <a:off x="4476750" y="4572343"/>
-            <a:ext cx="4305300" cy="762000"/>
+            <a:off x="4000500" y="4466730"/>
+            <a:ext cx="5067300" cy="762000"/>
           </a:xfrm>
           <a:prstGeom prst="rect">
             <a:avLst/>
@@ -16650,8 +16643,8 @@
         </p:nvSpPr>
         <p:spPr>
           <a:xfrm>
-            <a:off x="9144000" y="4572343"/>
-            <a:ext cx="2190750" cy="762000"/>
+            <a:off x="9429750" y="4466730"/>
+            <a:ext cx="1905000" cy="762000"/>
           </a:xfrm>
           <a:prstGeom prst="rect">
             <a:avLst/>
@@ -16689,7 +16682,7 @@
         </p:nvSpPr>
         <p:spPr>
           <a:xfrm>
-            <a:off x="685800" y="4933798"/>
+            <a:off x="685800" y="4828184"/>
             <a:ext cx="10820400" cy="9525"/>
           </a:xfrm>
           <a:prstGeom prst="rect">
@@ -16733,8 +16726,8 @@
         </p:nvSpPr>
         <p:spPr>
           <a:xfrm>
-            <a:off x="685800" y="5057623"/>
-            <a:ext cx="3448050" cy="762000"/>
+            <a:off x="685800" y="4952009"/>
+            <a:ext cx="2971800" cy="762000"/>
           </a:xfrm>
           <a:prstGeom prst="rect">
             <a:avLst/>
@@ -16772,8 +16765,8 @@
         </p:nvSpPr>
         <p:spPr>
           <a:xfrm>
-            <a:off x="4476750" y="5057623"/>
-            <a:ext cx="4305300" cy="762000"/>
+            <a:off x="4000500" y="4952009"/>
+            <a:ext cx="5067300" cy="762000"/>
           </a:xfrm>
           <a:prstGeom prst="rect">
             <a:avLst/>
@@ -16811,8 +16804,8 @@
         </p:nvSpPr>
         <p:spPr>
           <a:xfrm>
-            <a:off x="9144000" y="5057623"/>
-            <a:ext cx="2190750" cy="762000"/>
+            <a:off x="9429750" y="4952009"/>
+            <a:ext cx="1905000" cy="762000"/>
           </a:xfrm>
           <a:prstGeom prst="rect">
             <a:avLst/>
@@ -16850,7 +16843,7 @@
         </p:nvSpPr>
         <p:spPr>
           <a:xfrm>
-            <a:off x="685800" y="5419077"/>
+            <a:off x="685800" y="5313464"/>
             <a:ext cx="10820400" cy="9525"/>
           </a:xfrm>
           <a:prstGeom prst="rect">
@@ -16920,7 +16913,7 @@
                 </a:solidFill>
                 <a:latin typeface="Roboto"/>
               </a:rPr>
-              <a:t>Demonstração, Guilherme e Gabriel</a:t>
+              <a:t>Demonstração, Tiago, Guilherme e Gabriel</a:t>
             </a:r>
           </a:p>
         </p:txBody>
@@ -17061,7 +17054,7 @@
         </p:nvSpPr>
         <p:spPr>
           <a:xfrm>
-            <a:off x="704850" y="2998851"/>
+            <a:off x="704850" y="3137154"/>
             <a:ext cx="57150" cy="57150"/>
           </a:xfrm>
           <a:prstGeom prst="rect">
@@ -17105,7 +17098,7 @@
         </p:nvSpPr>
         <p:spPr>
           <a:xfrm>
-            <a:off x="971550" y="2889885"/>
+            <a:off x="971550" y="3028188"/>
             <a:ext cx="10134600" cy="95250"/>
           </a:xfrm>
           <a:prstGeom prst="rect">
@@ -17131,7 +17124,7 @@
                 </a:solidFill>
                 <a:latin typeface="Roboto"/>
               </a:rPr>
-              <a:t>Sprints de duas semanas, acompanhadas no quadro Kanban do Azure Boards. Cada história é quebrada em tarefas de tela e de API, com responsável.</a:t>
+              <a:t>Sprints de duas semanas, acompanhadas no quadro Kanban do Azure Boards. Cada história foi dividida em tarefas de tela e de API.</a:t>
             </a:r>
           </a:p>
         </p:txBody>
@@ -17144,7 +17137,7 @@
         </p:nvSpPr>
         <p:spPr>
           <a:xfrm>
-            <a:off x="704850" y="3837813"/>
+            <a:off x="704850" y="3976116"/>
             <a:ext cx="57150" cy="57150"/>
           </a:xfrm>
           <a:prstGeom prst="rect">
@@ -17188,7 +17181,7 @@
         </p:nvSpPr>
         <p:spPr>
           <a:xfrm>
-            <a:off x="971550" y="3728847"/>
+            <a:off x="971550" y="3867150"/>
             <a:ext cx="10134600" cy="95250"/>
           </a:xfrm>
           <a:prstGeom prst="rect">
@@ -17214,7 +17207,7 @@
                 </a:solidFill>
                 <a:latin typeface="Roboto"/>
               </a:rPr>
-              <a:t>Conversas pelo WhatsApp e no tempo de aula. As decisões ficam registradas na documentação do repositório.</a:t>
+              <a:t>Conversamos pelo WhatsApp e nas aulas. As decisões ficam na documentação do repositório.</a:t>
             </a:r>
           </a:p>
         </p:txBody>
@@ -17227,7 +17220,7 @@
         </p:nvSpPr>
         <p:spPr>
           <a:xfrm>
-            <a:off x="704850" y="4676775"/>
+            <a:off x="704850" y="4538472"/>
             <a:ext cx="57150" cy="57150"/>
           </a:xfrm>
           <a:prstGeom prst="rect">
@@ -17271,7 +17264,7 @@
         </p:nvSpPr>
         <p:spPr>
           <a:xfrm>
-            <a:off x="971550" y="4567809"/>
+            <a:off x="971550" y="4429506"/>
             <a:ext cx="10134600" cy="95250"/>
           </a:xfrm>
           <a:prstGeom prst="rect">
@@ -17297,7 +17290,7 @@
                 </a:solidFill>
                 <a:latin typeface="Roboto"/>
               </a:rPr>
-              <a:t>Integração por PR no GitHub. Um PR só entra na main com a integração contínua aprovada.</a:t>
+              <a:t>Cada mudança entra na main por PR, depois que a integração contínua passa.</a:t>
             </a:r>
           </a:p>
         </p:txBody>
@@ -17336,7 +17329,7 @@
                 </a:solidFill>
                 <a:latin typeface="Roboto"/>
               </a:rPr>
-              <a:t>Organização, Andreas</a:t>
+              <a:t>Organização, Tiago</a:t>
             </a:r>
           </a:p>
         </p:txBody>
@@ -17471,509 +17464,14 @@
       </p:sp>
       <p:sp>
         <p:nvSpPr>
-          <p:cNvPr id="4" name="Rounded Rectangle 3"/>
+          <p:cNvPr id="4" name="Rectangle 3"/>
           <p:cNvSpPr/>
           <p:nvPr/>
         </p:nvSpPr>
         <p:spPr>
           <a:xfrm>
-            <a:off x="685800" y="2428585"/>
-            <a:ext cx="3454400" cy="2133600"/>
-          </a:xfrm>
-          <a:prstGeom prst="roundRect">
-            <a:avLst>
-              <a:gd name="adj" fmla="val 3571"/>
-            </a:avLst>
-          </a:prstGeom>
-          <a:solidFill>
-            <a:srgbClr val="F2F2F5"/>
-          </a:solidFill>
-          <a:ln w="12700">
-            <a:solidFill>
-              <a:srgbClr val="D9D9D9"/>
-            </a:solidFill>
-          </a:ln>
-          <a:effectLst/>
-        </p:spPr>
-        <p:style>
-          <a:lnRef idx="1">
-            <a:schemeClr val="accent1"/>
-          </a:lnRef>
-          <a:fillRef idx="3">
-            <a:schemeClr val="accent1"/>
-          </a:fillRef>
-          <a:effectRef idx="2">
-            <a:schemeClr val="accent1"/>
-          </a:effectRef>
-          <a:fontRef idx="minor">
-            <a:schemeClr val="lt1"/>
-          </a:fontRef>
-        </p:style>
-        <p:txBody>
-          <a:bodyPr rtlCol="0" anchor="ctr" wrap="square" lIns="0" rIns="0" tIns="0" bIns="0"/>
-          <a:lstStyle/>
-          <a:p>
-            <a:pPr algn="ctr"/>
-          </a:p>
-        </p:txBody>
-      </p:sp>
-      <p:sp>
-        <p:nvSpPr>
-          <p:cNvPr id="5" name="TextBox 4"/>
-          <p:cNvSpPr txBox="1"/>
-          <p:nvPr/>
-        </p:nvSpPr>
-        <p:spPr>
-          <a:xfrm>
-            <a:off x="914400" y="2619085"/>
-            <a:ext cx="2997200" cy="167640"/>
-          </a:xfrm>
-          <a:prstGeom prst="rect">
-            <a:avLst/>
-          </a:prstGeom>
-          <a:noFill/>
-        </p:spPr>
-        <p:txBody>
-          <a:bodyPr wrap="square" lIns="0" rIns="0" tIns="0" bIns="0" anchor="t">
-            <a:spAutoFit/>
-          </a:bodyPr>
-          <a:lstStyle/>
-          <a:p>
-            <a:pPr algn="l">
-              <a:lnSpc>
-                <a:spcPct val="120000"/>
-              </a:lnSpc>
-            </a:pPr>
-            <a:r>
-              <a:rPr sz="819" b="1" i="0" spc="140">
-                <a:solidFill>
-                  <a:srgbClr val="E94D1C"/>
-                </a:solidFill>
-                <a:latin typeface="Roboto"/>
-              </a:rPr>
-              <a:t>INTEGRAÇÃO</a:t>
-            </a:r>
-          </a:p>
-        </p:txBody>
-      </p:sp>
-      <p:sp>
-        <p:nvSpPr>
-          <p:cNvPr id="6" name="TextBox 5"/>
-          <p:cNvSpPr txBox="1"/>
-          <p:nvPr/>
-        </p:nvSpPr>
-        <p:spPr>
-          <a:xfrm>
-            <a:off x="914400" y="2847685"/>
-            <a:ext cx="2997200" cy="304800"/>
-          </a:xfrm>
-          <a:prstGeom prst="rect">
-            <a:avLst/>
-          </a:prstGeom>
-          <a:noFill/>
-        </p:spPr>
-        <p:txBody>
-          <a:bodyPr wrap="square" lIns="0" rIns="0" tIns="0" bIns="0" anchor="t">
-            <a:spAutoFit/>
-          </a:bodyPr>
-          <a:lstStyle/>
-          <a:p>
-            <a:pPr algn="l">
-              <a:lnSpc>
-                <a:spcPct val="120000"/>
-              </a:lnSpc>
-            </a:pPr>
-            <a:r>
-              <a:rPr sz="1500" b="1" i="0">
-                <a:solidFill>
-                  <a:srgbClr val="21049A"/>
-                </a:solidFill>
-                <a:latin typeface="Roboto"/>
-              </a:rPr>
-              <a:t>Trabalho feito em paralelo</a:t>
-            </a:r>
-          </a:p>
-        </p:txBody>
-      </p:sp>
-      <p:sp>
-        <p:nvSpPr>
-          <p:cNvPr id="7" name="TextBox 6"/>
-          <p:cNvSpPr txBox="1"/>
-          <p:nvPr/>
-        </p:nvSpPr>
-        <p:spPr>
-          <a:xfrm>
-            <a:off x="914400" y="3228685"/>
-            <a:ext cx="2997200" cy="1181100"/>
-          </a:xfrm>
-          <a:prstGeom prst="rect">
-            <a:avLst/>
-          </a:prstGeom>
-          <a:noFill/>
-        </p:spPr>
-        <p:txBody>
-          <a:bodyPr wrap="square" lIns="0" rIns="0" tIns="0" bIns="0" anchor="t">
-            <a:spAutoFit/>
-          </a:bodyPr>
-          <a:lstStyle/>
-          <a:p>
-            <a:pPr algn="l">
-              <a:lnSpc>
-                <a:spcPct val="145000"/>
-              </a:lnSpc>
-            </a:pPr>
-            <a:r>
-              <a:rPr sz="1350" b="0" i="0">
-                <a:solidFill>
-                  <a:srgbClr val="3A3A44"/>
-                </a:solidFill>
-                <a:latin typeface="Roboto"/>
-              </a:rPr>
-              <a:t>O front e o back foram escritos fora da main e precisaram ser adequados ao pacote de tipos e às camadas para entrar.</a:t>
-            </a:r>
-          </a:p>
-        </p:txBody>
-      </p:sp>
-      <p:sp>
-        <p:nvSpPr>
-          <p:cNvPr id="8" name="Rounded Rectangle 7"/>
-          <p:cNvSpPr/>
-          <p:nvPr/>
-        </p:nvSpPr>
-        <p:spPr>
-          <a:xfrm>
-            <a:off x="4368800" y="2428585"/>
-            <a:ext cx="3454400" cy="2133600"/>
-          </a:xfrm>
-          <a:prstGeom prst="roundRect">
-            <a:avLst>
-              <a:gd name="adj" fmla="val 3571"/>
-            </a:avLst>
-          </a:prstGeom>
-          <a:solidFill>
-            <a:srgbClr val="F2F2F5"/>
-          </a:solidFill>
-          <a:ln w="12700">
-            <a:solidFill>
-              <a:srgbClr val="D9D9D9"/>
-            </a:solidFill>
-          </a:ln>
-          <a:effectLst/>
-        </p:spPr>
-        <p:style>
-          <a:lnRef idx="1">
-            <a:schemeClr val="accent1"/>
-          </a:lnRef>
-          <a:fillRef idx="3">
-            <a:schemeClr val="accent1"/>
-          </a:fillRef>
-          <a:effectRef idx="2">
-            <a:schemeClr val="accent1"/>
-          </a:effectRef>
-          <a:fontRef idx="minor">
-            <a:schemeClr val="lt1"/>
-          </a:fontRef>
-        </p:style>
-        <p:txBody>
-          <a:bodyPr rtlCol="0" anchor="ctr" wrap="square" lIns="0" rIns="0" tIns="0" bIns="0"/>
-          <a:lstStyle/>
-          <a:p>
-            <a:pPr algn="ctr"/>
-          </a:p>
-        </p:txBody>
-      </p:sp>
-      <p:sp>
-        <p:nvSpPr>
-          <p:cNvPr id="9" name="TextBox 8"/>
-          <p:cNvSpPr txBox="1"/>
-          <p:nvPr/>
-        </p:nvSpPr>
-        <p:spPr>
-          <a:xfrm>
-            <a:off x="4597400" y="2619085"/>
-            <a:ext cx="2997200" cy="167640"/>
-          </a:xfrm>
-          <a:prstGeom prst="rect">
-            <a:avLst/>
-          </a:prstGeom>
-          <a:noFill/>
-        </p:spPr>
-        <p:txBody>
-          <a:bodyPr wrap="square" lIns="0" rIns="0" tIns="0" bIns="0" anchor="t">
-            <a:spAutoFit/>
-          </a:bodyPr>
-          <a:lstStyle/>
-          <a:p>
-            <a:pPr algn="l">
-              <a:lnSpc>
-                <a:spcPct val="120000"/>
-              </a:lnSpc>
-            </a:pPr>
-            <a:r>
-              <a:rPr sz="819" b="1" i="0" spc="140">
-                <a:solidFill>
-                  <a:srgbClr val="E94D1C"/>
-                </a:solidFill>
-                <a:latin typeface="Roboto"/>
-              </a:rPr>
-              <a:t>FRONT-END</a:t>
-            </a:r>
-          </a:p>
-        </p:txBody>
-      </p:sp>
-      <p:sp>
-        <p:nvSpPr>
-          <p:cNvPr id="10" name="TextBox 9"/>
-          <p:cNvSpPr txBox="1"/>
-          <p:nvPr/>
-        </p:nvSpPr>
-        <p:spPr>
-          <a:xfrm>
-            <a:off x="4597400" y="2847685"/>
-            <a:ext cx="2997200" cy="304800"/>
-          </a:xfrm>
-          <a:prstGeom prst="rect">
-            <a:avLst/>
-          </a:prstGeom>
-          <a:noFill/>
-        </p:spPr>
-        <p:txBody>
-          <a:bodyPr wrap="square" lIns="0" rIns="0" tIns="0" bIns="0" anchor="t">
-            <a:spAutoFit/>
-          </a:bodyPr>
-          <a:lstStyle/>
-          <a:p>
-            <a:pPr algn="l">
-              <a:lnSpc>
-                <a:spcPct val="120000"/>
-              </a:lnSpc>
-            </a:pPr>
-            <a:r>
-              <a:rPr sz="1500" b="1" i="0">
-                <a:solidFill>
-                  <a:srgbClr val="21049A"/>
-                </a:solidFill>
-                <a:latin typeface="Roboto"/>
-              </a:rPr>
-              <a:t>Regras no protótipo</a:t>
-            </a:r>
-          </a:p>
-        </p:txBody>
-      </p:sp>
-      <p:sp>
-        <p:nvSpPr>
-          <p:cNvPr id="11" name="TextBox 10"/>
-          <p:cNvSpPr txBox="1"/>
-          <p:nvPr/>
-        </p:nvSpPr>
-        <p:spPr>
-          <a:xfrm>
-            <a:off x="4597400" y="3228685"/>
-            <a:ext cx="2997200" cy="1181100"/>
-          </a:xfrm>
-          <a:prstGeom prst="rect">
-            <a:avLst/>
-          </a:prstGeom>
-          <a:noFill/>
-        </p:spPr>
-        <p:txBody>
-          <a:bodyPr wrap="square" lIns="0" rIns="0" tIns="0" bIns="0" anchor="t">
-            <a:spAutoFit/>
-          </a:bodyPr>
-          <a:lstStyle/>
-          <a:p>
-            <a:pPr algn="l">
-              <a:lnSpc>
-                <a:spcPct val="145000"/>
-              </a:lnSpc>
-            </a:pPr>
-            <a:r>
-              <a:rPr sz="1350" b="0" i="0">
-                <a:solidFill>
-                  <a:srgbClr val="3A3A44"/>
-                </a:solidFill>
-                <a:latin typeface="Roboto"/>
-              </a:rPr>
-              <a:t>O protótipo nasceu antes de a arquitetura estar no código. Contagem de vagas, CSV e token ficavam na tela.</a:t>
-            </a:r>
-          </a:p>
-        </p:txBody>
-      </p:sp>
-      <p:sp>
-        <p:nvSpPr>
-          <p:cNvPr id="12" name="Rounded Rectangle 11"/>
-          <p:cNvSpPr/>
-          <p:nvPr/>
-        </p:nvSpPr>
-        <p:spPr>
-          <a:xfrm>
-            <a:off x="8051800" y="2428585"/>
-            <a:ext cx="3454400" cy="2133600"/>
-          </a:xfrm>
-          <a:prstGeom prst="roundRect">
-            <a:avLst>
-              <a:gd name="adj" fmla="val 3571"/>
-            </a:avLst>
-          </a:prstGeom>
-          <a:solidFill>
-            <a:srgbClr val="F2F2F5"/>
-          </a:solidFill>
-          <a:ln w="12700">
-            <a:solidFill>
-              <a:srgbClr val="D9D9D9"/>
-            </a:solidFill>
-          </a:ln>
-          <a:effectLst/>
-        </p:spPr>
-        <p:style>
-          <a:lnRef idx="1">
-            <a:schemeClr val="accent1"/>
-          </a:lnRef>
-          <a:fillRef idx="3">
-            <a:schemeClr val="accent1"/>
-          </a:fillRef>
-          <a:effectRef idx="2">
-            <a:schemeClr val="accent1"/>
-          </a:effectRef>
-          <a:fontRef idx="minor">
-            <a:schemeClr val="lt1"/>
-          </a:fontRef>
-        </p:style>
-        <p:txBody>
-          <a:bodyPr rtlCol="0" anchor="ctr" wrap="square" lIns="0" rIns="0" tIns="0" bIns="0"/>
-          <a:lstStyle/>
-          <a:p>
-            <a:pPr algn="ctr"/>
-          </a:p>
-        </p:txBody>
-      </p:sp>
-      <p:sp>
-        <p:nvSpPr>
-          <p:cNvPr id="13" name="TextBox 12"/>
-          <p:cNvSpPr txBox="1"/>
-          <p:nvPr/>
-        </p:nvSpPr>
-        <p:spPr>
-          <a:xfrm>
-            <a:off x="8280400" y="2619085"/>
-            <a:ext cx="2997200" cy="167640"/>
-          </a:xfrm>
-          <a:prstGeom prst="rect">
-            <a:avLst/>
-          </a:prstGeom>
-          <a:noFill/>
-        </p:spPr>
-        <p:txBody>
-          <a:bodyPr wrap="square" lIns="0" rIns="0" tIns="0" bIns="0" anchor="t">
-            <a:spAutoFit/>
-          </a:bodyPr>
-          <a:lstStyle/>
-          <a:p>
-            <a:pPr algn="l">
-              <a:lnSpc>
-                <a:spcPct val="120000"/>
-              </a:lnSpc>
-            </a:pPr>
-            <a:r>
-              <a:rPr sz="819" b="1" i="0" spc="140">
-                <a:solidFill>
-                  <a:srgbClr val="E94D1C"/>
-                </a:solidFill>
-                <a:latin typeface="Roboto"/>
-              </a:rPr>
-              <a:t>BACK-END</a:t>
-            </a:r>
-          </a:p>
-        </p:txBody>
-      </p:sp>
-      <p:sp>
-        <p:nvSpPr>
-          <p:cNvPr id="14" name="TextBox 13"/>
-          <p:cNvSpPr txBox="1"/>
-          <p:nvPr/>
-        </p:nvSpPr>
-        <p:spPr>
-          <a:xfrm>
-            <a:off x="8280400" y="2847685"/>
-            <a:ext cx="2997200" cy="304800"/>
-          </a:xfrm>
-          <a:prstGeom prst="rect">
-            <a:avLst/>
-          </a:prstGeom>
-          <a:noFill/>
-        </p:spPr>
-        <p:txBody>
-          <a:bodyPr wrap="square" lIns="0" rIns="0" tIns="0" bIns="0" anchor="t">
-            <a:spAutoFit/>
-          </a:bodyPr>
-          <a:lstStyle/>
-          <a:p>
-            <a:pPr algn="l">
-              <a:lnSpc>
-                <a:spcPct val="120000"/>
-              </a:lnSpc>
-            </a:pPr>
-            <a:r>
-              <a:rPr sz="1500" b="1" i="0">
-                <a:solidFill>
-                  <a:srgbClr val="21049A"/>
-                </a:solidFill>
-                <a:latin typeface="Roboto"/>
-              </a:rPr>
-              <a:t>Regra na camada errada</a:t>
-            </a:r>
-          </a:p>
-        </p:txBody>
-      </p:sp>
-      <p:sp>
-        <p:nvSpPr>
-          <p:cNvPr id="15" name="TextBox 14"/>
-          <p:cNvSpPr txBox="1"/>
-          <p:nvPr/>
-        </p:nvSpPr>
-        <p:spPr>
-          <a:xfrm>
-            <a:off x="8280400" y="3228685"/>
-            <a:ext cx="2997200" cy="1181100"/>
-          </a:xfrm>
-          <a:prstGeom prst="rect">
-            <a:avLst/>
-          </a:prstGeom>
-          <a:noFill/>
-        </p:spPr>
-        <p:txBody>
-          <a:bodyPr wrap="square" lIns="0" rIns="0" tIns="0" bIns="0" anchor="t">
-            <a:spAutoFit/>
-          </a:bodyPr>
-          <a:lstStyle/>
-          <a:p>
-            <a:pPr algn="l">
-              <a:lnSpc>
-                <a:spcPct val="145000"/>
-              </a:lnSpc>
-            </a:pPr>
-            <a:r>
-              <a:rPr sz="1350" b="0" i="0">
-                <a:solidFill>
-                  <a:srgbClr val="3A3A44"/>
-                </a:solidFill>
-                <a:latin typeface="Roboto"/>
-              </a:rPr>
-              <a:t>A regra das vagas estava na consulta da camada de Dados. O cálculo passou para o Domínio.</a:t>
-            </a:r>
-          </a:p>
-        </p:txBody>
-      </p:sp>
-      <p:sp>
-        <p:nvSpPr>
-          <p:cNvPr id="16" name="Rectangle 15"/>
-          <p:cNvSpPr/>
-          <p:nvPr/>
-        </p:nvSpPr>
-        <p:spPr>
-          <a:xfrm>
-            <a:off x="685800" y="5562021"/>
-            <a:ext cx="28575" cy="457779"/>
+            <a:off x="704850" y="2579370"/>
+            <a:ext cx="57150" cy="57150"/>
           </a:xfrm>
           <a:prstGeom prst="rect">
             <a:avLst/>
@@ -18010,14 +17508,14 @@
       </p:sp>
       <p:sp>
         <p:nvSpPr>
-          <p:cNvPr id="17" name="TextBox 16"/>
+          <p:cNvPr id="5" name="TextBox 4"/>
           <p:cNvSpPr txBox="1"/>
           <p:nvPr/>
         </p:nvSpPr>
         <p:spPr>
           <a:xfrm>
-            <a:off x="876300" y="5542971"/>
-            <a:ext cx="10629900" cy="591129"/>
+            <a:off x="971550" y="2470404"/>
+            <a:ext cx="10134600" cy="95250"/>
           </a:xfrm>
           <a:prstGeom prst="rect">
             <a:avLst/>
@@ -18032,31 +17530,75 @@
           <a:p>
             <a:pPr algn="l">
               <a:lnSpc>
-                <a:spcPct val="150000"/>
+                <a:spcPct val="130000"/>
               </a:lnSpc>
             </a:pPr>
             <a:r>
-              <a:rPr sz="1280" b="0" i="0">
-                <a:solidFill>
-                  <a:srgbClr val="3A3A44"/>
+              <a:rPr sz="1650" b="0" i="0">
+                <a:solidFill>
+                  <a:srgbClr val="1A1A1E"/>
                 </a:solidFill>
                 <a:latin typeface="Roboto"/>
               </a:rPr>
-              <a:t>Lições: definir os tipos compartilhados antes das telas, integrar front e back antes do fim da sprint, e manter as regras de negócio no Domínio desde a primeira versão.</a:t>
-            </a:r>
-          </a:p>
-        </p:txBody>
-      </p:sp>
-      <p:sp>
-        <p:nvSpPr>
-          <p:cNvPr id="18" name="TextBox 17"/>
+              <a:t>O front e o back foram feitos em paralelo, fora da main, e precisaram ser adaptados ao pacote de tipos e às camadas para entrar.</a:t>
+            </a:r>
+          </a:p>
+        </p:txBody>
+      </p:sp>
+      <p:sp>
+        <p:nvSpPr>
+          <p:cNvPr id="6" name="Rectangle 5"/>
+          <p:cNvSpPr/>
+          <p:nvPr/>
+        </p:nvSpPr>
+        <p:spPr>
+          <a:xfrm>
+            <a:off x="704850" y="3418332"/>
+            <a:ext cx="57150" cy="57150"/>
+          </a:xfrm>
+          <a:prstGeom prst="rect">
+            <a:avLst/>
+          </a:prstGeom>
+          <a:solidFill>
+            <a:srgbClr val="E94D1C"/>
+          </a:solidFill>
+          <a:ln>
+            <a:noFill/>
+          </a:ln>
+          <a:effectLst/>
+        </p:spPr>
+        <p:style>
+          <a:lnRef idx="1">
+            <a:schemeClr val="accent1"/>
+          </a:lnRef>
+          <a:fillRef idx="3">
+            <a:schemeClr val="accent1"/>
+          </a:fillRef>
+          <a:effectRef idx="2">
+            <a:schemeClr val="accent1"/>
+          </a:effectRef>
+          <a:fontRef idx="minor">
+            <a:schemeClr val="lt1"/>
+          </a:fontRef>
+        </p:style>
+        <p:txBody>
+          <a:bodyPr rtlCol="0" anchor="ctr" wrap="square" lIns="0" rIns="0" tIns="0" bIns="0"/>
+          <a:lstStyle/>
+          <a:p>
+            <a:pPr algn="ctr"/>
+          </a:p>
+        </p:txBody>
+      </p:sp>
+      <p:sp>
+        <p:nvSpPr>
+          <p:cNvPr id="7" name="TextBox 6"/>
           <p:cNvSpPr txBox="1"/>
           <p:nvPr/>
         </p:nvSpPr>
         <p:spPr>
           <a:xfrm>
-            <a:off x="685800" y="6324600"/>
-            <a:ext cx="6667500" cy="182880"/>
+            <a:off x="971550" y="3309366"/>
+            <a:ext cx="10134600" cy="95250"/>
           </a:xfrm>
           <a:prstGeom prst="rect">
             <a:avLst/>
@@ -18071,24 +17613,229 @@
           <a:p>
             <a:pPr algn="l">
               <a:lnSpc>
-                <a:spcPct val="120000"/>
+                <a:spcPct val="130000"/>
               </a:lnSpc>
             </a:pPr>
             <a:r>
-              <a:rPr sz="900" b="0" i="0">
-                <a:solidFill>
-                  <a:srgbClr val="6B6B78"/>
+              <a:rPr sz="1650" b="0" i="0">
+                <a:solidFill>
+                  <a:srgbClr val="1A1A1E"/>
                 </a:solidFill>
                 <a:latin typeface="Roboto"/>
               </a:rPr>
-              <a:t>Dificuldades, Andreas</a:t>
-            </a:r>
-          </a:p>
-        </p:txBody>
-      </p:sp>
-      <p:sp>
-        <p:nvSpPr>
-          <p:cNvPr id="19" name="TextBox 18"/>
+              <a:t>O protótipo do front foi feito antes de a arquitetura estar no código, e contava vagas, montava o CSV e guardava o token na própria tela.</a:t>
+            </a:r>
+          </a:p>
+        </p:txBody>
+      </p:sp>
+      <p:sp>
+        <p:nvSpPr>
+          <p:cNvPr id="8" name="Rectangle 7"/>
+          <p:cNvSpPr/>
+          <p:nvPr/>
+        </p:nvSpPr>
+        <p:spPr>
+          <a:xfrm>
+            <a:off x="704850" y="4257294"/>
+            <a:ext cx="57150" cy="57150"/>
+          </a:xfrm>
+          <a:prstGeom prst="rect">
+            <a:avLst/>
+          </a:prstGeom>
+          <a:solidFill>
+            <a:srgbClr val="E94D1C"/>
+          </a:solidFill>
+          <a:ln>
+            <a:noFill/>
+          </a:ln>
+          <a:effectLst/>
+        </p:spPr>
+        <p:style>
+          <a:lnRef idx="1">
+            <a:schemeClr val="accent1"/>
+          </a:lnRef>
+          <a:fillRef idx="3">
+            <a:schemeClr val="accent1"/>
+          </a:fillRef>
+          <a:effectRef idx="2">
+            <a:schemeClr val="accent1"/>
+          </a:effectRef>
+          <a:fontRef idx="minor">
+            <a:schemeClr val="lt1"/>
+          </a:fontRef>
+        </p:style>
+        <p:txBody>
+          <a:bodyPr rtlCol="0" anchor="ctr" wrap="square" lIns="0" rIns="0" tIns="0" bIns="0"/>
+          <a:lstStyle/>
+          <a:p>
+            <a:pPr algn="ctr"/>
+          </a:p>
+        </p:txBody>
+      </p:sp>
+      <p:sp>
+        <p:nvSpPr>
+          <p:cNvPr id="9" name="TextBox 8"/>
+          <p:cNvSpPr txBox="1"/>
+          <p:nvPr/>
+        </p:nvSpPr>
+        <p:spPr>
+          <a:xfrm>
+            <a:off x="971550" y="4148328"/>
+            <a:ext cx="10134600" cy="95250"/>
+          </a:xfrm>
+          <a:prstGeom prst="rect">
+            <a:avLst/>
+          </a:prstGeom>
+          <a:noFill/>
+        </p:spPr>
+        <p:txBody>
+          <a:bodyPr wrap="square" lIns="0" rIns="0" tIns="0" bIns="0" anchor="t">
+            <a:spAutoFit/>
+          </a:bodyPr>
+          <a:lstStyle/>
+          <a:p>
+            <a:pPr algn="l">
+              <a:lnSpc>
+                <a:spcPct val="130000"/>
+              </a:lnSpc>
+            </a:pPr>
+            <a:r>
+              <a:rPr sz="1650" b="0" i="0">
+                <a:solidFill>
+                  <a:srgbClr val="1A1A1E"/>
+                </a:solidFill>
+                <a:latin typeface="Roboto"/>
+              </a:rPr>
+              <a:t>Na primeira versão do back-end, a regra das vagas estava na consulta SQL da camada de Dados. O cálculo foi movido para o Domínio.</a:t>
+            </a:r>
+          </a:p>
+        </p:txBody>
+      </p:sp>
+      <p:sp>
+        <p:nvSpPr>
+          <p:cNvPr id="10" name="Rectangle 9"/>
+          <p:cNvSpPr/>
+          <p:nvPr/>
+        </p:nvSpPr>
+        <p:spPr>
+          <a:xfrm>
+            <a:off x="704850" y="5096256"/>
+            <a:ext cx="57150" cy="57150"/>
+          </a:xfrm>
+          <a:prstGeom prst="rect">
+            <a:avLst/>
+          </a:prstGeom>
+          <a:solidFill>
+            <a:srgbClr val="E94D1C"/>
+          </a:solidFill>
+          <a:ln>
+            <a:noFill/>
+          </a:ln>
+          <a:effectLst/>
+        </p:spPr>
+        <p:style>
+          <a:lnRef idx="1">
+            <a:schemeClr val="accent1"/>
+          </a:lnRef>
+          <a:fillRef idx="3">
+            <a:schemeClr val="accent1"/>
+          </a:fillRef>
+          <a:effectRef idx="2">
+            <a:schemeClr val="accent1"/>
+          </a:effectRef>
+          <a:fontRef idx="minor">
+            <a:schemeClr val="lt1"/>
+          </a:fontRef>
+        </p:style>
+        <p:txBody>
+          <a:bodyPr rtlCol="0" anchor="ctr" wrap="square" lIns="0" rIns="0" tIns="0" bIns="0"/>
+          <a:lstStyle/>
+          <a:p>
+            <a:pPr algn="ctr"/>
+          </a:p>
+        </p:txBody>
+      </p:sp>
+      <p:sp>
+        <p:nvSpPr>
+          <p:cNvPr id="11" name="TextBox 10"/>
+          <p:cNvSpPr txBox="1"/>
+          <p:nvPr/>
+        </p:nvSpPr>
+        <p:spPr>
+          <a:xfrm>
+            <a:off x="971550" y="4987290"/>
+            <a:ext cx="10134600" cy="95250"/>
+          </a:xfrm>
+          <a:prstGeom prst="rect">
+            <a:avLst/>
+          </a:prstGeom>
+          <a:noFill/>
+        </p:spPr>
+        <p:txBody>
+          <a:bodyPr wrap="square" lIns="0" rIns="0" tIns="0" bIns="0" anchor="t">
+            <a:spAutoFit/>
+          </a:bodyPr>
+          <a:lstStyle/>
+          <a:p>
+            <a:pPr algn="l">
+              <a:lnSpc>
+                <a:spcPct val="130000"/>
+              </a:lnSpc>
+            </a:pPr>
+            <a:r>
+              <a:rPr sz="1650" b="0" i="0">
+                <a:solidFill>
+                  <a:srgbClr val="1A1A1E"/>
+                </a:solidFill>
+                <a:latin typeface="Roboto"/>
+              </a:rPr>
+              <a:t>Faríamos diferente: definir o pacote de tipos antes das telas e integrar front e back mais cedo.</a:t>
+            </a:r>
+          </a:p>
+        </p:txBody>
+      </p:sp>
+      <p:sp>
+        <p:nvSpPr>
+          <p:cNvPr id="12" name="TextBox 11"/>
+          <p:cNvSpPr txBox="1"/>
+          <p:nvPr/>
+        </p:nvSpPr>
+        <p:spPr>
+          <a:xfrm>
+            <a:off x="685800" y="6324600"/>
+            <a:ext cx="6667500" cy="182880"/>
+          </a:xfrm>
+          <a:prstGeom prst="rect">
+            <a:avLst/>
+          </a:prstGeom>
+          <a:noFill/>
+        </p:spPr>
+        <p:txBody>
+          <a:bodyPr wrap="square" lIns="0" rIns="0" tIns="0" bIns="0" anchor="t">
+            <a:spAutoFit/>
+          </a:bodyPr>
+          <a:lstStyle/>
+          <a:p>
+            <a:pPr algn="l">
+              <a:lnSpc>
+                <a:spcPct val="120000"/>
+              </a:lnSpc>
+            </a:pPr>
+            <a:r>
+              <a:rPr sz="900" b="0" i="0">
+                <a:solidFill>
+                  <a:srgbClr val="6B6B78"/>
+                </a:solidFill>
+                <a:latin typeface="Roboto"/>
+              </a:rPr>
+              <a:t>Dificuldades, Tiago</a:t>
+            </a:r>
+          </a:p>
+        </p:txBody>
+      </p:sp>
+      <p:sp>
+        <p:nvSpPr>
+          <p:cNvPr id="13" name="TextBox 12"/>
           <p:cNvSpPr txBox="1"/>
           <p:nvPr/>
         </p:nvSpPr>
@@ -18222,7 +17969,7 @@
         </p:nvSpPr>
         <p:spPr>
           <a:xfrm>
-            <a:off x="704850" y="2574798"/>
+            <a:off x="704850" y="2713101"/>
             <a:ext cx="57150" cy="57150"/>
           </a:xfrm>
           <a:prstGeom prst="rect">
@@ -18266,7 +18013,7 @@
         </p:nvSpPr>
         <p:spPr>
           <a:xfrm>
-            <a:off x="971550" y="2465832"/>
+            <a:off x="971550" y="2604135"/>
             <a:ext cx="10134600" cy="95250"/>
           </a:xfrm>
           <a:prstGeom prst="rect">
@@ -18292,7 +18039,7 @@
                 </a:solidFill>
                 <a:latin typeface="Roboto"/>
               </a:rPr>
-              <a:t>Revisar os artefatos das Sprints 1 a 3 contra o código, ligando cada história ao caso de uso, à rota, à tela e ao teste.</a:t>
+              <a:t>Revisar os artefatos das Sprints 1 a 3 contra o código, história por história.</a:t>
             </a:r>
           </a:p>
         </p:txBody>
@@ -18305,7 +18052,7 @@
         </p:nvSpPr>
         <p:spPr>
           <a:xfrm>
-            <a:off x="704850" y="3413760"/>
+            <a:off x="704850" y="3275457"/>
             <a:ext cx="57150" cy="57150"/>
           </a:xfrm>
           <a:prstGeom prst="rect">
@@ -18349,7 +18096,7 @@
         </p:nvSpPr>
         <p:spPr>
           <a:xfrm>
-            <a:off x="971550" y="3304794"/>
+            <a:off x="971550" y="3166491"/>
             <a:ext cx="10134600" cy="95250"/>
           </a:xfrm>
           <a:prstGeom prst="rect">
@@ -18388,7 +18135,7 @@
         </p:nvSpPr>
         <p:spPr>
           <a:xfrm>
-            <a:off x="704850" y="3976116"/>
+            <a:off x="704850" y="3837813"/>
             <a:ext cx="57150" cy="57150"/>
           </a:xfrm>
           <a:prstGeom prst="rect">
@@ -18432,7 +18179,7 @@
         </p:nvSpPr>
         <p:spPr>
           <a:xfrm>
-            <a:off x="971550" y="3867150"/>
+            <a:off x="971550" y="3728847"/>
             <a:ext cx="10134600" cy="95250"/>
           </a:xfrm>
           <a:prstGeom prst="rect">
@@ -18471,7 +18218,7 @@
         </p:nvSpPr>
         <p:spPr>
           <a:xfrm>
-            <a:off x="704850" y="4538472"/>
+            <a:off x="704850" y="4400169"/>
             <a:ext cx="57150" cy="57150"/>
           </a:xfrm>
           <a:prstGeom prst="rect">
@@ -18515,7 +18262,7 @@
         </p:nvSpPr>
         <p:spPr>
           <a:xfrm>
-            <a:off x="971550" y="4429506"/>
+            <a:off x="971550" y="4291203"/>
             <a:ext cx="10134600" cy="95250"/>
           </a:xfrm>
           <a:prstGeom prst="rect">
@@ -18554,7 +18301,7 @@
         </p:nvSpPr>
         <p:spPr>
           <a:xfrm>
-            <a:off x="704850" y="5100828"/>
+            <a:off x="704850" y="4962525"/>
             <a:ext cx="57150" cy="57150"/>
           </a:xfrm>
           <a:prstGeom prst="rect">
@@ -18598,7 +18345,7 @@
         </p:nvSpPr>
         <p:spPr>
           <a:xfrm>
-            <a:off x="971550" y="4991862"/>
+            <a:off x="971550" y="4853559"/>
             <a:ext cx="10134600" cy="95250"/>
           </a:xfrm>
           <a:prstGeom prst="rect">
@@ -18663,7 +18410,7 @@
                 </a:solidFill>
                 <a:latin typeface="Roboto"/>
               </a:rPr>
-              <a:t>Planejamento, Andreas</a:t>
+              <a:t>Planejamento, Tiago</a:t>
             </a:r>
           </a:p>
         </p:txBody>
@@ -18903,7 +18650,7 @@
         </p:nvSpPr>
         <p:spPr>
           <a:xfrm>
-            <a:off x="914400" y="2762250"/>
+            <a:off x="914400" y="2609850"/>
             <a:ext cx="8572500" cy="1524000"/>
           </a:xfrm>
           <a:prstGeom prst="rect">
@@ -18929,11 +18676,11 @@
                 </a:solidFill>
                 <a:latin typeface="Roboto"/>
               </a:rPr>
-              <a:t>Andreas Grings: problema, requisitos e planejamento</a:t>
-            </a:r>
-          </a:p>
-          <a:p>
-            <a:pPr>
+              <a:t>Andreas Grings: problema e requisitos</a:t>
+            </a:r>
+          </a:p>
+          <a:p>
+            <a:pPr algn="l">
               <a:lnSpc>
                 <a:spcPct val="150000"/>
               </a:lnSpc>
@@ -18945,11 +18692,11 @@
                 </a:solidFill>
                 <a:latin typeface="Roboto"/>
               </a:rPr>
-              <a:t>Tiago Passos: arquitetura, Docker e GitHub</a:t>
-            </a:r>
-          </a:p>
-          <a:p>
-            <a:pPr>
+              <a:t>Tiago Passos: arquitetura, Docker, GitHub e planejamento</a:t>
+            </a:r>
+          </a:p>
+          <a:p>
+            <a:pPr algn="l">
               <a:lnSpc>
                 <a:spcPct val="150000"/>
               </a:lnSpc>
@@ -18965,7 +18712,7 @@
             </a:r>
           </a:p>
           <a:p>
-            <a:pPr>
+            <a:pPr algn="l">
               <a:lnSpc>
                 <a:spcPct val="150000"/>
               </a:lnSpc>
@@ -18977,7 +18724,7 @@
                 </a:solidFill>
                 <a:latin typeface="Roboto"/>
               </a:rPr>
-              <a:t>Gabriel Tomasi: back-end, regras e testes</a:t>
+              <a:t>Gabriel Tomasi: back-end e testes</a:t>
             </a:r>
           </a:p>
         </p:txBody>
@@ -19016,7 +18763,7 @@
                 </a:solidFill>
                 <a:latin typeface="Roboto"/>
               </a:rPr>
-              <a:t>Perguntas, Andreas</a:t>
+              <a:t>Perguntas, Tiago</a:t>
             </a:r>
           </a:p>
         </p:txBody>
@@ -19363,7 +19110,7 @@
                 </a:solidFill>
                 <a:latin typeface="Roboto"/>
               </a:rPr>
-              <a:t>Capturas da aplicação rodando localmente em 26/10/2026.</a:t>
+              <a:t>Capturas de 26/10/2026.</a:t>
             </a:r>
           </a:p>
         </p:txBody>
@@ -19885,7 +19632,7 @@
                 </a:solidFill>
                 <a:latin typeface="Roboto"/>
               </a:rPr>
-              <a:t>Capturas da aplicação rodando localmente em 26/10/2026.</a:t>
+              <a:t>Capturas de 26/10/2026.</a:t>
             </a:r>
           </a:p>
         </p:txBody>
@@ -20188,7 +19935,7 @@
                 </a:solidFill>
                 <a:latin typeface="Roboto"/>
               </a:rPr>
-              <a:t>Link do convite depois de despublicar</a:t>
+              <a:t>Convite despublicado</a:t>
             </a:r>
           </a:p>
         </p:txBody>
@@ -20271,7 +20018,7 @@
                 </a:solidFill>
                 <a:latin typeface="Roboto"/>
               </a:rPr>
-              <a:t>Capturas da aplicação rodando localmente em 26/10/2026.</a:t>
+              <a:t>Capturas de 26/10/2026.</a:t>
             </a:r>
           </a:p>
         </p:txBody>
@@ -20598,22 +20345,13 @@
               </a:lnSpc>
             </a:pPr>
             <a:r>
-              <a:rPr sz="1650" b="1" i="0">
+              <a:rPr sz="1650" b="0" i="0">
                 <a:solidFill>
                   <a:srgbClr val="1A1A1E"/>
                 </a:solidFill>
                 <a:latin typeface="Roboto"/>
               </a:rPr>
-              <a:t>Anfitriã:</a:t>
-            </a:r>
-            <a:r>
-              <a:rPr sz="1650" b="0" i="0">
-                <a:solidFill>
-                  <a:srgbClr val="1A1A1E"/>
-                </a:solidFill>
-                <a:latin typeface="Roboto"/>
-              </a:rPr>
-              <a:t> cria o convite, compartilha o link e acompanha as respostas.</a:t>
+              <a:t>A anfitriã cria o convite, envia o link e acompanha as respostas.</a:t>
             </a:r>
           </a:p>
         </p:txBody>
@@ -20690,22 +20428,13 @@
               </a:lnSpc>
             </a:pPr>
             <a:r>
-              <a:rPr sz="1650" b="1" i="0">
+              <a:rPr sz="1650" b="0" i="0">
                 <a:solidFill>
                   <a:srgbClr val="1A1A1E"/>
                 </a:solidFill>
                 <a:latin typeface="Roboto"/>
               </a:rPr>
-              <a:t>Convidado:</a:t>
-            </a:r>
-            <a:r>
-              <a:rPr sz="1650" b="0" i="0">
-                <a:solidFill>
-                  <a:srgbClr val="1A1A1E"/>
-                </a:solidFill>
-                <a:latin typeface="Roboto"/>
-              </a:rPr>
-              <a:t> abre o link e responde sem criar conta.</a:t>
+              <a:t>O convidado abre o link e responde sem criar conta.</a:t>
             </a:r>
           </a:p>
         </p:txBody>
@@ -20782,22 +20511,13 @@
               </a:lnSpc>
             </a:pPr>
             <a:r>
-              <a:rPr sz="1650" b="1" i="0">
+              <a:rPr sz="1650" b="0" i="0">
                 <a:solidFill>
                   <a:srgbClr val="1A1A1E"/>
                 </a:solidFill>
                 <a:latin typeface="Roboto"/>
               </a:rPr>
-              <a:t>Buffet:</a:t>
-            </a:r>
-            <a:r>
-              <a:rPr sz="1650" b="0" i="0">
-                <a:solidFill>
-                  <a:srgbClr val="1A1A1E"/>
-                </a:solidFill>
-                <a:latin typeface="Roboto"/>
-              </a:rPr>
-              <a:t> recebe a lista de restrições alimentares para planejar o cardápio.</a:t>
+              <a:t>O buffet recebe a lista de restrições alimentares.</a:t>
             </a:r>
           </a:p>
         </p:txBody>
@@ -21183,7 +20903,7 @@
                 </a:solidFill>
                 <a:latin typeface="Roboto"/>
               </a:rPr>
-              <a:t>Capturas do Azure Boards e do GitHub em 26/10/2026.</a:t>
+              <a:t>Capturas de 26/10/2026.</a:t>
             </a:r>
           </a:p>
         </p:txBody>
@@ -21357,27 +21077,101 @@
       </p:sp>
       <p:sp>
         <p:nvSpPr>
-          <p:cNvPr id="4" name="Rounded Rectangle 3"/>
+          <p:cNvPr id="4" name="TextBox 3"/>
+          <p:cNvSpPr txBox="1"/>
+          <p:nvPr/>
+        </p:nvSpPr>
+        <p:spPr>
+          <a:xfrm>
+            <a:off x="685800" y="2144611"/>
+            <a:ext cx="3143250" cy="167640"/>
+          </a:xfrm>
+          <a:prstGeom prst="rect">
+            <a:avLst/>
+          </a:prstGeom>
+          <a:noFill/>
+        </p:spPr>
+        <p:txBody>
+          <a:bodyPr wrap="square" lIns="0" rIns="0" tIns="0" bIns="0" anchor="t">
+            <a:spAutoFit/>
+          </a:bodyPr>
+          <a:lstStyle/>
+          <a:p>
+            <a:pPr algn="l">
+              <a:lnSpc>
+                <a:spcPct val="120000"/>
+              </a:lnSpc>
+            </a:pPr>
+            <a:r>
+              <a:rPr sz="819" b="1" i="0" spc="120">
+                <a:solidFill>
+                  <a:srgbClr val="21049A"/>
+                </a:solidFill>
+                <a:latin typeface="Roboto"/>
+              </a:rPr>
+              <a:t>FUNCIONALIDADE</a:t>
+            </a:r>
+          </a:p>
+        </p:txBody>
+      </p:sp>
+      <p:sp>
+        <p:nvSpPr>
+          <p:cNvPr id="5" name="TextBox 4"/>
+          <p:cNvSpPr txBox="1"/>
+          <p:nvPr/>
+        </p:nvSpPr>
+        <p:spPr>
+          <a:xfrm>
+            <a:off x="4000500" y="2144611"/>
+            <a:ext cx="7505700" cy="167640"/>
+          </a:xfrm>
+          <a:prstGeom prst="rect">
+            <a:avLst/>
+          </a:prstGeom>
+          <a:noFill/>
+        </p:spPr>
+        <p:txBody>
+          <a:bodyPr wrap="square" lIns="0" rIns="0" tIns="0" bIns="0" anchor="t">
+            <a:spAutoFit/>
+          </a:bodyPr>
+          <a:lstStyle/>
+          <a:p>
+            <a:pPr algn="l">
+              <a:lnSpc>
+                <a:spcPct val="120000"/>
+              </a:lnSpc>
+            </a:pPr>
+            <a:r>
+              <a:rPr sz="819" b="1" i="0" spc="120">
+                <a:solidFill>
+                  <a:srgbClr val="21049A"/>
+                </a:solidFill>
+                <a:latin typeface="Roboto"/>
+              </a:rPr>
+              <a:t>O QUE PERMITE</a:t>
+            </a:r>
+          </a:p>
+        </p:txBody>
+      </p:sp>
+      <p:sp>
+        <p:nvSpPr>
+          <p:cNvPr id="6" name="Rectangle 5"/>
           <p:cNvSpPr/>
           <p:nvPr/>
         </p:nvSpPr>
         <p:spPr>
           <a:xfrm>
-            <a:off x="685800" y="1729519"/>
-            <a:ext cx="3454400" cy="1775536"/>
-          </a:xfrm>
-          <a:prstGeom prst="roundRect">
-            <a:avLst>
-              <a:gd name="adj" fmla="val 4291"/>
-            </a:avLst>
+            <a:off x="685800" y="2373211"/>
+            <a:ext cx="10820400" cy="19050"/>
+          </a:xfrm>
+          <a:prstGeom prst="rect">
+            <a:avLst/>
           </a:prstGeom>
           <a:solidFill>
-            <a:srgbClr val="F2F2F5"/>
+            <a:srgbClr val="21049A"/>
           </a:solidFill>
-          <a:ln w="12700">
-            <a:solidFill>
-              <a:srgbClr val="D9D9D9"/>
-            </a:solidFill>
+          <a:ln>
+            <a:noFill/>
           </a:ln>
           <a:effectLst/>
         </p:spPr>
@@ -21405,14 +21199,14 @@
       </p:sp>
       <p:sp>
         <p:nvSpPr>
-          <p:cNvPr id="5" name="TextBox 4"/>
+          <p:cNvPr id="7" name="TextBox 6"/>
           <p:cNvSpPr txBox="1"/>
           <p:nvPr/>
         </p:nvSpPr>
         <p:spPr>
           <a:xfrm>
-            <a:off x="914400" y="1920019"/>
-            <a:ext cx="2997200" cy="167640"/>
+            <a:off x="685800" y="2525611"/>
+            <a:ext cx="2971800" cy="762000"/>
           </a:xfrm>
           <a:prstGeom prst="rect">
             <a:avLst/>
@@ -21427,31 +21221,31 @@
           <a:p>
             <a:pPr algn="l">
               <a:lnSpc>
-                <a:spcPct val="120000"/>
+                <a:spcPct val="135000"/>
               </a:lnSpc>
             </a:pPr>
             <a:r>
-              <a:rPr sz="819" b="1" i="0" spc="140">
-                <a:solidFill>
-                  <a:srgbClr val="E94D1C"/>
+              <a:rPr sz="1350" b="1" i="0">
+                <a:solidFill>
+                  <a:srgbClr val="21049A"/>
                 </a:solidFill>
                 <a:latin typeface="Roboto"/>
               </a:rPr>
-              <a:t>1 HISTÓRIA</a:t>
-            </a:r>
-          </a:p>
-        </p:txBody>
-      </p:sp>
-      <p:sp>
-        <p:nvSpPr>
-          <p:cNvPr id="6" name="TextBox 5"/>
+              <a:t>Conta do anfitrião</a:t>
+            </a:r>
+          </a:p>
+        </p:txBody>
+      </p:sp>
+      <p:sp>
+        <p:nvSpPr>
+          <p:cNvPr id="8" name="TextBox 7"/>
           <p:cNvSpPr txBox="1"/>
           <p:nvPr/>
         </p:nvSpPr>
         <p:spPr>
           <a:xfrm>
-            <a:off x="914400" y="2148619"/>
-            <a:ext cx="2997200" cy="304800"/>
+            <a:off x="4000500" y="2525611"/>
+            <a:ext cx="7334250" cy="762000"/>
           </a:xfrm>
           <a:prstGeom prst="rect">
             <a:avLst/>
@@ -21466,83 +21260,40 @@
           <a:p>
             <a:pPr algn="l">
               <a:lnSpc>
-                <a:spcPct val="120000"/>
+                <a:spcPct val="135000"/>
               </a:lnSpc>
             </a:pPr>
             <a:r>
-              <a:rPr sz="1500" b="1" i="0">
-                <a:solidFill>
-                  <a:srgbClr val="21049A"/>
+              <a:rPr sz="1280" b="0" i="0">
+                <a:solidFill>
+                  <a:srgbClr val="1A1A1E"/>
                 </a:solidFill>
                 <a:latin typeface="Roboto"/>
               </a:rPr>
-              <a:t>Conta do anfitrião</a:t>
-            </a:r>
-          </a:p>
-        </p:txBody>
-      </p:sp>
-      <p:sp>
-        <p:nvSpPr>
-          <p:cNvPr id="7" name="TextBox 6"/>
-          <p:cNvSpPr txBox="1"/>
-          <p:nvPr/>
-        </p:nvSpPr>
-        <p:spPr>
-          <a:xfrm>
-            <a:off x="914400" y="2529619"/>
-            <a:ext cx="2997200" cy="823036"/>
-          </a:xfrm>
-          <a:prstGeom prst="rect">
-            <a:avLst/>
-          </a:prstGeom>
-          <a:noFill/>
-        </p:spPr>
-        <p:txBody>
-          <a:bodyPr wrap="square" lIns="0" rIns="0" tIns="0" bIns="0" anchor="t">
-            <a:spAutoFit/>
-          </a:bodyPr>
-          <a:lstStyle/>
-          <a:p>
-            <a:pPr algn="l">
-              <a:lnSpc>
-                <a:spcPct val="145000"/>
-              </a:lnSpc>
-            </a:pPr>
-            <a:r>
-              <a:rPr sz="1350" b="0" i="0">
-                <a:solidFill>
-                  <a:srgbClr val="3A3A44"/>
-                </a:solidFill>
-                <a:latin typeface="Roboto"/>
-              </a:rPr>
-              <a:t>Criar conta e entrar.</a:t>
-            </a:r>
-          </a:p>
-        </p:txBody>
-      </p:sp>
-      <p:sp>
-        <p:nvSpPr>
-          <p:cNvPr id="8" name="Rounded Rectangle 7"/>
+              <a:t>Criar conta e entrar</a:t>
+            </a:r>
+          </a:p>
+        </p:txBody>
+      </p:sp>
+      <p:sp>
+        <p:nvSpPr>
+          <p:cNvPr id="9" name="Rectangle 8"/>
           <p:cNvSpPr/>
           <p:nvPr/>
         </p:nvSpPr>
         <p:spPr>
           <a:xfrm>
-            <a:off x="4368800" y="1729519"/>
-            <a:ext cx="3454400" cy="1775536"/>
-          </a:xfrm>
-          <a:prstGeom prst="roundRect">
-            <a:avLst>
-              <a:gd name="adj" fmla="val 4291"/>
-            </a:avLst>
+            <a:off x="685800" y="2887066"/>
+            <a:ext cx="10820400" cy="9525"/>
+          </a:xfrm>
+          <a:prstGeom prst="rect">
+            <a:avLst/>
           </a:prstGeom>
           <a:solidFill>
-            <a:srgbClr val="F2F2F5"/>
+            <a:srgbClr val="EDEDF2"/>
           </a:solidFill>
-          <a:ln w="12700">
-            <a:solidFill>
-              <a:srgbClr val="D9D9D9"/>
-            </a:solidFill>
+          <a:ln>
+            <a:noFill/>
           </a:ln>
           <a:effectLst/>
         </p:spPr>
@@ -21570,14 +21321,14 @@
       </p:sp>
       <p:sp>
         <p:nvSpPr>
-          <p:cNvPr id="9" name="TextBox 8"/>
+          <p:cNvPr id="10" name="TextBox 9"/>
           <p:cNvSpPr txBox="1"/>
           <p:nvPr/>
         </p:nvSpPr>
         <p:spPr>
           <a:xfrm>
-            <a:off x="4597400" y="1920019"/>
-            <a:ext cx="2997200" cy="167640"/>
+            <a:off x="685800" y="3010891"/>
+            <a:ext cx="2971800" cy="762000"/>
           </a:xfrm>
           <a:prstGeom prst="rect">
             <a:avLst/>
@@ -21592,31 +21343,31 @@
           <a:p>
             <a:pPr algn="l">
               <a:lnSpc>
-                <a:spcPct val="120000"/>
+                <a:spcPct val="135000"/>
               </a:lnSpc>
             </a:pPr>
             <a:r>
-              <a:rPr sz="819" b="1" i="0" spc="140">
-                <a:solidFill>
-                  <a:srgbClr val="E94D1C"/>
+              <a:rPr sz="1350" b="1" i="0">
+                <a:solidFill>
+                  <a:srgbClr val="21049A"/>
                 </a:solidFill>
                 <a:latin typeface="Roboto"/>
               </a:rPr>
-              <a:t>3 HISTÓRIAS</a:t>
-            </a:r>
-          </a:p>
-        </p:txBody>
-      </p:sp>
-      <p:sp>
-        <p:nvSpPr>
-          <p:cNvPr id="10" name="TextBox 9"/>
+              <a:t>Criação do convite</a:t>
+            </a:r>
+          </a:p>
+        </p:txBody>
+      </p:sp>
+      <p:sp>
+        <p:nvSpPr>
+          <p:cNvPr id="11" name="TextBox 10"/>
           <p:cNvSpPr txBox="1"/>
           <p:nvPr/>
         </p:nvSpPr>
         <p:spPr>
           <a:xfrm>
-            <a:off x="4597400" y="2148619"/>
-            <a:ext cx="2997200" cy="304800"/>
+            <a:off x="4000500" y="3010891"/>
+            <a:ext cx="7334250" cy="762000"/>
           </a:xfrm>
           <a:prstGeom prst="rect">
             <a:avLst/>
@@ -21631,83 +21382,40 @@
           <a:p>
             <a:pPr algn="l">
               <a:lnSpc>
-                <a:spcPct val="120000"/>
+                <a:spcPct val="135000"/>
               </a:lnSpc>
             </a:pPr>
             <a:r>
-              <a:rPr sz="1500" b="1" i="0">
-                <a:solidFill>
-                  <a:srgbClr val="21049A"/>
+              <a:rPr sz="1280" b="0" i="0">
+                <a:solidFill>
+                  <a:srgbClr val="1A1A1E"/>
                 </a:solidFill>
                 <a:latin typeface="Roboto"/>
               </a:rPr>
-              <a:t>Criação do convite</a:t>
-            </a:r>
-          </a:p>
-        </p:txBody>
-      </p:sp>
-      <p:sp>
-        <p:nvSpPr>
-          <p:cNvPr id="11" name="TextBox 10"/>
-          <p:cNvSpPr txBox="1"/>
-          <p:nvPr/>
-        </p:nvSpPr>
-        <p:spPr>
-          <a:xfrm>
-            <a:off x="4597400" y="2529619"/>
-            <a:ext cx="2997200" cy="823036"/>
-          </a:xfrm>
-          <a:prstGeom prst="rect">
-            <a:avLst/>
-          </a:prstGeom>
-          <a:noFill/>
-        </p:spPr>
-        <p:txBody>
-          <a:bodyPr wrap="square" lIns="0" rIns="0" tIns="0" bIns="0" anchor="t">
-            <a:spAutoFit/>
-          </a:bodyPr>
-          <a:lstStyle/>
-          <a:p>
-            <a:pPr algn="l">
-              <a:lnSpc>
-                <a:spcPct val="145000"/>
-              </a:lnSpc>
-            </a:pPr>
-            <a:r>
-              <a:rPr sz="1350" b="0" i="0">
-                <a:solidFill>
-                  <a:srgbClr val="3A3A44"/>
-                </a:solidFill>
-                <a:latin typeface="Roboto"/>
-              </a:rPr>
-              <a:t>Criar o convite, escolher template e cores e ver a prévia.</a:t>
-            </a:r>
-          </a:p>
-        </p:txBody>
-      </p:sp>
-      <p:sp>
-        <p:nvSpPr>
-          <p:cNvPr id="12" name="Rounded Rectangle 11"/>
+              <a:t>Preencher os dados da festa, escolher template e cores e ver a prévia</a:t>
+            </a:r>
+          </a:p>
+        </p:txBody>
+      </p:sp>
+      <p:sp>
+        <p:nvSpPr>
+          <p:cNvPr id="12" name="Rectangle 11"/>
           <p:cNvSpPr/>
           <p:nvPr/>
         </p:nvSpPr>
         <p:spPr>
           <a:xfrm>
-            <a:off x="8051800" y="1729519"/>
-            <a:ext cx="3454400" cy="1775536"/>
-          </a:xfrm>
-          <a:prstGeom prst="roundRect">
-            <a:avLst>
-              <a:gd name="adj" fmla="val 4291"/>
-            </a:avLst>
+            <a:off x="685800" y="3372345"/>
+            <a:ext cx="10820400" cy="9525"/>
+          </a:xfrm>
+          <a:prstGeom prst="rect">
+            <a:avLst/>
           </a:prstGeom>
           <a:solidFill>
-            <a:srgbClr val="F2F2F5"/>
+            <a:srgbClr val="EDEDF2"/>
           </a:solidFill>
-          <a:ln w="12700">
-            <a:solidFill>
-              <a:srgbClr val="D9D9D9"/>
-            </a:solidFill>
+          <a:ln>
+            <a:noFill/>
           </a:ln>
           <a:effectLst/>
         </p:spPr>
@@ -21741,8 +21449,8 @@
         </p:nvSpPr>
         <p:spPr>
           <a:xfrm>
-            <a:off x="8280400" y="1920019"/>
-            <a:ext cx="2997200" cy="167640"/>
+            <a:off x="685800" y="3496170"/>
+            <a:ext cx="2971800" cy="762000"/>
           </a:xfrm>
           <a:prstGeom prst="rect">
             <a:avLst/>
@@ -21757,17 +21465,17 @@
           <a:p>
             <a:pPr algn="l">
               <a:lnSpc>
-                <a:spcPct val="120000"/>
+                <a:spcPct val="135000"/>
               </a:lnSpc>
             </a:pPr>
             <a:r>
-              <a:rPr sz="819" b="1" i="0" spc="140">
-                <a:solidFill>
-                  <a:srgbClr val="E94D1C"/>
+              <a:rPr sz="1350" b="1" i="0">
+                <a:solidFill>
+                  <a:srgbClr val="21049A"/>
                 </a:solidFill>
                 <a:latin typeface="Roboto"/>
               </a:rPr>
-              <a:t>2 HISTÓRIAS</a:t>
+              <a:t>Compartilhamento</a:t>
             </a:r>
           </a:p>
         </p:txBody>
@@ -21780,8 +21488,8 @@
         </p:nvSpPr>
         <p:spPr>
           <a:xfrm>
-            <a:off x="8280400" y="2148619"/>
-            <a:ext cx="2997200" cy="304800"/>
+            <a:off x="4000500" y="3496170"/>
+            <a:ext cx="7334250" cy="762000"/>
           </a:xfrm>
           <a:prstGeom prst="rect">
             <a:avLst/>
@@ -21796,83 +21504,40 @@
           <a:p>
             <a:pPr algn="l">
               <a:lnSpc>
-                <a:spcPct val="120000"/>
+                <a:spcPct val="135000"/>
               </a:lnSpc>
             </a:pPr>
             <a:r>
-              <a:rPr sz="1500" b="1" i="0">
-                <a:solidFill>
-                  <a:srgbClr val="21049A"/>
+              <a:rPr sz="1280" b="0" i="0">
+                <a:solidFill>
+                  <a:srgbClr val="1A1A1E"/>
                 </a:solidFill>
                 <a:latin typeface="Roboto"/>
               </a:rPr>
-              <a:t>Compartilhamento</a:t>
-            </a:r>
-          </a:p>
-        </p:txBody>
-      </p:sp>
-      <p:sp>
-        <p:nvSpPr>
-          <p:cNvPr id="15" name="TextBox 14"/>
-          <p:cNvSpPr txBox="1"/>
-          <p:nvPr/>
-        </p:nvSpPr>
-        <p:spPr>
-          <a:xfrm>
-            <a:off x="8280400" y="2529619"/>
-            <a:ext cx="2997200" cy="823036"/>
-          </a:xfrm>
-          <a:prstGeom prst="rect">
-            <a:avLst/>
-          </a:prstGeom>
-          <a:noFill/>
-        </p:spPr>
-        <p:txBody>
-          <a:bodyPr wrap="square" lIns="0" rIns="0" tIns="0" bIns="0" anchor="t">
-            <a:spAutoFit/>
-          </a:bodyPr>
-          <a:lstStyle/>
-          <a:p>
-            <a:pPr algn="l">
-              <a:lnSpc>
-                <a:spcPct val="145000"/>
-              </a:lnSpc>
-            </a:pPr>
-            <a:r>
-              <a:rPr sz="1350" b="0" i="0">
-                <a:solidFill>
-                  <a:srgbClr val="3A3A44"/>
-                </a:solidFill>
-                <a:latin typeface="Roboto"/>
-              </a:rPr>
-              <a:t>Gerar o link, publicar e despublicar.</a:t>
-            </a:r>
-          </a:p>
-        </p:txBody>
-      </p:sp>
-      <p:sp>
-        <p:nvSpPr>
-          <p:cNvPr id="16" name="Rounded Rectangle 15"/>
+              <a:t>Publicar, copiar o link e despublicar</a:t>
+            </a:r>
+          </a:p>
+        </p:txBody>
+      </p:sp>
+      <p:sp>
+        <p:nvSpPr>
+          <p:cNvPr id="15" name="Rectangle 14"/>
           <p:cNvSpPr/>
           <p:nvPr/>
         </p:nvSpPr>
         <p:spPr>
           <a:xfrm>
-            <a:off x="685800" y="3733655"/>
-            <a:ext cx="3454400" cy="1775536"/>
-          </a:xfrm>
-          <a:prstGeom prst="roundRect">
-            <a:avLst>
-              <a:gd name="adj" fmla="val 4291"/>
-            </a:avLst>
+            <a:off x="685800" y="3857625"/>
+            <a:ext cx="10820400" cy="9525"/>
+          </a:xfrm>
+          <a:prstGeom prst="rect">
+            <a:avLst/>
           </a:prstGeom>
           <a:solidFill>
-            <a:srgbClr val="F2F2F5"/>
+            <a:srgbClr val="EDEDF2"/>
           </a:solidFill>
-          <a:ln w="12700">
-            <a:solidFill>
-              <a:srgbClr val="D9D9D9"/>
-            </a:solidFill>
+          <a:ln>
+            <a:noFill/>
           </a:ln>
           <a:effectLst/>
         </p:spPr>
@@ -21900,14 +21565,14 @@
       </p:sp>
       <p:sp>
         <p:nvSpPr>
-          <p:cNvPr id="17" name="TextBox 16"/>
+          <p:cNvPr id="16" name="TextBox 15"/>
           <p:cNvSpPr txBox="1"/>
           <p:nvPr/>
         </p:nvSpPr>
         <p:spPr>
           <a:xfrm>
-            <a:off x="914400" y="3924155"/>
-            <a:ext cx="2997200" cy="167640"/>
+            <a:off x="685800" y="3981450"/>
+            <a:ext cx="2971800" cy="762000"/>
           </a:xfrm>
           <a:prstGeom prst="rect">
             <a:avLst/>
@@ -21922,31 +21587,31 @@
           <a:p>
             <a:pPr algn="l">
               <a:lnSpc>
-                <a:spcPct val="120000"/>
+                <a:spcPct val="135000"/>
               </a:lnSpc>
             </a:pPr>
             <a:r>
-              <a:rPr sz="819" b="1" i="0" spc="140">
-                <a:solidFill>
-                  <a:srgbClr val="E94D1C"/>
+              <a:rPr sz="1350" b="1" i="0">
+                <a:solidFill>
+                  <a:srgbClr val="21049A"/>
                 </a:solidFill>
                 <a:latin typeface="Roboto"/>
               </a:rPr>
-              <a:t>3 HISTÓRIAS</a:t>
-            </a:r>
-          </a:p>
-        </p:txBody>
-      </p:sp>
-      <p:sp>
-        <p:nvSpPr>
-          <p:cNvPr id="18" name="TextBox 17"/>
+              <a:t>Confirmação de presença</a:t>
+            </a:r>
+          </a:p>
+        </p:txBody>
+      </p:sp>
+      <p:sp>
+        <p:nvSpPr>
+          <p:cNvPr id="17" name="TextBox 16"/>
           <p:cNvSpPr txBox="1"/>
           <p:nvPr/>
         </p:nvSpPr>
         <p:spPr>
           <a:xfrm>
-            <a:off x="914400" y="4152755"/>
-            <a:ext cx="2997200" cy="304800"/>
+            <a:off x="4000500" y="3981450"/>
+            <a:ext cx="7334250" cy="762000"/>
           </a:xfrm>
           <a:prstGeom prst="rect">
             <a:avLst/>
@@ -21961,83 +21626,40 @@
           <a:p>
             <a:pPr algn="l">
               <a:lnSpc>
-                <a:spcPct val="120000"/>
+                <a:spcPct val="135000"/>
               </a:lnSpc>
             </a:pPr>
             <a:r>
-              <a:rPr sz="1500" b="1" i="0">
-                <a:solidFill>
-                  <a:srgbClr val="21049A"/>
+              <a:rPr sz="1280" b="0" i="0">
+                <a:solidFill>
+                  <a:srgbClr val="1A1A1E"/>
                 </a:solidFill>
                 <a:latin typeface="Roboto"/>
               </a:rPr>
-              <a:t>Confirmação</a:t>
-            </a:r>
-          </a:p>
-        </p:txBody>
-      </p:sp>
-      <p:sp>
-        <p:nvSpPr>
-          <p:cNvPr id="19" name="TextBox 18"/>
-          <p:cNvSpPr txBox="1"/>
-          <p:nvPr/>
-        </p:nvSpPr>
-        <p:spPr>
-          <a:xfrm>
-            <a:off x="914400" y="4533755"/>
-            <a:ext cx="2997200" cy="823036"/>
-          </a:xfrm>
-          <a:prstGeom prst="rect">
-            <a:avLst/>
-          </a:prstGeom>
-          <a:noFill/>
-        </p:spPr>
-        <p:txBody>
-          <a:bodyPr wrap="square" lIns="0" rIns="0" tIns="0" bIns="0" anchor="t">
-            <a:spAutoFit/>
-          </a:bodyPr>
-          <a:lstStyle/>
-          <a:p>
-            <a:pPr algn="l">
-              <a:lnSpc>
-                <a:spcPct val="145000"/>
-              </a:lnSpc>
-            </a:pPr>
-            <a:r>
-              <a:rPr sz="1350" b="0" i="0">
-                <a:solidFill>
-                  <a:srgbClr val="3A3A44"/>
-                </a:solidFill>
-                <a:latin typeface="Roboto"/>
-              </a:rPr>
-              <a:t>Responder sem conta, informar acompanhantes e alterar pelo link pessoal.</a:t>
-            </a:r>
-          </a:p>
-        </p:txBody>
-      </p:sp>
-      <p:sp>
-        <p:nvSpPr>
-          <p:cNvPr id="20" name="Rounded Rectangle 19"/>
+              <a:t>Responder sem conta, informar acompanhantes e alterar depois pelo link pessoal</a:t>
+            </a:r>
+          </a:p>
+        </p:txBody>
+      </p:sp>
+      <p:sp>
+        <p:nvSpPr>
+          <p:cNvPr id="18" name="Rectangle 17"/>
           <p:cNvSpPr/>
           <p:nvPr/>
         </p:nvSpPr>
         <p:spPr>
           <a:xfrm>
-            <a:off x="4368800" y="3733655"/>
-            <a:ext cx="3454400" cy="1775536"/>
-          </a:xfrm>
-          <a:prstGeom prst="roundRect">
-            <a:avLst>
-              <a:gd name="adj" fmla="val 4291"/>
-            </a:avLst>
+            <a:off x="685800" y="4342905"/>
+            <a:ext cx="10820400" cy="9525"/>
+          </a:xfrm>
+          <a:prstGeom prst="rect">
+            <a:avLst/>
           </a:prstGeom>
           <a:solidFill>
-            <a:srgbClr val="F2F2F5"/>
+            <a:srgbClr val="EDEDF2"/>
           </a:solidFill>
-          <a:ln w="12700">
-            <a:solidFill>
-              <a:srgbClr val="D9D9D9"/>
-            </a:solidFill>
+          <a:ln>
+            <a:noFill/>
           </a:ln>
           <a:effectLst/>
         </p:spPr>
@@ -22065,14 +21687,14 @@
       </p:sp>
       <p:sp>
         <p:nvSpPr>
-          <p:cNvPr id="21" name="TextBox 20"/>
+          <p:cNvPr id="19" name="TextBox 18"/>
           <p:cNvSpPr txBox="1"/>
           <p:nvPr/>
         </p:nvSpPr>
         <p:spPr>
           <a:xfrm>
-            <a:off x="4597400" y="3924155"/>
-            <a:ext cx="2997200" cy="167640"/>
+            <a:off x="685800" y="4466730"/>
+            <a:ext cx="2971800" cy="762000"/>
           </a:xfrm>
           <a:prstGeom prst="rect">
             <a:avLst/>
@@ -22087,31 +21709,31 @@
           <a:p>
             <a:pPr algn="l">
               <a:lnSpc>
-                <a:spcPct val="120000"/>
+                <a:spcPct val="135000"/>
               </a:lnSpc>
             </a:pPr>
             <a:r>
-              <a:rPr sz="819" b="1" i="0" spc="140">
-                <a:solidFill>
-                  <a:srgbClr val="E94D1C"/>
+              <a:rPr sz="1350" b="1" i="0">
+                <a:solidFill>
+                  <a:srgbClr val="21049A"/>
                 </a:solidFill>
                 <a:latin typeface="Roboto"/>
               </a:rPr>
-              <a:t>1 HISTÓRIA</a:t>
-            </a:r>
-          </a:p>
-        </p:txBody>
-      </p:sp>
-      <p:sp>
-        <p:nvSpPr>
-          <p:cNvPr id="22" name="TextBox 21"/>
+              <a:t>Restrições alimentares</a:t>
+            </a:r>
+          </a:p>
+        </p:txBody>
+      </p:sp>
+      <p:sp>
+        <p:nvSpPr>
+          <p:cNvPr id="20" name="TextBox 19"/>
           <p:cNvSpPr txBox="1"/>
           <p:nvPr/>
         </p:nvSpPr>
         <p:spPr>
           <a:xfrm>
-            <a:off x="4597400" y="4152755"/>
-            <a:ext cx="2997200" cy="304800"/>
+            <a:off x="4000500" y="4466730"/>
+            <a:ext cx="7334250" cy="762000"/>
           </a:xfrm>
           <a:prstGeom prst="rect">
             <a:avLst/>
@@ -22126,83 +21748,40 @@
           <a:p>
             <a:pPr algn="l">
               <a:lnSpc>
-                <a:spcPct val="120000"/>
+                <a:spcPct val="135000"/>
               </a:lnSpc>
             </a:pPr>
             <a:r>
-              <a:rPr sz="1500" b="1" i="0">
-                <a:solidFill>
-                  <a:srgbClr val="21049A"/>
+              <a:rPr sz="1280" b="0" i="0">
+                <a:solidFill>
+                  <a:srgbClr val="1A1A1E"/>
                 </a:solidFill>
                 <a:latin typeface="Roboto"/>
               </a:rPr>
-              <a:t>Restrições alimentares</a:t>
-            </a:r>
-          </a:p>
-        </p:txBody>
-      </p:sp>
-      <p:sp>
-        <p:nvSpPr>
-          <p:cNvPr id="23" name="TextBox 22"/>
-          <p:cNvSpPr txBox="1"/>
-          <p:nvPr/>
-        </p:nvSpPr>
-        <p:spPr>
-          <a:xfrm>
-            <a:off x="4597400" y="4533755"/>
-            <a:ext cx="2997200" cy="823036"/>
-          </a:xfrm>
-          <a:prstGeom prst="rect">
-            <a:avLst/>
-          </a:prstGeom>
-          <a:noFill/>
-        </p:spPr>
-        <p:txBody>
-          <a:bodyPr wrap="square" lIns="0" rIns="0" tIns="0" bIns="0" anchor="t">
-            <a:spAutoFit/>
-          </a:bodyPr>
-          <a:lstStyle/>
-          <a:p>
-            <a:pPr algn="l">
-              <a:lnSpc>
-                <a:spcPct val="145000"/>
-              </a:lnSpc>
-            </a:pPr>
-            <a:r>
-              <a:rPr sz="1350" b="0" i="0">
-                <a:solidFill>
-                  <a:srgbClr val="3A3A44"/>
-                </a:solidFill>
-                <a:latin typeface="Roboto"/>
-              </a:rPr>
-              <a:t>Informar a restrição. Alergia exige descrição.</a:t>
-            </a:r>
-          </a:p>
-        </p:txBody>
-      </p:sp>
-      <p:sp>
-        <p:nvSpPr>
-          <p:cNvPr id="24" name="Rounded Rectangle 23"/>
+              <a:t>Informar a restrição. Alergia pede descrição</a:t>
+            </a:r>
+          </a:p>
+        </p:txBody>
+      </p:sp>
+      <p:sp>
+        <p:nvSpPr>
+          <p:cNvPr id="21" name="Rectangle 20"/>
           <p:cNvSpPr/>
           <p:nvPr/>
         </p:nvSpPr>
         <p:spPr>
           <a:xfrm>
-            <a:off x="8051800" y="3733655"/>
-            <a:ext cx="3454400" cy="1775536"/>
-          </a:xfrm>
-          <a:prstGeom prst="roundRect">
-            <a:avLst>
-              <a:gd name="adj" fmla="val 4291"/>
-            </a:avLst>
+            <a:off x="685800" y="4828184"/>
+            <a:ext cx="10820400" cy="9525"/>
+          </a:xfrm>
+          <a:prstGeom prst="rect">
+            <a:avLst/>
           </a:prstGeom>
           <a:solidFill>
-            <a:srgbClr val="F2F2F5"/>
+            <a:srgbClr val="EDEDF2"/>
           </a:solidFill>
-          <a:ln w="12700">
-            <a:solidFill>
-              <a:srgbClr val="D9D9D9"/>
-            </a:solidFill>
+          <a:ln>
+            <a:noFill/>
           </a:ln>
           <a:effectLst/>
         </p:spPr>
@@ -22230,14 +21809,14 @@
       </p:sp>
       <p:sp>
         <p:nvSpPr>
-          <p:cNvPr id="25" name="TextBox 24"/>
+          <p:cNvPr id="22" name="TextBox 21"/>
           <p:cNvSpPr txBox="1"/>
           <p:nvPr/>
         </p:nvSpPr>
         <p:spPr>
           <a:xfrm>
-            <a:off x="8280400" y="3924155"/>
-            <a:ext cx="2997200" cy="167640"/>
+            <a:off x="685800" y="4952009"/>
+            <a:ext cx="2971800" cy="762000"/>
           </a:xfrm>
           <a:prstGeom prst="rect">
             <a:avLst/>
@@ -22252,31 +21831,31 @@
           <a:p>
             <a:pPr algn="l">
               <a:lnSpc>
-                <a:spcPct val="120000"/>
+                <a:spcPct val="135000"/>
               </a:lnSpc>
             </a:pPr>
             <a:r>
-              <a:rPr sz="819" b="1" i="0" spc="140">
-                <a:solidFill>
-                  <a:srgbClr val="E94D1C"/>
+              <a:rPr sz="1350" b="1" i="0">
+                <a:solidFill>
+                  <a:srgbClr val="21049A"/>
                 </a:solidFill>
                 <a:latin typeface="Roboto"/>
               </a:rPr>
-              <a:t>2 HISTÓRIAS</a:t>
-            </a:r>
-          </a:p>
-        </p:txBody>
-      </p:sp>
-      <p:sp>
-        <p:nvSpPr>
-          <p:cNvPr id="26" name="TextBox 25"/>
+              <a:t>Painel</a:t>
+            </a:r>
+          </a:p>
+        </p:txBody>
+      </p:sp>
+      <p:sp>
+        <p:nvSpPr>
+          <p:cNvPr id="23" name="TextBox 22"/>
           <p:cNvSpPr txBox="1"/>
           <p:nvPr/>
         </p:nvSpPr>
         <p:spPr>
           <a:xfrm>
-            <a:off x="8280400" y="4152755"/>
-            <a:ext cx="2997200" cy="304800"/>
+            <a:off x="4000500" y="4952009"/>
+            <a:ext cx="7334250" cy="762000"/>
           </a:xfrm>
           <a:prstGeom prst="rect">
             <a:avLst/>
@@ -22291,76 +21870,37 @@
           <a:p>
             <a:pPr algn="l">
               <a:lnSpc>
-                <a:spcPct val="120000"/>
+                <a:spcPct val="135000"/>
               </a:lnSpc>
             </a:pPr>
             <a:r>
-              <a:rPr sz="1500" b="1" i="0">
-                <a:solidFill>
-                  <a:srgbClr val="21049A"/>
+              <a:rPr sz="1280" b="0" i="0">
+                <a:solidFill>
+                  <a:srgbClr val="1A1A1E"/>
                 </a:solidFill>
                 <a:latin typeface="Roboto"/>
               </a:rPr>
-              <a:t>Painel</a:t>
-            </a:r>
-          </a:p>
-        </p:txBody>
-      </p:sp>
-      <p:sp>
-        <p:nvSpPr>
-          <p:cNvPr id="27" name="TextBox 26"/>
-          <p:cNvSpPr txBox="1"/>
-          <p:nvPr/>
-        </p:nvSpPr>
-        <p:spPr>
-          <a:xfrm>
-            <a:off x="8280400" y="4533755"/>
-            <a:ext cx="2997200" cy="823036"/>
-          </a:xfrm>
-          <a:prstGeom prst="rect">
-            <a:avLst/>
-          </a:prstGeom>
-          <a:noFill/>
-        </p:spPr>
-        <p:txBody>
-          <a:bodyPr wrap="square" lIns="0" rIns="0" tIns="0" bIns="0" anchor="t">
-            <a:spAutoFit/>
-          </a:bodyPr>
-          <a:lstStyle/>
-          <a:p>
-            <a:pPr algn="l">
-              <a:lnSpc>
-                <a:spcPct val="145000"/>
-              </a:lnSpc>
-            </a:pPr>
-            <a:r>
-              <a:rPr sz="1350" b="0" i="0">
-                <a:solidFill>
-                  <a:srgbClr val="3A3A44"/>
-                </a:solidFill>
-                <a:latin typeface="Roboto"/>
-              </a:rPr>
-              <a:t>Lista de presença e consolidação das restrições, com exportação em CSV.</a:t>
-            </a:r>
-          </a:p>
-        </p:txBody>
-      </p:sp>
-      <p:sp>
-        <p:nvSpPr>
-          <p:cNvPr id="28" name="Rectangle 27"/>
+              <a:t>Ver a lista de presença e exportar as restrições em CSV</a:t>
+            </a:r>
+          </a:p>
+        </p:txBody>
+      </p:sp>
+      <p:sp>
+        <p:nvSpPr>
+          <p:cNvPr id="24" name="Rectangle 23"/>
           <p:cNvSpPr/>
           <p:nvPr/>
         </p:nvSpPr>
         <p:spPr>
           <a:xfrm>
-            <a:off x="685800" y="5809960"/>
-            <a:ext cx="28575" cy="209840"/>
+            <a:off x="685800" y="5313464"/>
+            <a:ext cx="10820400" cy="9525"/>
           </a:xfrm>
           <a:prstGeom prst="rect">
             <a:avLst/>
           </a:prstGeom>
           <a:solidFill>
-            <a:srgbClr val="E94D1C"/>
+            <a:srgbClr val="EDEDF2"/>
           </a:solidFill>
           <a:ln>
             <a:noFill/>
@@ -22391,14 +21931,14 @@
       </p:sp>
       <p:sp>
         <p:nvSpPr>
-          <p:cNvPr id="29" name="TextBox 28"/>
+          <p:cNvPr id="25" name="TextBox 24"/>
           <p:cNvSpPr txBox="1"/>
           <p:nvPr/>
         </p:nvSpPr>
         <p:spPr>
           <a:xfrm>
-            <a:off x="876300" y="5790910"/>
-            <a:ext cx="10629900" cy="343190"/>
+            <a:off x="685800" y="6324600"/>
+            <a:ext cx="6667500" cy="182880"/>
           </a:xfrm>
           <a:prstGeom prst="rect">
             <a:avLst/>
@@ -22413,45 +21953,6 @@
           <a:p>
             <a:pPr algn="l">
               <a:lnSpc>
-                <a:spcPct val="150000"/>
-              </a:lnSpc>
-            </a:pPr>
-            <a:r>
-              <a:rPr sz="1280" b="0" i="0">
-                <a:solidFill>
-                  <a:srgbClr val="3A3A44"/>
-                </a:solidFill>
-                <a:latin typeface="Roboto"/>
-              </a:rPr>
-              <a:t>As doze histórias estão implementadas, integradas e rodando pelo docker compose.</a:t>
-            </a:r>
-          </a:p>
-        </p:txBody>
-      </p:sp>
-      <p:sp>
-        <p:nvSpPr>
-          <p:cNvPr id="30" name="TextBox 29"/>
-          <p:cNvSpPr txBox="1"/>
-          <p:nvPr/>
-        </p:nvSpPr>
-        <p:spPr>
-          <a:xfrm>
-            <a:off x="685800" y="6324600"/>
-            <a:ext cx="6667500" cy="182880"/>
-          </a:xfrm>
-          <a:prstGeom prst="rect">
-            <a:avLst/>
-          </a:prstGeom>
-          <a:noFill/>
-        </p:spPr>
-        <p:txBody>
-          <a:bodyPr wrap="square" lIns="0" rIns="0" tIns="0" bIns="0" anchor="t">
-            <a:spAutoFit/>
-          </a:bodyPr>
-          <a:lstStyle/>
-          <a:p>
-            <a:pPr algn="l">
-              <a:lnSpc>
                 <a:spcPct val="120000"/>
               </a:lnSpc>
             </a:pPr>
@@ -22469,7 +21970,7 @@
       </p:sp>
       <p:sp>
         <p:nvSpPr>
-          <p:cNvPr id="31" name="TextBox 30"/>
+          <p:cNvPr id="26" name="TextBox 25"/>
           <p:cNvSpPr txBox="1"/>
           <p:nvPr/>
         </p:nvSpPr>
@@ -23334,7 +22835,7 @@
                 </a:solidFill>
                 <a:latin typeface="Roboto"/>
               </a:rPr>
-              <a:t>Integração do front e do back</a:t>
+              <a:t>Integração front e back</a:t>
             </a:r>
           </a:p>
         </p:txBody>
@@ -23596,7 +23097,7 @@
                 </a:solidFill>
                 <a:latin typeface="Roboto"/>
               </a:rPr>
-              <a:t>Problema e escopo, Andreas</a:t>
+              <a:t>Arquitetura, Tiago</a:t>
             </a:r>
           </a:p>
         </p:txBody>
@@ -23852,7 +23353,7 @@
             </a:r>
           </a:p>
           <a:p>
-            <a:pPr>
+            <a:pPr algn="ctr">
               <a:lnSpc>
                 <a:spcPct val="120000"/>
               </a:lnSpc>
@@ -24921,7 +24422,7 @@
             </a:r>
           </a:p>
           <a:p>
-            <a:pPr>
+            <a:pPr algn="ctr">
               <a:lnSpc>
                 <a:spcPct val="120000"/>
               </a:lnSpc>
@@ -25012,7 +24513,7 @@
             </a:r>
           </a:p>
           <a:p>
-            <a:pPr>
+            <a:pPr algn="ctr">
               <a:lnSpc>
                 <a:spcPct val="120000"/>
               </a:lnSpc>
@@ -25103,7 +24604,7 @@
             </a:r>
           </a:p>
           <a:p>
-            <a:pPr>
+            <a:pPr algn="ctr">
               <a:lnSpc>
                 <a:spcPct val="120000"/>
               </a:lnSpc>
@@ -26525,7 +26026,7 @@
         </p:nvSpPr>
         <p:spPr>
           <a:xfrm>
-            <a:off x="685800" y="2483108"/>
+            <a:off x="685800" y="2654703"/>
             <a:ext cx="4381500" cy="167640"/>
           </a:xfrm>
           <a:prstGeom prst="rect">
@@ -26564,7 +26065,7 @@
         </p:nvSpPr>
         <p:spPr>
           <a:xfrm>
-            <a:off x="5334000" y="2483108"/>
+            <a:off x="5334000" y="2654703"/>
             <a:ext cx="6172200" cy="167640"/>
           </a:xfrm>
           <a:prstGeom prst="rect">
@@ -26603,7 +26104,7 @@
         </p:nvSpPr>
         <p:spPr>
           <a:xfrm>
-            <a:off x="685800" y="2711708"/>
+            <a:off x="685800" y="2883303"/>
             <a:ext cx="10820400" cy="19050"/>
           </a:xfrm>
           <a:prstGeom prst="rect">
@@ -26647,7 +26148,7 @@
         </p:nvSpPr>
         <p:spPr>
           <a:xfrm>
-            <a:off x="685800" y="2864108"/>
+            <a:off x="685800" y="3035703"/>
             <a:ext cx="4210050" cy="762000"/>
           </a:xfrm>
           <a:prstGeom prst="rect">
@@ -26686,7 +26187,7 @@
         </p:nvSpPr>
         <p:spPr>
           <a:xfrm>
-            <a:off x="5334000" y="2864108"/>
+            <a:off x="5334000" y="3035703"/>
             <a:ext cx="6000750" cy="762000"/>
           </a:xfrm>
           <a:prstGeom prst="rect">
@@ -26725,7 +26226,7 @@
         </p:nvSpPr>
         <p:spPr>
           <a:xfrm>
-            <a:off x="685800" y="3661218"/>
+            <a:off x="685800" y="3832812"/>
             <a:ext cx="10820400" cy="9525"/>
           </a:xfrm>
           <a:prstGeom prst="rect">
@@ -26769,7 +26270,7 @@
         </p:nvSpPr>
         <p:spPr>
           <a:xfrm>
-            <a:off x="685800" y="3785043"/>
+            <a:off x="685800" y="3956637"/>
             <a:ext cx="4210050" cy="762000"/>
           </a:xfrm>
           <a:prstGeom prst="rect">
@@ -26808,7 +26309,7 @@
         </p:nvSpPr>
         <p:spPr>
           <a:xfrm>
-            <a:off x="5334000" y="3785043"/>
+            <a:off x="5334000" y="3956637"/>
             <a:ext cx="6000750" cy="762000"/>
           </a:xfrm>
           <a:prstGeom prst="rect">
@@ -26847,7 +26348,7 @@
         </p:nvSpPr>
         <p:spPr>
           <a:xfrm>
-            <a:off x="685800" y="4146497"/>
+            <a:off x="685800" y="4318092"/>
             <a:ext cx="10820400" cy="9525"/>
           </a:xfrm>
           <a:prstGeom prst="rect">
@@ -26891,7 +26392,7 @@
         </p:nvSpPr>
         <p:spPr>
           <a:xfrm>
-            <a:off x="685800" y="4270322"/>
+            <a:off x="685800" y="4441917"/>
             <a:ext cx="4210050" cy="762000"/>
           </a:xfrm>
           <a:prstGeom prst="rect">
@@ -26930,7 +26431,7 @@
         </p:nvSpPr>
         <p:spPr>
           <a:xfrm>
-            <a:off x="5334000" y="4270322"/>
+            <a:off x="5334000" y="4441917"/>
             <a:ext cx="6000750" cy="762000"/>
           </a:xfrm>
           <a:prstGeom prst="rect">
@@ -26969,7 +26470,7 @@
         </p:nvSpPr>
         <p:spPr>
           <a:xfrm>
-            <a:off x="685800" y="4631777"/>
+            <a:off x="685800" y="4803372"/>
             <a:ext cx="10820400" cy="9525"/>
           </a:xfrm>
           <a:prstGeom prst="rect">
@@ -27007,58 +26508,14 @@
       </p:sp>
       <p:sp>
         <p:nvSpPr>
-          <p:cNvPr id="16" name="Rectangle 15"/>
-          <p:cNvSpPr/>
-          <p:nvPr/>
-        </p:nvSpPr>
-        <p:spPr>
-          <a:xfrm>
-            <a:off x="685800" y="5809960"/>
-            <a:ext cx="28575" cy="209840"/>
-          </a:xfrm>
-          <a:prstGeom prst="rect">
-            <a:avLst/>
-          </a:prstGeom>
-          <a:solidFill>
-            <a:srgbClr val="E94D1C"/>
-          </a:solidFill>
-          <a:ln>
-            <a:noFill/>
-          </a:ln>
-          <a:effectLst/>
-        </p:spPr>
-        <p:style>
-          <a:lnRef idx="1">
-            <a:schemeClr val="accent1"/>
-          </a:lnRef>
-          <a:fillRef idx="3">
-            <a:schemeClr val="accent1"/>
-          </a:fillRef>
-          <a:effectRef idx="2">
-            <a:schemeClr val="accent1"/>
-          </a:effectRef>
-          <a:fontRef idx="minor">
-            <a:schemeClr val="lt1"/>
-          </a:fontRef>
-        </p:style>
-        <p:txBody>
-          <a:bodyPr rtlCol="0" anchor="ctr" wrap="square" lIns="0" rIns="0" tIns="0" bIns="0"/>
-          <a:lstStyle/>
-          <a:p>
-            <a:pPr algn="ctr"/>
-          </a:p>
-        </p:txBody>
-      </p:sp>
-      <p:sp>
-        <p:nvSpPr>
-          <p:cNvPr id="17" name="TextBox 16"/>
+          <p:cNvPr id="16" name="TextBox 15"/>
           <p:cNvSpPr txBox="1"/>
           <p:nvPr/>
         </p:nvSpPr>
         <p:spPr>
           <a:xfrm>
-            <a:off x="876300" y="5790910"/>
-            <a:ext cx="10629900" cy="343190"/>
+            <a:off x="685800" y="6324600"/>
+            <a:ext cx="6667500" cy="182880"/>
           </a:xfrm>
           <a:prstGeom prst="rect">
             <a:avLst/>
@@ -27073,45 +26530,6 @@
           <a:p>
             <a:pPr algn="l">
               <a:lnSpc>
-                <a:spcPct val="150000"/>
-              </a:lnSpc>
-            </a:pPr>
-            <a:r>
-              <a:rPr sz="1280" b="0" i="0">
-                <a:solidFill>
-                  <a:srgbClr val="3A3A44"/>
-                </a:solidFill>
-                <a:latin typeface="Roboto"/>
-              </a:rPr>
-              <a:t>A regra do teto de vagas está no bloco do back-end.</a:t>
-            </a:r>
-          </a:p>
-        </p:txBody>
-      </p:sp>
-      <p:sp>
-        <p:nvSpPr>
-          <p:cNvPr id="18" name="TextBox 17"/>
-          <p:cNvSpPr txBox="1"/>
-          <p:nvPr/>
-        </p:nvSpPr>
-        <p:spPr>
-          <a:xfrm>
-            <a:off x="685800" y="6324600"/>
-            <a:ext cx="6667500" cy="182880"/>
-          </a:xfrm>
-          <a:prstGeom prst="rect">
-            <a:avLst/>
-          </a:prstGeom>
-          <a:noFill/>
-        </p:spPr>
-        <p:txBody>
-          <a:bodyPr wrap="square" lIns="0" rIns="0" tIns="0" bIns="0" anchor="t">
-            <a:spAutoFit/>
-          </a:bodyPr>
-          <a:lstStyle/>
-          <a:p>
-            <a:pPr algn="l">
-              <a:lnSpc>
                 <a:spcPct val="120000"/>
               </a:lnSpc>
             </a:pPr>
@@ -27129,7 +26547,7 @@
       </p:sp>
       <p:sp>
         <p:nvSpPr>
-          <p:cNvPr id="19" name="TextBox 18"/>
+          <p:cNvPr id="17" name="TextBox 16"/>
           <p:cNvSpPr txBox="1"/>
           <p:nvPr/>
         </p:nvSpPr>
@@ -27271,8 +26689,8 @@
         </p:blipFill>
         <p:spPr>
           <a:xfrm>
-            <a:off x="1608497" y="1676400"/>
-            <a:ext cx="5302593" cy="3314121"/>
+            <a:off x="982655" y="1819275"/>
+            <a:ext cx="6096000" cy="3810000"/>
           </a:xfrm>
           <a:prstGeom prst="rect">
             <a:avLst/>
@@ -27292,8 +26710,8 @@
         </p:nvSpPr>
         <p:spPr>
           <a:xfrm>
-            <a:off x="1417997" y="5085771"/>
-            <a:ext cx="5683593" cy="228600"/>
+            <a:off x="792155" y="5724525"/>
+            <a:ext cx="6477000" cy="228600"/>
           </a:xfrm>
           <a:prstGeom prst="rect">
             <a:avLst/>
@@ -27339,8 +26757,8 @@
         </p:blipFill>
         <p:spPr>
           <a:xfrm>
-            <a:off x="7215890" y="1676400"/>
-            <a:ext cx="1531407" cy="3314121"/>
+            <a:off x="7383455" y="1819275"/>
+            <a:ext cx="1760545" cy="3810000"/>
           </a:xfrm>
           <a:prstGeom prst="rect">
             <a:avLst/>
@@ -27360,8 +26778,8 @@
         </p:nvSpPr>
         <p:spPr>
           <a:xfrm>
-            <a:off x="7025390" y="5085771"/>
-            <a:ext cx="1912407" cy="228600"/>
+            <a:off x="7192955" y="5724525"/>
+            <a:ext cx="2141545" cy="228600"/>
           </a:xfrm>
           <a:prstGeom prst="rect">
             <a:avLst/>
@@ -27407,8 +26825,8 @@
         </p:blipFill>
         <p:spPr>
           <a:xfrm>
-            <a:off x="9052097" y="1676400"/>
-            <a:ext cx="1531407" cy="3314121"/>
+            <a:off x="9448800" y="1819275"/>
+            <a:ext cx="1760545" cy="3810000"/>
           </a:xfrm>
           <a:prstGeom prst="rect">
             <a:avLst/>
@@ -27428,8 +26846,8 @@
         </p:nvSpPr>
         <p:spPr>
           <a:xfrm>
-            <a:off x="8861597" y="5085771"/>
-            <a:ext cx="1912407" cy="228600"/>
+            <a:off x="9258300" y="5724525"/>
+            <a:ext cx="2141545" cy="228600"/>
           </a:xfrm>
           <a:prstGeom prst="rect">
             <a:avLst/>
@@ -27454,65 +26872,21 @@
                 </a:solidFill>
                 <a:latin typeface="Roboto"/>
               </a:rPr>
-              <a:t>Resposta enviada, com o link pessoal</a:t>
-            </a:r>
-          </a:p>
-        </p:txBody>
-      </p:sp>
-      <p:sp>
-        <p:nvSpPr>
-          <p:cNvPr id="10" name="Rectangle 9"/>
-          <p:cNvSpPr/>
-          <p:nvPr/>
-        </p:nvSpPr>
-        <p:spPr>
-          <a:xfrm>
-            <a:off x="685800" y="5562021"/>
-            <a:ext cx="28575" cy="457779"/>
-          </a:xfrm>
-          <a:prstGeom prst="rect">
-            <a:avLst/>
-          </a:prstGeom>
-          <a:solidFill>
-            <a:srgbClr val="E94D1C"/>
-          </a:solidFill>
-          <a:ln>
-            <a:noFill/>
-          </a:ln>
-          <a:effectLst/>
-        </p:spPr>
-        <p:style>
-          <a:lnRef idx="1">
-            <a:schemeClr val="accent1"/>
-          </a:lnRef>
-          <a:fillRef idx="3">
-            <a:schemeClr val="accent1"/>
-          </a:fillRef>
-          <a:effectRef idx="2">
-            <a:schemeClr val="accent1"/>
-          </a:effectRef>
-          <a:fontRef idx="minor">
-            <a:schemeClr val="lt1"/>
-          </a:fontRef>
-        </p:style>
-        <p:txBody>
-          <a:bodyPr rtlCol="0" anchor="ctr" wrap="square" lIns="0" rIns="0" tIns="0" bIns="0"/>
-          <a:lstStyle/>
-          <a:p>
-            <a:pPr algn="ctr"/>
-          </a:p>
-        </p:txBody>
-      </p:sp>
-      <p:sp>
-        <p:nvSpPr>
-          <p:cNvPr id="11" name="TextBox 10"/>
+              <a:t>Resposta enviada</a:t>
+            </a:r>
+          </a:p>
+        </p:txBody>
+      </p:sp>
+      <p:sp>
+        <p:nvSpPr>
+          <p:cNvPr id="10" name="TextBox 9"/>
           <p:cNvSpPr txBox="1"/>
           <p:nvPr/>
         </p:nvSpPr>
         <p:spPr>
           <a:xfrm>
-            <a:off x="876300" y="5542971"/>
-            <a:ext cx="10629900" cy="591129"/>
+            <a:off x="685800" y="6324600"/>
+            <a:ext cx="6667500" cy="182880"/>
           </a:xfrm>
           <a:prstGeom prst="rect">
             <a:avLst/>
@@ -27527,45 +26901,6 @@
           <a:p>
             <a:pPr algn="l">
               <a:lnSpc>
-                <a:spcPct val="150000"/>
-              </a:lnSpc>
-            </a:pPr>
-            <a:r>
-              <a:rPr sz="1280" b="0" i="0">
-                <a:solidFill>
-                  <a:srgbClr val="3A3A44"/>
-                </a:solidFill>
-                <a:latin typeface="Roboto"/>
-              </a:rPr>
-              <a:t>As telas partiram do protótipo e foram adequadas à arquitetura: o visual foi mantido, reescrito em CSS puro, e as regras de negócio saíram da tela.</a:t>
-            </a:r>
-          </a:p>
-        </p:txBody>
-      </p:sp>
-      <p:sp>
-        <p:nvSpPr>
-          <p:cNvPr id="12" name="TextBox 11"/>
-          <p:cNvSpPr txBox="1"/>
-          <p:nvPr/>
-        </p:nvSpPr>
-        <p:spPr>
-          <a:xfrm>
-            <a:off x="685800" y="6324600"/>
-            <a:ext cx="6667500" cy="182880"/>
-          </a:xfrm>
-          <a:prstGeom prst="rect">
-            <a:avLst/>
-          </a:prstGeom>
-          <a:noFill/>
-        </p:spPr>
-        <p:txBody>
-          <a:bodyPr wrap="square" lIns="0" rIns="0" tIns="0" bIns="0" anchor="t">
-            <a:spAutoFit/>
-          </a:bodyPr>
-          <a:lstStyle/>
-          <a:p>
-            <a:pPr algn="l">
-              <a:lnSpc>
                 <a:spcPct val="120000"/>
               </a:lnSpc>
             </a:pPr>
@@ -27583,7 +26918,7 @@
       </p:sp>
       <p:sp>
         <p:nvSpPr>
-          <p:cNvPr id="13" name="TextBox 12"/>
+          <p:cNvPr id="11" name="TextBox 10"/>
           <p:cNvSpPr txBox="1"/>
           <p:nvPr/>
         </p:nvSpPr>
@@ -27717,7 +27052,7 @@
         </p:nvSpPr>
         <p:spPr>
           <a:xfrm>
-            <a:off x="685800" y="2418664"/>
+            <a:off x="685800" y="2629891"/>
             <a:ext cx="2286000" cy="167640"/>
           </a:xfrm>
           <a:prstGeom prst="rect">
@@ -27756,7 +27091,7 @@
         </p:nvSpPr>
         <p:spPr>
           <a:xfrm>
-            <a:off x="3143250" y="2418664"/>
+            <a:off x="3143250" y="2629891"/>
             <a:ext cx="3905250" cy="167640"/>
           </a:xfrm>
           <a:prstGeom prst="rect">
@@ -27795,7 +27130,7 @@
         </p:nvSpPr>
         <p:spPr>
           <a:xfrm>
-            <a:off x="7239000" y="2418664"/>
+            <a:off x="7239000" y="2629891"/>
             <a:ext cx="4267200" cy="167640"/>
           </a:xfrm>
           <a:prstGeom prst="rect">
@@ -27834,7 +27169,7 @@
         </p:nvSpPr>
         <p:spPr>
           <a:xfrm>
-            <a:off x="685800" y="2647264"/>
+            <a:off x="685800" y="2858491"/>
             <a:ext cx="10820400" cy="19050"/>
           </a:xfrm>
           <a:prstGeom prst="rect">
@@ -27878,7 +27213,7 @@
         </p:nvSpPr>
         <p:spPr>
           <a:xfrm>
-            <a:off x="685800" y="2799664"/>
+            <a:off x="685800" y="3010891"/>
             <a:ext cx="2114550" cy="762000"/>
           </a:xfrm>
           <a:prstGeom prst="rect">
@@ -27917,7 +27252,7 @@
         </p:nvSpPr>
         <p:spPr>
           <a:xfrm>
-            <a:off x="3143250" y="2799664"/>
+            <a:off x="3143250" y="3010891"/>
             <a:ext cx="3733800" cy="762000"/>
           </a:xfrm>
           <a:prstGeom prst="rect">
@@ -27956,7 +27291,7 @@
         </p:nvSpPr>
         <p:spPr>
           <a:xfrm>
-            <a:off x="7239000" y="2799664"/>
+            <a:off x="7239000" y="3010891"/>
             <a:ext cx="4095750" cy="762000"/>
           </a:xfrm>
           <a:prstGeom prst="rect">
@@ -27982,7 +27317,7 @@
                 </a:solidFill>
                 <a:latin typeface="Roboto"/>
               </a:rPr>
-              <a:t>Sem contagem. A lotação aparece só quando a resposta é recusada</a:t>
+              <a:t>Sem contagem. A lotação só aparece na recusa</a:t>
             </a:r>
           </a:p>
         </p:txBody>
@@ -28143,7 +27478,7 @@
                 </a:solidFill>
                 <a:latin typeface="Roboto"/>
               </a:rPr>
-              <a:t>Gerado pela API, com proteção contra fórmula de planilha</a:t>
+              <a:t>Gerado pela API, com proteção contra fórmulas</a:t>
             </a:r>
           </a:p>
         </p:txBody>
@@ -28156,7 +27491,7 @@
         </p:nvSpPr>
         <p:spPr>
           <a:xfrm>
-            <a:off x="685800" y="4068851"/>
+            <a:off x="685800" y="3857625"/>
             <a:ext cx="10820400" cy="9525"/>
           </a:xfrm>
           <a:prstGeom prst="rect">
@@ -28200,7 +27535,7 @@
         </p:nvSpPr>
         <p:spPr>
           <a:xfrm>
-            <a:off x="685800" y="4192676"/>
+            <a:off x="685800" y="3981450"/>
             <a:ext cx="2114550" cy="762000"/>
           </a:xfrm>
           <a:prstGeom prst="rect">
@@ -28239,7 +27574,7 @@
         </p:nvSpPr>
         <p:spPr>
           <a:xfrm>
-            <a:off x="3143250" y="4192676"/>
+            <a:off x="3143250" y="3981450"/>
             <a:ext cx="3733800" cy="762000"/>
           </a:xfrm>
           <a:prstGeom prst="rect">
@@ -28278,7 +27613,7 @@
         </p:nvSpPr>
         <p:spPr>
           <a:xfrm>
-            <a:off x="7239000" y="4192676"/>
+            <a:off x="7239000" y="3981450"/>
             <a:ext cx="4095750" cy="762000"/>
           </a:xfrm>
           <a:prstGeom prst="rect">
@@ -28317,7 +27652,7 @@
         </p:nvSpPr>
         <p:spPr>
           <a:xfrm>
-            <a:off x="685800" y="4554131"/>
+            <a:off x="685800" y="4342905"/>
             <a:ext cx="10820400" cy="9525"/>
           </a:xfrm>
           <a:prstGeom prst="rect">
@@ -28361,7 +27696,7 @@
         </p:nvSpPr>
         <p:spPr>
           <a:xfrm>
-            <a:off x="685800" y="4677956"/>
+            <a:off x="685800" y="4466730"/>
             <a:ext cx="2114550" cy="762000"/>
           </a:xfrm>
           <a:prstGeom prst="rect">
@@ -28400,7 +27735,7 @@
         </p:nvSpPr>
         <p:spPr>
           <a:xfrm>
-            <a:off x="3143250" y="4677956"/>
+            <a:off x="3143250" y="4466730"/>
             <a:ext cx="3733800" cy="762000"/>
           </a:xfrm>
           <a:prstGeom prst="rect">
@@ -28439,7 +27774,7 @@
         </p:nvSpPr>
         <p:spPr>
           <a:xfrm>
-            <a:off x="7239000" y="4677956"/>
+            <a:off x="7239000" y="4466730"/>
             <a:ext cx="4095750" cy="762000"/>
           </a:xfrm>
           <a:prstGeom prst="rect">
@@ -28478,7 +27813,7 @@
         </p:nvSpPr>
         <p:spPr>
           <a:xfrm>
-            <a:off x="685800" y="5039411"/>
+            <a:off x="685800" y="4828184"/>
             <a:ext cx="10820400" cy="9525"/>
           </a:xfrm>
           <a:prstGeom prst="rect">

</xml_diff>

<commit_message>
docs: demonstração do T3 conduzida pelo Tiago e sem roteiro no slide
</commit_message>
<xml_diff>
--- a/trabalhos/T3-Apresentacao-Intermediaria.pptx
+++ b/trabalhos/T3-Apresentacao-Intermediaria.pptx
@@ -752,7 +752,7 @@
           <a:lstStyle/>
           <a:p>
             <a:r>
-              <a:t>O Tiago opera a tela, na máquina dele, e os outros dois narram: o Guilherme as telas do anfitrião e o Gabriel a parte do convidado e o que a API faz. Abrir dizendo: a conta já está criada para poupar tempo; a tela de entrada está no apêndice. Depois da demonstração, na mesma tela: o quadro do Azure Boards (Guilherme narra) e o GitHub (Tiago).</a:t>
+              <a:t>Tiago. Trocar do PDF para o navegador. Abrir dizendo: a conta já está criada para poupar tempo; a tela de entrada está no apêndice. Passos: criar, personalizar e publicar o convite; responder como convidado, com acompanhante e alergia; tentar responder no convite lotado; alterar a resposta pelo link pessoal; mostrar o painel e baixar o CSV; despublicar e abrir de novo o link do convite. Depois, na mesma tela: o quadro Kanban no Azure Boards e o GitHub, com os PRs e os checks. Voltar ao PDF no slide 13.</a:t>
             </a:r>
           </a:p>
         </p:txBody>
@@ -15674,14 +15674,6 @@
 <file path=ppt/slides/slide12.xml><?xml version="1.0" encoding="utf-8"?>
 <p:sld xmlns:a="http://schemas.openxmlformats.org/drawingml/2006/main" xmlns:p="http://schemas.openxmlformats.org/presentationml/2006/main" xmlns:r="http://schemas.openxmlformats.org/officeDocument/2006/relationships">
   <p:cSld>
-    <p:bg>
-      <p:bgPr>
-        <a:solidFill>
-          <a:srgbClr val="FFFFFF"/>
-        </a:solidFill>
-        <a:effectLst/>
-      </p:bgPr>
-    </p:bg>
     <p:spTree>
       <p:nvGrpSpPr>
         <p:cNvPr id="1" name=""/>
@@ -15691,7 +15683,7 @@
       <p:grpSpPr/>
       <p:pic>
         <p:nvPicPr>
-          <p:cNvPr id="2" name="Picture 1" descr="u-azul.png"/>
+          <p:cNvPr id="2" name="Picture 1" descr="fundo-secao.jpg"/>
           <p:cNvPicPr>
             <a:picLocks noChangeAspect="1"/>
           </p:cNvPicPr>
@@ -15705,6 +15697,30 @@
         </p:blipFill>
         <p:spPr>
           <a:xfrm>
+            <a:off x="0" y="0"/>
+            <a:ext cx="12192000" cy="6858000"/>
+          </a:xfrm>
+          <a:prstGeom prst="rect">
+            <a:avLst/>
+          </a:prstGeom>
+        </p:spPr>
+      </p:pic>
+      <p:pic>
+        <p:nvPicPr>
+          <p:cNvPr id="3" name="Picture 2" descr="u-branco.png"/>
+          <p:cNvPicPr>
+            <a:picLocks noChangeAspect="1"/>
+          </p:cNvPicPr>
+          <p:nvPr/>
+        </p:nvPicPr>
+        <p:blipFill>
+          <a:blip r:embed="rId3"/>
+          <a:stretch>
+            <a:fillRect/>
+          </a:stretch>
+        </p:blipFill>
+        <p:spPr>
+          <a:xfrm>
             <a:off x="10744200" y="457200"/>
             <a:ext cx="342900" cy="342900"/>
           </a:xfrm>
@@ -15715,14 +15731,14 @@
       </p:pic>
       <p:sp>
         <p:nvSpPr>
-          <p:cNvPr id="3" name="TextBox 2"/>
+          <p:cNvPr id="4" name="TextBox 3"/>
           <p:cNvSpPr txBox="1"/>
           <p:nvPr/>
         </p:nvSpPr>
         <p:spPr>
           <a:xfrm>
-            <a:off x="685800" y="685800"/>
-            <a:ext cx="9620250" cy="1524000"/>
+            <a:off x="914400" y="1866900"/>
+            <a:ext cx="9715500" cy="1905000"/>
           </a:xfrm>
           <a:prstGeom prst="rect">
             <a:avLst/>
@@ -15737,31 +15753,31 @@
           <a:p>
             <a:pPr algn="l">
               <a:lnSpc>
-                <a:spcPct val="104000"/>
+                <a:spcPct val="106000"/>
               </a:lnSpc>
             </a:pPr>
             <a:r>
-              <a:rPr sz="3000" b="1" i="0">
-                <a:solidFill>
-                  <a:srgbClr val="21049A"/>
+              <a:rPr sz="3900" b="1" i="0">
+                <a:solidFill>
+                  <a:srgbClr val="FFFFFF"/>
                 </a:solidFill>
                 <a:latin typeface="Roboto"/>
               </a:rPr>
-              <a:t>Roteiro da demonstração</a:t>
-            </a:r>
-          </a:p>
-        </p:txBody>
-      </p:sp>
-      <p:sp>
-        <p:nvSpPr>
-          <p:cNvPr id="4" name="TextBox 3"/>
+              <a:t>Demonstração</a:t>
+            </a:r>
+          </a:p>
+        </p:txBody>
+      </p:sp>
+      <p:sp>
+        <p:nvSpPr>
+          <p:cNvPr id="5" name="TextBox 4"/>
           <p:cNvSpPr txBox="1"/>
           <p:nvPr/>
         </p:nvSpPr>
         <p:spPr>
           <a:xfrm>
-            <a:off x="685800" y="2144611"/>
-            <a:ext cx="3143250" cy="167640"/>
+            <a:off x="685800" y="6324600"/>
+            <a:ext cx="6667500" cy="182880"/>
           </a:xfrm>
           <a:prstGeom prst="rect">
             <a:avLst/>
@@ -15780,27 +15796,27 @@
               </a:lnSpc>
             </a:pPr>
             <a:r>
-              <a:rPr sz="819" b="1" i="0" spc="120">
-                <a:solidFill>
-                  <a:srgbClr val="21049A"/>
+              <a:rPr sz="900" b="0" i="0">
+                <a:solidFill>
+                  <a:srgbClr val="FFFFFF"/>
                 </a:solidFill>
                 <a:latin typeface="Roboto"/>
               </a:rPr>
-              <a:t>PASSO</a:t>
-            </a:r>
-          </a:p>
-        </p:txBody>
-      </p:sp>
-      <p:sp>
-        <p:nvSpPr>
-          <p:cNvPr id="5" name="TextBox 4"/>
+              <a:t>Demonstração, Tiago</a:t>
+            </a:r>
+          </a:p>
+        </p:txBody>
+      </p:sp>
+      <p:sp>
+        <p:nvSpPr>
+          <p:cNvPr id="6" name="TextBox 5"/>
           <p:cNvSpPr txBox="1"/>
           <p:nvPr/>
         </p:nvSpPr>
         <p:spPr>
           <a:xfrm>
-            <a:off x="4000500" y="2144611"/>
-            <a:ext cx="5238750" cy="167640"/>
+            <a:off x="10477500" y="6324600"/>
+            <a:ext cx="1028700" cy="182880"/>
           </a:xfrm>
           <a:prstGeom prst="rect">
             <a:avLst/>
@@ -15813,1142 +15829,15 @@
           </a:bodyPr>
           <a:lstStyle/>
           <a:p>
-            <a:pPr algn="l">
+            <a:pPr algn="r">
               <a:lnSpc>
                 <a:spcPct val="120000"/>
               </a:lnSpc>
             </a:pPr>
             <a:r>
-              <a:rPr sz="819" b="1" i="0" spc="120">
-                <a:solidFill>
-                  <a:srgbClr val="21049A"/>
-                </a:solidFill>
-                <a:latin typeface="Roboto"/>
-              </a:rPr>
-              <a:t>O QUE MOSTRA</a:t>
-            </a:r>
-          </a:p>
-        </p:txBody>
-      </p:sp>
-      <p:sp>
-        <p:nvSpPr>
-          <p:cNvPr id="6" name="TextBox 5"/>
-          <p:cNvSpPr txBox="1"/>
-          <p:nvPr/>
-        </p:nvSpPr>
-        <p:spPr>
-          <a:xfrm>
-            <a:off x="9429750" y="2144611"/>
-            <a:ext cx="2076450" cy="167640"/>
-          </a:xfrm>
-          <a:prstGeom prst="rect">
-            <a:avLst/>
-          </a:prstGeom>
-          <a:noFill/>
-        </p:spPr>
-        <p:txBody>
-          <a:bodyPr wrap="square" lIns="0" rIns="0" tIns="0" bIns="0" anchor="t">
-            <a:spAutoFit/>
-          </a:bodyPr>
-          <a:lstStyle/>
-          <a:p>
-            <a:pPr algn="l">
-              <a:lnSpc>
-                <a:spcPct val="120000"/>
-              </a:lnSpc>
-            </a:pPr>
-            <a:r>
-              <a:rPr sz="819" b="1" i="0" spc="120">
-                <a:solidFill>
-                  <a:srgbClr val="21049A"/>
-                </a:solidFill>
-                <a:latin typeface="Roboto"/>
-              </a:rPr>
-              <a:t>QUEM FALA</a:t>
-            </a:r>
-          </a:p>
-        </p:txBody>
-      </p:sp>
-      <p:sp>
-        <p:nvSpPr>
-          <p:cNvPr id="7" name="Rectangle 6"/>
-          <p:cNvSpPr/>
-          <p:nvPr/>
-        </p:nvSpPr>
-        <p:spPr>
-          <a:xfrm>
-            <a:off x="685800" y="2373211"/>
-            <a:ext cx="10820400" cy="19050"/>
-          </a:xfrm>
-          <a:prstGeom prst="rect">
-            <a:avLst/>
-          </a:prstGeom>
-          <a:solidFill>
-            <a:srgbClr val="21049A"/>
-          </a:solidFill>
-          <a:ln>
-            <a:noFill/>
-          </a:ln>
-          <a:effectLst/>
-        </p:spPr>
-        <p:style>
-          <a:lnRef idx="1">
-            <a:schemeClr val="accent1"/>
-          </a:lnRef>
-          <a:fillRef idx="3">
-            <a:schemeClr val="accent1"/>
-          </a:fillRef>
-          <a:effectRef idx="2">
-            <a:schemeClr val="accent1"/>
-          </a:effectRef>
-          <a:fontRef idx="minor">
-            <a:schemeClr val="lt1"/>
-          </a:fontRef>
-        </p:style>
-        <p:txBody>
-          <a:bodyPr rtlCol="0" anchor="ctr" wrap="square" lIns="0" rIns="0" tIns="0" bIns="0"/>
-          <a:lstStyle/>
-          <a:p>
-            <a:pPr algn="ctr"/>
-          </a:p>
-        </p:txBody>
-      </p:sp>
-      <p:sp>
-        <p:nvSpPr>
-          <p:cNvPr id="8" name="TextBox 7"/>
-          <p:cNvSpPr txBox="1"/>
-          <p:nvPr/>
-        </p:nvSpPr>
-        <p:spPr>
-          <a:xfrm>
-            <a:off x="685800" y="2525611"/>
-            <a:ext cx="2971800" cy="762000"/>
-          </a:xfrm>
-          <a:prstGeom prst="rect">
-            <a:avLst/>
-          </a:prstGeom>
-          <a:noFill/>
-        </p:spPr>
-        <p:txBody>
-          <a:bodyPr wrap="square" lIns="0" rIns="0" tIns="0" bIns="0" anchor="t">
-            <a:spAutoFit/>
-          </a:bodyPr>
-          <a:lstStyle/>
-          <a:p>
-            <a:pPr algn="l">
-              <a:lnSpc>
-                <a:spcPct val="135000"/>
-              </a:lnSpc>
-            </a:pPr>
-            <a:r>
-              <a:rPr sz="1350" b="1" i="0">
-                <a:solidFill>
-                  <a:srgbClr val="21049A"/>
-                </a:solidFill>
-                <a:latin typeface="Roboto"/>
-              </a:rPr>
-              <a:t>Criar, personalizar e publicar</a:t>
-            </a:r>
-          </a:p>
-        </p:txBody>
-      </p:sp>
-      <p:sp>
-        <p:nvSpPr>
-          <p:cNvPr id="9" name="TextBox 8"/>
-          <p:cNvSpPr txBox="1"/>
-          <p:nvPr/>
-        </p:nvSpPr>
-        <p:spPr>
-          <a:xfrm>
-            <a:off x="4000500" y="2525611"/>
-            <a:ext cx="5067300" cy="762000"/>
-          </a:xfrm>
-          <a:prstGeom prst="rect">
-            <a:avLst/>
-          </a:prstGeom>
-          <a:noFill/>
-        </p:spPr>
-        <p:txBody>
-          <a:bodyPr wrap="square" lIns="0" rIns="0" tIns="0" bIns="0" anchor="t">
-            <a:spAutoFit/>
-          </a:bodyPr>
-          <a:lstStyle/>
-          <a:p>
-            <a:pPr algn="l">
-              <a:lnSpc>
-                <a:spcPct val="135000"/>
-              </a:lnSpc>
-            </a:pPr>
-            <a:r>
-              <a:rPr sz="1280" b="0" i="0">
-                <a:solidFill>
-                  <a:srgbClr val="1A1A1E"/>
-                </a:solidFill>
-                <a:latin typeface="Roboto"/>
-              </a:rPr>
-              <a:t>Template, cores, prévia e o link gerado</a:t>
-            </a:r>
-          </a:p>
-        </p:txBody>
-      </p:sp>
-      <p:sp>
-        <p:nvSpPr>
-          <p:cNvPr id="10" name="TextBox 9"/>
-          <p:cNvSpPr txBox="1"/>
-          <p:nvPr/>
-        </p:nvSpPr>
-        <p:spPr>
-          <a:xfrm>
-            <a:off x="9429750" y="2525611"/>
-            <a:ext cx="1905000" cy="762000"/>
-          </a:xfrm>
-          <a:prstGeom prst="rect">
-            <a:avLst/>
-          </a:prstGeom>
-          <a:noFill/>
-        </p:spPr>
-        <p:txBody>
-          <a:bodyPr wrap="square" lIns="0" rIns="0" tIns="0" bIns="0" anchor="t">
-            <a:spAutoFit/>
-          </a:bodyPr>
-          <a:lstStyle/>
-          <a:p>
-            <a:pPr algn="l">
-              <a:lnSpc>
-                <a:spcPct val="135000"/>
-              </a:lnSpc>
-            </a:pPr>
-            <a:r>
-              <a:rPr sz="1280" b="0" i="0">
-                <a:solidFill>
-                  <a:srgbClr val="1A1A1E"/>
-                </a:solidFill>
-                <a:latin typeface="Roboto"/>
-              </a:rPr>
-              <a:t>Guilherme</a:t>
-            </a:r>
-          </a:p>
-        </p:txBody>
-      </p:sp>
-      <p:sp>
-        <p:nvSpPr>
-          <p:cNvPr id="11" name="Rectangle 10"/>
-          <p:cNvSpPr/>
-          <p:nvPr/>
-        </p:nvSpPr>
-        <p:spPr>
-          <a:xfrm>
-            <a:off x="685800" y="2887066"/>
-            <a:ext cx="10820400" cy="9525"/>
-          </a:xfrm>
-          <a:prstGeom prst="rect">
-            <a:avLst/>
-          </a:prstGeom>
-          <a:solidFill>
-            <a:srgbClr val="EDEDF2"/>
-          </a:solidFill>
-          <a:ln>
-            <a:noFill/>
-          </a:ln>
-          <a:effectLst/>
-        </p:spPr>
-        <p:style>
-          <a:lnRef idx="1">
-            <a:schemeClr val="accent1"/>
-          </a:lnRef>
-          <a:fillRef idx="3">
-            <a:schemeClr val="accent1"/>
-          </a:fillRef>
-          <a:effectRef idx="2">
-            <a:schemeClr val="accent1"/>
-          </a:effectRef>
-          <a:fontRef idx="minor">
-            <a:schemeClr val="lt1"/>
-          </a:fontRef>
-        </p:style>
-        <p:txBody>
-          <a:bodyPr rtlCol="0" anchor="ctr" wrap="square" lIns="0" rIns="0" tIns="0" bIns="0"/>
-          <a:lstStyle/>
-          <a:p>
-            <a:pPr algn="ctr"/>
-          </a:p>
-        </p:txBody>
-      </p:sp>
-      <p:sp>
-        <p:nvSpPr>
-          <p:cNvPr id="12" name="TextBox 11"/>
-          <p:cNvSpPr txBox="1"/>
-          <p:nvPr/>
-        </p:nvSpPr>
-        <p:spPr>
-          <a:xfrm>
-            <a:off x="685800" y="3010891"/>
-            <a:ext cx="2971800" cy="762000"/>
-          </a:xfrm>
-          <a:prstGeom prst="rect">
-            <a:avLst/>
-          </a:prstGeom>
-          <a:noFill/>
-        </p:spPr>
-        <p:txBody>
-          <a:bodyPr wrap="square" lIns="0" rIns="0" tIns="0" bIns="0" anchor="t">
-            <a:spAutoFit/>
-          </a:bodyPr>
-          <a:lstStyle/>
-          <a:p>
-            <a:pPr algn="l">
-              <a:lnSpc>
-                <a:spcPct val="135000"/>
-              </a:lnSpc>
-            </a:pPr>
-            <a:r>
-              <a:rPr sz="1350" b="1" i="0">
-                <a:solidFill>
-                  <a:srgbClr val="21049A"/>
-                </a:solidFill>
-                <a:latin typeface="Roboto"/>
-              </a:rPr>
-              <a:t>Responder como convidado</a:t>
-            </a:r>
-          </a:p>
-        </p:txBody>
-      </p:sp>
-      <p:sp>
-        <p:nvSpPr>
-          <p:cNvPr id="13" name="TextBox 12"/>
-          <p:cNvSpPr txBox="1"/>
-          <p:nvPr/>
-        </p:nvSpPr>
-        <p:spPr>
-          <a:xfrm>
-            <a:off x="4000500" y="3010891"/>
-            <a:ext cx="5067300" cy="762000"/>
-          </a:xfrm>
-          <a:prstGeom prst="rect">
-            <a:avLst/>
-          </a:prstGeom>
-          <a:noFill/>
-        </p:spPr>
-        <p:txBody>
-          <a:bodyPr wrap="square" lIns="0" rIns="0" tIns="0" bIns="0" anchor="t">
-            <a:spAutoFit/>
-          </a:bodyPr>
-          <a:lstStyle/>
-          <a:p>
-            <a:pPr algn="l">
-              <a:lnSpc>
-                <a:spcPct val="135000"/>
-              </a:lnSpc>
-            </a:pPr>
-            <a:r>
-              <a:rPr sz="1280" b="0" i="0">
-                <a:solidFill>
-                  <a:srgbClr val="1A1A1E"/>
-                </a:solidFill>
-                <a:latin typeface="Roboto"/>
-              </a:rPr>
-              <a:t>Resposta sem conta, com acompanhante e restrição alimentar</a:t>
-            </a:r>
-          </a:p>
-        </p:txBody>
-      </p:sp>
-      <p:sp>
-        <p:nvSpPr>
-          <p:cNvPr id="14" name="TextBox 13"/>
-          <p:cNvSpPr txBox="1"/>
-          <p:nvPr/>
-        </p:nvSpPr>
-        <p:spPr>
-          <a:xfrm>
-            <a:off x="9429750" y="3010891"/>
-            <a:ext cx="1905000" cy="762000"/>
-          </a:xfrm>
-          <a:prstGeom prst="rect">
-            <a:avLst/>
-          </a:prstGeom>
-          <a:noFill/>
-        </p:spPr>
-        <p:txBody>
-          <a:bodyPr wrap="square" lIns="0" rIns="0" tIns="0" bIns="0" anchor="t">
-            <a:spAutoFit/>
-          </a:bodyPr>
-          <a:lstStyle/>
-          <a:p>
-            <a:pPr algn="l">
-              <a:lnSpc>
-                <a:spcPct val="135000"/>
-              </a:lnSpc>
-            </a:pPr>
-            <a:r>
-              <a:rPr sz="1280" b="0" i="0">
-                <a:solidFill>
-                  <a:srgbClr val="1A1A1E"/>
-                </a:solidFill>
-                <a:latin typeface="Roboto"/>
-              </a:rPr>
-              <a:t>Gabriel</a:t>
-            </a:r>
-          </a:p>
-        </p:txBody>
-      </p:sp>
-      <p:sp>
-        <p:nvSpPr>
-          <p:cNvPr id="15" name="Rectangle 14"/>
-          <p:cNvSpPr/>
-          <p:nvPr/>
-        </p:nvSpPr>
-        <p:spPr>
-          <a:xfrm>
-            <a:off x="685800" y="3372345"/>
-            <a:ext cx="10820400" cy="9525"/>
-          </a:xfrm>
-          <a:prstGeom prst="rect">
-            <a:avLst/>
-          </a:prstGeom>
-          <a:solidFill>
-            <a:srgbClr val="EDEDF2"/>
-          </a:solidFill>
-          <a:ln>
-            <a:noFill/>
-          </a:ln>
-          <a:effectLst/>
-        </p:spPr>
-        <p:style>
-          <a:lnRef idx="1">
-            <a:schemeClr val="accent1"/>
-          </a:lnRef>
-          <a:fillRef idx="3">
-            <a:schemeClr val="accent1"/>
-          </a:fillRef>
-          <a:effectRef idx="2">
-            <a:schemeClr val="accent1"/>
-          </a:effectRef>
-          <a:fontRef idx="minor">
-            <a:schemeClr val="lt1"/>
-          </a:fontRef>
-        </p:style>
-        <p:txBody>
-          <a:bodyPr rtlCol="0" anchor="ctr" wrap="square" lIns="0" rIns="0" tIns="0" bIns="0"/>
-          <a:lstStyle/>
-          <a:p>
-            <a:pPr algn="ctr"/>
-          </a:p>
-        </p:txBody>
-      </p:sp>
-      <p:sp>
-        <p:nvSpPr>
-          <p:cNvPr id="16" name="TextBox 15"/>
-          <p:cNvSpPr txBox="1"/>
-          <p:nvPr/>
-        </p:nvSpPr>
-        <p:spPr>
-          <a:xfrm>
-            <a:off x="685800" y="3496170"/>
-            <a:ext cx="2971800" cy="762000"/>
-          </a:xfrm>
-          <a:prstGeom prst="rect">
-            <a:avLst/>
-          </a:prstGeom>
-          <a:noFill/>
-        </p:spPr>
-        <p:txBody>
-          <a:bodyPr wrap="square" lIns="0" rIns="0" tIns="0" bIns="0" anchor="t">
-            <a:spAutoFit/>
-          </a:bodyPr>
-          <a:lstStyle/>
-          <a:p>
-            <a:pPr algn="l">
-              <a:lnSpc>
-                <a:spcPct val="135000"/>
-              </a:lnSpc>
-            </a:pPr>
-            <a:r>
-              <a:rPr sz="1350" b="1" i="0">
-                <a:solidFill>
-                  <a:srgbClr val="21049A"/>
-                </a:solidFill>
-                <a:latin typeface="Roboto"/>
-              </a:rPr>
-              <a:t>Responder num convite lotado</a:t>
-            </a:r>
-          </a:p>
-        </p:txBody>
-      </p:sp>
-      <p:sp>
-        <p:nvSpPr>
-          <p:cNvPr id="17" name="TextBox 16"/>
-          <p:cNvSpPr txBox="1"/>
-          <p:nvPr/>
-        </p:nvSpPr>
-        <p:spPr>
-          <a:xfrm>
-            <a:off x="4000500" y="3496170"/>
-            <a:ext cx="5067300" cy="762000"/>
-          </a:xfrm>
-          <a:prstGeom prst="rect">
-            <a:avLst/>
-          </a:prstGeom>
-          <a:noFill/>
-        </p:spPr>
-        <p:txBody>
-          <a:bodyPr wrap="square" lIns="0" rIns="0" tIns="0" bIns="0" anchor="t">
-            <a:spAutoFit/>
-          </a:bodyPr>
-          <a:lstStyle/>
-          <a:p>
-            <a:pPr algn="l">
-              <a:lnSpc>
-                <a:spcPct val="135000"/>
-              </a:lnSpc>
-            </a:pPr>
-            <a:r>
-              <a:rPr sz="1280" b="0" i="0">
-                <a:solidFill>
-                  <a:srgbClr val="1A1A1E"/>
-                </a:solidFill>
-                <a:latin typeface="Roboto"/>
-              </a:rPr>
-              <a:t>A recusa pelo teto de vagas</a:t>
-            </a:r>
-          </a:p>
-        </p:txBody>
-      </p:sp>
-      <p:sp>
-        <p:nvSpPr>
-          <p:cNvPr id="18" name="TextBox 17"/>
-          <p:cNvSpPr txBox="1"/>
-          <p:nvPr/>
-        </p:nvSpPr>
-        <p:spPr>
-          <a:xfrm>
-            <a:off x="9429750" y="3496170"/>
-            <a:ext cx="1905000" cy="762000"/>
-          </a:xfrm>
-          <a:prstGeom prst="rect">
-            <a:avLst/>
-          </a:prstGeom>
-          <a:noFill/>
-        </p:spPr>
-        <p:txBody>
-          <a:bodyPr wrap="square" lIns="0" rIns="0" tIns="0" bIns="0" anchor="t">
-            <a:spAutoFit/>
-          </a:bodyPr>
-          <a:lstStyle/>
-          <a:p>
-            <a:pPr algn="l">
-              <a:lnSpc>
-                <a:spcPct val="135000"/>
-              </a:lnSpc>
-            </a:pPr>
-            <a:r>
-              <a:rPr sz="1280" b="0" i="0">
-                <a:solidFill>
-                  <a:srgbClr val="1A1A1E"/>
-                </a:solidFill>
-                <a:latin typeface="Roboto"/>
-              </a:rPr>
-              <a:t>Gabriel</a:t>
-            </a:r>
-          </a:p>
-        </p:txBody>
-      </p:sp>
-      <p:sp>
-        <p:nvSpPr>
-          <p:cNvPr id="19" name="Rectangle 18"/>
-          <p:cNvSpPr/>
-          <p:nvPr/>
-        </p:nvSpPr>
-        <p:spPr>
-          <a:xfrm>
-            <a:off x="685800" y="3857625"/>
-            <a:ext cx="10820400" cy="9525"/>
-          </a:xfrm>
-          <a:prstGeom prst="rect">
-            <a:avLst/>
-          </a:prstGeom>
-          <a:solidFill>
-            <a:srgbClr val="EDEDF2"/>
-          </a:solidFill>
-          <a:ln>
-            <a:noFill/>
-          </a:ln>
-          <a:effectLst/>
-        </p:spPr>
-        <p:style>
-          <a:lnRef idx="1">
-            <a:schemeClr val="accent1"/>
-          </a:lnRef>
-          <a:fillRef idx="3">
-            <a:schemeClr val="accent1"/>
-          </a:fillRef>
-          <a:effectRef idx="2">
-            <a:schemeClr val="accent1"/>
-          </a:effectRef>
-          <a:fontRef idx="minor">
-            <a:schemeClr val="lt1"/>
-          </a:fontRef>
-        </p:style>
-        <p:txBody>
-          <a:bodyPr rtlCol="0" anchor="ctr" wrap="square" lIns="0" rIns="0" tIns="0" bIns="0"/>
-          <a:lstStyle/>
-          <a:p>
-            <a:pPr algn="ctr"/>
-          </a:p>
-        </p:txBody>
-      </p:sp>
-      <p:sp>
-        <p:nvSpPr>
-          <p:cNvPr id="20" name="TextBox 19"/>
-          <p:cNvSpPr txBox="1"/>
-          <p:nvPr/>
-        </p:nvSpPr>
-        <p:spPr>
-          <a:xfrm>
-            <a:off x="685800" y="3981450"/>
-            <a:ext cx="2971800" cy="762000"/>
-          </a:xfrm>
-          <a:prstGeom prst="rect">
-            <a:avLst/>
-          </a:prstGeom>
-          <a:noFill/>
-        </p:spPr>
-        <p:txBody>
-          <a:bodyPr wrap="square" lIns="0" rIns="0" tIns="0" bIns="0" anchor="t">
-            <a:spAutoFit/>
-          </a:bodyPr>
-          <a:lstStyle/>
-          <a:p>
-            <a:pPr algn="l">
-              <a:lnSpc>
-                <a:spcPct val="135000"/>
-              </a:lnSpc>
-            </a:pPr>
-            <a:r>
-              <a:rPr sz="1350" b="1" i="0">
-                <a:solidFill>
-                  <a:srgbClr val="21049A"/>
-                </a:solidFill>
-                <a:latin typeface="Roboto"/>
-              </a:rPr>
-              <a:t>Alterar pelo link pessoal</a:t>
-            </a:r>
-          </a:p>
-        </p:txBody>
-      </p:sp>
-      <p:sp>
-        <p:nvSpPr>
-          <p:cNvPr id="21" name="TextBox 20"/>
-          <p:cNvSpPr txBox="1"/>
-          <p:nvPr/>
-        </p:nvSpPr>
-        <p:spPr>
-          <a:xfrm>
-            <a:off x="4000500" y="3981450"/>
-            <a:ext cx="5067300" cy="762000"/>
-          </a:xfrm>
-          <a:prstGeom prst="rect">
-            <a:avLst/>
-          </a:prstGeom>
-          <a:noFill/>
-        </p:spPr>
-        <p:txBody>
-          <a:bodyPr wrap="square" lIns="0" rIns="0" tIns="0" bIns="0" anchor="t">
-            <a:spAutoFit/>
-          </a:bodyPr>
-          <a:lstStyle/>
-          <a:p>
-            <a:pPr algn="l">
-              <a:lnSpc>
-                <a:spcPct val="135000"/>
-              </a:lnSpc>
-            </a:pPr>
-            <a:r>
-              <a:rPr sz="1280" b="0" i="0">
-                <a:solidFill>
-                  <a:srgbClr val="1A1A1E"/>
-                </a:solidFill>
-                <a:latin typeface="Roboto"/>
-              </a:rPr>
-              <a:t>A troca da resposta para talvez</a:t>
-            </a:r>
-          </a:p>
-        </p:txBody>
-      </p:sp>
-      <p:sp>
-        <p:nvSpPr>
-          <p:cNvPr id="22" name="TextBox 21"/>
-          <p:cNvSpPr txBox="1"/>
-          <p:nvPr/>
-        </p:nvSpPr>
-        <p:spPr>
-          <a:xfrm>
-            <a:off x="9429750" y="3981450"/>
-            <a:ext cx="1905000" cy="762000"/>
-          </a:xfrm>
-          <a:prstGeom prst="rect">
-            <a:avLst/>
-          </a:prstGeom>
-          <a:noFill/>
-        </p:spPr>
-        <p:txBody>
-          <a:bodyPr wrap="square" lIns="0" rIns="0" tIns="0" bIns="0" anchor="t">
-            <a:spAutoFit/>
-          </a:bodyPr>
-          <a:lstStyle/>
-          <a:p>
-            <a:pPr algn="l">
-              <a:lnSpc>
-                <a:spcPct val="135000"/>
-              </a:lnSpc>
-            </a:pPr>
-            <a:r>
-              <a:rPr sz="1280" b="0" i="0">
-                <a:solidFill>
-                  <a:srgbClr val="1A1A1E"/>
-                </a:solidFill>
-                <a:latin typeface="Roboto"/>
-              </a:rPr>
-              <a:t>Gabriel</a:t>
-            </a:r>
-          </a:p>
-        </p:txBody>
-      </p:sp>
-      <p:sp>
-        <p:nvSpPr>
-          <p:cNvPr id="23" name="Rectangle 22"/>
-          <p:cNvSpPr/>
-          <p:nvPr/>
-        </p:nvSpPr>
-        <p:spPr>
-          <a:xfrm>
-            <a:off x="685800" y="4342905"/>
-            <a:ext cx="10820400" cy="9525"/>
-          </a:xfrm>
-          <a:prstGeom prst="rect">
-            <a:avLst/>
-          </a:prstGeom>
-          <a:solidFill>
-            <a:srgbClr val="EDEDF2"/>
-          </a:solidFill>
-          <a:ln>
-            <a:noFill/>
-          </a:ln>
-          <a:effectLst/>
-        </p:spPr>
-        <p:style>
-          <a:lnRef idx="1">
-            <a:schemeClr val="accent1"/>
-          </a:lnRef>
-          <a:fillRef idx="3">
-            <a:schemeClr val="accent1"/>
-          </a:fillRef>
-          <a:effectRef idx="2">
-            <a:schemeClr val="accent1"/>
-          </a:effectRef>
-          <a:fontRef idx="minor">
-            <a:schemeClr val="lt1"/>
-          </a:fontRef>
-        </p:style>
-        <p:txBody>
-          <a:bodyPr rtlCol="0" anchor="ctr" wrap="square" lIns="0" rIns="0" tIns="0" bIns="0"/>
-          <a:lstStyle/>
-          <a:p>
-            <a:pPr algn="ctr"/>
-          </a:p>
-        </p:txBody>
-      </p:sp>
-      <p:sp>
-        <p:nvSpPr>
-          <p:cNvPr id="24" name="TextBox 23"/>
-          <p:cNvSpPr txBox="1"/>
-          <p:nvPr/>
-        </p:nvSpPr>
-        <p:spPr>
-          <a:xfrm>
-            <a:off x="685800" y="4466730"/>
-            <a:ext cx="2971800" cy="762000"/>
-          </a:xfrm>
-          <a:prstGeom prst="rect">
-            <a:avLst/>
-          </a:prstGeom>
-          <a:noFill/>
-        </p:spPr>
-        <p:txBody>
-          <a:bodyPr wrap="square" lIns="0" rIns="0" tIns="0" bIns="0" anchor="t">
-            <a:spAutoFit/>
-          </a:bodyPr>
-          <a:lstStyle/>
-          <a:p>
-            <a:pPr algn="l">
-              <a:lnSpc>
-                <a:spcPct val="135000"/>
-              </a:lnSpc>
-            </a:pPr>
-            <a:r>
-              <a:rPr sz="1350" b="1" i="0">
-                <a:solidFill>
-                  <a:srgbClr val="21049A"/>
-                </a:solidFill>
-                <a:latin typeface="Roboto"/>
-              </a:rPr>
-              <a:t>Painel e CSV</a:t>
-            </a:r>
-          </a:p>
-        </p:txBody>
-      </p:sp>
-      <p:sp>
-        <p:nvSpPr>
-          <p:cNvPr id="25" name="TextBox 24"/>
-          <p:cNvSpPr txBox="1"/>
-          <p:nvPr/>
-        </p:nvSpPr>
-        <p:spPr>
-          <a:xfrm>
-            <a:off x="4000500" y="4466730"/>
-            <a:ext cx="5067300" cy="762000"/>
-          </a:xfrm>
-          <a:prstGeom prst="rect">
-            <a:avLst/>
-          </a:prstGeom>
-          <a:noFill/>
-        </p:spPr>
-        <p:txBody>
-          <a:bodyPr wrap="square" lIns="0" rIns="0" tIns="0" bIns="0" anchor="t">
-            <a:spAutoFit/>
-          </a:bodyPr>
-          <a:lstStyle/>
-          <a:p>
-            <a:pPr algn="l">
-              <a:lnSpc>
-                <a:spcPct val="135000"/>
-              </a:lnSpc>
-            </a:pPr>
-            <a:r>
-              <a:rPr sz="1280" b="0" i="0">
-                <a:solidFill>
-                  <a:srgbClr val="1A1A1E"/>
-                </a:solidFill>
-                <a:latin typeface="Roboto"/>
-              </a:rPr>
-              <a:t>Lista de presença e restrições exportadas</a:t>
-            </a:r>
-          </a:p>
-        </p:txBody>
-      </p:sp>
-      <p:sp>
-        <p:nvSpPr>
-          <p:cNvPr id="26" name="TextBox 25"/>
-          <p:cNvSpPr txBox="1"/>
-          <p:nvPr/>
-        </p:nvSpPr>
-        <p:spPr>
-          <a:xfrm>
-            <a:off x="9429750" y="4466730"/>
-            <a:ext cx="1905000" cy="762000"/>
-          </a:xfrm>
-          <a:prstGeom prst="rect">
-            <a:avLst/>
-          </a:prstGeom>
-          <a:noFill/>
-        </p:spPr>
-        <p:txBody>
-          <a:bodyPr wrap="square" lIns="0" rIns="0" tIns="0" bIns="0" anchor="t">
-            <a:spAutoFit/>
-          </a:bodyPr>
-          <a:lstStyle/>
-          <a:p>
-            <a:pPr algn="l">
-              <a:lnSpc>
-                <a:spcPct val="135000"/>
-              </a:lnSpc>
-            </a:pPr>
-            <a:r>
-              <a:rPr sz="1280" b="0" i="0">
-                <a:solidFill>
-                  <a:srgbClr val="1A1A1E"/>
-                </a:solidFill>
-                <a:latin typeface="Roboto"/>
-              </a:rPr>
-              <a:t>Guilherme</a:t>
-            </a:r>
-          </a:p>
-        </p:txBody>
-      </p:sp>
-      <p:sp>
-        <p:nvSpPr>
-          <p:cNvPr id="27" name="Rectangle 26"/>
-          <p:cNvSpPr/>
-          <p:nvPr/>
-        </p:nvSpPr>
-        <p:spPr>
-          <a:xfrm>
-            <a:off x="685800" y="4828184"/>
-            <a:ext cx="10820400" cy="9525"/>
-          </a:xfrm>
-          <a:prstGeom prst="rect">
-            <a:avLst/>
-          </a:prstGeom>
-          <a:solidFill>
-            <a:srgbClr val="EDEDF2"/>
-          </a:solidFill>
-          <a:ln>
-            <a:noFill/>
-          </a:ln>
-          <a:effectLst/>
-        </p:spPr>
-        <p:style>
-          <a:lnRef idx="1">
-            <a:schemeClr val="accent1"/>
-          </a:lnRef>
-          <a:fillRef idx="3">
-            <a:schemeClr val="accent1"/>
-          </a:fillRef>
-          <a:effectRef idx="2">
-            <a:schemeClr val="accent1"/>
-          </a:effectRef>
-          <a:fontRef idx="minor">
-            <a:schemeClr val="lt1"/>
-          </a:fontRef>
-        </p:style>
-        <p:txBody>
-          <a:bodyPr rtlCol="0" anchor="ctr" wrap="square" lIns="0" rIns="0" tIns="0" bIns="0"/>
-          <a:lstStyle/>
-          <a:p>
-            <a:pPr algn="ctr"/>
-          </a:p>
-        </p:txBody>
-      </p:sp>
-      <p:sp>
-        <p:nvSpPr>
-          <p:cNvPr id="28" name="TextBox 27"/>
-          <p:cNvSpPr txBox="1"/>
-          <p:nvPr/>
-        </p:nvSpPr>
-        <p:spPr>
-          <a:xfrm>
-            <a:off x="685800" y="4952009"/>
-            <a:ext cx="2971800" cy="762000"/>
-          </a:xfrm>
-          <a:prstGeom prst="rect">
-            <a:avLst/>
-          </a:prstGeom>
-          <a:noFill/>
-        </p:spPr>
-        <p:txBody>
-          <a:bodyPr wrap="square" lIns="0" rIns="0" tIns="0" bIns="0" anchor="t">
-            <a:spAutoFit/>
-          </a:bodyPr>
-          <a:lstStyle/>
-          <a:p>
-            <a:pPr algn="l">
-              <a:lnSpc>
-                <a:spcPct val="135000"/>
-              </a:lnSpc>
-            </a:pPr>
-            <a:r>
-              <a:rPr sz="1350" b="1" i="0">
-                <a:solidFill>
-                  <a:srgbClr val="21049A"/>
-                </a:solidFill>
-                <a:latin typeface="Roboto"/>
-              </a:rPr>
-              <a:t>Despublicar</a:t>
-            </a:r>
-          </a:p>
-        </p:txBody>
-      </p:sp>
-      <p:sp>
-        <p:nvSpPr>
-          <p:cNvPr id="29" name="TextBox 28"/>
-          <p:cNvSpPr txBox="1"/>
-          <p:nvPr/>
-        </p:nvSpPr>
-        <p:spPr>
-          <a:xfrm>
-            <a:off x="4000500" y="4952009"/>
-            <a:ext cx="5067300" cy="762000"/>
-          </a:xfrm>
-          <a:prstGeom prst="rect">
-            <a:avLst/>
-          </a:prstGeom>
-          <a:noFill/>
-        </p:spPr>
-        <p:txBody>
-          <a:bodyPr wrap="square" lIns="0" rIns="0" tIns="0" bIns="0" anchor="t">
-            <a:spAutoFit/>
-          </a:bodyPr>
-          <a:lstStyle/>
-          <a:p>
-            <a:pPr algn="l">
-              <a:lnSpc>
-                <a:spcPct val="135000"/>
-              </a:lnSpc>
-            </a:pPr>
-            <a:r>
-              <a:rPr sz="1280" b="0" i="0">
-                <a:solidFill>
-                  <a:srgbClr val="1A1A1E"/>
-                </a:solidFill>
-                <a:latin typeface="Roboto"/>
-              </a:rPr>
-              <a:t>O link do convite deixa de abrir</a:t>
-            </a:r>
-          </a:p>
-        </p:txBody>
-      </p:sp>
-      <p:sp>
-        <p:nvSpPr>
-          <p:cNvPr id="30" name="TextBox 29"/>
-          <p:cNvSpPr txBox="1"/>
-          <p:nvPr/>
-        </p:nvSpPr>
-        <p:spPr>
-          <a:xfrm>
-            <a:off x="9429750" y="4952009"/>
-            <a:ext cx="1905000" cy="762000"/>
-          </a:xfrm>
-          <a:prstGeom prst="rect">
-            <a:avLst/>
-          </a:prstGeom>
-          <a:noFill/>
-        </p:spPr>
-        <p:txBody>
-          <a:bodyPr wrap="square" lIns="0" rIns="0" tIns="0" bIns="0" anchor="t">
-            <a:spAutoFit/>
-          </a:bodyPr>
-          <a:lstStyle/>
-          <a:p>
-            <a:pPr algn="l">
-              <a:lnSpc>
-                <a:spcPct val="135000"/>
-              </a:lnSpc>
-            </a:pPr>
-            <a:r>
-              <a:rPr sz="1280" b="0" i="0">
-                <a:solidFill>
-                  <a:srgbClr val="1A1A1E"/>
-                </a:solidFill>
-                <a:latin typeface="Roboto"/>
-              </a:rPr>
-              <a:t>Guilherme</a:t>
-            </a:r>
-          </a:p>
-        </p:txBody>
-      </p:sp>
-      <p:sp>
-        <p:nvSpPr>
-          <p:cNvPr id="31" name="Rectangle 30"/>
-          <p:cNvSpPr/>
-          <p:nvPr/>
-        </p:nvSpPr>
-        <p:spPr>
-          <a:xfrm>
-            <a:off x="685800" y="5313464"/>
-            <a:ext cx="10820400" cy="9525"/>
-          </a:xfrm>
-          <a:prstGeom prst="rect">
-            <a:avLst/>
-          </a:prstGeom>
-          <a:solidFill>
-            <a:srgbClr val="EDEDF2"/>
-          </a:solidFill>
-          <a:ln>
-            <a:noFill/>
-          </a:ln>
-          <a:effectLst/>
-        </p:spPr>
-        <p:style>
-          <a:lnRef idx="1">
-            <a:schemeClr val="accent1"/>
-          </a:lnRef>
-          <a:fillRef idx="3">
-            <a:schemeClr val="accent1"/>
-          </a:fillRef>
-          <a:effectRef idx="2">
-            <a:schemeClr val="accent1"/>
-          </a:effectRef>
-          <a:fontRef idx="minor">
-            <a:schemeClr val="lt1"/>
-          </a:fontRef>
-        </p:style>
-        <p:txBody>
-          <a:bodyPr rtlCol="0" anchor="ctr" wrap="square" lIns="0" rIns="0" tIns="0" bIns="0"/>
-          <a:lstStyle/>
-          <a:p>
-            <a:pPr algn="ctr"/>
-          </a:p>
-        </p:txBody>
-      </p:sp>
-      <p:sp>
-        <p:nvSpPr>
-          <p:cNvPr id="32" name="TextBox 31"/>
-          <p:cNvSpPr txBox="1"/>
-          <p:nvPr/>
-        </p:nvSpPr>
-        <p:spPr>
-          <a:xfrm>
-            <a:off x="685800" y="6324600"/>
-            <a:ext cx="6667500" cy="182880"/>
-          </a:xfrm>
-          <a:prstGeom prst="rect">
-            <a:avLst/>
-          </a:prstGeom>
-          <a:noFill/>
-        </p:spPr>
-        <p:txBody>
-          <a:bodyPr wrap="square" lIns="0" rIns="0" tIns="0" bIns="0" anchor="t">
-            <a:spAutoFit/>
-          </a:bodyPr>
-          <a:lstStyle/>
-          <a:p>
-            <a:pPr algn="l">
-              <a:lnSpc>
-                <a:spcPct val="120000"/>
-              </a:lnSpc>
-            </a:pPr>
-            <a:r>
-              <a:rPr sz="900" b="0" i="0">
-                <a:solidFill>
-                  <a:srgbClr val="6B6B78"/>
-                </a:solidFill>
-                <a:latin typeface="Roboto"/>
-              </a:rPr>
-              <a:t>Demonstração, Tiago, Guilherme e Gabriel</a:t>
-            </a:r>
-          </a:p>
-        </p:txBody>
-      </p:sp>
-      <p:sp>
-        <p:nvSpPr>
-          <p:cNvPr id="33" name="TextBox 32"/>
-          <p:cNvSpPr txBox="1"/>
-          <p:nvPr/>
-        </p:nvSpPr>
-        <p:spPr>
-          <a:xfrm>
-            <a:off x="10477500" y="6324600"/>
-            <a:ext cx="1028700" cy="182880"/>
-          </a:xfrm>
-          <a:prstGeom prst="rect">
-            <a:avLst/>
-          </a:prstGeom>
-          <a:noFill/>
-        </p:spPr>
-        <p:txBody>
-          <a:bodyPr wrap="square" lIns="0" rIns="0" tIns="0" bIns="0" anchor="t">
-            <a:spAutoFit/>
-          </a:bodyPr>
-          <a:lstStyle/>
-          <a:p>
-            <a:pPr algn="r">
-              <a:lnSpc>
-                <a:spcPct val="120000"/>
-              </a:lnSpc>
-            </a:pPr>
-            <a:r>
               <a:rPr sz="900" b="1" i="0">
                 <a:solidFill>
-                  <a:srgbClr val="21049A"/>
+                  <a:srgbClr val="FFFFFF"/>
                 </a:solidFill>
                 <a:latin typeface="Roboto"/>
               </a:rPr>

</xml_diff>